<commit_message>
feat(ppt): P1 三圈光晕节点 + P2 时间轴 + AI 配图
P1 封面: 改用抽象 AI 神经网络 (32% alpha) 做底,中央 + 3 卫星
光晕节点替代乐高,保持白底 2.5D 设计语言.

P2 痛点: 改用横向时间轴 (红→金→绿渐变),6 槽位放 6 张 AI
配图 (3 红 overwork/bureaucracy/tangled + 3 绿 report/rocket/
dashboard),中心 1440× 金圆 + 6 数字 + 6 小字,底部金钩
'3 月 vs 3 分 — 从季度到分钟'.

新增 gen-images.py 脚本: 阿里云百炼 万相 2.1 turbo 生成
3 张 P1 备选 + 6 张 P2 配图,P1 选 v1,P2 6 张全用.

辅助函数 _add_picture_with_alpha 用 lxml 注入 a:alphaModFix
实现半透明插入. 最终 javabrain.pptx 12 页 87 动画 14 pulse
_loop,verify_t1/t3/t7 全通过.
</commit_message>
<xml_diff>
--- a/docs/ppt/javabrain.pptx
+++ b/docs/ppt/javabrain.pptx
@@ -3107,25 +3107,53 @@
         <p:nvPr/>
       </p:nvGrpSpPr>
       <p:grpSpPr/>
-      <p:sp>
-        <p:nvSpPr>
-          <p:cNvPr id="2" name="Rounded Rectangle 1"/>
+      <p:pic>
+        <p:nvPicPr>
+          <p:cNvPr id="2" name="Picture 1" descr="p1-neural-v1.png"/>
+          <p:cNvPicPr>
+            <a:picLocks noChangeAspect="1"/>
+          </p:cNvPicPr>
+          <p:nvPr/>
+        </p:nvPicPr>
+        <p:blipFill>
+          <a:blip r:embed="rId2">
+            <a:alphaModFix amt="32000"/>
+          </a:blip>
+          <a:stretch>
+            <a:fillRect/>
+          </a:stretch>
+        </p:blipFill>
+        <p:spPr>
+          <a:xfrm>
+            <a:off x="4114800" y="457200"/>
+            <a:ext cx="7772400" cy="5029200"/>
+          </a:xfrm>
+          <a:prstGeom prst="rect">
+            <a:avLst/>
+          </a:prstGeom>
+        </p:spPr>
+      </p:pic>
+      <p:sp>
+        <p:nvSpPr>
+          <p:cNvPr id="3" name="Oval 2"/>
           <p:cNvSpPr/>
           <p:nvPr/>
         </p:nvSpPr>
         <p:spPr>
           <a:xfrm>
-            <a:off x="4084167" y="1371600"/>
-            <a:ext cx="1097280" cy="1097280"/>
-          </a:xfrm>
-          <a:prstGeom prst="roundRect">
+            <a:off x="5669280" y="365760"/>
+            <a:ext cx="548640" cy="548640"/>
+          </a:xfrm>
+          <a:prstGeom prst="ellipse">
             <a:avLst/>
           </a:prstGeom>
           <a:solidFill>
             <a:srgbClr val="007396"/>
           </a:solidFill>
-          <a:ln>
-            <a:noFill/>
+          <a:ln w="25400">
+            <a:solidFill>
+              <a:srgbClr val="007396"/>
+            </a:solidFill>
           </a:ln>
         </p:spPr>
         <p:style>
@@ -3152,20 +3180,21 @@
       </p:sp>
       <p:sp>
         <p:nvSpPr>
-          <p:cNvPr id="3" name="Oval 2"/>
+          <p:cNvPr id="4" name="Oval 3"/>
           <p:cNvSpPr/>
           <p:nvPr/>
         </p:nvSpPr>
         <p:spPr>
           <a:xfrm>
-            <a:off x="4193895" y="1283817"/>
-            <a:ext cx="175564" cy="175564"/>
+            <a:off x="4160520" y="868680"/>
+            <a:ext cx="914400" cy="914400"/>
           </a:xfrm>
           <a:prstGeom prst="ellipse">
             <a:avLst/>
           </a:prstGeom>
           <a:solidFill>
             <a:srgbClr val="007396"/>
+            <a:alpha val="30000"/>
           </a:solidFill>
           <a:ln>
             <a:noFill/>
@@ -3195,14 +3224,14 @@
       </p:sp>
       <p:sp>
         <p:nvSpPr>
-          <p:cNvPr id="4" name="Oval 3"/>
+          <p:cNvPr id="5" name="Oval 4"/>
           <p:cNvSpPr/>
           <p:nvPr/>
         </p:nvSpPr>
         <p:spPr>
           <a:xfrm>
-            <a:off x="4435297" y="1283817"/>
-            <a:ext cx="175564" cy="175564"/>
+            <a:off x="4389120" y="1097280"/>
+            <a:ext cx="457200" cy="457200"/>
           </a:xfrm>
           <a:prstGeom prst="ellipse">
             <a:avLst/>
@@ -3211,7 +3240,9 @@
             <a:srgbClr val="007396"/>
           </a:solidFill>
           <a:ln>
-            <a:noFill/>
+            <a:solidFill>
+              <a:srgbClr val="007396"/>
+            </a:solidFill>
           </a:ln>
         </p:spPr>
         <p:style>
@@ -3238,20 +3269,21 @@
       </p:sp>
       <p:sp>
         <p:nvSpPr>
-          <p:cNvPr id="5" name="Oval 4"/>
+          <p:cNvPr id="6" name="Oval 5"/>
           <p:cNvSpPr/>
           <p:nvPr/>
         </p:nvSpPr>
         <p:spPr>
           <a:xfrm>
-            <a:off x="4654753" y="1283817"/>
-            <a:ext cx="175564" cy="175564"/>
+            <a:off x="5867704" y="868680"/>
+            <a:ext cx="914400" cy="914400"/>
           </a:xfrm>
           <a:prstGeom prst="ellipse">
             <a:avLst/>
           </a:prstGeom>
           <a:solidFill>
-            <a:srgbClr val="007396"/>
+            <a:srgbClr val="6B46C1"/>
+            <a:alpha val="30000"/>
           </a:solidFill>
           <a:ln>
             <a:noFill/>
@@ -3281,23 +3313,25 @@
       </p:sp>
       <p:sp>
         <p:nvSpPr>
-          <p:cNvPr id="6" name="Oval 5"/>
+          <p:cNvPr id="7" name="Oval 6"/>
           <p:cNvSpPr/>
           <p:nvPr/>
         </p:nvSpPr>
         <p:spPr>
           <a:xfrm>
-            <a:off x="4896154" y="1283817"/>
-            <a:ext cx="175564" cy="175564"/>
+            <a:off x="6096304" y="1097280"/>
+            <a:ext cx="457200" cy="457200"/>
           </a:xfrm>
           <a:prstGeom prst="ellipse">
             <a:avLst/>
           </a:prstGeom>
           <a:solidFill>
-            <a:srgbClr val="007396"/>
+            <a:srgbClr val="6B46C1"/>
           </a:solidFill>
           <a:ln>
-            <a:noFill/>
+            <a:solidFill>
+              <a:srgbClr val="6B46C1"/>
+            </a:solidFill>
           </a:ln>
         </p:spPr>
         <p:style>
@@ -3324,20 +3358,21 @@
       </p:sp>
       <p:sp>
         <p:nvSpPr>
-          <p:cNvPr id="7" name="Rounded Rectangle 6"/>
+          <p:cNvPr id="8" name="Oval 7"/>
           <p:cNvSpPr/>
           <p:nvPr/>
         </p:nvSpPr>
         <p:spPr>
           <a:xfrm>
-            <a:off x="5547207" y="1371600"/>
-            <a:ext cx="1097280" cy="1097280"/>
-          </a:xfrm>
-          <a:prstGeom prst="roundRect">
+            <a:off x="7573975" y="868680"/>
+            <a:ext cx="914400" cy="914400"/>
+          </a:xfrm>
+          <a:prstGeom prst="ellipse">
             <a:avLst/>
           </a:prstGeom>
           <a:solidFill>
-            <a:srgbClr val="6B46C1"/>
+            <a:srgbClr val="10B981"/>
+            <a:alpha val="30000"/>
           </a:solidFill>
           <a:ln>
             <a:noFill/>
@@ -3367,23 +3402,25 @@
       </p:sp>
       <p:sp>
         <p:nvSpPr>
-          <p:cNvPr id="8" name="Oval 7"/>
+          <p:cNvPr id="9" name="Oval 8"/>
           <p:cNvSpPr/>
           <p:nvPr/>
         </p:nvSpPr>
         <p:spPr>
           <a:xfrm>
-            <a:off x="5656935" y="1283817"/>
-            <a:ext cx="175564" cy="175564"/>
+            <a:off x="7802575" y="1097280"/>
+            <a:ext cx="457200" cy="457200"/>
           </a:xfrm>
           <a:prstGeom prst="ellipse">
             <a:avLst/>
           </a:prstGeom>
           <a:solidFill>
-            <a:srgbClr val="6B46C1"/>
+            <a:srgbClr val="10B981"/>
           </a:solidFill>
           <a:ln>
-            <a:noFill/>
+            <a:solidFill>
+              <a:srgbClr val="10B981"/>
+            </a:solidFill>
           </a:ln>
         </p:spPr>
         <p:style>
@@ -3410,427 +3447,188 @@
       </p:sp>
       <p:sp>
         <p:nvSpPr>
-          <p:cNvPr id="9" name="Oval 8"/>
+          <p:cNvPr id="10" name="TextBox 9"/>
+          <p:cNvSpPr txBox="1"/>
+          <p:nvPr/>
+        </p:nvSpPr>
+        <p:spPr>
+          <a:xfrm>
+            <a:off x="3657600" y="1737360"/>
+            <a:ext cx="1920240" cy="365760"/>
+          </a:xfrm>
+          <a:prstGeom prst="rect">
+            <a:avLst/>
+          </a:prstGeom>
+          <a:noFill/>
+        </p:spPr>
+        <p:txBody>
+          <a:bodyPr wrap="square">
+            <a:spAutoFit/>
+          </a:bodyPr>
+          <a:lstStyle/>
+          <a:p>
+            <a:pPr algn="ctr"/>
+            <a:r>
+              <a:rPr sz="1400" b="1">
+                <a:solidFill>
+                  <a:srgbClr val="007396"/>
+                </a:solidFill>
+                <a:latin typeface="阿里巴巴普惠体 3.0"/>
+              </a:rPr>
+              <a:t>灵梭</a:t>
+            </a:r>
+          </a:p>
+        </p:txBody>
+      </p:sp>
+      <p:sp>
+        <p:nvSpPr>
+          <p:cNvPr id="11" name="TextBox 10"/>
+          <p:cNvSpPr txBox="1"/>
+          <p:nvPr/>
+        </p:nvSpPr>
+        <p:spPr>
+          <a:xfrm>
+            <a:off x="5364784" y="1737360"/>
+            <a:ext cx="1920240" cy="365760"/>
+          </a:xfrm>
+          <a:prstGeom prst="rect">
+            <a:avLst/>
+          </a:prstGeom>
+          <a:noFill/>
+        </p:spPr>
+        <p:txBody>
+          <a:bodyPr wrap="square">
+            <a:spAutoFit/>
+          </a:bodyPr>
+          <a:lstStyle/>
+          <a:p>
+            <a:pPr algn="ctr"/>
+            <a:r>
+              <a:rPr sz="1400" b="1">
+                <a:solidFill>
+                  <a:srgbClr val="6B46C1"/>
+                </a:solidFill>
+                <a:latin typeface="阿里巴巴普惠体 3.0"/>
+              </a:rPr>
+              <a:t>SQL工坊</a:t>
+            </a:r>
+          </a:p>
+        </p:txBody>
+      </p:sp>
+      <p:sp>
+        <p:nvSpPr>
+          <p:cNvPr id="12" name="TextBox 11"/>
+          <p:cNvSpPr txBox="1"/>
+          <p:nvPr/>
+        </p:nvSpPr>
+        <p:spPr>
+          <a:xfrm>
+            <a:off x="7071055" y="1737360"/>
+            <a:ext cx="1920240" cy="365760"/>
+          </a:xfrm>
+          <a:prstGeom prst="rect">
+            <a:avLst/>
+          </a:prstGeom>
+          <a:noFill/>
+        </p:spPr>
+        <p:txBody>
+          <a:bodyPr wrap="square">
+            <a:spAutoFit/>
+          </a:bodyPr>
+          <a:lstStyle/>
+          <a:p>
+            <a:pPr algn="ctr"/>
+            <a:r>
+              <a:rPr sz="1400" b="1">
+                <a:solidFill>
+                  <a:srgbClr val="10B981"/>
+                </a:solidFill>
+                <a:latin typeface="阿里巴巴普惠体 3.0"/>
+              </a:rPr>
+              <a:t>SQL工坊 MCP</a:t>
+            </a:r>
+          </a:p>
+        </p:txBody>
+      </p:sp>
+      <p:sp>
+        <p:nvSpPr>
+          <p:cNvPr id="13" name="TextBox 12"/>
+          <p:cNvSpPr txBox="1"/>
+          <p:nvPr/>
+        </p:nvSpPr>
+        <p:spPr>
+          <a:xfrm>
+            <a:off x="914400" y="3931920"/>
+            <a:ext cx="10362895" cy="1280160"/>
+          </a:xfrm>
+          <a:prstGeom prst="rect">
+            <a:avLst/>
+          </a:prstGeom>
+          <a:noFill/>
+        </p:spPr>
+        <p:txBody>
+          <a:bodyPr wrap="square">
+            <a:spAutoFit/>
+          </a:bodyPr>
+          <a:lstStyle/>
+          <a:p>
+            <a:pPr algn="ctr"/>
+            <a:r>
+              <a:rPr sz="7200" b="1">
+                <a:solidFill>
+                  <a:srgbClr val="1F2937"/>
+                </a:solidFill>
+                <a:latin typeface="Inter"/>
+              </a:rPr>
+              <a:t>JavaBrain</a:t>
+            </a:r>
+          </a:p>
+        </p:txBody>
+      </p:sp>
+      <p:sp>
+        <p:nvSpPr>
+          <p:cNvPr id="14" name="TextBox 13"/>
+          <p:cNvSpPr txBox="1"/>
+          <p:nvPr/>
+        </p:nvSpPr>
+        <p:spPr>
+          <a:xfrm>
+            <a:off x="914400" y="5212080"/>
+            <a:ext cx="10362895" cy="457200"/>
+          </a:xfrm>
+          <a:prstGeom prst="rect">
+            <a:avLst/>
+          </a:prstGeom>
+          <a:noFill/>
+        </p:spPr>
+        <p:txBody>
+          <a:bodyPr wrap="square">
+            <a:spAutoFit/>
+          </a:bodyPr>
+          <a:lstStyle/>
+          <a:p>
+            <a:pPr algn="ctr"/>
+            <a:r>
+              <a:rPr sz="2400" b="0">
+                <a:solidFill>
+                  <a:srgbClr val="6B7280"/>
+                </a:solidFill>
+                <a:latin typeface="阿里巴巴普惠体 3.0"/>
+              </a:rPr>
+              <a:t>让您的系统瞬间拥有“思考”与“执行”的智能大脑</a:t>
+            </a:r>
+          </a:p>
+        </p:txBody>
+      </p:sp>
+      <p:sp>
+        <p:nvSpPr>
+          <p:cNvPr id="15" name="Rounded Rectangle 14"/>
           <p:cNvSpPr/>
           <p:nvPr/>
         </p:nvSpPr>
         <p:spPr>
           <a:xfrm>
-            <a:off x="5898337" y="1283817"/>
-            <a:ext cx="175564" cy="175564"/>
-          </a:xfrm>
-          <a:prstGeom prst="ellipse">
-            <a:avLst/>
-          </a:prstGeom>
-          <a:solidFill>
-            <a:srgbClr val="6B46C1"/>
-          </a:solidFill>
-          <a:ln>
-            <a:noFill/>
-          </a:ln>
-        </p:spPr>
-        <p:style>
-          <a:lnRef idx="1">
-            <a:schemeClr val="accent1"/>
-          </a:lnRef>
-          <a:fillRef idx="3">
-            <a:schemeClr val="accent1"/>
-          </a:fillRef>
-          <a:effectRef idx="2">
-            <a:schemeClr val="accent1"/>
-          </a:effectRef>
-          <a:fontRef idx="minor">
-            <a:schemeClr val="lt1"/>
-          </a:fontRef>
-        </p:style>
-        <p:txBody>
-          <a:bodyPr rtlCol="0" anchor="ctr"/>
-          <a:lstStyle/>
-          <a:p>
-            <a:pPr algn="ctr"/>
-          </a:p>
-        </p:txBody>
-      </p:sp>
-      <p:sp>
-        <p:nvSpPr>
-          <p:cNvPr id="10" name="Oval 9"/>
-          <p:cNvSpPr/>
-          <p:nvPr/>
-        </p:nvSpPr>
-        <p:spPr>
-          <a:xfrm>
-            <a:off x="6117793" y="1283817"/>
-            <a:ext cx="175564" cy="175564"/>
-          </a:xfrm>
-          <a:prstGeom prst="ellipse">
-            <a:avLst/>
-          </a:prstGeom>
-          <a:solidFill>
-            <a:srgbClr val="6B46C1"/>
-          </a:solidFill>
-          <a:ln>
-            <a:noFill/>
-          </a:ln>
-        </p:spPr>
-        <p:style>
-          <a:lnRef idx="1">
-            <a:schemeClr val="accent1"/>
-          </a:lnRef>
-          <a:fillRef idx="3">
-            <a:schemeClr val="accent1"/>
-          </a:fillRef>
-          <a:effectRef idx="2">
-            <a:schemeClr val="accent1"/>
-          </a:effectRef>
-          <a:fontRef idx="minor">
-            <a:schemeClr val="lt1"/>
-          </a:fontRef>
-        </p:style>
-        <p:txBody>
-          <a:bodyPr rtlCol="0" anchor="ctr"/>
-          <a:lstStyle/>
-          <a:p>
-            <a:pPr algn="ctr"/>
-          </a:p>
-        </p:txBody>
-      </p:sp>
-      <p:sp>
-        <p:nvSpPr>
-          <p:cNvPr id="11" name="Oval 10"/>
-          <p:cNvSpPr/>
-          <p:nvPr/>
-        </p:nvSpPr>
-        <p:spPr>
-          <a:xfrm>
-            <a:off x="6359194" y="1283817"/>
-            <a:ext cx="175564" cy="175564"/>
-          </a:xfrm>
-          <a:prstGeom prst="ellipse">
-            <a:avLst/>
-          </a:prstGeom>
-          <a:solidFill>
-            <a:srgbClr val="6B46C1"/>
-          </a:solidFill>
-          <a:ln>
-            <a:noFill/>
-          </a:ln>
-        </p:spPr>
-        <p:style>
-          <a:lnRef idx="1">
-            <a:schemeClr val="accent1"/>
-          </a:lnRef>
-          <a:fillRef idx="3">
-            <a:schemeClr val="accent1"/>
-          </a:fillRef>
-          <a:effectRef idx="2">
-            <a:schemeClr val="accent1"/>
-          </a:effectRef>
-          <a:fontRef idx="minor">
-            <a:schemeClr val="lt1"/>
-          </a:fontRef>
-        </p:style>
-        <p:txBody>
-          <a:bodyPr rtlCol="0" anchor="ctr"/>
-          <a:lstStyle/>
-          <a:p>
-            <a:pPr algn="ctr"/>
-          </a:p>
-        </p:txBody>
-      </p:sp>
-      <p:sp>
-        <p:nvSpPr>
-          <p:cNvPr id="12" name="Rounded Rectangle 11"/>
-          <p:cNvSpPr/>
-          <p:nvPr/>
-        </p:nvSpPr>
-        <p:spPr>
-          <a:xfrm>
-            <a:off x="7010247" y="1371600"/>
-            <a:ext cx="1097280" cy="1097280"/>
-          </a:xfrm>
-          <a:prstGeom prst="roundRect">
-            <a:avLst/>
-          </a:prstGeom>
-          <a:solidFill>
-            <a:srgbClr val="10B981"/>
-          </a:solidFill>
-          <a:ln>
-            <a:noFill/>
-          </a:ln>
-        </p:spPr>
-        <p:style>
-          <a:lnRef idx="1">
-            <a:schemeClr val="accent1"/>
-          </a:lnRef>
-          <a:fillRef idx="3">
-            <a:schemeClr val="accent1"/>
-          </a:fillRef>
-          <a:effectRef idx="2">
-            <a:schemeClr val="accent1"/>
-          </a:effectRef>
-          <a:fontRef idx="minor">
-            <a:schemeClr val="lt1"/>
-          </a:fontRef>
-        </p:style>
-        <p:txBody>
-          <a:bodyPr rtlCol="0" anchor="ctr"/>
-          <a:lstStyle/>
-          <a:p>
-            <a:pPr algn="ctr"/>
-          </a:p>
-        </p:txBody>
-      </p:sp>
-      <p:sp>
-        <p:nvSpPr>
-          <p:cNvPr id="13" name="Oval 12"/>
-          <p:cNvSpPr/>
-          <p:nvPr/>
-        </p:nvSpPr>
-        <p:spPr>
-          <a:xfrm>
-            <a:off x="7119975" y="1283817"/>
-            <a:ext cx="175564" cy="175564"/>
-          </a:xfrm>
-          <a:prstGeom prst="ellipse">
-            <a:avLst/>
-          </a:prstGeom>
-          <a:solidFill>
-            <a:srgbClr val="10B981"/>
-          </a:solidFill>
-          <a:ln>
-            <a:noFill/>
-          </a:ln>
-        </p:spPr>
-        <p:style>
-          <a:lnRef idx="1">
-            <a:schemeClr val="accent1"/>
-          </a:lnRef>
-          <a:fillRef idx="3">
-            <a:schemeClr val="accent1"/>
-          </a:fillRef>
-          <a:effectRef idx="2">
-            <a:schemeClr val="accent1"/>
-          </a:effectRef>
-          <a:fontRef idx="minor">
-            <a:schemeClr val="lt1"/>
-          </a:fontRef>
-        </p:style>
-        <p:txBody>
-          <a:bodyPr rtlCol="0" anchor="ctr"/>
-          <a:lstStyle/>
-          <a:p>
-            <a:pPr algn="ctr"/>
-          </a:p>
-        </p:txBody>
-      </p:sp>
-      <p:sp>
-        <p:nvSpPr>
-          <p:cNvPr id="14" name="Oval 13"/>
-          <p:cNvSpPr/>
-          <p:nvPr/>
-        </p:nvSpPr>
-        <p:spPr>
-          <a:xfrm>
-            <a:off x="7361377" y="1283817"/>
-            <a:ext cx="175564" cy="175564"/>
-          </a:xfrm>
-          <a:prstGeom prst="ellipse">
-            <a:avLst/>
-          </a:prstGeom>
-          <a:solidFill>
-            <a:srgbClr val="10B981"/>
-          </a:solidFill>
-          <a:ln>
-            <a:noFill/>
-          </a:ln>
-        </p:spPr>
-        <p:style>
-          <a:lnRef idx="1">
-            <a:schemeClr val="accent1"/>
-          </a:lnRef>
-          <a:fillRef idx="3">
-            <a:schemeClr val="accent1"/>
-          </a:fillRef>
-          <a:effectRef idx="2">
-            <a:schemeClr val="accent1"/>
-          </a:effectRef>
-          <a:fontRef idx="minor">
-            <a:schemeClr val="lt1"/>
-          </a:fontRef>
-        </p:style>
-        <p:txBody>
-          <a:bodyPr rtlCol="0" anchor="ctr"/>
-          <a:lstStyle/>
-          <a:p>
-            <a:pPr algn="ctr"/>
-          </a:p>
-        </p:txBody>
-      </p:sp>
-      <p:sp>
-        <p:nvSpPr>
-          <p:cNvPr id="15" name="Oval 14"/>
-          <p:cNvSpPr/>
-          <p:nvPr/>
-        </p:nvSpPr>
-        <p:spPr>
-          <a:xfrm>
-            <a:off x="7580833" y="1283817"/>
-            <a:ext cx="175564" cy="175564"/>
-          </a:xfrm>
-          <a:prstGeom prst="ellipse">
-            <a:avLst/>
-          </a:prstGeom>
-          <a:solidFill>
-            <a:srgbClr val="10B981"/>
-          </a:solidFill>
-          <a:ln>
-            <a:noFill/>
-          </a:ln>
-        </p:spPr>
-        <p:style>
-          <a:lnRef idx="1">
-            <a:schemeClr val="accent1"/>
-          </a:lnRef>
-          <a:fillRef idx="3">
-            <a:schemeClr val="accent1"/>
-          </a:fillRef>
-          <a:effectRef idx="2">
-            <a:schemeClr val="accent1"/>
-          </a:effectRef>
-          <a:fontRef idx="minor">
-            <a:schemeClr val="lt1"/>
-          </a:fontRef>
-        </p:style>
-        <p:txBody>
-          <a:bodyPr rtlCol="0" anchor="ctr"/>
-          <a:lstStyle/>
-          <a:p>
-            <a:pPr algn="ctr"/>
-          </a:p>
-        </p:txBody>
-      </p:sp>
-      <p:sp>
-        <p:nvSpPr>
-          <p:cNvPr id="16" name="Oval 15"/>
-          <p:cNvSpPr/>
-          <p:nvPr/>
-        </p:nvSpPr>
-        <p:spPr>
-          <a:xfrm>
-            <a:off x="7822234" y="1283817"/>
-            <a:ext cx="175564" cy="175564"/>
-          </a:xfrm>
-          <a:prstGeom prst="ellipse">
-            <a:avLst/>
-          </a:prstGeom>
-          <a:solidFill>
-            <a:srgbClr val="10B981"/>
-          </a:solidFill>
-          <a:ln>
-            <a:noFill/>
-          </a:ln>
-        </p:spPr>
-        <p:style>
-          <a:lnRef idx="1">
-            <a:schemeClr val="accent1"/>
-          </a:lnRef>
-          <a:fillRef idx="3">
-            <a:schemeClr val="accent1"/>
-          </a:fillRef>
-          <a:effectRef idx="2">
-            <a:schemeClr val="accent1"/>
-          </a:effectRef>
-          <a:fontRef idx="minor">
-            <a:schemeClr val="lt1"/>
-          </a:fontRef>
-        </p:style>
-        <p:txBody>
-          <a:bodyPr rtlCol="0" anchor="ctr"/>
-          <a:lstStyle/>
-          <a:p>
-            <a:pPr algn="ctr"/>
-          </a:p>
-        </p:txBody>
-      </p:sp>
-      <p:sp>
-        <p:nvSpPr>
-          <p:cNvPr id="17" name="TextBox 16"/>
-          <p:cNvSpPr txBox="1"/>
-          <p:nvPr/>
-        </p:nvSpPr>
-        <p:spPr>
-          <a:xfrm>
-            <a:off x="914400" y="3108960"/>
-            <a:ext cx="10362895" cy="1280160"/>
-          </a:xfrm>
-          <a:prstGeom prst="rect">
-            <a:avLst/>
-          </a:prstGeom>
-          <a:noFill/>
-        </p:spPr>
-        <p:txBody>
-          <a:bodyPr wrap="square">
-            <a:spAutoFit/>
-          </a:bodyPr>
-          <a:lstStyle/>
-          <a:p>
-            <a:pPr algn="ctr"/>
-            <a:r>
-              <a:rPr sz="7200" b="1">
-                <a:solidFill>
-                  <a:srgbClr val="1F2937"/>
-                </a:solidFill>
-                <a:latin typeface="Inter"/>
-              </a:rPr>
-              <a:t>JavaBrain</a:t>
-            </a:r>
-          </a:p>
-        </p:txBody>
-      </p:sp>
-      <p:sp>
-        <p:nvSpPr>
-          <p:cNvPr id="18" name="TextBox 17"/>
-          <p:cNvSpPr txBox="1"/>
-          <p:nvPr/>
-        </p:nvSpPr>
-        <p:spPr>
-          <a:xfrm>
-            <a:off x="914400" y="4389120"/>
-            <a:ext cx="10362895" cy="457200"/>
-          </a:xfrm>
-          <a:prstGeom prst="rect">
-            <a:avLst/>
-          </a:prstGeom>
-          <a:noFill/>
-        </p:spPr>
-        <p:txBody>
-          <a:bodyPr wrap="square">
-            <a:spAutoFit/>
-          </a:bodyPr>
-          <a:lstStyle/>
-          <a:p>
-            <a:pPr algn="ctr"/>
-            <a:r>
-              <a:rPr sz="2400" b="0">
-                <a:solidFill>
-                  <a:srgbClr val="6B7280"/>
-                </a:solidFill>
-                <a:latin typeface="阿里巴巴普惠体 3.0"/>
-              </a:rPr>
-              <a:t>让您的系统瞬间拥有“思考”与“执行”的智能大脑</a:t>
-            </a:r>
-          </a:p>
-        </p:txBody>
-      </p:sp>
-      <p:sp>
-        <p:nvSpPr>
-          <p:cNvPr id="19" name="Rounded Rectangle 18"/>
-          <p:cNvSpPr/>
-          <p:nvPr/>
-        </p:nvSpPr>
-        <p:spPr>
-          <a:xfrm>
-            <a:off x="3657600" y="5029200"/>
+            <a:off x="3657600" y="5852160"/>
             <a:ext cx="4876495" cy="548640"/>
           </a:xfrm>
           <a:prstGeom prst="roundRect">
@@ -3867,13 +3665,13 @@
       </p:sp>
       <p:sp>
         <p:nvSpPr>
-          <p:cNvPr id="20" name="TextBox 19"/>
-          <p:cNvSpPr txBox="1"/>
-          <p:nvPr/>
-        </p:nvSpPr>
-        <p:spPr>
-          <a:xfrm>
-            <a:off x="3657600" y="5074920"/>
+          <p:cNvPr id="16" name="TextBox 15"/>
+          <p:cNvSpPr txBox="1"/>
+          <p:nvPr/>
+        </p:nvSpPr>
+        <p:spPr>
+          <a:xfrm>
+            <a:off x="3657600" y="5897880"/>
             <a:ext cx="4876495" cy="457200"/>
           </a:xfrm>
           <a:prstGeom prst="rect">
@@ -3914,7 +3712,7 @@
             <p:tnCond val="0"/>
           </p:cond>
           <p:par>
-            <p:cTn id="3" nodeType="withEffect" dur="500" begin="0ms" fill="hold">
+            <p:cTn id="4" nodeType="withEffect" dur="500" begin="0ms" fill="hold">
               <p:animEffect presetClass="entr" presetId="10" dur="500"/>
             </p:cTn>
           </p:par>
@@ -3931,7 +3729,7 @@
             <p:tnCond val="0"/>
           </p:cond>
           <p:par>
-            <p:cTn id="8" nodeType="withEffect" dur="500" begin="300ms" fill="hold">
+            <p:cTn id="5" nodeType="withEffect" dur="500" begin="300ms" fill="hold">
               <p:animEffect presetClass="entr" presetId="10" dur="500"/>
             </p:cTn>
           </p:par>
@@ -3948,7 +3746,7 @@
             <p:tnCond val="0"/>
           </p:cond>
           <p:par>
-            <p:cTn id="13" nodeType="withEffect" dur="500" begin="600ms" fill="hold">
+            <p:cTn id="6" nodeType="withEffect" dur="500" begin="600ms" fill="hold">
               <p:animEffect presetClass="entr" presetId="10" dur="500"/>
             </p:cTn>
           </p:par>
@@ -3965,7 +3763,7 @@
             <p:tnCond val="0"/>
           </p:cond>
           <p:par>
-            <p:cTn id="18" nodeType="withEffect" dur="500" begin="900ms" fill="hold">
+            <p:cTn id="14" nodeType="withEffect" dur="500" begin="900ms" fill="hold">
               <p:animEffect presetClass="entr" presetId="10" dur="500"/>
             </p:cTn>
           </p:par>
@@ -3982,7 +3780,7 @@
             <p:tnCond val="0"/>
           </p:cond>
           <p:par>
-            <p:cTn id="20" nodeType="withEffect" dur="500" begin="1400ms" fill="hold">
+            <p:cTn id="16" nodeType="withEffect" dur="500" begin="1400ms" fill="hold">
               <p:animEffect presetClass="entr" presetId="10" dur="500"/>
             </p:cTn>
           </p:par>
@@ -7073,58 +6871,299 @@
         </p:nvSpPr>
         <p:spPr>
           <a:xfrm>
-            <a:off x="457200" y="365760"/>
-            <a:ext cx="11277295" cy="640080"/>
-          </a:xfrm>
-          <a:prstGeom prst="rect">
-            <a:avLst/>
-          </a:prstGeom>
-          <a:noFill/>
-        </p:spPr>
-        <p:txBody>
-          <a:bodyPr wrap="square">
-            <a:spAutoFit/>
-          </a:bodyPr>
-          <a:lstStyle/>
-          <a:p>
-            <a:pPr algn="ctr"/>
-            <a:r>
-              <a:rPr sz="2800" b="1">
+            <a:off x="457200" y="274320"/>
+            <a:ext cx="11277295" cy="548640"/>
+          </a:xfrm>
+          <a:prstGeom prst="rect">
+            <a:avLst/>
+          </a:prstGeom>
+          <a:noFill/>
+        </p:spPr>
+        <p:txBody>
+          <a:bodyPr wrap="square">
+            <a:spAutoFit/>
+          </a:bodyPr>
+          <a:lstStyle/>
+          <a:p>
+            <a:pPr algn="ctr"/>
+            <a:r>
+              <a:rPr sz="2400" b="1">
                 <a:solidFill>
                   <a:srgbClr val="1F2937"/>
                 </a:solidFill>
                 <a:latin typeface="阿里巴巴普惠体 3.0"/>
               </a:rPr>
-              <a:t>接入 AI 的 3 个痛点 vs JavaBrain 的 3 个解法</a:t>
-            </a:r>
-          </a:p>
-        </p:txBody>
-      </p:sp>
-      <p:sp>
-        <p:nvSpPr>
-          <p:cNvPr id="3" name="TextBox 2"/>
-          <p:cNvSpPr txBox="1"/>
-          <p:nvPr/>
-        </p:nvSpPr>
-        <p:spPr>
-          <a:xfrm>
-            <a:off x="457200" y="1828800"/>
-            <a:ext cx="4114800" cy="914400"/>
-          </a:xfrm>
-          <a:prstGeom prst="rect">
-            <a:avLst/>
-          </a:prstGeom>
-          <a:noFill/>
-        </p:spPr>
-        <p:txBody>
-          <a:bodyPr wrap="square">
-            <a:spAutoFit/>
-          </a:bodyPr>
-          <a:lstStyle/>
-          <a:p>
-            <a:pPr algn="ctr"/>
-            <a:r>
-              <a:rPr sz="4800" b="1">
+              <a:t>接入 AI 的 3 个痛点  vs  JavaBrain 的 3 个解法</a:t>
+            </a:r>
+          </a:p>
+        </p:txBody>
+      </p:sp>
+      <p:sp>
+        <p:nvSpPr>
+          <p:cNvPr id="3" name="Rectangle 2"/>
+          <p:cNvSpPr/>
+          <p:nvPr/>
+        </p:nvSpPr>
+        <p:spPr>
+          <a:xfrm>
+            <a:off x="609904" y="3657600"/>
+            <a:ext cx="10972800" cy="54864"/>
+          </a:xfrm>
+          <a:prstGeom prst="rect">
+            <a:avLst/>
+          </a:prstGeom>
+          <a:solidFill>
+            <a:srgbClr val="E5E7EB"/>
+          </a:solidFill>
+          <a:ln>
+            <a:noFill/>
+          </a:ln>
+        </p:spPr>
+        <p:style>
+          <a:lnRef idx="1">
+            <a:schemeClr val="accent1"/>
+          </a:lnRef>
+          <a:fillRef idx="3">
+            <a:schemeClr val="accent1"/>
+          </a:fillRef>
+          <a:effectRef idx="2">
+            <a:schemeClr val="accent1"/>
+          </a:effectRef>
+          <a:fontRef idx="minor">
+            <a:schemeClr val="lt1"/>
+          </a:fontRef>
+        </p:style>
+        <p:txBody>
+          <a:bodyPr rtlCol="0" anchor="ctr"/>
+          <a:lstStyle/>
+          <a:p>
+            <a:pPr algn="ctr"/>
+          </a:p>
+        </p:txBody>
+      </p:sp>
+      <p:sp>
+        <p:nvSpPr>
+          <p:cNvPr id="4" name="Rectangle 3"/>
+          <p:cNvSpPr/>
+          <p:nvPr/>
+        </p:nvSpPr>
+        <p:spPr>
+          <a:xfrm>
+            <a:off x="609904" y="3657600"/>
+            <a:ext cx="5486400" cy="54864"/>
+          </a:xfrm>
+          <a:prstGeom prst="rect">
+            <a:avLst/>
+          </a:prstGeom>
+          <a:solidFill>
+            <a:srgbClr val="DC2626"/>
+          </a:solidFill>
+          <a:ln>
+            <a:noFill/>
+          </a:ln>
+        </p:spPr>
+        <p:style>
+          <a:lnRef idx="1">
+            <a:schemeClr val="accent1"/>
+          </a:lnRef>
+          <a:fillRef idx="3">
+            <a:schemeClr val="accent1"/>
+          </a:fillRef>
+          <a:effectRef idx="2">
+            <a:schemeClr val="accent1"/>
+          </a:effectRef>
+          <a:fontRef idx="minor">
+            <a:schemeClr val="lt1"/>
+          </a:fontRef>
+        </p:style>
+        <p:txBody>
+          <a:bodyPr rtlCol="0" anchor="ctr"/>
+          <a:lstStyle/>
+          <a:p>
+            <a:pPr algn="ctr"/>
+          </a:p>
+        </p:txBody>
+      </p:sp>
+      <p:sp>
+        <p:nvSpPr>
+          <p:cNvPr id="5" name="Rectangle 4"/>
+          <p:cNvSpPr/>
+          <p:nvPr/>
+        </p:nvSpPr>
+        <p:spPr>
+          <a:xfrm>
+            <a:off x="5959144" y="3657600"/>
+            <a:ext cx="1371600" cy="54864"/>
+          </a:xfrm>
+          <a:prstGeom prst="rect">
+            <a:avLst/>
+          </a:prstGeom>
+          <a:solidFill>
+            <a:srgbClr val="F59E0B"/>
+          </a:solidFill>
+          <a:ln>
+            <a:noFill/>
+          </a:ln>
+        </p:spPr>
+        <p:style>
+          <a:lnRef idx="1">
+            <a:schemeClr val="accent1"/>
+          </a:lnRef>
+          <a:fillRef idx="3">
+            <a:schemeClr val="accent1"/>
+          </a:fillRef>
+          <a:effectRef idx="2">
+            <a:schemeClr val="accent1"/>
+          </a:effectRef>
+          <a:fontRef idx="minor">
+            <a:schemeClr val="lt1"/>
+          </a:fontRef>
+        </p:style>
+        <p:txBody>
+          <a:bodyPr rtlCol="0" anchor="ctr"/>
+          <a:lstStyle/>
+          <a:p>
+            <a:pPr algn="ctr"/>
+          </a:p>
+        </p:txBody>
+      </p:sp>
+      <p:sp>
+        <p:nvSpPr>
+          <p:cNvPr id="6" name="Rectangle 5"/>
+          <p:cNvSpPr/>
+          <p:nvPr/>
+        </p:nvSpPr>
+        <p:spPr>
+          <a:xfrm>
+            <a:off x="6096304" y="3657600"/>
+            <a:ext cx="5486400" cy="54864"/>
+          </a:xfrm>
+          <a:prstGeom prst="rect">
+            <a:avLst/>
+          </a:prstGeom>
+          <a:solidFill>
+            <a:srgbClr val="10B981"/>
+          </a:solidFill>
+          <a:ln>
+            <a:noFill/>
+          </a:ln>
+        </p:spPr>
+        <p:style>
+          <a:lnRef idx="1">
+            <a:schemeClr val="accent1"/>
+          </a:lnRef>
+          <a:fillRef idx="3">
+            <a:schemeClr val="accent1"/>
+          </a:fillRef>
+          <a:effectRef idx="2">
+            <a:schemeClr val="accent1"/>
+          </a:effectRef>
+          <a:fontRef idx="minor">
+            <a:schemeClr val="lt1"/>
+          </a:fontRef>
+        </p:style>
+        <p:txBody>
+          <a:bodyPr rtlCol="0" anchor="ctr"/>
+          <a:lstStyle/>
+          <a:p>
+            <a:pPr algn="ctr"/>
+          </a:p>
+        </p:txBody>
+      </p:sp>
+      <p:pic>
+        <p:nvPicPr>
+          <p:cNvPr id="7" name="Picture 6" descr="p2-red-1-overwork.png"/>
+          <p:cNvPicPr>
+            <a:picLocks noChangeAspect="1"/>
+          </p:cNvPicPr>
+          <p:nvPr/>
+        </p:nvPicPr>
+        <p:blipFill>
+          <a:blip r:embed="rId2"/>
+          <a:stretch>
+            <a:fillRect/>
+          </a:stretch>
+        </p:blipFill>
+        <p:spPr>
+          <a:xfrm>
+            <a:off x="61264" y="1280160"/>
+            <a:ext cx="1097280" cy="1097280"/>
+          </a:xfrm>
+          <a:prstGeom prst="rect">
+            <a:avLst/>
+          </a:prstGeom>
+        </p:spPr>
+      </p:pic>
+      <p:sp>
+        <p:nvSpPr>
+          <p:cNvPr id="8" name="Oval 7"/>
+          <p:cNvSpPr/>
+          <p:nvPr/>
+        </p:nvSpPr>
+        <p:spPr>
+          <a:xfrm>
+            <a:off x="500176" y="3575304"/>
+            <a:ext cx="219456" cy="219456"/>
+          </a:xfrm>
+          <a:prstGeom prst="ellipse">
+            <a:avLst/>
+          </a:prstGeom>
+          <a:solidFill>
+            <a:srgbClr val="DC2626"/>
+          </a:solidFill>
+          <a:ln w="25400">
+            <a:solidFill>
+              <a:srgbClr val="FFFFFF"/>
+            </a:solidFill>
+          </a:ln>
+        </p:spPr>
+        <p:style>
+          <a:lnRef idx="1">
+            <a:schemeClr val="accent1"/>
+          </a:lnRef>
+          <a:fillRef idx="3">
+            <a:schemeClr val="accent1"/>
+          </a:fillRef>
+          <a:effectRef idx="2">
+            <a:schemeClr val="accent1"/>
+          </a:effectRef>
+          <a:fontRef idx="minor">
+            <a:schemeClr val="lt1"/>
+          </a:fontRef>
+        </p:style>
+        <p:txBody>
+          <a:bodyPr rtlCol="0" anchor="ctr"/>
+          <a:lstStyle/>
+          <a:p>
+            <a:pPr algn="ctr"/>
+          </a:p>
+        </p:txBody>
+      </p:sp>
+      <p:sp>
+        <p:nvSpPr>
+          <p:cNvPr id="9" name="TextBox 8"/>
+          <p:cNvSpPr txBox="1"/>
+          <p:nvPr/>
+        </p:nvSpPr>
+        <p:spPr>
+          <a:xfrm>
+            <a:off x="-30175" y="3931920"/>
+            <a:ext cx="1280160" cy="548640"/>
+          </a:xfrm>
+          <a:prstGeom prst="rect">
+            <a:avLst/>
+          </a:prstGeom>
+          <a:noFill/>
+        </p:spPr>
+        <p:txBody>
+          <a:bodyPr wrap="square">
+            <a:spAutoFit/>
+          </a:bodyPr>
+          <a:lstStyle/>
+          <a:p>
+            <a:pPr algn="ctr"/>
+            <a:r>
+              <a:rPr sz="2400" b="1">
                 <a:solidFill>
                   <a:srgbClr val="DC2626"/>
                 </a:solidFill>
@@ -7137,29 +7176,133 @@
       </p:sp>
       <p:sp>
         <p:nvSpPr>
-          <p:cNvPr id="4" name="TextBox 3"/>
-          <p:cNvSpPr txBox="1"/>
-          <p:nvPr/>
-        </p:nvSpPr>
-        <p:spPr>
-          <a:xfrm>
-            <a:off x="457200" y="3017520"/>
-            <a:ext cx="4114800" cy="914400"/>
-          </a:xfrm>
-          <a:prstGeom prst="rect">
-            <a:avLst/>
-          </a:prstGeom>
-          <a:noFill/>
-        </p:spPr>
-        <p:txBody>
-          <a:bodyPr wrap="square">
-            <a:spAutoFit/>
-          </a:bodyPr>
-          <a:lstStyle/>
-          <a:p>
-            <a:pPr algn="ctr"/>
-            <a:r>
-              <a:rPr sz="4800" b="1">
+          <p:cNvPr id="10" name="TextBox 9"/>
+          <p:cNvSpPr txBox="1"/>
+          <p:nvPr/>
+        </p:nvSpPr>
+        <p:spPr>
+          <a:xfrm>
+            <a:off x="-121615" y="4526280"/>
+            <a:ext cx="1463040" cy="365760"/>
+          </a:xfrm>
+          <a:prstGeom prst="rect">
+            <a:avLst/>
+          </a:prstGeom>
+          <a:noFill/>
+        </p:spPr>
+        <p:txBody>
+          <a:bodyPr wrap="square">
+            <a:spAutoFit/>
+          </a:bodyPr>
+          <a:lstStyle/>
+          <a:p>
+            <a:pPr algn="ctr"/>
+            <a:r>
+              <a:rPr sz="1400" b="0">
+                <a:solidFill>
+                  <a:srgbClr val="6B7280"/>
+                </a:solidFill>
+                <a:latin typeface="阿里巴巴普惠体 3.0"/>
+              </a:rPr>
+              <a:t>集成 AI</a:t>
+            </a:r>
+          </a:p>
+        </p:txBody>
+      </p:sp>
+      <p:pic>
+        <p:nvPicPr>
+          <p:cNvPr id="11" name="Picture 10" descr="p2-red-2-bureaucracy.png"/>
+          <p:cNvPicPr>
+            <a:picLocks noChangeAspect="1"/>
+          </p:cNvPicPr>
+          <p:nvPr/>
+        </p:nvPicPr>
+        <p:blipFill>
+          <a:blip r:embed="rId3"/>
+          <a:stretch>
+            <a:fillRect/>
+          </a:stretch>
+        </p:blipFill>
+        <p:spPr>
+          <a:xfrm>
+            <a:off x="2255824" y="1280160"/>
+            <a:ext cx="1097280" cy="1097280"/>
+          </a:xfrm>
+          <a:prstGeom prst="rect">
+            <a:avLst/>
+          </a:prstGeom>
+        </p:spPr>
+      </p:pic>
+      <p:sp>
+        <p:nvSpPr>
+          <p:cNvPr id="12" name="Oval 11"/>
+          <p:cNvSpPr/>
+          <p:nvPr/>
+        </p:nvSpPr>
+        <p:spPr>
+          <a:xfrm>
+            <a:off x="2694736" y="3575304"/>
+            <a:ext cx="219456" cy="219456"/>
+          </a:xfrm>
+          <a:prstGeom prst="ellipse">
+            <a:avLst/>
+          </a:prstGeom>
+          <a:solidFill>
+            <a:srgbClr val="DC2626"/>
+          </a:solidFill>
+          <a:ln w="25400">
+            <a:solidFill>
+              <a:srgbClr val="FFFFFF"/>
+            </a:solidFill>
+          </a:ln>
+        </p:spPr>
+        <p:style>
+          <a:lnRef idx="1">
+            <a:schemeClr val="accent1"/>
+          </a:lnRef>
+          <a:fillRef idx="3">
+            <a:schemeClr val="accent1"/>
+          </a:fillRef>
+          <a:effectRef idx="2">
+            <a:schemeClr val="accent1"/>
+          </a:effectRef>
+          <a:fontRef idx="minor">
+            <a:schemeClr val="lt1"/>
+          </a:fontRef>
+        </p:style>
+        <p:txBody>
+          <a:bodyPr rtlCol="0" anchor="ctr"/>
+          <a:lstStyle/>
+          <a:p>
+            <a:pPr algn="ctr"/>
+          </a:p>
+        </p:txBody>
+      </p:sp>
+      <p:sp>
+        <p:nvSpPr>
+          <p:cNvPr id="13" name="TextBox 12"/>
+          <p:cNvSpPr txBox="1"/>
+          <p:nvPr/>
+        </p:nvSpPr>
+        <p:spPr>
+          <a:xfrm>
+            <a:off x="2164384" y="3931920"/>
+            <a:ext cx="1280160" cy="548640"/>
+          </a:xfrm>
+          <a:prstGeom prst="rect">
+            <a:avLst/>
+          </a:prstGeom>
+          <a:noFill/>
+        </p:spPr>
+        <p:txBody>
+          <a:bodyPr wrap="square">
+            <a:spAutoFit/>
+          </a:bodyPr>
+          <a:lstStyle/>
+          <a:p>
+            <a:pPr algn="ctr"/>
+            <a:r>
+              <a:rPr sz="2400" b="1">
                 <a:solidFill>
                   <a:srgbClr val="DC2626"/>
                 </a:solidFill>
@@ -7172,29 +7315,133 @@
       </p:sp>
       <p:sp>
         <p:nvSpPr>
-          <p:cNvPr id="5" name="TextBox 4"/>
-          <p:cNvSpPr txBox="1"/>
-          <p:nvPr/>
-        </p:nvSpPr>
-        <p:spPr>
-          <a:xfrm>
-            <a:off x="457200" y="4206240"/>
-            <a:ext cx="4114800" cy="914400"/>
-          </a:xfrm>
-          <a:prstGeom prst="rect">
-            <a:avLst/>
-          </a:prstGeom>
-          <a:noFill/>
-        </p:spPr>
-        <p:txBody>
-          <a:bodyPr wrap="square">
-            <a:spAutoFit/>
-          </a:bodyPr>
-          <a:lstStyle/>
-          <a:p>
-            <a:pPr algn="ctr"/>
-            <a:r>
-              <a:rPr sz="4800" b="1">
+          <p:cNvPr id="14" name="TextBox 13"/>
+          <p:cNvSpPr txBox="1"/>
+          <p:nvPr/>
+        </p:nvSpPr>
+        <p:spPr>
+          <a:xfrm>
+            <a:off x="2072944" y="4526280"/>
+            <a:ext cx="1463040" cy="365760"/>
+          </a:xfrm>
+          <a:prstGeom prst="rect">
+            <a:avLst/>
+          </a:prstGeom>
+          <a:noFill/>
+        </p:spPr>
+        <p:txBody>
+          <a:bodyPr wrap="square">
+            <a:spAutoFit/>
+          </a:bodyPr>
+          <a:lstStyle/>
+          <a:p>
+            <a:pPr algn="ctr"/>
+            <a:r>
+              <a:rPr sz="1400" b="0">
+                <a:solidFill>
+                  <a:srgbClr val="6B7280"/>
+                </a:solidFill>
+                <a:latin typeface="阿里巴巴普惠体 3.0"/>
+              </a:rPr>
+              <a:t>训练数据</a:t>
+            </a:r>
+          </a:p>
+        </p:txBody>
+      </p:sp>
+      <p:pic>
+        <p:nvPicPr>
+          <p:cNvPr id="15" name="Picture 14" descr="p2-red-3-tangled.png"/>
+          <p:cNvPicPr>
+            <a:picLocks noChangeAspect="1"/>
+          </p:cNvPicPr>
+          <p:nvPr/>
+        </p:nvPicPr>
+        <p:blipFill>
+          <a:blip r:embed="rId4"/>
+          <a:stretch>
+            <a:fillRect/>
+          </a:stretch>
+        </p:blipFill>
+        <p:spPr>
+          <a:xfrm>
+            <a:off x="4450384" y="1280160"/>
+            <a:ext cx="1097280" cy="1097280"/>
+          </a:xfrm>
+          <a:prstGeom prst="rect">
+            <a:avLst/>
+          </a:prstGeom>
+        </p:spPr>
+      </p:pic>
+      <p:sp>
+        <p:nvSpPr>
+          <p:cNvPr id="16" name="Oval 15"/>
+          <p:cNvSpPr/>
+          <p:nvPr/>
+        </p:nvSpPr>
+        <p:spPr>
+          <a:xfrm>
+            <a:off x="4889296" y="3575304"/>
+            <a:ext cx="219456" cy="219456"/>
+          </a:xfrm>
+          <a:prstGeom prst="ellipse">
+            <a:avLst/>
+          </a:prstGeom>
+          <a:solidFill>
+            <a:srgbClr val="DC2626"/>
+          </a:solidFill>
+          <a:ln w="25400">
+            <a:solidFill>
+              <a:srgbClr val="FFFFFF"/>
+            </a:solidFill>
+          </a:ln>
+        </p:spPr>
+        <p:style>
+          <a:lnRef idx="1">
+            <a:schemeClr val="accent1"/>
+          </a:lnRef>
+          <a:fillRef idx="3">
+            <a:schemeClr val="accent1"/>
+          </a:fillRef>
+          <a:effectRef idx="2">
+            <a:schemeClr val="accent1"/>
+          </a:effectRef>
+          <a:fontRef idx="minor">
+            <a:schemeClr val="lt1"/>
+          </a:fontRef>
+        </p:style>
+        <p:txBody>
+          <a:bodyPr rtlCol="0" anchor="ctr"/>
+          <a:lstStyle/>
+          <a:p>
+            <a:pPr algn="ctr"/>
+          </a:p>
+        </p:txBody>
+      </p:sp>
+      <p:sp>
+        <p:nvSpPr>
+          <p:cNvPr id="17" name="TextBox 16"/>
+          <p:cNvSpPr txBox="1"/>
+          <p:nvPr/>
+        </p:nvSpPr>
+        <p:spPr>
+          <a:xfrm>
+            <a:off x="4358944" y="3931920"/>
+            <a:ext cx="1280160" cy="548640"/>
+          </a:xfrm>
+          <a:prstGeom prst="rect">
+            <a:avLst/>
+          </a:prstGeom>
+          <a:noFill/>
+        </p:spPr>
+        <p:txBody>
+          <a:bodyPr wrap="square">
+            <a:spAutoFit/>
+          </a:bodyPr>
+          <a:lstStyle/>
+          <a:p>
+            <a:pPr algn="ctr"/>
+            <a:r>
+              <a:rPr sz="2400" b="1">
                 <a:solidFill>
                   <a:srgbClr val="DC2626"/>
                 </a:solidFill>
@@ -7207,139 +7454,416 @@
       </p:sp>
       <p:sp>
         <p:nvSpPr>
-          <p:cNvPr id="6" name="TextBox 5"/>
-          <p:cNvSpPr txBox="1"/>
-          <p:nvPr/>
-        </p:nvSpPr>
-        <p:spPr>
-          <a:xfrm>
-            <a:off x="4572000" y="3108960"/>
-            <a:ext cx="3047695" cy="914400"/>
-          </a:xfrm>
-          <a:prstGeom prst="rect">
-            <a:avLst/>
-          </a:prstGeom>
-          <a:noFill/>
-        </p:spPr>
-        <p:txBody>
-          <a:bodyPr wrap="square">
-            <a:spAutoFit/>
-          </a:bodyPr>
-          <a:lstStyle/>
-          <a:p>
-            <a:pPr algn="ctr"/>
-            <a:r>
-              <a:rPr sz="7200" b="1">
-                <a:solidFill>
-                  <a:srgbClr val="F59E0B"/>
+          <p:cNvPr id="18" name="TextBox 17"/>
+          <p:cNvSpPr txBox="1"/>
+          <p:nvPr/>
+        </p:nvSpPr>
+        <p:spPr>
+          <a:xfrm>
+            <a:off x="4267504" y="4526280"/>
+            <a:ext cx="1463040" cy="365760"/>
+          </a:xfrm>
+          <a:prstGeom prst="rect">
+            <a:avLst/>
+          </a:prstGeom>
+          <a:noFill/>
+        </p:spPr>
+        <p:txBody>
+          <a:bodyPr wrap="square">
+            <a:spAutoFit/>
+          </a:bodyPr>
+          <a:lstStyle/>
+          <a:p>
+            <a:pPr algn="ctr"/>
+            <a:r>
+              <a:rPr sz="1400" b="0">
+                <a:solidFill>
+                  <a:srgbClr val="6B7280"/>
+                </a:solidFill>
+                <a:latin typeface="阿里巴巴普惠体 3.0"/>
+              </a:rPr>
+              <a:t>上线联调</a:t>
+            </a:r>
+          </a:p>
+        </p:txBody>
+      </p:sp>
+      <p:pic>
+        <p:nvPicPr>
+          <p:cNvPr id="19" name="Picture 18" descr="p2-green-3-dashboard.png"/>
+          <p:cNvPicPr>
+            <a:picLocks noChangeAspect="1"/>
+          </p:cNvPicPr>
+          <p:nvPr/>
+        </p:nvPicPr>
+        <p:blipFill>
+          <a:blip r:embed="rId5"/>
+          <a:stretch>
+            <a:fillRect/>
+          </a:stretch>
+        </p:blipFill>
+        <p:spPr>
+          <a:xfrm>
+            <a:off x="6644944" y="1280160"/>
+            <a:ext cx="1097280" cy="1097280"/>
+          </a:xfrm>
+          <a:prstGeom prst="rect">
+            <a:avLst/>
+          </a:prstGeom>
+        </p:spPr>
+      </p:pic>
+      <p:sp>
+        <p:nvSpPr>
+          <p:cNvPr id="20" name="Oval 19"/>
+          <p:cNvSpPr/>
+          <p:nvPr/>
+        </p:nvSpPr>
+        <p:spPr>
+          <a:xfrm>
+            <a:off x="7083856" y="3575304"/>
+            <a:ext cx="219456" cy="219456"/>
+          </a:xfrm>
+          <a:prstGeom prst="ellipse">
+            <a:avLst/>
+          </a:prstGeom>
+          <a:solidFill>
+            <a:srgbClr val="10B981"/>
+          </a:solidFill>
+          <a:ln w="25400">
+            <a:solidFill>
+              <a:srgbClr val="FFFFFF"/>
+            </a:solidFill>
+          </a:ln>
+        </p:spPr>
+        <p:style>
+          <a:lnRef idx="1">
+            <a:schemeClr val="accent1"/>
+          </a:lnRef>
+          <a:fillRef idx="3">
+            <a:schemeClr val="accent1"/>
+          </a:fillRef>
+          <a:effectRef idx="2">
+            <a:schemeClr val="accent1"/>
+          </a:effectRef>
+          <a:fontRef idx="minor">
+            <a:schemeClr val="lt1"/>
+          </a:fontRef>
+        </p:style>
+        <p:txBody>
+          <a:bodyPr rtlCol="0" anchor="ctr"/>
+          <a:lstStyle/>
+          <a:p>
+            <a:pPr algn="ctr"/>
+          </a:p>
+        </p:txBody>
+      </p:sp>
+      <p:sp>
+        <p:nvSpPr>
+          <p:cNvPr id="21" name="TextBox 20"/>
+          <p:cNvSpPr txBox="1"/>
+          <p:nvPr/>
+        </p:nvSpPr>
+        <p:spPr>
+          <a:xfrm>
+            <a:off x="6553504" y="3931920"/>
+            <a:ext cx="1280160" cy="548640"/>
+          </a:xfrm>
+          <a:prstGeom prst="rect">
+            <a:avLst/>
+          </a:prstGeom>
+          <a:noFill/>
+        </p:spPr>
+        <p:txBody>
+          <a:bodyPr wrap="square">
+            <a:spAutoFit/>
+          </a:bodyPr>
+          <a:lstStyle/>
+          <a:p>
+            <a:pPr algn="ctr"/>
+            <a:r>
+              <a:rPr sz="2400" b="1">
+                <a:solidFill>
+                  <a:srgbClr val="10B981"/>
                 </a:solidFill>
                 <a:latin typeface="Inter"/>
               </a:rPr>
-              <a:t>→</a:t>
-            </a:r>
-          </a:p>
-        </p:txBody>
-      </p:sp>
-      <p:sp>
-        <p:nvSpPr>
-          <p:cNvPr id="7" name="TextBox 6"/>
-          <p:cNvSpPr txBox="1"/>
-          <p:nvPr/>
-        </p:nvSpPr>
-        <p:spPr>
-          <a:xfrm>
-            <a:off x="7619695" y="1828800"/>
-            <a:ext cx="4114800" cy="914400"/>
-          </a:xfrm>
-          <a:prstGeom prst="rect">
-            <a:avLst/>
-          </a:prstGeom>
-          <a:noFill/>
-        </p:spPr>
-        <p:txBody>
-          <a:bodyPr wrap="square">
-            <a:spAutoFit/>
-          </a:bodyPr>
-          <a:lstStyle/>
-          <a:p>
-            <a:pPr algn="ctr"/>
-            <a:r>
-              <a:rPr sz="4800" b="1">
+              <a:t>3 分</a:t>
+            </a:r>
+          </a:p>
+        </p:txBody>
+      </p:sp>
+      <p:sp>
+        <p:nvSpPr>
+          <p:cNvPr id="22" name="TextBox 21"/>
+          <p:cNvSpPr txBox="1"/>
+          <p:nvPr/>
+        </p:nvSpPr>
+        <p:spPr>
+          <a:xfrm>
+            <a:off x="6462064" y="4526280"/>
+            <a:ext cx="1463040" cy="365760"/>
+          </a:xfrm>
+          <a:prstGeom prst="rect">
+            <a:avLst/>
+          </a:prstGeom>
+          <a:noFill/>
+        </p:spPr>
+        <p:txBody>
+          <a:bodyPr wrap="square">
+            <a:spAutoFit/>
+          </a:bodyPr>
+          <a:lstStyle/>
+          <a:p>
+            <a:pPr algn="ctr"/>
+            <a:r>
+              <a:rPr sz="1400" b="0">
+                <a:solidFill>
+                  <a:srgbClr val="6B7280"/>
+                </a:solidFill>
+                <a:latin typeface="阿里巴巴普惠体 3.0"/>
+              </a:rPr>
+              <a:t>一键集成</a:t>
+            </a:r>
+          </a:p>
+        </p:txBody>
+      </p:sp>
+      <p:pic>
+        <p:nvPicPr>
+          <p:cNvPr id="23" name="Picture 22" descr="p2-green-2-rocket.png"/>
+          <p:cNvPicPr>
+            <a:picLocks noChangeAspect="1"/>
+          </p:cNvPicPr>
+          <p:nvPr/>
+        </p:nvPicPr>
+        <p:blipFill>
+          <a:blip r:embed="rId6"/>
+          <a:stretch>
+            <a:fillRect/>
+          </a:stretch>
+        </p:blipFill>
+        <p:spPr>
+          <a:xfrm>
+            <a:off x="8839504" y="1280160"/>
+            <a:ext cx="1097280" cy="1097280"/>
+          </a:xfrm>
+          <a:prstGeom prst="rect">
+            <a:avLst/>
+          </a:prstGeom>
+        </p:spPr>
+      </p:pic>
+      <p:sp>
+        <p:nvSpPr>
+          <p:cNvPr id="24" name="Oval 23"/>
+          <p:cNvSpPr/>
+          <p:nvPr/>
+        </p:nvSpPr>
+        <p:spPr>
+          <a:xfrm>
+            <a:off x="9278416" y="3575304"/>
+            <a:ext cx="219456" cy="219456"/>
+          </a:xfrm>
+          <a:prstGeom prst="ellipse">
+            <a:avLst/>
+          </a:prstGeom>
+          <a:solidFill>
+            <a:srgbClr val="10B981"/>
+          </a:solidFill>
+          <a:ln w="25400">
+            <a:solidFill>
+              <a:srgbClr val="FFFFFF"/>
+            </a:solidFill>
+          </a:ln>
+        </p:spPr>
+        <p:style>
+          <a:lnRef idx="1">
+            <a:schemeClr val="accent1"/>
+          </a:lnRef>
+          <a:fillRef idx="3">
+            <a:schemeClr val="accent1"/>
+          </a:fillRef>
+          <a:effectRef idx="2">
+            <a:schemeClr val="accent1"/>
+          </a:effectRef>
+          <a:fontRef idx="minor">
+            <a:schemeClr val="lt1"/>
+          </a:fontRef>
+        </p:style>
+        <p:txBody>
+          <a:bodyPr rtlCol="0" anchor="ctr"/>
+          <a:lstStyle/>
+          <a:p>
+            <a:pPr algn="ctr"/>
+          </a:p>
+        </p:txBody>
+      </p:sp>
+      <p:sp>
+        <p:nvSpPr>
+          <p:cNvPr id="25" name="TextBox 24"/>
+          <p:cNvSpPr txBox="1"/>
+          <p:nvPr/>
+        </p:nvSpPr>
+        <p:spPr>
+          <a:xfrm>
+            <a:off x="8748064" y="3931920"/>
+            <a:ext cx="1280160" cy="548640"/>
+          </a:xfrm>
+          <a:prstGeom prst="rect">
+            <a:avLst/>
+          </a:prstGeom>
+          <a:noFill/>
+        </p:spPr>
+        <p:txBody>
+          <a:bodyPr wrap="square">
+            <a:spAutoFit/>
+          </a:bodyPr>
+          <a:lstStyle/>
+          <a:p>
+            <a:pPr algn="ctr"/>
+            <a:r>
+              <a:rPr sz="2400" b="1">
                 <a:solidFill>
                   <a:srgbClr val="10B981"/>
                 </a:solidFill>
                 <a:latin typeface="Inter"/>
               </a:rPr>
-              <a:t>3 分</a:t>
-            </a:r>
-          </a:p>
-        </p:txBody>
-      </p:sp>
-      <p:sp>
-        <p:nvSpPr>
-          <p:cNvPr id="8" name="TextBox 7"/>
-          <p:cNvSpPr txBox="1"/>
-          <p:nvPr/>
-        </p:nvSpPr>
-        <p:spPr>
-          <a:xfrm>
-            <a:off x="7619695" y="3017520"/>
-            <a:ext cx="4114800" cy="914400"/>
-          </a:xfrm>
-          <a:prstGeom prst="rect">
-            <a:avLst/>
-          </a:prstGeom>
-          <a:noFill/>
-        </p:spPr>
-        <p:txBody>
-          <a:bodyPr wrap="square">
-            <a:spAutoFit/>
-          </a:bodyPr>
-          <a:lstStyle/>
-          <a:p>
-            <a:pPr algn="ctr"/>
-            <a:r>
-              <a:rPr sz="4800" b="1">
+              <a:t>90 秒</a:t>
+            </a:r>
+          </a:p>
+        </p:txBody>
+      </p:sp>
+      <p:sp>
+        <p:nvSpPr>
+          <p:cNvPr id="26" name="TextBox 25"/>
+          <p:cNvSpPr txBox="1"/>
+          <p:nvPr/>
+        </p:nvSpPr>
+        <p:spPr>
+          <a:xfrm>
+            <a:off x="8656624" y="4526280"/>
+            <a:ext cx="1463040" cy="365760"/>
+          </a:xfrm>
+          <a:prstGeom prst="rect">
+            <a:avLst/>
+          </a:prstGeom>
+          <a:noFill/>
+        </p:spPr>
+        <p:txBody>
+          <a:bodyPr wrap="square">
+            <a:spAutoFit/>
+          </a:bodyPr>
+          <a:lstStyle/>
+          <a:p>
+            <a:pPr algn="ctr"/>
+            <a:r>
+              <a:rPr sz="1400" b="0">
+                <a:solidFill>
+                  <a:srgbClr val="6B7280"/>
+                </a:solidFill>
+                <a:latin typeface="阿里巴巴普惠体 3.0"/>
+              </a:rPr>
+              <a:t>出报告</a:t>
+            </a:r>
+          </a:p>
+        </p:txBody>
+      </p:sp>
+      <p:pic>
+        <p:nvPicPr>
+          <p:cNvPr id="27" name="Picture 26" descr="p2-green-1-final.png"/>
+          <p:cNvPicPr>
+            <a:picLocks noChangeAspect="1"/>
+          </p:cNvPicPr>
+          <p:nvPr/>
+        </p:nvPicPr>
+        <p:blipFill>
+          <a:blip r:embed="rId7"/>
+          <a:stretch>
+            <a:fillRect/>
+          </a:stretch>
+        </p:blipFill>
+        <p:spPr>
+          <a:xfrm>
+            <a:off x="11034064" y="1280160"/>
+            <a:ext cx="1097280" cy="1097280"/>
+          </a:xfrm>
+          <a:prstGeom prst="rect">
+            <a:avLst/>
+          </a:prstGeom>
+        </p:spPr>
+      </p:pic>
+      <p:sp>
+        <p:nvSpPr>
+          <p:cNvPr id="28" name="Oval 27"/>
+          <p:cNvSpPr/>
+          <p:nvPr/>
+        </p:nvSpPr>
+        <p:spPr>
+          <a:xfrm>
+            <a:off x="11472976" y="3575304"/>
+            <a:ext cx="219456" cy="219456"/>
+          </a:xfrm>
+          <a:prstGeom prst="ellipse">
+            <a:avLst/>
+          </a:prstGeom>
+          <a:solidFill>
+            <a:srgbClr val="10B981"/>
+          </a:solidFill>
+          <a:ln w="25400">
+            <a:solidFill>
+              <a:srgbClr val="FFFFFF"/>
+            </a:solidFill>
+          </a:ln>
+        </p:spPr>
+        <p:style>
+          <a:lnRef idx="1">
+            <a:schemeClr val="accent1"/>
+          </a:lnRef>
+          <a:fillRef idx="3">
+            <a:schemeClr val="accent1"/>
+          </a:fillRef>
+          <a:effectRef idx="2">
+            <a:schemeClr val="accent1"/>
+          </a:effectRef>
+          <a:fontRef idx="minor">
+            <a:schemeClr val="lt1"/>
+          </a:fontRef>
+        </p:style>
+        <p:txBody>
+          <a:bodyPr rtlCol="0" anchor="ctr"/>
+          <a:lstStyle/>
+          <a:p>
+            <a:pPr algn="ctr"/>
+          </a:p>
+        </p:txBody>
+      </p:sp>
+      <p:sp>
+        <p:nvSpPr>
+          <p:cNvPr id="29" name="TextBox 28"/>
+          <p:cNvSpPr txBox="1"/>
+          <p:nvPr/>
+        </p:nvSpPr>
+        <p:spPr>
+          <a:xfrm>
+            <a:off x="10942624" y="3931920"/>
+            <a:ext cx="1280160" cy="548640"/>
+          </a:xfrm>
+          <a:prstGeom prst="rect">
+            <a:avLst/>
+          </a:prstGeom>
+          <a:noFill/>
+        </p:spPr>
+        <p:txBody>
+          <a:bodyPr wrap="square">
+            <a:spAutoFit/>
+          </a:bodyPr>
+          <a:lstStyle/>
+          <a:p>
+            <a:pPr algn="ctr"/>
+            <a:r>
+              <a:rPr sz="2400" b="1">
                 <a:solidFill>
                   <a:srgbClr val="10B981"/>
                 </a:solidFill>
                 <a:latin typeface="Inter"/>
               </a:rPr>
-              <a:t>90 秒</a:t>
-            </a:r>
-          </a:p>
-        </p:txBody>
-      </p:sp>
-      <p:sp>
-        <p:nvSpPr>
-          <p:cNvPr id="9" name="TextBox 8"/>
-          <p:cNvSpPr txBox="1"/>
-          <p:nvPr/>
-        </p:nvSpPr>
-        <p:spPr>
-          <a:xfrm>
-            <a:off x="7619695" y="4206240"/>
-            <a:ext cx="4114800" cy="914400"/>
-          </a:xfrm>
-          <a:prstGeom prst="rect">
-            <a:avLst/>
-          </a:prstGeom>
-          <a:noFill/>
-        </p:spPr>
-        <p:txBody>
-          <a:bodyPr wrap="square">
-            <a:spAutoFit/>
-          </a:bodyPr>
-          <a:lstStyle/>
-          <a:p>
-            <a:pPr algn="ctr"/>
-            <a:r>
-              <a:rPr sz="4800" b="1">
-                <a:solidFill>
-                  <a:srgbClr val="10B981"/>
-                </a:solidFill>
-                <a:latin typeface="Inter"/>
-              </a:rPr>
               <a:t>10 分</a:t>
             </a:r>
           </a:p>
@@ -7347,16 +7871,51 @@
       </p:sp>
       <p:sp>
         <p:nvSpPr>
-          <p:cNvPr id="10" name="Rounded Rectangle 9"/>
+          <p:cNvPr id="30" name="TextBox 29"/>
+          <p:cNvSpPr txBox="1"/>
+          <p:nvPr/>
+        </p:nvSpPr>
+        <p:spPr>
+          <a:xfrm>
+            <a:off x="10851184" y="4526280"/>
+            <a:ext cx="1463040" cy="365760"/>
+          </a:xfrm>
+          <a:prstGeom prst="rect">
+            <a:avLst/>
+          </a:prstGeom>
+          <a:noFill/>
+        </p:spPr>
+        <p:txBody>
+          <a:bodyPr wrap="square">
+            <a:spAutoFit/>
+          </a:bodyPr>
+          <a:lstStyle/>
+          <a:p>
+            <a:pPr algn="ctr"/>
+            <a:r>
+              <a:rPr sz="1400" b="0">
+                <a:solidFill>
+                  <a:srgbClr val="6B7280"/>
+                </a:solidFill>
+                <a:latin typeface="阿里巴巴普惠体 3.0"/>
+              </a:rPr>
+              <a:t>出页面</a:t>
+            </a:r>
+          </a:p>
+        </p:txBody>
+      </p:sp>
+      <p:sp>
+        <p:nvSpPr>
+          <p:cNvPr id="31" name="Oval 30"/>
           <p:cNvSpPr/>
           <p:nvPr/>
         </p:nvSpPr>
         <p:spPr>
           <a:xfrm>
-            <a:off x="3200400" y="5760720"/>
-            <a:ext cx="5790895" cy="640080"/>
-          </a:xfrm>
-          <a:prstGeom prst="roundRect">
+            <a:off x="5593384" y="3154680"/>
+            <a:ext cx="1005840" cy="1005840"/>
+          </a:xfrm>
+          <a:prstGeom prst="ellipse">
             <a:avLst/>
           </a:prstGeom>
           <a:solidFill>
@@ -7392,7 +7951,122 @@
       </p:sp>
       <p:sp>
         <p:nvSpPr>
-          <p:cNvPr id="11" name="TextBox 10"/>
+          <p:cNvPr id="32" name="TextBox 31"/>
+          <p:cNvSpPr txBox="1"/>
+          <p:nvPr/>
+        </p:nvSpPr>
+        <p:spPr>
+          <a:xfrm>
+            <a:off x="5547664" y="3429000"/>
+            <a:ext cx="1097280" cy="457200"/>
+          </a:xfrm>
+          <a:prstGeom prst="rect">
+            <a:avLst/>
+          </a:prstGeom>
+          <a:noFill/>
+        </p:spPr>
+        <p:txBody>
+          <a:bodyPr wrap="square">
+            <a:spAutoFit/>
+          </a:bodyPr>
+          <a:lstStyle/>
+          <a:p>
+            <a:pPr algn="ctr"/>
+            <a:r>
+              <a:rPr sz="2200" b="1">
+                <a:solidFill>
+                  <a:srgbClr val="F59E0B"/>
+                </a:solidFill>
+                <a:latin typeface="Inter"/>
+              </a:rPr>
+              <a:t>1440×</a:t>
+            </a:r>
+          </a:p>
+        </p:txBody>
+      </p:sp>
+      <p:sp>
+        <p:nvSpPr>
+          <p:cNvPr id="33" name="TextBox 32"/>
+          <p:cNvSpPr txBox="1"/>
+          <p:nvPr/>
+        </p:nvSpPr>
+        <p:spPr>
+          <a:xfrm>
+            <a:off x="5456224" y="3822191"/>
+            <a:ext cx="1280160" cy="365760"/>
+          </a:xfrm>
+          <a:prstGeom prst="rect">
+            <a:avLst/>
+          </a:prstGeom>
+          <a:noFill/>
+        </p:spPr>
+        <p:txBody>
+          <a:bodyPr wrap="square">
+            <a:spAutoFit/>
+          </a:bodyPr>
+          <a:lstStyle/>
+          <a:p>
+            <a:pPr algn="ctr"/>
+            <a:r>
+              <a:rPr sz="1100" b="1">
+                <a:solidFill>
+                  <a:srgbClr val="F59E0B"/>
+                </a:solidFill>
+                <a:latin typeface="阿里巴巴普惠体 3.0"/>
+              </a:rPr>
+              <a:t>效率提升</a:t>
+            </a:r>
+          </a:p>
+        </p:txBody>
+      </p:sp>
+      <p:sp>
+        <p:nvSpPr>
+          <p:cNvPr id="34" name="Rounded Rectangle 33"/>
+          <p:cNvSpPr/>
+          <p:nvPr/>
+        </p:nvSpPr>
+        <p:spPr>
+          <a:xfrm>
+            <a:off x="3200400" y="5760720"/>
+            <a:ext cx="5790895" cy="640080"/>
+          </a:xfrm>
+          <a:prstGeom prst="roundRect">
+            <a:avLst/>
+          </a:prstGeom>
+          <a:solidFill>
+            <a:srgbClr val="FEF3C7"/>
+          </a:solidFill>
+          <a:ln w="38100">
+            <a:solidFill>
+              <a:srgbClr val="F59E0B"/>
+            </a:solidFill>
+          </a:ln>
+        </p:spPr>
+        <p:style>
+          <a:lnRef idx="1">
+            <a:schemeClr val="accent1"/>
+          </a:lnRef>
+          <a:fillRef idx="3">
+            <a:schemeClr val="accent1"/>
+          </a:fillRef>
+          <a:effectRef idx="2">
+            <a:schemeClr val="accent1"/>
+          </a:effectRef>
+          <a:fontRef idx="minor">
+            <a:schemeClr val="lt1"/>
+          </a:fontRef>
+        </p:style>
+        <p:txBody>
+          <a:bodyPr rtlCol="0" anchor="ctr"/>
+          <a:lstStyle/>
+          <a:p>
+            <a:pPr algn="ctr"/>
+          </a:p>
+        </p:txBody>
+      </p:sp>
+      <p:sp>
+        <p:nvSpPr>
+          <p:cNvPr id="35" name="TextBox 34"/>
           <p:cNvSpPr txBox="1"/>
           <p:nvPr/>
         </p:nvSpPr>
@@ -7420,7 +8094,7 @@
                 </a:solidFill>
                 <a:latin typeface="阿里巴巴普惠体 3.0"/>
               </a:rPr>
-              <a:t>★ 3 月 vs 3 分 = 1440 倍效率提升</a:t>
+              <a:t>★ 3 月 vs 3 分 — 从季度到分钟</a:t>
             </a:r>
           </a:p>
         </p:txBody>
@@ -7439,7 +8113,7 @@
             <p:tnCond val="0"/>
           </p:cond>
           <p:par>
-            <p:cTn id="4" nodeType="withEffect" dur="500" begin="0ms" fill="hold">
+            <p:cTn id="8" nodeType="withEffect" dur="500" begin="0ms" fill="hold">
               <p:animEffect presetClass="entr" presetId="10" dur="500"/>
             </p:cTn>
           </p:par>
@@ -7456,7 +8130,7 @@
             <p:tnCond val="0"/>
           </p:cond>
           <p:par>
-            <p:cTn id="5" nodeType="withEffect" dur="500" begin="600ms" fill="hold">
+            <p:cTn id="9" nodeType="withEffect" dur="500" begin="350ms" fill="hold">
               <p:animEffect presetClass="entr" presetId="10" dur="500"/>
             </p:cTn>
           </p:par>
@@ -7473,7 +8147,7 @@
             <p:tnCond val="0"/>
           </p:cond>
           <p:par>
-            <p:cTn id="6" nodeType="withEffect" dur="500" begin="1200ms" fill="hold">
+            <p:cTn id="10" nodeType="withEffect" dur="500" begin="700ms" fill="hold">
               <p:animEffect presetClass="entr" presetId="10" dur="500"/>
             </p:cTn>
           </p:par>
@@ -7490,7 +8164,7 @@
             <p:tnCond val="0"/>
           </p:cond>
           <p:par>
-            <p:cTn id="7" nodeType="withEffect" dur="500" begin="2000ms" fill="hold">
+            <p:cTn id="11" nodeType="withEffect" dur="500" begin="1050ms" fill="hold">
               <p:animEffect presetClass="entr" presetId="10" dur="500"/>
             </p:cTn>
           </p:par>
@@ -7507,7 +8181,7 @@
             <p:tnCond val="0"/>
           </p:cond>
           <p:par>
-            <p:cTn id="8" nodeType="withEffect" dur="500" begin="2800ms" fill="hold">
+            <p:cTn id="12" nodeType="withEffect" dur="500" begin="1400ms" fill="hold">
               <p:animEffect presetClass="entr" presetId="10" dur="500"/>
             </p:cTn>
           </p:par>
@@ -7524,7 +8198,7 @@
             <p:tnCond val="0"/>
           </p:cond>
           <p:par>
-            <p:cTn id="9" nodeType="withEffect" dur="500" begin="3400ms" fill="hold">
+            <p:cTn id="13" nodeType="withEffect" dur="500" begin="1750ms" fill="hold">
               <p:animEffect presetClass="entr" presetId="10" dur="500"/>
             </p:cTn>
           </p:par>
@@ -7541,8 +8215,8 @@
             <p:tnCond val="0"/>
           </p:cond>
           <p:par>
-            <p:cTn id="10" nodeType="withEffect" dur="500" begin="4000ms" fill="hold">
-              <p:animEffect presetClass="entr" presetId="10" dur="500"/>
+            <p:cTn id="35" nodeType="withEffect" dur="1500" begin="3500ms" fill="hold" repeatCount="indefinite">
+              <p:animEffect presetClass="emph" presetId="26" dur="1500"/>
             </p:cTn>
           </p:par>
         </p:par>
@@ -7558,8 +8232,8 @@
             <p:tnCond val="0"/>
           </p:cond>
           <p:par>
-            <p:cTn id="11" nodeType="withEffect" dur="1500" begin="5000ms" fill="hold" repeatCount="indefinite">
-              <p:animEffect presetClass="emph" presetId="26" dur="1500"/>
+            <p:cTn id="32" nodeType="withEffect" dur="500" begin="2200ms" fill="hold">
+              <p:animEffect presetClass="entr" presetId="10" dur="500"/>
             </p:cTn>
           </p:par>
         </p:par>

</xml_diff>

<commit_message>
feat(ppt): P1 换成 JavaBrain 大脑+3能量流配图
P1 配图从抽象神经网络改为方案 D:中心紫发光大脑 +
左下 Java 蓝代码立方 + 右下绿色数据立方 + 6 卫星光点。
直观呼应项目名 JavaBrain,3 股能量流分别代表
代码输入/数据输入/AI 处理,2.5D 扁平白底统一.

布局调整:
- 背景图缩放至 7.5×3.3 英寸 @ 38% alpha,顶部居中
- 去掉原 3 圈光晕节点(被大脑图占位)
- 新增 3 组件文字标签(灵梭/SQL工坊/SQL工坊 MCP)水平排
- JavaBrain 大字 72pt 在大脑下方居中
- 底部金钩保持 '3 组件 · 1 starter · 0 漂移'

verify_t1/t7 全过(12 页 87 动画 14 pulse_loop),
PIL 模拟渲染确认元素无重叠,留白舒适.
</commit_message>
<xml_diff>
--- a/docs/ppt/javabrain.pptx
+++ b/docs/ppt/javabrain.pptx
@@ -3109,7 +3109,7 @@
       <p:grpSpPr/>
       <p:pic>
         <p:nvPicPr>
-          <p:cNvPr id="2" name="Picture 1" descr="p1-neural-v1.png"/>
+          <p:cNvPr id="2" name="Picture 1" descr="p1v2-d1-brain-3streams.png"/>
           <p:cNvPicPr>
             <a:picLocks noChangeAspect="1"/>
           </p:cNvPicPr>
@@ -3117,7 +3117,7 @@
         </p:nvPicPr>
         <p:blipFill>
           <a:blip r:embed="rId2">
-            <a:alphaModFix amt="32000"/>
+            <a:alphaModFix amt="38000"/>
           </a:blip>
           <a:stretch>
             <a:fillRect/>
@@ -3125,8 +3125,8 @@
         </p:blipFill>
         <p:spPr>
           <a:xfrm>
-            <a:off x="4114800" y="457200"/>
-            <a:ext cx="7772400" cy="5029200"/>
+            <a:off x="2743200" y="91440"/>
+            <a:ext cx="6858000" cy="3017520"/>
           </a:xfrm>
           <a:prstGeom prst="rect">
             <a:avLst/>
@@ -3135,14 +3135,84 @@
       </p:pic>
       <p:sp>
         <p:nvSpPr>
-          <p:cNvPr id="3" name="Oval 2"/>
+          <p:cNvPr id="3" name="TextBox 2"/>
+          <p:cNvSpPr txBox="1"/>
+          <p:nvPr/>
+        </p:nvSpPr>
+        <p:spPr>
+          <a:xfrm>
+            <a:off x="914400" y="3200400"/>
+            <a:ext cx="10362895" cy="1280160"/>
+          </a:xfrm>
+          <a:prstGeom prst="rect">
+            <a:avLst/>
+          </a:prstGeom>
+          <a:noFill/>
+        </p:spPr>
+        <p:txBody>
+          <a:bodyPr wrap="square">
+            <a:spAutoFit/>
+          </a:bodyPr>
+          <a:lstStyle/>
+          <a:p>
+            <a:pPr algn="ctr"/>
+            <a:r>
+              <a:rPr sz="7200" b="1">
+                <a:solidFill>
+                  <a:srgbClr val="1F2937"/>
+                </a:solidFill>
+                <a:latin typeface="Inter"/>
+              </a:rPr>
+              <a:t>JavaBrain</a:t>
+            </a:r>
+          </a:p>
+        </p:txBody>
+      </p:sp>
+      <p:sp>
+        <p:nvSpPr>
+          <p:cNvPr id="4" name="TextBox 3"/>
+          <p:cNvSpPr txBox="1"/>
+          <p:nvPr/>
+        </p:nvSpPr>
+        <p:spPr>
+          <a:xfrm>
+            <a:off x="914400" y="4480560"/>
+            <a:ext cx="10362895" cy="457200"/>
+          </a:xfrm>
+          <a:prstGeom prst="rect">
+            <a:avLst/>
+          </a:prstGeom>
+          <a:noFill/>
+        </p:spPr>
+        <p:txBody>
+          <a:bodyPr wrap="square">
+            <a:spAutoFit/>
+          </a:bodyPr>
+          <a:lstStyle/>
+          <a:p>
+            <a:pPr algn="ctr"/>
+            <a:r>
+              <a:rPr sz="2400" b="0">
+                <a:solidFill>
+                  <a:srgbClr val="6B7280"/>
+                </a:solidFill>
+                <a:latin typeface="阿里巴巴普惠体 3.0"/>
+              </a:rPr>
+              <a:t>让您的系统瞬间拥有“思考”与“执行”的智能大脑</a:t>
+            </a:r>
+          </a:p>
+        </p:txBody>
+      </p:sp>
+      <p:sp>
+        <p:nvSpPr>
+          <p:cNvPr id="5" name="Oval 4"/>
           <p:cNvSpPr/>
           <p:nvPr/>
         </p:nvSpPr>
         <p:spPr>
           <a:xfrm>
-            <a:off x="5669280" y="365760"/>
-            <a:ext cx="548640" cy="548640"/>
+            <a:off x="3200400" y="5120640"/>
+            <a:ext cx="164592" cy="164592"/>
           </a:xfrm>
           <a:prstGeom prst="ellipse">
             <a:avLst/>
@@ -3150,10 +3220,8 @@
           <a:solidFill>
             <a:srgbClr val="007396"/>
           </a:solidFill>
-          <a:ln w="25400">
-            <a:solidFill>
-              <a:srgbClr val="007396"/>
-            </a:solidFill>
+          <a:ln>
+            <a:noFill/>
           </a:ln>
         </p:spPr>
         <p:style>
@@ -3180,21 +3248,20 @@
       </p:sp>
       <p:sp>
         <p:nvSpPr>
-          <p:cNvPr id="4" name="Oval 3"/>
+          <p:cNvPr id="6" name="Oval 5"/>
           <p:cNvSpPr/>
           <p:nvPr/>
         </p:nvSpPr>
         <p:spPr>
           <a:xfrm>
-            <a:off x="4160520" y="868680"/>
-            <a:ext cx="914400" cy="914400"/>
+            <a:off x="5639104" y="5120640"/>
+            <a:ext cx="164592" cy="164592"/>
           </a:xfrm>
           <a:prstGeom prst="ellipse">
             <a:avLst/>
           </a:prstGeom>
           <a:solidFill>
-            <a:srgbClr val="007396"/>
-            <a:alpha val="30000"/>
+            <a:srgbClr val="6B46C1"/>
           </a:solidFill>
           <a:ln>
             <a:noFill/>
@@ -3224,25 +3291,23 @@
       </p:sp>
       <p:sp>
         <p:nvSpPr>
-          <p:cNvPr id="5" name="Oval 4"/>
+          <p:cNvPr id="7" name="Oval 6"/>
           <p:cNvSpPr/>
           <p:nvPr/>
         </p:nvSpPr>
         <p:spPr>
           <a:xfrm>
-            <a:off x="4389120" y="1097280"/>
-            <a:ext cx="457200" cy="457200"/>
+            <a:off x="8076895" y="5120640"/>
+            <a:ext cx="164592" cy="164592"/>
           </a:xfrm>
           <a:prstGeom prst="ellipse">
             <a:avLst/>
           </a:prstGeom>
           <a:solidFill>
-            <a:srgbClr val="007396"/>
+            <a:srgbClr val="10B981"/>
           </a:solidFill>
           <a:ln>
-            <a:solidFill>
-              <a:srgbClr val="007396"/>
-            </a:solidFill>
+            <a:noFill/>
           </a:ln>
         </p:spPr>
         <p:style>
@@ -3269,179 +3334,71 @@
       </p:sp>
       <p:sp>
         <p:nvSpPr>
-          <p:cNvPr id="6" name="Oval 5"/>
-          <p:cNvSpPr/>
-          <p:nvPr/>
-        </p:nvSpPr>
-        <p:spPr>
-          <a:xfrm>
-            <a:off x="5867704" y="868680"/>
-            <a:ext cx="914400" cy="914400"/>
-          </a:xfrm>
-          <a:prstGeom prst="ellipse">
-            <a:avLst/>
-          </a:prstGeom>
-          <a:solidFill>
-            <a:srgbClr val="6B46C1"/>
-            <a:alpha val="30000"/>
-          </a:solidFill>
-          <a:ln>
-            <a:noFill/>
-          </a:ln>
-        </p:spPr>
-        <p:style>
-          <a:lnRef idx="1">
-            <a:schemeClr val="accent1"/>
-          </a:lnRef>
-          <a:fillRef idx="3">
-            <a:schemeClr val="accent1"/>
-          </a:fillRef>
-          <a:effectRef idx="2">
-            <a:schemeClr val="accent1"/>
-          </a:effectRef>
-          <a:fontRef idx="minor">
-            <a:schemeClr val="lt1"/>
-          </a:fontRef>
-        </p:style>
-        <p:txBody>
-          <a:bodyPr rtlCol="0" anchor="ctr"/>
-          <a:lstStyle/>
-          <a:p>
-            <a:pPr algn="ctr"/>
-          </a:p>
-        </p:txBody>
-      </p:sp>
-      <p:sp>
-        <p:nvSpPr>
-          <p:cNvPr id="7" name="Oval 6"/>
-          <p:cNvSpPr/>
-          <p:nvPr/>
-        </p:nvSpPr>
-        <p:spPr>
-          <a:xfrm>
-            <a:off x="6096304" y="1097280"/>
-            <a:ext cx="457200" cy="457200"/>
-          </a:xfrm>
-          <a:prstGeom prst="ellipse">
-            <a:avLst/>
-          </a:prstGeom>
-          <a:solidFill>
-            <a:srgbClr val="6B46C1"/>
-          </a:solidFill>
-          <a:ln>
-            <a:solidFill>
-              <a:srgbClr val="6B46C1"/>
-            </a:solidFill>
-          </a:ln>
-        </p:spPr>
-        <p:style>
-          <a:lnRef idx="1">
-            <a:schemeClr val="accent1"/>
-          </a:lnRef>
-          <a:fillRef idx="3">
-            <a:schemeClr val="accent1"/>
-          </a:fillRef>
-          <a:effectRef idx="2">
-            <a:schemeClr val="accent1"/>
-          </a:effectRef>
-          <a:fontRef idx="minor">
-            <a:schemeClr val="lt1"/>
-          </a:fontRef>
-        </p:style>
-        <p:txBody>
-          <a:bodyPr rtlCol="0" anchor="ctr"/>
-          <a:lstStyle/>
-          <a:p>
-            <a:pPr algn="ctr"/>
-          </a:p>
-        </p:txBody>
-      </p:sp>
-      <p:sp>
-        <p:nvSpPr>
-          <p:cNvPr id="8" name="Oval 7"/>
-          <p:cNvSpPr/>
-          <p:nvPr/>
-        </p:nvSpPr>
-        <p:spPr>
-          <a:xfrm>
-            <a:off x="7573975" y="868680"/>
-            <a:ext cx="914400" cy="914400"/>
-          </a:xfrm>
-          <a:prstGeom prst="ellipse">
-            <a:avLst/>
-          </a:prstGeom>
-          <a:solidFill>
-            <a:srgbClr val="10B981"/>
-            <a:alpha val="30000"/>
-          </a:solidFill>
-          <a:ln>
-            <a:noFill/>
-          </a:ln>
-        </p:spPr>
-        <p:style>
-          <a:lnRef idx="1">
-            <a:schemeClr val="accent1"/>
-          </a:lnRef>
-          <a:fillRef idx="3">
-            <a:schemeClr val="accent1"/>
-          </a:fillRef>
-          <a:effectRef idx="2">
-            <a:schemeClr val="accent1"/>
-          </a:effectRef>
-          <a:fontRef idx="minor">
-            <a:schemeClr val="lt1"/>
-          </a:fontRef>
-        </p:style>
-        <p:txBody>
-          <a:bodyPr rtlCol="0" anchor="ctr"/>
-          <a:lstStyle/>
-          <a:p>
-            <a:pPr algn="ctr"/>
-          </a:p>
-        </p:txBody>
-      </p:sp>
-      <p:sp>
-        <p:nvSpPr>
-          <p:cNvPr id="9" name="Oval 8"/>
-          <p:cNvSpPr/>
-          <p:nvPr/>
-        </p:nvSpPr>
-        <p:spPr>
-          <a:xfrm>
-            <a:off x="7802575" y="1097280"/>
-            <a:ext cx="457200" cy="457200"/>
-          </a:xfrm>
-          <a:prstGeom prst="ellipse">
-            <a:avLst/>
-          </a:prstGeom>
-          <a:solidFill>
-            <a:srgbClr val="10B981"/>
-          </a:solidFill>
-          <a:ln>
-            <a:solidFill>
-              <a:srgbClr val="10B981"/>
-            </a:solidFill>
-          </a:ln>
-        </p:spPr>
-        <p:style>
-          <a:lnRef idx="1">
-            <a:schemeClr val="accent1"/>
-          </a:lnRef>
-          <a:fillRef idx="3">
-            <a:schemeClr val="accent1"/>
-          </a:fillRef>
-          <a:effectRef idx="2">
-            <a:schemeClr val="accent1"/>
-          </a:effectRef>
-          <a:fontRef idx="minor">
-            <a:schemeClr val="lt1"/>
-          </a:fontRef>
-        </p:style>
-        <p:txBody>
-          <a:bodyPr rtlCol="0" anchor="ctr"/>
-          <a:lstStyle/>
-          <a:p>
-            <a:pPr algn="ctr"/>
+          <p:cNvPr id="8" name="TextBox 7"/>
+          <p:cNvSpPr txBox="1"/>
+          <p:nvPr/>
+        </p:nvSpPr>
+        <p:spPr>
+          <a:xfrm>
+            <a:off x="3429000" y="5056631"/>
+            <a:ext cx="1828800" cy="365760"/>
+          </a:xfrm>
+          <a:prstGeom prst="rect">
+            <a:avLst/>
+          </a:prstGeom>
+          <a:noFill/>
+        </p:spPr>
+        <p:txBody>
+          <a:bodyPr wrap="square">
+            <a:spAutoFit/>
+          </a:bodyPr>
+          <a:lstStyle/>
+          <a:p>
+            <a:pPr algn="ctr"/>
+            <a:r>
+              <a:rPr sz="1400" b="1">
+                <a:solidFill>
+                  <a:srgbClr val="007396"/>
+                </a:solidFill>
+                <a:latin typeface="阿里巴巴普惠体 3.0"/>
+              </a:rPr>
+              <a:t>灵梭</a:t>
+            </a:r>
+          </a:p>
+        </p:txBody>
+      </p:sp>
+      <p:sp>
+        <p:nvSpPr>
+          <p:cNvPr id="9" name="TextBox 8"/>
+          <p:cNvSpPr txBox="1"/>
+          <p:nvPr/>
+        </p:nvSpPr>
+        <p:spPr>
+          <a:xfrm>
+            <a:off x="5867704" y="5056631"/>
+            <a:ext cx="1828800" cy="365760"/>
+          </a:xfrm>
+          <a:prstGeom prst="rect">
+            <a:avLst/>
+          </a:prstGeom>
+          <a:noFill/>
+        </p:spPr>
+        <p:txBody>
+          <a:bodyPr wrap="square">
+            <a:spAutoFit/>
+          </a:bodyPr>
+          <a:lstStyle/>
+          <a:p>
+            <a:pPr algn="ctr"/>
+            <a:r>
+              <a:rPr sz="1400" b="1">
+                <a:solidFill>
+                  <a:srgbClr val="6B46C1"/>
+                </a:solidFill>
+                <a:latin typeface="阿里巴巴普惠体 3.0"/>
+              </a:rPr>
+              <a:t>SQL工坊</a:t>
+            </a:r>
           </a:p>
         </p:txBody>
       </p:sp>
@@ -3453,8 +3410,8 @@
         </p:nvSpPr>
         <p:spPr>
           <a:xfrm>
-            <a:off x="3657600" y="1737360"/>
-            <a:ext cx="1920240" cy="365760"/>
+            <a:off x="8305495" y="5056631"/>
+            <a:ext cx="1828800" cy="365760"/>
           </a:xfrm>
           <a:prstGeom prst="rect">
             <a:avLst/>
@@ -3471,80 +3428,10 @@
             <a:r>
               <a:rPr sz="1400" b="1">
                 <a:solidFill>
-                  <a:srgbClr val="007396"/>
+                  <a:srgbClr val="10B981"/>
                 </a:solidFill>
                 <a:latin typeface="阿里巴巴普惠体 3.0"/>
               </a:rPr>
-              <a:t>灵梭</a:t>
-            </a:r>
-          </a:p>
-        </p:txBody>
-      </p:sp>
-      <p:sp>
-        <p:nvSpPr>
-          <p:cNvPr id="11" name="TextBox 10"/>
-          <p:cNvSpPr txBox="1"/>
-          <p:nvPr/>
-        </p:nvSpPr>
-        <p:spPr>
-          <a:xfrm>
-            <a:off x="5364784" y="1737360"/>
-            <a:ext cx="1920240" cy="365760"/>
-          </a:xfrm>
-          <a:prstGeom prst="rect">
-            <a:avLst/>
-          </a:prstGeom>
-          <a:noFill/>
-        </p:spPr>
-        <p:txBody>
-          <a:bodyPr wrap="square">
-            <a:spAutoFit/>
-          </a:bodyPr>
-          <a:lstStyle/>
-          <a:p>
-            <a:pPr algn="ctr"/>
-            <a:r>
-              <a:rPr sz="1400" b="1">
-                <a:solidFill>
-                  <a:srgbClr val="6B46C1"/>
-                </a:solidFill>
-                <a:latin typeface="阿里巴巴普惠体 3.0"/>
-              </a:rPr>
-              <a:t>SQL工坊</a:t>
-            </a:r>
-          </a:p>
-        </p:txBody>
-      </p:sp>
-      <p:sp>
-        <p:nvSpPr>
-          <p:cNvPr id="12" name="TextBox 11"/>
-          <p:cNvSpPr txBox="1"/>
-          <p:nvPr/>
-        </p:nvSpPr>
-        <p:spPr>
-          <a:xfrm>
-            <a:off x="7071055" y="1737360"/>
-            <a:ext cx="1920240" cy="365760"/>
-          </a:xfrm>
-          <a:prstGeom prst="rect">
-            <a:avLst/>
-          </a:prstGeom>
-          <a:noFill/>
-        </p:spPr>
-        <p:txBody>
-          <a:bodyPr wrap="square">
-            <a:spAutoFit/>
-          </a:bodyPr>
-          <a:lstStyle/>
-          <a:p>
-            <a:pPr algn="ctr"/>
-            <a:r>
-              <a:rPr sz="1400" b="1">
-                <a:solidFill>
-                  <a:srgbClr val="10B981"/>
-                </a:solidFill>
-                <a:latin typeface="阿里巴巴普惠体 3.0"/>
-              </a:rPr>
               <a:t>SQL工坊 MCP</a:t>
             </a:r>
           </a:p>
@@ -3552,77 +3439,7 @@
       </p:sp>
       <p:sp>
         <p:nvSpPr>
-          <p:cNvPr id="13" name="TextBox 12"/>
-          <p:cNvSpPr txBox="1"/>
-          <p:nvPr/>
-        </p:nvSpPr>
-        <p:spPr>
-          <a:xfrm>
-            <a:off x="914400" y="3931920"/>
-            <a:ext cx="10362895" cy="1280160"/>
-          </a:xfrm>
-          <a:prstGeom prst="rect">
-            <a:avLst/>
-          </a:prstGeom>
-          <a:noFill/>
-        </p:spPr>
-        <p:txBody>
-          <a:bodyPr wrap="square">
-            <a:spAutoFit/>
-          </a:bodyPr>
-          <a:lstStyle/>
-          <a:p>
-            <a:pPr algn="ctr"/>
-            <a:r>
-              <a:rPr sz="7200" b="1">
-                <a:solidFill>
-                  <a:srgbClr val="1F2937"/>
-                </a:solidFill>
-                <a:latin typeface="Inter"/>
-              </a:rPr>
-              <a:t>JavaBrain</a:t>
-            </a:r>
-          </a:p>
-        </p:txBody>
-      </p:sp>
-      <p:sp>
-        <p:nvSpPr>
-          <p:cNvPr id="14" name="TextBox 13"/>
-          <p:cNvSpPr txBox="1"/>
-          <p:nvPr/>
-        </p:nvSpPr>
-        <p:spPr>
-          <a:xfrm>
-            <a:off x="914400" y="5212080"/>
-            <a:ext cx="10362895" cy="457200"/>
-          </a:xfrm>
-          <a:prstGeom prst="rect">
-            <a:avLst/>
-          </a:prstGeom>
-          <a:noFill/>
-        </p:spPr>
-        <p:txBody>
-          <a:bodyPr wrap="square">
-            <a:spAutoFit/>
-          </a:bodyPr>
-          <a:lstStyle/>
-          <a:p>
-            <a:pPr algn="ctr"/>
-            <a:r>
-              <a:rPr sz="2400" b="0">
-                <a:solidFill>
-                  <a:srgbClr val="6B7280"/>
-                </a:solidFill>
-                <a:latin typeface="阿里巴巴普惠体 3.0"/>
-              </a:rPr>
-              <a:t>让您的系统瞬间拥有“思考”与“执行”的智能大脑</a:t>
-            </a:r>
-          </a:p>
-        </p:txBody>
-      </p:sp>
-      <p:sp>
-        <p:nvSpPr>
-          <p:cNvPr id="15" name="Rounded Rectangle 14"/>
+          <p:cNvPr id="11" name="Rounded Rectangle 10"/>
           <p:cNvSpPr/>
           <p:nvPr/>
         </p:nvSpPr>
@@ -3665,7 +3482,7 @@
       </p:sp>
       <p:sp>
         <p:nvSpPr>
-          <p:cNvPr id="16" name="TextBox 15"/>
+          <p:cNvPr id="12" name="TextBox 11"/>
           <p:cNvSpPr txBox="1"/>
           <p:nvPr/>
         </p:nvSpPr>
@@ -3729,7 +3546,7 @@
             <p:tnCond val="0"/>
           </p:cond>
           <p:par>
-            <p:cTn id="5" nodeType="withEffect" dur="500" begin="300ms" fill="hold">
+            <p:cTn id="5" nodeType="withEffect" dur="500" begin="400ms" fill="hold">
               <p:animEffect presetClass="entr" presetId="10" dur="500"/>
             </p:cTn>
           </p:par>
@@ -3746,7 +3563,7 @@
             <p:tnCond val="0"/>
           </p:cond>
           <p:par>
-            <p:cTn id="6" nodeType="withEffect" dur="500" begin="600ms" fill="hold">
+            <p:cTn id="6" nodeType="withEffect" dur="500" begin="800ms" fill="hold">
               <p:animEffect presetClass="entr" presetId="10" dur="500"/>
             </p:cTn>
           </p:par>
@@ -3763,7 +3580,7 @@
             <p:tnCond val="0"/>
           </p:cond>
           <p:par>
-            <p:cTn id="14" nodeType="withEffect" dur="500" begin="900ms" fill="hold">
+            <p:cTn id="9" nodeType="withEffect" dur="500" begin="1000ms" fill="hold">
               <p:animEffect presetClass="entr" presetId="10" dur="500"/>
             </p:cTn>
           </p:par>
@@ -3780,7 +3597,7 @@
             <p:tnCond val="0"/>
           </p:cond>
           <p:par>
-            <p:cTn id="16" nodeType="withEffect" dur="500" begin="1400ms" fill="hold">
+            <p:cTn id="12" nodeType="withEffect" dur="500" begin="1400ms" fill="hold">
               <p:animEffect presetClass="entr" presetId="10" dur="500"/>
             </p:cTn>
           </p:par>

</xml_diff>

<commit_message>
refactor(ppt): P1 金钩改文案 + 删 P4-a/P5-a 页码提示 + P9 字号
P1 金钩 '3 组件 · 1 starter · 0 漂移' → '3 分钟接入 AI'
- 数字钩呼应 P2 时间轴结论(3 分)
- P1 不必强调 starter(MCP 算 sql-forge 范畴,3 组件
  叙事在 P3 已有);0 漂移概念太技术,放封面不直观
- 字号 18pt → 22pt 加强冲击

P4-a 删 '▼ 下一页 · 6 大功能模块' 提示
P5-a 删 '▼ 下一页 · 4 starter + 6 功能' 提示
- 讲者自己翻页,页码提示多余

P9 字号调整(信息密度高,注脚偏小):
- 卡片标题 14pt → 15pt
- 卡片描述 11pt → 13pt
- 底部金钩 14pt → 15pt

P5-b 第二行 3 卡(Amis/实体/零直连)和 P6/P7
S1-S5 步骤(用户提问/NL2SQL/...)实际 PPT 内容齐全,
预览图 PIL 字体不支持 emoji 才显示为方框.

verify_t1/t3/t7 全过,12 页 87 动画 14 pulse_loop
保持不变. verify_t1.py 同步更新金钩文案.
</commit_message>
<xml_diff>
--- a/docs/ppt/javabrain.pptx
+++ b/docs/ppt/javabrain.pptx
@@ -3504,13 +3504,13 @@
           <a:p>
             <a:pPr algn="ctr"/>
             <a:r>
-              <a:rPr sz="1800" b="1">
+              <a:rPr sz="2200" b="1">
                 <a:solidFill>
                   <a:srgbClr val="FFFFFF"/>
                 </a:solidFill>
                 <a:latin typeface="阿里巴巴普惠体 3.0"/>
               </a:rPr>
-              <a:t>3 组件 · 1 starter · 0 漂移</a:t>
+              <a:t>3 分钟接入 AI</a:t>
             </a:r>
           </a:p>
         </p:txBody>
@@ -4811,7 +4811,7 @@
           <a:p>
             <a:pPr algn="ctr"/>
             <a:r>
-              <a:rPr sz="1400" b="1">
+              <a:rPr sz="1500" b="1">
                 <a:solidFill>
                   <a:srgbClr val="007396"/>
                 </a:solidFill>
@@ -4846,7 +4846,7 @@
           <a:p>
             <a:pPr algn="ctr"/>
             <a:r>
-              <a:rPr sz="1100" b="0">
+              <a:rPr sz="1300" b="0">
                 <a:solidFill>
                   <a:srgbClr val="6B7280"/>
                 </a:solidFill>
@@ -4926,7 +4926,7 @@
           <a:p>
             <a:pPr algn="ctr"/>
             <a:r>
-              <a:rPr sz="1400" b="1">
+              <a:rPr sz="1500" b="1">
                 <a:solidFill>
                   <a:srgbClr val="007396"/>
                 </a:solidFill>
@@ -4961,7 +4961,7 @@
           <a:p>
             <a:pPr algn="ctr"/>
             <a:r>
-              <a:rPr sz="1100" b="0">
+              <a:rPr sz="1300" b="0">
                 <a:solidFill>
                   <a:srgbClr val="6B7280"/>
                 </a:solidFill>
@@ -5041,7 +5041,7 @@
           <a:p>
             <a:pPr algn="ctr"/>
             <a:r>
-              <a:rPr sz="1400" b="1">
+              <a:rPr sz="1500" b="1">
                 <a:solidFill>
                   <a:srgbClr val="007396"/>
                 </a:solidFill>
@@ -5076,7 +5076,7 @@
           <a:p>
             <a:pPr algn="ctr"/>
             <a:r>
-              <a:rPr sz="1100" b="0">
+              <a:rPr sz="1300" b="0">
                 <a:solidFill>
                   <a:srgbClr val="6B7280"/>
                 </a:solidFill>
@@ -5156,7 +5156,7 @@
           <a:p>
             <a:pPr algn="ctr"/>
             <a:r>
-              <a:rPr sz="1400" b="1">
+              <a:rPr sz="1500" b="1">
                 <a:solidFill>
                   <a:srgbClr val="007396"/>
                 </a:solidFill>
@@ -5191,7 +5191,7 @@
           <a:p>
             <a:pPr algn="ctr"/>
             <a:r>
-              <a:rPr sz="1100" b="0">
+              <a:rPr sz="1300" b="0">
                 <a:solidFill>
                   <a:srgbClr val="6B7280"/>
                 </a:solidFill>
@@ -5306,7 +5306,7 @@
           <a:p>
             <a:pPr algn="ctr"/>
             <a:r>
-              <a:rPr sz="1400" b="1">
+              <a:rPr sz="1500" b="1">
                 <a:solidFill>
                   <a:srgbClr val="6B46C1"/>
                 </a:solidFill>
@@ -5341,7 +5341,7 @@
           <a:p>
             <a:pPr algn="ctr"/>
             <a:r>
-              <a:rPr sz="1100" b="0">
+              <a:rPr sz="1300" b="0">
                 <a:solidFill>
                   <a:srgbClr val="6B7280"/>
                 </a:solidFill>
@@ -5421,7 +5421,7 @@
           <a:p>
             <a:pPr algn="ctr"/>
             <a:r>
-              <a:rPr sz="1400" b="1">
+              <a:rPr sz="1500" b="1">
                 <a:solidFill>
                   <a:srgbClr val="6B46C1"/>
                 </a:solidFill>
@@ -5456,7 +5456,7 @@
           <a:p>
             <a:pPr algn="ctr"/>
             <a:r>
-              <a:rPr sz="1100" b="0">
+              <a:rPr sz="1300" b="0">
                 <a:solidFill>
                   <a:srgbClr val="6B7280"/>
                 </a:solidFill>
@@ -5536,7 +5536,7 @@
           <a:p>
             <a:pPr algn="ctr"/>
             <a:r>
-              <a:rPr sz="1400" b="1">
+              <a:rPr sz="1500" b="1">
                 <a:solidFill>
                   <a:srgbClr val="6B46C1"/>
                 </a:solidFill>
@@ -5571,7 +5571,7 @@
           <a:p>
             <a:pPr algn="ctr"/>
             <a:r>
-              <a:rPr sz="1100" b="0">
+              <a:rPr sz="1300" b="0">
                 <a:solidFill>
                   <a:srgbClr val="6B7280"/>
                 </a:solidFill>
@@ -5651,7 +5651,7 @@
           <a:p>
             <a:pPr algn="ctr"/>
             <a:r>
-              <a:rPr sz="1400" b="1">
+              <a:rPr sz="1500" b="1">
                 <a:solidFill>
                   <a:srgbClr val="6B46C1"/>
                 </a:solidFill>
@@ -5686,7 +5686,7 @@
           <a:p>
             <a:pPr algn="ctr"/>
             <a:r>
-              <a:rPr sz="1100" b="0">
+              <a:rPr sz="1300" b="0">
                 <a:solidFill>
                   <a:srgbClr val="6B7280"/>
                 </a:solidFill>
@@ -5766,7 +5766,7 @@
           <a:p>
             <a:pPr algn="ctr"/>
             <a:r>
-              <a:rPr sz="1400" b="1">
+              <a:rPr sz="1500" b="1">
                 <a:solidFill>
                   <a:srgbClr val="F59E0B"/>
                 </a:solidFill>
@@ -5846,7 +5846,7 @@
           <a:p>
             <a:pPr algn="ctr"/>
             <a:r>
-              <a:rPr sz="1400" b="1">
+              <a:rPr sz="1500" b="1">
                 <a:solidFill>
                   <a:srgbClr val="F59E0B"/>
                 </a:solidFill>
@@ -5926,7 +5926,7 @@
           <a:p>
             <a:pPr algn="ctr"/>
             <a:r>
-              <a:rPr sz="1400" b="1">
+              <a:rPr sz="1500" b="1">
                 <a:solidFill>
                   <a:srgbClr val="F59E0B"/>
                 </a:solidFill>
@@ -9507,41 +9507,6 @@
           </a:p>
         </p:txBody>
       </p:sp>
-      <p:sp>
-        <p:nvSpPr>
-          <p:cNvPr id="12" name="TextBox 11"/>
-          <p:cNvSpPr txBox="1"/>
-          <p:nvPr/>
-        </p:nvSpPr>
-        <p:spPr>
-          <a:xfrm>
-            <a:off x="457200" y="5486400"/>
-            <a:ext cx="11277295" cy="365760"/>
-          </a:xfrm>
-          <a:prstGeom prst="rect">
-            <a:avLst/>
-          </a:prstGeom>
-          <a:noFill/>
-        </p:spPr>
-        <p:txBody>
-          <a:bodyPr wrap="square">
-            <a:spAutoFit/>
-          </a:bodyPr>
-          <a:lstStyle/>
-          <a:p>
-            <a:pPr algn="ctr"/>
-            <a:r>
-              <a:rPr sz="1600" b="1">
-                <a:solidFill>
-                  <a:srgbClr val="6B46C1"/>
-                </a:solidFill>
-                <a:latin typeface="阿里巴巴普惠体 3.0"/>
-              </a:rPr>
-              <a:t>▼ 下一页 · 6 大功能模块</a:t>
-            </a:r>
-          </a:p>
-        </p:txBody>
-      </p:sp>
     </p:spTree>
   </p:cSld>
   <p:clrMapOvr>
@@ -10964,41 +10929,6 @@
           <a:p>
             <a:r>
               <a:t>数据不出企业</a:t>
-            </a:r>
-          </a:p>
-        </p:txBody>
-      </p:sp>
-      <p:sp>
-        <p:nvSpPr>
-          <p:cNvPr id="12" name="TextBox 11"/>
-          <p:cNvSpPr txBox="1"/>
-          <p:nvPr/>
-        </p:nvSpPr>
-        <p:spPr>
-          <a:xfrm>
-            <a:off x="457200" y="5486400"/>
-            <a:ext cx="11277295" cy="365760"/>
-          </a:xfrm>
-          <a:prstGeom prst="rect">
-            <a:avLst/>
-          </a:prstGeom>
-          <a:noFill/>
-        </p:spPr>
-        <p:txBody>
-          <a:bodyPr wrap="square">
-            <a:spAutoFit/>
-          </a:bodyPr>
-          <a:lstStyle/>
-          <a:p>
-            <a:pPr algn="ctr"/>
-            <a:r>
-              <a:rPr sz="1600" b="1">
-                <a:solidFill>
-                  <a:srgbClr val="6B46C1"/>
-                </a:solidFill>
-                <a:latin typeface="阿里巴巴普惠体 3.0"/>
-              </a:rPr>
-              <a:t>▼ 下一页 · 4 starter + 6 功能</a:t>
             </a:r>
           </a:p>
         </p:txBody>

</xml_diff>

<commit_message>
feat(ppt): P10 加 JavaBrain logo + 12 页统一加页码
- P10 标题上方加 JavaBrain 大脑+积木 logo(透明背景版 p10_brain_logo.png)
  - 大字下移至 y=0.75,字号 60pt,与 logo 上下呼应不重叠
- 12 页统一加右下角页码 'XX / 12'(灰色 10pt,品牌系统一致)
- P4-a/P5-a 改 3 步进阶后验证测试同步更新
- 累计 98 动画 + 14 indefinite,12 页全部通过 verify_t1/t3/t7

Co-Authored-By: Claude Fable 5 <noreply@anthropic.com>
</commit_message>
<xml_diff>
--- a/docs/ppt/javabrain.pptx
+++ b/docs/ppt/javabrain.pptx
@@ -3515,6 +3515,41 @@
           </a:p>
         </p:txBody>
       </p:sp>
+      <p:sp>
+        <p:nvSpPr>
+          <p:cNvPr id="13" name="TextBox 12"/>
+          <p:cNvSpPr txBox="1"/>
+          <p:nvPr/>
+        </p:nvSpPr>
+        <p:spPr>
+          <a:xfrm>
+            <a:off x="10607040" y="6446520"/>
+            <a:ext cx="1280160" cy="274320"/>
+          </a:xfrm>
+          <a:prstGeom prst="rect">
+            <a:avLst/>
+          </a:prstGeom>
+          <a:noFill/>
+        </p:spPr>
+        <p:txBody>
+          <a:bodyPr wrap="square">
+            <a:spAutoFit/>
+          </a:bodyPr>
+          <a:lstStyle/>
+          <a:p>
+            <a:pPr algn="ctr"/>
+            <a:r>
+              <a:rPr sz="1000" b="0">
+                <a:solidFill>
+                  <a:srgbClr val="6B7280"/>
+                </a:solidFill>
+                <a:latin typeface="Inter"/>
+              </a:rPr>
+              <a:t>01 / 12</a:t>
+            </a:r>
+          </a:p>
+        </p:txBody>
+      </p:sp>
     </p:spTree>
   </p:cSld>
   <p:clrMapOvr>
@@ -3634,23 +3669,23 @@
         </p:nvSpPr>
         <p:spPr>
           <a:xfrm>
-            <a:off x="457200" y="365760"/>
-            <a:ext cx="11277295" cy="548640"/>
-          </a:xfrm>
-          <a:prstGeom prst="rect">
-            <a:avLst/>
-          </a:prstGeom>
-          <a:noFill/>
-        </p:spPr>
-        <p:txBody>
-          <a:bodyPr wrap="square">
-            <a:spAutoFit/>
-          </a:bodyPr>
-          <a:lstStyle/>
-          <a:p>
-            <a:pPr algn="ctr"/>
-            <a:r>
-              <a:rPr sz="2800" b="1">
+            <a:off x="457200" y="274320"/>
+            <a:ext cx="11277295" cy="457200"/>
+          </a:xfrm>
+          <a:prstGeom prst="rect">
+            <a:avLst/>
+          </a:prstGeom>
+          <a:noFill/>
+        </p:spPr>
+        <p:txBody>
+          <a:bodyPr wrap="square">
+            <a:spAutoFit/>
+          </a:bodyPr>
+          <a:lstStyle/>
+          <a:p>
+            <a:pPr algn="ctr"/>
+            <a:r>
+              <a:rPr sz="2400" b="1">
                 <a:solidFill>
                   <a:srgbClr val="1F2937"/>
                 </a:solidFill>
@@ -3669,23 +3704,23 @@
         </p:nvSpPr>
         <p:spPr>
           <a:xfrm>
-            <a:off x="457200" y="1188720"/>
-            <a:ext cx="5029200" cy="365760"/>
-          </a:xfrm>
-          <a:prstGeom prst="rect">
-            <a:avLst/>
-          </a:prstGeom>
-          <a:noFill/>
-        </p:spPr>
-        <p:txBody>
-          <a:bodyPr wrap="square">
-            <a:spAutoFit/>
-          </a:bodyPr>
-          <a:lstStyle/>
-          <a:p>
-            <a:pPr algn="ctr"/>
-            <a:r>
-              <a:rPr sz="1800" b="1">
+            <a:off x="274320" y="868680"/>
+            <a:ext cx="3657600" cy="320040"/>
+          </a:xfrm>
+          <a:prstGeom prst="rect">
+            <a:avLst/>
+          </a:prstGeom>
+          <a:noFill/>
+        </p:spPr>
+        <p:txBody>
+          <a:bodyPr wrap="square">
+            <a:spAutoFit/>
+          </a:bodyPr>
+          <a:lstStyle/>
+          <a:p>
+            <a:pPr algn="ctr"/>
+            <a:r>
+              <a:rPr sz="1500" b="1">
                 <a:solidFill>
                   <a:srgbClr val="007396"/>
                 </a:solidFill>
@@ -3704,29 +3739,29 @@
         </p:nvSpPr>
         <p:spPr>
           <a:xfrm>
-            <a:off x="640080" y="1737360"/>
-            <a:ext cx="5486400" cy="457200"/>
-          </a:xfrm>
-          <a:prstGeom prst="rect">
-            <a:avLst/>
-          </a:prstGeom>
-          <a:noFill/>
-        </p:spPr>
-        <p:txBody>
-          <a:bodyPr wrap="square">
-            <a:spAutoFit/>
-          </a:bodyPr>
-          <a:lstStyle/>
-          <a:p>
-            <a:pPr algn="ctr"/>
-            <a:r>
-              <a:rPr sz="1600" b="0">
+            <a:off x="365760" y="1371600"/>
+            <a:ext cx="3657600" cy="365760"/>
+          </a:xfrm>
+          <a:prstGeom prst="rect">
+            <a:avLst/>
+          </a:prstGeom>
+          <a:noFill/>
+        </p:spPr>
+        <p:txBody>
+          <a:bodyPr wrap="square">
+            <a:spAutoFit/>
+          </a:bodyPr>
+          <a:lstStyle/>
+          <a:p>
+            <a:pPr algn="ctr"/>
+            <a:r>
+              <a:rPr sz="1300" b="0">
                 <a:solidFill>
                   <a:srgbClr val="1F2937"/>
                 </a:solidFill>
                 <a:latin typeface="阿里巴巴普惠体 3.0"/>
               </a:rPr>
-              <a:t>✓ 7 张表测试(简单/字典/自关联/多外键)</a:t>
+              <a:t>✓ 7 张表测试(简单/字典/自关联)</a:t>
             </a:r>
           </a:p>
         </p:txBody>
@@ -3739,29 +3774,29 @@
         </p:nvSpPr>
         <p:spPr>
           <a:xfrm>
-            <a:off x="640080" y="2377439"/>
-            <a:ext cx="5486400" cy="457200"/>
-          </a:xfrm>
-          <a:prstGeom prst="rect">
-            <a:avLst/>
-          </a:prstGeom>
-          <a:noFill/>
-        </p:spPr>
-        <p:txBody>
-          <a:bodyPr wrap="square">
-            <a:spAutoFit/>
-          </a:bodyPr>
-          <a:lstStyle/>
-          <a:p>
-            <a:pPr algn="ctr"/>
-            <a:r>
-              <a:rPr sz="1600" b="0">
+            <a:off x="365760" y="1874519"/>
+            <a:ext cx="3657600" cy="365760"/>
+          </a:xfrm>
+          <a:prstGeom prst="rect">
+            <a:avLst/>
+          </a:prstGeom>
+          <a:noFill/>
+        </p:spPr>
+        <p:txBody>
+          <a:bodyPr wrap="square">
+            <a:spAutoFit/>
+          </a:bodyPr>
+          <a:lstStyle/>
+          <a:p>
+            <a:pPr algn="ctr"/>
+            <a:r>
+              <a:rPr sz="1300" b="0">
                 <a:solidFill>
                   <a:srgbClr val="1F2937"/>
                 </a:solidFill>
                 <a:latin typeface="阿里巴巴普惠体 3.0"/>
               </a:rPr>
-              <a:t>✓ 0 漂移 / 0 错误链接 / 0 中文乱码</a:t>
+              <a:t>✓ 0 漂移 / 0 错误链接 / 0 乱码</a:t>
             </a:r>
           </a:p>
         </p:txBody>
@@ -3774,23 +3809,23 @@
         </p:nvSpPr>
         <p:spPr>
           <a:xfrm>
-            <a:off x="640080" y="3017520"/>
-            <a:ext cx="5486400" cy="457200"/>
-          </a:xfrm>
-          <a:prstGeom prst="rect">
-            <a:avLst/>
-          </a:prstGeom>
-          <a:noFill/>
-        </p:spPr>
-        <p:txBody>
-          <a:bodyPr wrap="square">
-            <a:spAutoFit/>
-          </a:bodyPr>
-          <a:lstStyle/>
-          <a:p>
-            <a:pPr algn="ctr"/>
-            <a:r>
-              <a:rPr sz="1600" b="0">
+            <a:off x="365760" y="2377440"/>
+            <a:ext cx="3657600" cy="365760"/>
+          </a:xfrm>
+          <a:prstGeom prst="rect">
+            <a:avLst/>
+          </a:prstGeom>
+          <a:noFill/>
+        </p:spPr>
+        <p:txBody>
+          <a:bodyPr wrap="square">
+            <a:spAutoFit/>
+          </a:bodyPr>
+          <a:lstStyle/>
+          <a:p>
+            <a:pPr algn="ctr"/>
+            <a:r>
+              <a:rPr sz="1300" b="0">
                 <a:solidFill>
                   <a:srgbClr val="1F2937"/>
                 </a:solidFill>
@@ -3809,23 +3844,23 @@
         </p:nvSpPr>
         <p:spPr>
           <a:xfrm>
-            <a:off x="640080" y="3657599"/>
-            <a:ext cx="5486400" cy="457200"/>
-          </a:xfrm>
-          <a:prstGeom prst="rect">
-            <a:avLst/>
-          </a:prstGeom>
-          <a:noFill/>
-        </p:spPr>
-        <p:txBody>
-          <a:bodyPr wrap="square">
-            <a:spAutoFit/>
-          </a:bodyPr>
-          <a:lstStyle/>
-          <a:p>
-            <a:pPr algn="ctr"/>
-            <a:r>
-              <a:rPr sz="1600" b="1">
+            <a:off x="365760" y="2880360"/>
+            <a:ext cx="3657600" cy="365760"/>
+          </a:xfrm>
+          <a:prstGeom prst="rect">
+            <a:avLst/>
+          </a:prstGeom>
+          <a:noFill/>
+        </p:spPr>
+        <p:txBody>
+          <a:bodyPr wrap="square">
+            <a:spAutoFit/>
+          </a:bodyPr>
+          <a:lstStyle/>
+          <a:p>
+            <a:pPr algn="ctr"/>
+            <a:r>
+              <a:rPr sz="1300" b="1">
                 <a:solidFill>
                   <a:srgbClr val="F59E0B"/>
                 </a:solidFill>
@@ -3844,29 +3879,29 @@
         </p:nvSpPr>
         <p:spPr>
           <a:xfrm>
-            <a:off x="6400800" y="1188720"/>
-            <a:ext cx="5029200" cy="365760"/>
-          </a:xfrm>
-          <a:prstGeom prst="rect">
-            <a:avLst/>
-          </a:prstGeom>
-          <a:noFill/>
-        </p:spPr>
-        <p:txBody>
-          <a:bodyPr wrap="square">
-            <a:spAutoFit/>
-          </a:bodyPr>
-          <a:lstStyle/>
-          <a:p>
-            <a:pPr algn="ctr"/>
-            <a:r>
-              <a:rPr sz="1800" b="1">
+            <a:off x="4297680" y="868680"/>
+            <a:ext cx="3200400" cy="320040"/>
+          </a:xfrm>
+          <a:prstGeom prst="rect">
+            <a:avLst/>
+          </a:prstGeom>
+          <a:noFill/>
+        </p:spPr>
+        <p:txBody>
+          <a:bodyPr wrap="square">
+            <a:spAutoFit/>
+          </a:bodyPr>
+          <a:lstStyle/>
+          <a:p>
+            <a:pPr algn="ctr"/>
+            <a:r>
+              <a:rPr sz="1500" b="1">
                 <a:solidFill>
                   <a:srgbClr val="6B46C1"/>
                 </a:solidFill>
                 <a:latin typeface="阿里巴巴普惠体 3.0"/>
               </a:rPr>
-              <a:t>商业派 · 5 项对比</a:t>
+              <a:t>开发时间 · 3 种方案</a:t>
             </a:r>
           </a:p>
         </p:txBody>
@@ -3879,8 +3914,382 @@
         </p:nvSpPr>
         <p:spPr>
           <a:xfrm>
-            <a:off x="6400800" y="1737360"/>
-            <a:ext cx="5029200" cy="411480"/>
+            <a:off x="4480560" y="2011680"/>
+            <a:ext cx="822960" cy="2560320"/>
+          </a:xfrm>
+          <a:prstGeom prst="rect">
+            <a:avLst/>
+          </a:prstGeom>
+          <a:solidFill>
+            <a:srgbClr val="E5E7EB"/>
+          </a:solidFill>
+          <a:ln>
+            <a:noFill/>
+          </a:ln>
+        </p:spPr>
+        <p:style>
+          <a:lnRef idx="1">
+            <a:schemeClr val="accent1"/>
+          </a:lnRef>
+          <a:fillRef idx="3">
+            <a:schemeClr val="accent1"/>
+          </a:fillRef>
+          <a:effectRef idx="2">
+            <a:schemeClr val="accent1"/>
+          </a:effectRef>
+          <a:fontRef idx="minor">
+            <a:schemeClr val="lt1"/>
+          </a:fontRef>
+        </p:style>
+        <p:txBody>
+          <a:bodyPr rtlCol="0" anchor="ctr"/>
+          <a:lstStyle/>
+          <a:p>
+            <a:pPr algn="ctr"/>
+          </a:p>
+        </p:txBody>
+      </p:sp>
+      <p:sp>
+        <p:nvSpPr>
+          <p:cNvPr id="10" name="TextBox 9"/>
+          <p:cNvSpPr txBox="1"/>
+          <p:nvPr/>
+        </p:nvSpPr>
+        <p:spPr>
+          <a:xfrm>
+            <a:off x="4480560" y="1691640"/>
+            <a:ext cx="822960" cy="274320"/>
+          </a:xfrm>
+          <a:prstGeom prst="rect">
+            <a:avLst/>
+          </a:prstGeom>
+          <a:noFill/>
+        </p:spPr>
+        <p:txBody>
+          <a:bodyPr wrap="square">
+            <a:spAutoFit/>
+          </a:bodyPr>
+          <a:lstStyle/>
+          <a:p>
+            <a:pPr algn="ctr"/>
+            <a:r>
+              <a:rPr sz="1100" b="1">
+                <a:solidFill>
+                  <a:srgbClr val="E5E7EB"/>
+                </a:solidFill>
+                <a:latin typeface="阿里巴巴普惠体 3.0"/>
+              </a:rPr>
+              <a:t>30天</a:t>
+            </a:r>
+          </a:p>
+        </p:txBody>
+      </p:sp>
+      <p:sp>
+        <p:nvSpPr>
+          <p:cNvPr id="11" name="TextBox 10"/>
+          <p:cNvSpPr txBox="1"/>
+          <p:nvPr/>
+        </p:nvSpPr>
+        <p:spPr>
+          <a:xfrm>
+            <a:off x="4480560" y="4709160"/>
+            <a:ext cx="822960" cy="274320"/>
+          </a:xfrm>
+          <a:prstGeom prst="rect">
+            <a:avLst/>
+          </a:prstGeom>
+          <a:noFill/>
+        </p:spPr>
+        <p:txBody>
+          <a:bodyPr wrap="square">
+            <a:spAutoFit/>
+          </a:bodyPr>
+          <a:lstStyle/>
+          <a:p>
+            <a:pPr algn="ctr"/>
+            <a:r>
+              <a:rPr sz="1100" b="1">
+                <a:solidFill>
+                  <a:srgbClr val="1F2937"/>
+                </a:solidFill>
+                <a:latin typeface="阿里巴巴普惠体 3.0"/>
+              </a:rPr>
+              <a:t>传统开发</a:t>
+            </a:r>
+          </a:p>
+        </p:txBody>
+      </p:sp>
+      <p:sp>
+        <p:nvSpPr>
+          <p:cNvPr id="12" name="Rectangle 11"/>
+          <p:cNvSpPr/>
+          <p:nvPr/>
+        </p:nvSpPr>
+        <p:spPr>
+          <a:xfrm>
+            <a:off x="5532120" y="3718560"/>
+            <a:ext cx="822960" cy="853439"/>
+          </a:xfrm>
+          <a:prstGeom prst="rect">
+            <a:avLst/>
+          </a:prstGeom>
+          <a:solidFill>
+            <a:srgbClr val="DC2626"/>
+          </a:solidFill>
+          <a:ln>
+            <a:noFill/>
+          </a:ln>
+        </p:spPr>
+        <p:style>
+          <a:lnRef idx="1">
+            <a:schemeClr val="accent1"/>
+          </a:lnRef>
+          <a:fillRef idx="3">
+            <a:schemeClr val="accent1"/>
+          </a:fillRef>
+          <a:effectRef idx="2">
+            <a:schemeClr val="accent1"/>
+          </a:effectRef>
+          <a:fontRef idx="minor">
+            <a:schemeClr val="lt1"/>
+          </a:fontRef>
+        </p:style>
+        <p:txBody>
+          <a:bodyPr rtlCol="0" anchor="ctr"/>
+          <a:lstStyle/>
+          <a:p>
+            <a:pPr algn="ctr"/>
+          </a:p>
+        </p:txBody>
+      </p:sp>
+      <p:sp>
+        <p:nvSpPr>
+          <p:cNvPr id="13" name="TextBox 12"/>
+          <p:cNvSpPr txBox="1"/>
+          <p:nvPr/>
+        </p:nvSpPr>
+        <p:spPr>
+          <a:xfrm>
+            <a:off x="5532120" y="3398519"/>
+            <a:ext cx="822960" cy="274320"/>
+          </a:xfrm>
+          <a:prstGeom prst="rect">
+            <a:avLst/>
+          </a:prstGeom>
+          <a:noFill/>
+        </p:spPr>
+        <p:txBody>
+          <a:bodyPr wrap="square">
+            <a:spAutoFit/>
+          </a:bodyPr>
+          <a:lstStyle/>
+          <a:p>
+            <a:pPr algn="ctr"/>
+            <a:r>
+              <a:rPr sz="1100" b="1">
+                <a:solidFill>
+                  <a:srgbClr val="DC2626"/>
+                </a:solidFill>
+                <a:latin typeface="阿里巴巴普惠体 3.0"/>
+              </a:rPr>
+              <a:t>10天</a:t>
+            </a:r>
+          </a:p>
+        </p:txBody>
+      </p:sp>
+      <p:sp>
+        <p:nvSpPr>
+          <p:cNvPr id="14" name="TextBox 13"/>
+          <p:cNvSpPr txBox="1"/>
+          <p:nvPr/>
+        </p:nvSpPr>
+        <p:spPr>
+          <a:xfrm>
+            <a:off x="5532120" y="4709160"/>
+            <a:ext cx="822960" cy="274320"/>
+          </a:xfrm>
+          <a:prstGeom prst="rect">
+            <a:avLst/>
+          </a:prstGeom>
+          <a:noFill/>
+        </p:spPr>
+        <p:txBody>
+          <a:bodyPr wrap="square">
+            <a:spAutoFit/>
+          </a:bodyPr>
+          <a:lstStyle/>
+          <a:p>
+            <a:pPr algn="ctr"/>
+            <a:r>
+              <a:rPr sz="1100" b="1">
+                <a:solidFill>
+                  <a:srgbClr val="1F2937"/>
+                </a:solidFill>
+                <a:latin typeface="阿里巴巴普惠体 3.0"/>
+              </a:rPr>
+              <a:t>集成 AI</a:t>
+            </a:r>
+          </a:p>
+        </p:txBody>
+      </p:sp>
+      <p:sp>
+        <p:nvSpPr>
+          <p:cNvPr id="15" name="Rectangle 14"/>
+          <p:cNvSpPr/>
+          <p:nvPr/>
+        </p:nvSpPr>
+        <p:spPr>
+          <a:xfrm>
+            <a:off x="6583680" y="4486656"/>
+            <a:ext cx="822960" cy="85343"/>
+          </a:xfrm>
+          <a:prstGeom prst="rect">
+            <a:avLst/>
+          </a:prstGeom>
+          <a:solidFill>
+            <a:srgbClr val="10B981"/>
+          </a:solidFill>
+          <a:ln>
+            <a:noFill/>
+          </a:ln>
+        </p:spPr>
+        <p:style>
+          <a:lnRef idx="1">
+            <a:schemeClr val="accent1"/>
+          </a:lnRef>
+          <a:fillRef idx="3">
+            <a:schemeClr val="accent1"/>
+          </a:fillRef>
+          <a:effectRef idx="2">
+            <a:schemeClr val="accent1"/>
+          </a:effectRef>
+          <a:fontRef idx="minor">
+            <a:schemeClr val="lt1"/>
+          </a:fontRef>
+        </p:style>
+        <p:txBody>
+          <a:bodyPr rtlCol="0" anchor="ctr"/>
+          <a:lstStyle/>
+          <a:p>
+            <a:pPr algn="ctr"/>
+          </a:p>
+        </p:txBody>
+      </p:sp>
+      <p:sp>
+        <p:nvSpPr>
+          <p:cNvPr id="16" name="TextBox 15"/>
+          <p:cNvSpPr txBox="1"/>
+          <p:nvPr/>
+        </p:nvSpPr>
+        <p:spPr>
+          <a:xfrm>
+            <a:off x="6583680" y="4166616"/>
+            <a:ext cx="822960" cy="274320"/>
+          </a:xfrm>
+          <a:prstGeom prst="rect">
+            <a:avLst/>
+          </a:prstGeom>
+          <a:noFill/>
+        </p:spPr>
+        <p:txBody>
+          <a:bodyPr wrap="square">
+            <a:spAutoFit/>
+          </a:bodyPr>
+          <a:lstStyle/>
+          <a:p>
+            <a:pPr algn="ctr"/>
+            <a:r>
+              <a:rPr sz="1100" b="1">
+                <a:solidFill>
+                  <a:srgbClr val="10B981"/>
+                </a:solidFill>
+                <a:latin typeface="阿里巴巴普惠体 3.0"/>
+              </a:rPr>
+              <a:t>1天</a:t>
+            </a:r>
+          </a:p>
+        </p:txBody>
+      </p:sp>
+      <p:sp>
+        <p:nvSpPr>
+          <p:cNvPr id="17" name="TextBox 16"/>
+          <p:cNvSpPr txBox="1"/>
+          <p:nvPr/>
+        </p:nvSpPr>
+        <p:spPr>
+          <a:xfrm>
+            <a:off x="6583680" y="4709160"/>
+            <a:ext cx="822960" cy="274320"/>
+          </a:xfrm>
+          <a:prstGeom prst="rect">
+            <a:avLst/>
+          </a:prstGeom>
+          <a:noFill/>
+        </p:spPr>
+        <p:txBody>
+          <a:bodyPr wrap="square">
+            <a:spAutoFit/>
+          </a:bodyPr>
+          <a:lstStyle/>
+          <a:p>
+            <a:pPr algn="ctr"/>
+            <a:r>
+              <a:rPr sz="1100" b="1">
+                <a:solidFill>
+                  <a:srgbClr val="1F2937"/>
+                </a:solidFill>
+                <a:latin typeface="阿里巴巴普惠体 3.0"/>
+              </a:rPr>
+              <a:t>JavaBrain</a:t>
+            </a:r>
+          </a:p>
+        </p:txBody>
+      </p:sp>
+      <p:sp>
+        <p:nvSpPr>
+          <p:cNvPr id="18" name="TextBox 17"/>
+          <p:cNvSpPr txBox="1"/>
+          <p:nvPr/>
+        </p:nvSpPr>
+        <p:spPr>
+          <a:xfrm>
+            <a:off x="7589520" y="868680"/>
+            <a:ext cx="4389120" cy="320040"/>
+          </a:xfrm>
+          <a:prstGeom prst="rect">
+            <a:avLst/>
+          </a:prstGeom>
+          <a:noFill/>
+        </p:spPr>
+        <p:txBody>
+          <a:bodyPr wrap="square">
+            <a:spAutoFit/>
+          </a:bodyPr>
+          <a:lstStyle/>
+          <a:p>
+            <a:pPr algn="ctr"/>
+            <a:r>
+              <a:rPr sz="1500" b="1">
+                <a:solidFill>
+                  <a:srgbClr val="6B46C1"/>
+                </a:solidFill>
+                <a:latin typeface="阿里巴巴普惠体 3.0"/>
+              </a:rPr>
+              <a:t>商业派 · 5 项对比</a:t>
+            </a:r>
+          </a:p>
+        </p:txBody>
+      </p:sp>
+      <p:sp>
+        <p:nvSpPr>
+          <p:cNvPr id="19" name="Rectangle 18"/>
+          <p:cNvSpPr/>
+          <p:nvPr/>
+        </p:nvSpPr>
+        <p:spPr>
+          <a:xfrm>
+            <a:off x="7589520" y="1371600"/>
+            <a:ext cx="4389120" cy="411480"/>
           </a:xfrm>
           <a:prstGeom prst="rect">
             <a:avLst/>
@@ -3918,28 +4327,28 @@
       </p:sp>
       <p:sp>
         <p:nvSpPr>
-          <p:cNvPr id="10" name="TextBox 9"/>
-          <p:cNvSpPr txBox="1"/>
-          <p:nvPr/>
-        </p:nvSpPr>
-        <p:spPr>
-          <a:xfrm>
-            <a:off x="6583680" y="1783080"/>
-            <a:ext cx="3200400" cy="365760"/>
-          </a:xfrm>
-          <a:prstGeom prst="rect">
-            <a:avLst/>
-          </a:prstGeom>
-          <a:noFill/>
-        </p:spPr>
-        <p:txBody>
-          <a:bodyPr wrap="square">
-            <a:spAutoFit/>
-          </a:bodyPr>
-          <a:lstStyle/>
-          <a:p>
-            <a:r>
-              <a:rPr sz="1600" b="0">
+          <p:cNvPr id="20" name="TextBox 19"/>
+          <p:cNvSpPr txBox="1"/>
+          <p:nvPr/>
+        </p:nvSpPr>
+        <p:spPr>
+          <a:xfrm>
+            <a:off x="7772400" y="1417320"/>
+            <a:ext cx="2743200" cy="365760"/>
+          </a:xfrm>
+          <a:prstGeom prst="rect">
+            <a:avLst/>
+          </a:prstGeom>
+          <a:noFill/>
+        </p:spPr>
+        <p:txBody>
+          <a:bodyPr wrap="square">
+            <a:spAutoFit/>
+          </a:bodyPr>
+          <a:lstStyle/>
+          <a:p>
+            <a:r>
+              <a:rPr sz="1400" b="0">
                 <a:solidFill>
                   <a:srgbClr val="1F2937"/>
                 </a:solidFill>
@@ -3952,29 +4361,29 @@
       </p:sp>
       <p:sp>
         <p:nvSpPr>
-          <p:cNvPr id="11" name="TextBox 10"/>
-          <p:cNvSpPr txBox="1"/>
-          <p:nvPr/>
-        </p:nvSpPr>
-        <p:spPr>
-          <a:xfrm>
-            <a:off x="9875520" y="1783080"/>
-            <a:ext cx="1371600" cy="365760"/>
-          </a:xfrm>
-          <a:prstGeom prst="rect">
-            <a:avLst/>
-          </a:prstGeom>
-          <a:noFill/>
-        </p:spPr>
-        <p:txBody>
-          <a:bodyPr wrap="square">
-            <a:spAutoFit/>
-          </a:bodyPr>
-          <a:lstStyle/>
-          <a:p>
-            <a:pPr algn="ctr"/>
-            <a:r>
-              <a:rPr sz="1800" b="1">
+          <p:cNvPr id="21" name="TextBox 20"/>
+          <p:cNvSpPr txBox="1"/>
+          <p:nvPr/>
+        </p:nvSpPr>
+        <p:spPr>
+          <a:xfrm>
+            <a:off x="10698480" y="1417320"/>
+            <a:ext cx="1097280" cy="365760"/>
+          </a:xfrm>
+          <a:prstGeom prst="rect">
+            <a:avLst/>
+          </a:prstGeom>
+          <a:noFill/>
+        </p:spPr>
+        <p:txBody>
+          <a:bodyPr wrap="square">
+            <a:spAutoFit/>
+          </a:bodyPr>
+          <a:lstStyle/>
+          <a:p>
+            <a:pPr algn="ctr"/>
+            <a:r>
+              <a:rPr sz="1600" b="1">
                 <a:solidFill>
                   <a:srgbClr val="10B981"/>
                 </a:solidFill>
@@ -3987,14 +4396,14 @@
       </p:sp>
       <p:sp>
         <p:nvSpPr>
-          <p:cNvPr id="12" name="Rectangle 11"/>
+          <p:cNvPr id="22" name="Rectangle 21"/>
           <p:cNvSpPr/>
           <p:nvPr/>
         </p:nvSpPr>
         <p:spPr>
           <a:xfrm>
-            <a:off x="6400800" y="2194560"/>
-            <a:ext cx="5029200" cy="411480"/>
+            <a:off x="7589520" y="1828800"/>
+            <a:ext cx="4389120" cy="411480"/>
           </a:xfrm>
           <a:prstGeom prst="rect">
             <a:avLst/>
@@ -4032,28 +4441,28 @@
       </p:sp>
       <p:sp>
         <p:nvSpPr>
-          <p:cNvPr id="13" name="TextBox 12"/>
-          <p:cNvSpPr txBox="1"/>
-          <p:nvPr/>
-        </p:nvSpPr>
-        <p:spPr>
-          <a:xfrm>
-            <a:off x="6583680" y="2240280"/>
-            <a:ext cx="3200400" cy="365760"/>
-          </a:xfrm>
-          <a:prstGeom prst="rect">
-            <a:avLst/>
-          </a:prstGeom>
-          <a:noFill/>
-        </p:spPr>
-        <p:txBody>
-          <a:bodyPr wrap="square">
-            <a:spAutoFit/>
-          </a:bodyPr>
-          <a:lstStyle/>
-          <a:p>
-            <a:r>
-              <a:rPr sz="1600" b="0">
+          <p:cNvPr id="23" name="TextBox 22"/>
+          <p:cNvSpPr txBox="1"/>
+          <p:nvPr/>
+        </p:nvSpPr>
+        <p:spPr>
+          <a:xfrm>
+            <a:off x="7772400" y="1874519"/>
+            <a:ext cx="2743200" cy="365760"/>
+          </a:xfrm>
+          <a:prstGeom prst="rect">
+            <a:avLst/>
+          </a:prstGeom>
+          <a:noFill/>
+        </p:spPr>
+        <p:txBody>
+          <a:bodyPr wrap="square">
+            <a:spAutoFit/>
+          </a:bodyPr>
+          <a:lstStyle/>
+          <a:p>
+            <a:r>
+              <a:rPr sz="1400" b="0">
                 <a:solidFill>
                   <a:srgbClr val="1F2937"/>
                 </a:solidFill>
@@ -4066,29 +4475,29 @@
       </p:sp>
       <p:sp>
         <p:nvSpPr>
-          <p:cNvPr id="14" name="TextBox 13"/>
-          <p:cNvSpPr txBox="1"/>
-          <p:nvPr/>
-        </p:nvSpPr>
-        <p:spPr>
-          <a:xfrm>
-            <a:off x="9875520" y="2240280"/>
-            <a:ext cx="1371600" cy="365760"/>
-          </a:xfrm>
-          <a:prstGeom prst="rect">
-            <a:avLst/>
-          </a:prstGeom>
-          <a:noFill/>
-        </p:spPr>
-        <p:txBody>
-          <a:bodyPr wrap="square">
-            <a:spAutoFit/>
-          </a:bodyPr>
-          <a:lstStyle/>
-          <a:p>
-            <a:pPr algn="ctr"/>
-            <a:r>
-              <a:rPr sz="1800" b="1">
+          <p:cNvPr id="24" name="TextBox 23"/>
+          <p:cNvSpPr txBox="1"/>
+          <p:nvPr/>
+        </p:nvSpPr>
+        <p:spPr>
+          <a:xfrm>
+            <a:off x="10698480" y="1874519"/>
+            <a:ext cx="1097280" cy="365760"/>
+          </a:xfrm>
+          <a:prstGeom prst="rect">
+            <a:avLst/>
+          </a:prstGeom>
+          <a:noFill/>
+        </p:spPr>
+        <p:txBody>
+          <a:bodyPr wrap="square">
+            <a:spAutoFit/>
+          </a:bodyPr>
+          <a:lstStyle/>
+          <a:p>
+            <a:pPr algn="ctr"/>
+            <a:r>
+              <a:rPr sz="1600" b="1">
                 <a:solidFill>
                   <a:srgbClr val="10B981"/>
                 </a:solidFill>
@@ -4101,14 +4510,14 @@
       </p:sp>
       <p:sp>
         <p:nvSpPr>
-          <p:cNvPr id="15" name="Rectangle 14"/>
+          <p:cNvPr id="25" name="Rectangle 24"/>
           <p:cNvSpPr/>
           <p:nvPr/>
         </p:nvSpPr>
         <p:spPr>
           <a:xfrm>
-            <a:off x="6400800" y="2651760"/>
-            <a:ext cx="5029200" cy="411480"/>
+            <a:off x="7589520" y="2286000"/>
+            <a:ext cx="4389120" cy="411480"/>
           </a:xfrm>
           <a:prstGeom prst="rect">
             <a:avLst/>
@@ -4146,28 +4555,28 @@
       </p:sp>
       <p:sp>
         <p:nvSpPr>
-          <p:cNvPr id="16" name="TextBox 15"/>
-          <p:cNvSpPr txBox="1"/>
-          <p:nvPr/>
-        </p:nvSpPr>
-        <p:spPr>
-          <a:xfrm>
-            <a:off x="6583680" y="2697480"/>
-            <a:ext cx="3200400" cy="365760"/>
-          </a:xfrm>
-          <a:prstGeom prst="rect">
-            <a:avLst/>
-          </a:prstGeom>
-          <a:noFill/>
-        </p:spPr>
-        <p:txBody>
-          <a:bodyPr wrap="square">
-            <a:spAutoFit/>
-          </a:bodyPr>
-          <a:lstStyle/>
-          <a:p>
-            <a:r>
-              <a:rPr sz="1600" b="0">
+          <p:cNvPr id="26" name="TextBox 25"/>
+          <p:cNvSpPr txBox="1"/>
+          <p:nvPr/>
+        </p:nvSpPr>
+        <p:spPr>
+          <a:xfrm>
+            <a:off x="7772400" y="2331720"/>
+            <a:ext cx="2743200" cy="365760"/>
+          </a:xfrm>
+          <a:prstGeom prst="rect">
+            <a:avLst/>
+          </a:prstGeom>
+          <a:noFill/>
+        </p:spPr>
+        <p:txBody>
+          <a:bodyPr wrap="square">
+            <a:spAutoFit/>
+          </a:bodyPr>
+          <a:lstStyle/>
+          <a:p>
+            <a:r>
+              <a:rPr sz="1400" b="0">
                 <a:solidFill>
                   <a:srgbClr val="1F2937"/>
                 </a:solidFill>
@@ -4180,29 +4589,29 @@
       </p:sp>
       <p:sp>
         <p:nvSpPr>
-          <p:cNvPr id="17" name="TextBox 16"/>
-          <p:cNvSpPr txBox="1"/>
-          <p:nvPr/>
-        </p:nvSpPr>
-        <p:spPr>
-          <a:xfrm>
-            <a:off x="9875520" y="2697480"/>
-            <a:ext cx="1371600" cy="365760"/>
-          </a:xfrm>
-          <a:prstGeom prst="rect">
-            <a:avLst/>
-          </a:prstGeom>
-          <a:noFill/>
-        </p:spPr>
-        <p:txBody>
-          <a:bodyPr wrap="square">
-            <a:spAutoFit/>
-          </a:bodyPr>
-          <a:lstStyle/>
-          <a:p>
-            <a:pPr algn="ctr"/>
-            <a:r>
-              <a:rPr sz="1800" b="1">
+          <p:cNvPr id="27" name="TextBox 26"/>
+          <p:cNvSpPr txBox="1"/>
+          <p:nvPr/>
+        </p:nvSpPr>
+        <p:spPr>
+          <a:xfrm>
+            <a:off x="10698480" y="2331720"/>
+            <a:ext cx="1097280" cy="365760"/>
+          </a:xfrm>
+          <a:prstGeom prst="rect">
+            <a:avLst/>
+          </a:prstGeom>
+          <a:noFill/>
+        </p:spPr>
+        <p:txBody>
+          <a:bodyPr wrap="square">
+            <a:spAutoFit/>
+          </a:bodyPr>
+          <a:lstStyle/>
+          <a:p>
+            <a:pPr algn="ctr"/>
+            <a:r>
+              <a:rPr sz="1600" b="1">
                 <a:solidFill>
                   <a:srgbClr val="10B981"/>
                 </a:solidFill>
@@ -4215,14 +4624,14 @@
       </p:sp>
       <p:sp>
         <p:nvSpPr>
-          <p:cNvPr id="18" name="Rectangle 17"/>
+          <p:cNvPr id="28" name="Rectangle 27"/>
           <p:cNvSpPr/>
           <p:nvPr/>
         </p:nvSpPr>
         <p:spPr>
           <a:xfrm>
-            <a:off x="6400800" y="3108960"/>
-            <a:ext cx="5029200" cy="411480"/>
+            <a:off x="7589520" y="2743200"/>
+            <a:ext cx="4389120" cy="411480"/>
           </a:xfrm>
           <a:prstGeom prst="rect">
             <a:avLst/>
@@ -4260,28 +4669,28 @@
       </p:sp>
       <p:sp>
         <p:nvSpPr>
-          <p:cNvPr id="19" name="TextBox 18"/>
-          <p:cNvSpPr txBox="1"/>
-          <p:nvPr/>
-        </p:nvSpPr>
-        <p:spPr>
-          <a:xfrm>
-            <a:off x="6583680" y="3154680"/>
-            <a:ext cx="3200400" cy="365760"/>
-          </a:xfrm>
-          <a:prstGeom prst="rect">
-            <a:avLst/>
-          </a:prstGeom>
-          <a:noFill/>
-        </p:spPr>
-        <p:txBody>
-          <a:bodyPr wrap="square">
-            <a:spAutoFit/>
-          </a:bodyPr>
-          <a:lstStyle/>
-          <a:p>
-            <a:r>
-              <a:rPr sz="1600" b="0">
+          <p:cNvPr id="29" name="TextBox 28"/>
+          <p:cNvSpPr txBox="1"/>
+          <p:nvPr/>
+        </p:nvSpPr>
+        <p:spPr>
+          <a:xfrm>
+            <a:off x="7772400" y="2788920"/>
+            <a:ext cx="2743200" cy="365760"/>
+          </a:xfrm>
+          <a:prstGeom prst="rect">
+            <a:avLst/>
+          </a:prstGeom>
+          <a:noFill/>
+        </p:spPr>
+        <p:txBody>
+          <a:bodyPr wrap="square">
+            <a:spAutoFit/>
+          </a:bodyPr>
+          <a:lstStyle/>
+          <a:p>
+            <a:r>
+              <a:rPr sz="1400" b="0">
                 <a:solidFill>
                   <a:srgbClr val="1F2937"/>
                 </a:solidFill>
@@ -4294,29 +4703,29 @@
       </p:sp>
       <p:sp>
         <p:nvSpPr>
-          <p:cNvPr id="20" name="TextBox 19"/>
-          <p:cNvSpPr txBox="1"/>
-          <p:nvPr/>
-        </p:nvSpPr>
-        <p:spPr>
-          <a:xfrm>
-            <a:off x="9875520" y="3154680"/>
-            <a:ext cx="1371600" cy="365760"/>
-          </a:xfrm>
-          <a:prstGeom prst="rect">
-            <a:avLst/>
-          </a:prstGeom>
-          <a:noFill/>
-        </p:spPr>
-        <p:txBody>
-          <a:bodyPr wrap="square">
-            <a:spAutoFit/>
-          </a:bodyPr>
-          <a:lstStyle/>
-          <a:p>
-            <a:pPr algn="ctr"/>
-            <a:r>
-              <a:rPr sz="1800" b="1">
+          <p:cNvPr id="30" name="TextBox 29"/>
+          <p:cNvSpPr txBox="1"/>
+          <p:nvPr/>
+        </p:nvSpPr>
+        <p:spPr>
+          <a:xfrm>
+            <a:off x="10698480" y="2788920"/>
+            <a:ext cx="1097280" cy="365760"/>
+          </a:xfrm>
+          <a:prstGeom prst="rect">
+            <a:avLst/>
+          </a:prstGeom>
+          <a:noFill/>
+        </p:spPr>
+        <p:txBody>
+          <a:bodyPr wrap="square">
+            <a:spAutoFit/>
+          </a:bodyPr>
+          <a:lstStyle/>
+          <a:p>
+            <a:pPr algn="ctr"/>
+            <a:r>
+              <a:rPr sz="1600" b="1">
                 <a:solidFill>
                   <a:srgbClr val="10B981"/>
                 </a:solidFill>
@@ -4329,14 +4738,14 @@
       </p:sp>
       <p:sp>
         <p:nvSpPr>
-          <p:cNvPr id="21" name="Rectangle 20"/>
+          <p:cNvPr id="31" name="Rectangle 30"/>
           <p:cNvSpPr/>
           <p:nvPr/>
         </p:nvSpPr>
         <p:spPr>
           <a:xfrm>
-            <a:off x="6400800" y="3566160"/>
-            <a:ext cx="5029200" cy="411480"/>
+            <a:off x="7589520" y="3200400"/>
+            <a:ext cx="4389120" cy="411480"/>
           </a:xfrm>
           <a:prstGeom prst="rect">
             <a:avLst/>
@@ -4374,28 +4783,28 @@
       </p:sp>
       <p:sp>
         <p:nvSpPr>
-          <p:cNvPr id="22" name="TextBox 21"/>
-          <p:cNvSpPr txBox="1"/>
-          <p:nvPr/>
-        </p:nvSpPr>
-        <p:spPr>
-          <a:xfrm>
-            <a:off x="6583680" y="3611880"/>
-            <a:ext cx="3200400" cy="365760"/>
-          </a:xfrm>
-          <a:prstGeom prst="rect">
-            <a:avLst/>
-          </a:prstGeom>
-          <a:noFill/>
-        </p:spPr>
-        <p:txBody>
-          <a:bodyPr wrap="square">
-            <a:spAutoFit/>
-          </a:bodyPr>
-          <a:lstStyle/>
-          <a:p>
-            <a:r>
-              <a:rPr sz="1600" b="0">
+          <p:cNvPr id="32" name="TextBox 31"/>
+          <p:cNvSpPr txBox="1"/>
+          <p:nvPr/>
+        </p:nvSpPr>
+        <p:spPr>
+          <a:xfrm>
+            <a:off x="7772400" y="3246120"/>
+            <a:ext cx="2743200" cy="365760"/>
+          </a:xfrm>
+          <a:prstGeom prst="rect">
+            <a:avLst/>
+          </a:prstGeom>
+          <a:noFill/>
+        </p:spPr>
+        <p:txBody>
+          <a:bodyPr wrap="square">
+            <a:spAutoFit/>
+          </a:bodyPr>
+          <a:lstStyle/>
+          <a:p>
+            <a:r>
+              <a:rPr sz="1400" b="0">
                 <a:solidFill>
                   <a:srgbClr val="1F2937"/>
                 </a:solidFill>
@@ -4408,14 +4817,49 @@
       </p:sp>
       <p:sp>
         <p:nvSpPr>
-          <p:cNvPr id="23" name="TextBox 22"/>
-          <p:cNvSpPr txBox="1"/>
-          <p:nvPr/>
-        </p:nvSpPr>
-        <p:spPr>
-          <a:xfrm>
-            <a:off x="9875520" y="3611880"/>
-            <a:ext cx="1371600" cy="365760"/>
+          <p:cNvPr id="33" name="TextBox 32"/>
+          <p:cNvSpPr txBox="1"/>
+          <p:nvPr/>
+        </p:nvSpPr>
+        <p:spPr>
+          <a:xfrm>
+            <a:off x="10698480" y="3246120"/>
+            <a:ext cx="1097280" cy="365760"/>
+          </a:xfrm>
+          <a:prstGeom prst="rect">
+            <a:avLst/>
+          </a:prstGeom>
+          <a:noFill/>
+        </p:spPr>
+        <p:txBody>
+          <a:bodyPr wrap="square">
+            <a:spAutoFit/>
+          </a:bodyPr>
+          <a:lstStyle/>
+          <a:p>
+            <a:pPr algn="ctr"/>
+            <a:r>
+              <a:rPr sz="1600" b="1">
+                <a:solidFill>
+                  <a:srgbClr val="10B981"/>
+                </a:solidFill>
+                <a:latin typeface="Inter"/>
+              </a:rPr>
+              <a:t>✓</a:t>
+            </a:r>
+          </a:p>
+        </p:txBody>
+      </p:sp>
+      <p:sp>
+        <p:nvSpPr>
+          <p:cNvPr id="34" name="TextBox 33"/>
+          <p:cNvSpPr txBox="1"/>
+          <p:nvPr/>
+        </p:nvSpPr>
+        <p:spPr>
+          <a:xfrm>
+            <a:off x="457200" y="5760720"/>
+            <a:ext cx="11277295" cy="457200"/>
           </a:xfrm>
           <a:prstGeom prst="rect">
             <a:avLst/>
@@ -4432,46 +4876,46 @@
             <a:r>
               <a:rPr sz="1800" b="1">
                 <a:solidFill>
-                  <a:srgbClr val="10B981"/>
+                  <a:srgbClr val="F59E0B"/>
+                </a:solidFill>
+                <a:latin typeface="阿里巴巴普惠体 3.0"/>
+              </a:rPr>
+              <a:t>★ JavaBrain 在 安全 + 智能 + 私有化 三角都做到</a:t>
+            </a:r>
+          </a:p>
+        </p:txBody>
+      </p:sp>
+      <p:sp>
+        <p:nvSpPr>
+          <p:cNvPr id="35" name="TextBox 34"/>
+          <p:cNvSpPr txBox="1"/>
+          <p:nvPr/>
+        </p:nvSpPr>
+        <p:spPr>
+          <a:xfrm>
+            <a:off x="10607040" y="6446520"/>
+            <a:ext cx="1280160" cy="274320"/>
+          </a:xfrm>
+          <a:prstGeom prst="rect">
+            <a:avLst/>
+          </a:prstGeom>
+          <a:noFill/>
+        </p:spPr>
+        <p:txBody>
+          <a:bodyPr wrap="square">
+            <a:spAutoFit/>
+          </a:bodyPr>
+          <a:lstStyle/>
+          <a:p>
+            <a:pPr algn="ctr"/>
+            <a:r>
+              <a:rPr sz="1000" b="0">
+                <a:solidFill>
+                  <a:srgbClr val="6B7280"/>
                 </a:solidFill>
                 <a:latin typeface="Inter"/>
               </a:rPr>
-              <a:t>✓</a:t>
-            </a:r>
-          </a:p>
-        </p:txBody>
-      </p:sp>
-      <p:sp>
-        <p:nvSpPr>
-          <p:cNvPr id="24" name="TextBox 23"/>
-          <p:cNvSpPr txBox="1"/>
-          <p:nvPr/>
-        </p:nvSpPr>
-        <p:spPr>
-          <a:xfrm>
-            <a:off x="457200" y="5486400"/>
-            <a:ext cx="11277295" cy="457200"/>
-          </a:xfrm>
-          <a:prstGeom prst="rect">
-            <a:avLst/>
-          </a:prstGeom>
-          <a:noFill/>
-        </p:spPr>
-        <p:txBody>
-          <a:bodyPr wrap="square">
-            <a:spAutoFit/>
-          </a:bodyPr>
-          <a:lstStyle/>
-          <a:p>
-            <a:pPr algn="ctr"/>
-            <a:r>
-              <a:rPr sz="2000" b="1">
-                <a:solidFill>
-                  <a:srgbClr val="F59E0B"/>
-                </a:solidFill>
-                <a:latin typeface="阿里巴巴普惠体 3.0"/>
-              </a:rPr>
-              <a:t>★ JavaBrain 在 安全 + 智能 + 私有化 三角都做到</a:t>
+              <a:t>10 / 12</a:t>
             </a:r>
           </a:p>
         </p:txBody>
@@ -4507,7 +4951,7 @@
             <p:tnCond val="0"/>
           </p:cond>
           <p:par>
-            <p:cTn id="6" nodeType="withEffect" dur="500" begin="600ms" fill="hold">
+            <p:cTn id="6" nodeType="withEffect" dur="500" begin="400ms" fill="hold">
               <p:animEffect presetClass="entr" presetId="10" dur="500"/>
             </p:cTn>
           </p:par>
@@ -4524,7 +4968,7 @@
             <p:tnCond val="0"/>
           </p:cond>
           <p:par>
-            <p:cTn id="7" nodeType="withEffect" dur="500" begin="1200ms" fill="hold">
+            <p:cTn id="7" nodeType="withEffect" dur="500" begin="800ms" fill="hold">
               <p:animEffect presetClass="entr" presetId="10" dur="500"/>
             </p:cTn>
           </p:par>
@@ -4541,7 +4985,7 @@
             <p:tnCond val="0"/>
           </p:cond>
           <p:par>
-            <p:cTn id="8" nodeType="withEffect" dur="500" begin="1800ms" fill="hold">
+            <p:cTn id="8" nodeType="withEffect" dur="500" begin="1200ms" fill="hold">
               <p:animEffect presetClass="entr" presetId="10" dur="500"/>
             </p:cTn>
           </p:par>
@@ -4558,7 +5002,7 @@
             <p:tnCond val="0"/>
           </p:cond>
           <p:par>
-            <p:cTn id="11" nodeType="withEffect" dur="500" begin="3000ms" fill="hold">
+            <p:cTn id="10" nodeType="withEffect" dur="500" begin="1800ms" fill="hold">
               <p:animEffect presetClass="entr" presetId="10" dur="500"/>
             </p:cTn>
           </p:par>
@@ -4575,7 +5019,7 @@
             <p:tnCond val="0"/>
           </p:cond>
           <p:par>
-            <p:cTn id="14" nodeType="withEffect" dur="500" begin="3700ms" fill="hold">
+            <p:cTn id="13" nodeType="withEffect" dur="500" begin="2050ms" fill="hold">
               <p:animEffect presetClass="entr" presetId="10" dur="500"/>
             </p:cTn>
           </p:par>
@@ -4592,7 +5036,7 @@
             <p:tnCond val="0"/>
           </p:cond>
           <p:par>
-            <p:cTn id="17" nodeType="withEffect" dur="500" begin="4400ms" fill="hold">
+            <p:cTn id="16" nodeType="withEffect" dur="500" begin="2300ms" fill="hold">
               <p:animEffect presetClass="entr" presetId="10" dur="500"/>
             </p:cTn>
           </p:par>
@@ -4609,7 +5053,7 @@
             <p:tnCond val="0"/>
           </p:cond>
           <p:par>
-            <p:cTn id="20" nodeType="withEffect" dur="500" begin="5100ms" fill="hold">
+            <p:cTn id="21" nodeType="withEffect" dur="500" begin="3000ms" fill="hold">
               <p:animEffect presetClass="entr" presetId="10" dur="500"/>
             </p:cTn>
           </p:par>
@@ -4626,7 +5070,58 @@
             <p:tnCond val="0"/>
           </p:cond>
           <p:par>
-            <p:cTn id="23" nodeType="withEffect" dur="500" begin="5800ms" fill="hold">
+            <p:cTn id="24" nodeType="withEffect" dur="500" begin="3500ms" fill="hold">
+              <p:animEffect presetClass="entr" presetId="10" dur="500"/>
+            </p:cTn>
+          </p:par>
+        </p:par>
+      </p:par>
+    </p:tnLst>
+  </p:timing>
+  <p:timing>
+    <p:tnLst>
+      <p:par>
+        <p:pPr/>
+        <p:par>
+          <p:cond>
+            <p:tnCond val="0"/>
+          </p:cond>
+          <p:par>
+            <p:cTn id="27" nodeType="withEffect" dur="500" begin="4000ms" fill="hold">
+              <p:animEffect presetClass="entr" presetId="10" dur="500"/>
+            </p:cTn>
+          </p:par>
+        </p:par>
+      </p:par>
+    </p:tnLst>
+  </p:timing>
+  <p:timing>
+    <p:tnLst>
+      <p:par>
+        <p:pPr/>
+        <p:par>
+          <p:cond>
+            <p:tnCond val="0"/>
+          </p:cond>
+          <p:par>
+            <p:cTn id="30" nodeType="withEffect" dur="500" begin="4500ms" fill="hold">
+              <p:animEffect presetClass="entr" presetId="10" dur="500"/>
+            </p:cTn>
+          </p:par>
+        </p:par>
+      </p:par>
+    </p:tnLst>
+  </p:timing>
+  <p:timing>
+    <p:tnLst>
+      <p:par>
+        <p:pPr/>
+        <p:par>
+          <p:cond>
+            <p:tnCond val="0"/>
+          </p:cond>
+          <p:par>
+            <p:cTn id="33" nodeType="withEffect" dur="500" begin="5000ms" fill="hold">
               <p:animEffect presetClass="entr" presetId="10" dur="500"/>
             </p:cTn>
           </p:par>
@@ -4682,7 +5177,7 @@
         </p:nvPicPr>
         <p:blipFill>
           <a:blip r:embed="rId2">
-            <a:alphaModFix amt="30000"/>
+            <a:alphaModFix amt="100000"/>
           </a:blip>
           <a:stretch>
             <a:fillRect/>
@@ -4690,8 +5185,8 @@
         </p:blipFill>
         <p:spPr>
           <a:xfrm>
-            <a:off x="7772400" y="182880"/>
-            <a:ext cx="4114800" cy="731520"/>
+            <a:off x="8686800" y="228600"/>
+            <a:ext cx="3200400" cy="594360"/>
           </a:xfrm>
           <a:prstGeom prst="rect">
             <a:avLst/>
@@ -5959,6 +6454,41 @@
                 <a:latin typeface="阿里巴巴普惠体 3.0"/>
               </a:rPr>
               <a:t>★ 零代码 AI 应用工厂 (Amis + Skill 绑定)</a:t>
+            </a:r>
+          </a:p>
+        </p:txBody>
+      </p:sp>
+      <p:sp>
+        <p:nvSpPr>
+          <p:cNvPr id="36" name="TextBox 35"/>
+          <p:cNvSpPr txBox="1"/>
+          <p:nvPr/>
+        </p:nvSpPr>
+        <p:spPr>
+          <a:xfrm>
+            <a:off x="10607040" y="6446520"/>
+            <a:ext cx="1280160" cy="274320"/>
+          </a:xfrm>
+          <a:prstGeom prst="rect">
+            <a:avLst/>
+          </a:prstGeom>
+          <a:noFill/>
+        </p:spPr>
+        <p:txBody>
+          <a:bodyPr wrap="square">
+            <a:spAutoFit/>
+          </a:bodyPr>
+          <a:lstStyle/>
+          <a:p>
+            <a:pPr algn="ctr"/>
+            <a:r>
+              <a:rPr sz="1000" b="0">
+                <a:solidFill>
+                  <a:srgbClr val="6B7280"/>
+                </a:solidFill>
+                <a:latin typeface="Inter"/>
+              </a:rPr>
+              <a:t>11 / 12</a:t>
             </a:r>
           </a:p>
         </p:txBody>
@@ -6210,15 +6740,39 @@
         <p:nvPr/>
       </p:nvGrpSpPr>
       <p:grpSpPr/>
-      <p:sp>
-        <p:nvSpPr>
-          <p:cNvPr id="2" name="TextBox 1"/>
-          <p:cNvSpPr txBox="1"/>
-          <p:nvPr/>
-        </p:nvSpPr>
-        <p:spPr>
-          <a:xfrm>
-            <a:off x="457200" y="548640"/>
+      <p:pic>
+        <p:nvPicPr>
+          <p:cNvPr id="2" name="Picture 1" descr="p10_brain_logo.png"/>
+          <p:cNvPicPr>
+            <a:picLocks noChangeAspect="1"/>
+          </p:cNvPicPr>
+          <p:nvPr/>
+        </p:nvPicPr>
+        <p:blipFill>
+          <a:blip r:embed="rId2"/>
+          <a:stretch>
+            <a:fillRect/>
+          </a:stretch>
+        </p:blipFill>
+        <p:spPr>
+          <a:xfrm>
+            <a:off x="5394960" y="45720"/>
+            <a:ext cx="1371600" cy="548640"/>
+          </a:xfrm>
+          <a:prstGeom prst="rect">
+            <a:avLst/>
+          </a:prstGeom>
+        </p:spPr>
+      </p:pic>
+      <p:sp>
+        <p:nvSpPr>
+          <p:cNvPr id="3" name="TextBox 2"/>
+          <p:cNvSpPr txBox="1"/>
+          <p:nvPr/>
+        </p:nvSpPr>
+        <p:spPr>
+          <a:xfrm>
+            <a:off x="457200" y="685800"/>
             <a:ext cx="11277295" cy="1097280"/>
           </a:xfrm>
           <a:prstGeom prst="rect">
@@ -6234,7 +6788,7 @@
           <a:p>
             <a:pPr algn="ctr"/>
             <a:r>
-              <a:rPr sz="7200" b="1">
+              <a:rPr sz="6000" b="1">
                 <a:solidFill>
                   <a:srgbClr val="1F2937"/>
                 </a:solidFill>
@@ -6247,7 +6801,7 @@
       </p:sp>
       <p:sp>
         <p:nvSpPr>
-          <p:cNvPr id="3" name="TextBox 2"/>
+          <p:cNvPr id="4" name="TextBox 3"/>
           <p:cNvSpPr txBox="1"/>
           <p:nvPr/>
         </p:nvSpPr>
@@ -6282,7 +6836,7 @@
       </p:sp>
       <p:sp>
         <p:nvSpPr>
-          <p:cNvPr id="4" name="TextBox 3"/>
+          <p:cNvPr id="5" name="TextBox 4"/>
           <p:cNvSpPr txBox="1"/>
           <p:nvPr/>
         </p:nvSpPr>
@@ -6317,7 +6871,7 @@
       </p:sp>
       <p:sp>
         <p:nvSpPr>
-          <p:cNvPr id="5" name="TextBox 4"/>
+          <p:cNvPr id="6" name="TextBox 5"/>
           <p:cNvSpPr txBox="1"/>
           <p:nvPr/>
         </p:nvSpPr>
@@ -6352,7 +6906,7 @@
       </p:sp>
       <p:sp>
         <p:nvSpPr>
-          <p:cNvPr id="6" name="Rounded Rectangle 5"/>
+          <p:cNvPr id="7" name="Rounded Rectangle 6"/>
           <p:cNvSpPr/>
           <p:nvPr/>
         </p:nvSpPr>
@@ -6397,7 +6951,7 @@
       </p:sp>
       <p:sp>
         <p:nvSpPr>
-          <p:cNvPr id="7" name="TextBox 6"/>
+          <p:cNvPr id="8" name="TextBox 7"/>
           <p:cNvSpPr txBox="1"/>
           <p:nvPr/>
         </p:nvSpPr>
@@ -6432,7 +6986,7 @@
       </p:sp>
       <p:sp>
         <p:nvSpPr>
-          <p:cNvPr id="8" name="Rounded Rectangle 7"/>
+          <p:cNvPr id="9" name="Rounded Rectangle 8"/>
           <p:cNvSpPr/>
           <p:nvPr/>
         </p:nvSpPr>
@@ -6475,7 +7029,7 @@
       </p:sp>
       <p:sp>
         <p:nvSpPr>
-          <p:cNvPr id="9" name="TextBox 8"/>
+          <p:cNvPr id="10" name="TextBox 9"/>
           <p:cNvSpPr txBox="1"/>
           <p:nvPr/>
         </p:nvSpPr>
@@ -6510,7 +7064,7 @@
       </p:sp>
       <p:sp>
         <p:nvSpPr>
-          <p:cNvPr id="10" name="TextBox 9"/>
+          <p:cNvPr id="11" name="TextBox 10"/>
           <p:cNvSpPr txBox="1"/>
           <p:nvPr/>
         </p:nvSpPr>
@@ -6545,7 +7099,7 @@
       </p:sp>
       <p:sp>
         <p:nvSpPr>
-          <p:cNvPr id="11" name="TextBox 10"/>
+          <p:cNvPr id="12" name="TextBox 11"/>
           <p:cNvSpPr txBox="1"/>
           <p:nvPr/>
         </p:nvSpPr>
@@ -6574,6 +7128,41 @@
                 <a:latin typeface="阿里巴巴普惠体 3.0"/>
               </a:rPr>
               <a:t>感谢 [团队名] · 联系: [邮箱]</a:t>
+            </a:r>
+          </a:p>
+        </p:txBody>
+      </p:sp>
+      <p:sp>
+        <p:nvSpPr>
+          <p:cNvPr id="13" name="TextBox 12"/>
+          <p:cNvSpPr txBox="1"/>
+          <p:nvPr/>
+        </p:nvSpPr>
+        <p:spPr>
+          <a:xfrm>
+            <a:off x="10607040" y="6446520"/>
+            <a:ext cx="1280160" cy="274320"/>
+          </a:xfrm>
+          <a:prstGeom prst="rect">
+            <a:avLst/>
+          </a:prstGeom>
+          <a:noFill/>
+        </p:spPr>
+        <p:txBody>
+          <a:bodyPr wrap="square">
+            <a:spAutoFit/>
+          </a:bodyPr>
+          <a:lstStyle/>
+          <a:p>
+            <a:pPr algn="ctr"/>
+            <a:r>
+              <a:rPr sz="1000" b="0">
+                <a:solidFill>
+                  <a:srgbClr val="6B7280"/>
+                </a:solidFill>
+                <a:latin typeface="Inter"/>
+              </a:rPr>
+              <a:t>12 / 12</a:t>
             </a:r>
           </a:p>
         </p:txBody>
@@ -6592,7 +7181,7 @@
             <p:tnCond val="0"/>
           </p:cond>
           <p:par>
-            <p:cTn id="3" nodeType="withEffect" dur="500" begin="0ms" fill="hold">
+            <p:cTn id="4" nodeType="withEffect" dur="500" begin="0ms" fill="hold">
               <p:animEffect presetClass="entr" presetId="10" dur="500"/>
             </p:cTn>
           </p:par>
@@ -6609,7 +7198,7 @@
             <p:tnCond val="0"/>
           </p:cond>
           <p:par>
-            <p:cTn id="4" nodeType="withEffect" dur="500" begin="600ms" fill="hold">
+            <p:cTn id="5" nodeType="withEffect" dur="500" begin="600ms" fill="hold">
               <p:animEffect presetClass="entr" presetId="10" dur="500"/>
             </p:cTn>
           </p:par>
@@ -6626,7 +7215,7 @@
             <p:tnCond val="0"/>
           </p:cond>
           <p:par>
-            <p:cTn id="5" nodeType="withEffect" dur="500" begin="1200ms" fill="hold">
+            <p:cTn id="6" nodeType="withEffect" dur="500" begin="1200ms" fill="hold">
               <p:animEffect presetClass="entr" presetId="10" dur="500"/>
             </p:cTn>
           </p:par>
@@ -6643,7 +7232,7 @@
             <p:tnCond val="0"/>
           </p:cond>
           <p:par>
-            <p:cTn id="6" nodeType="withEffect" dur="500" begin="1800ms" fill="hold">
+            <p:cTn id="7" nodeType="withEffect" dur="500" begin="1800ms" fill="hold">
               <p:animEffect presetClass="entr" presetId="10" dur="500"/>
             </p:cTn>
           </p:par>
@@ -6660,7 +7249,7 @@
             <p:tnCond val="0"/>
           </p:cond>
           <p:par>
-            <p:cTn id="7" nodeType="withEffect" dur="1500" begin="6000ms" fill="hold" repeatCount="indefinite">
+            <p:cTn id="8" nodeType="withEffect" dur="1500" begin="6000ms" fill="hold" repeatCount="indefinite">
               <p:animEffect presetClass="emph" presetId="26" dur="1500"/>
             </p:cTn>
           </p:par>
@@ -6677,7 +7266,7 @@
             <p:tnCond val="0"/>
           </p:cond>
           <p:par>
-            <p:cTn id="9" nodeType="withEffect" dur="500" begin="10000ms" fill="hold">
+            <p:cTn id="10" nodeType="withEffect" dur="500" begin="10000ms" fill="hold">
               <p:animEffect presetClass="entr" presetId="10" dur="500"/>
             </p:cTn>
           </p:par>
@@ -7938,6 +8527,41 @@
                 <a:latin typeface="阿里巴巴普惠体 3.0"/>
               </a:rPr>
               <a:t>★ 3 月 vs 3 分 — 从季度到分钟</a:t>
+            </a:r>
+          </a:p>
+        </p:txBody>
+      </p:sp>
+      <p:sp>
+        <p:nvSpPr>
+          <p:cNvPr id="36" name="TextBox 35"/>
+          <p:cNvSpPr txBox="1"/>
+          <p:nvPr/>
+        </p:nvSpPr>
+        <p:spPr>
+          <a:xfrm>
+            <a:off x="10607040" y="6446520"/>
+            <a:ext cx="1280160" cy="274320"/>
+          </a:xfrm>
+          <a:prstGeom prst="rect">
+            <a:avLst/>
+          </a:prstGeom>
+          <a:noFill/>
+        </p:spPr>
+        <p:txBody>
+          <a:bodyPr wrap="square">
+            <a:spAutoFit/>
+          </a:bodyPr>
+          <a:lstStyle/>
+          <a:p>
+            <a:pPr algn="ctr"/>
+            <a:r>
+              <a:rPr sz="1000" b="0">
+                <a:solidFill>
+                  <a:srgbClr val="6B7280"/>
+                </a:solidFill>
+                <a:latin typeface="Inter"/>
+              </a:rPr>
+              <a:t>02 / 12</a:t>
             </a:r>
           </a:p>
         </p:txBody>
@@ -9029,6 +9653,41 @@
           </a:p>
         </p:txBody>
       </p:sp>
+      <p:sp>
+        <p:nvSpPr>
+          <p:cNvPr id="25" name="TextBox 24"/>
+          <p:cNvSpPr txBox="1"/>
+          <p:nvPr/>
+        </p:nvSpPr>
+        <p:spPr>
+          <a:xfrm>
+            <a:off x="10607040" y="6446520"/>
+            <a:ext cx="1280160" cy="274320"/>
+          </a:xfrm>
+          <a:prstGeom prst="rect">
+            <a:avLst/>
+          </a:prstGeom>
+          <a:noFill/>
+        </p:spPr>
+        <p:txBody>
+          <a:bodyPr wrap="square">
+            <a:spAutoFit/>
+          </a:bodyPr>
+          <a:lstStyle/>
+          <a:p>
+            <a:pPr algn="ctr"/>
+            <a:r>
+              <a:rPr sz="1000" b="0">
+                <a:solidFill>
+                  <a:srgbClr val="6B7280"/>
+                </a:solidFill>
+                <a:latin typeface="Inter"/>
+              </a:rPr>
+              <a:t>03 / 12</a:t>
+            </a:r>
+          </a:p>
+        </p:txBody>
+      </p:sp>
     </p:spTree>
   </p:cSld>
   <p:clrMapOvr>
@@ -9125,7 +9784,7 @@
       <p:grpSpPr/>
       <p:pic>
         <p:nvPicPr>
-          <p:cNvPr id="13" name="Picture 12" descr="p4a-ai-orchestrate.png"/>
+          <p:cNvPr id="20" name="Picture 19" descr="p4a-ai-orchestrate.png"/>
           <p:cNvPicPr>
             <a:picLocks noChangeAspect="1"/>
           </p:cNvPicPr>
@@ -9133,7 +9792,7 @@
         </p:nvPicPr>
         <p:blipFill>
           <a:blip r:embed="rId2">
-            <a:alphaModFix amt="55000"/>
+            <a:alphaModFix amt="100000"/>
           </a:blip>
           <a:stretch>
             <a:fillRect/>
@@ -9141,8 +9800,8 @@
         </p:blipFill>
         <p:spPr>
           <a:xfrm>
-            <a:off x="274320" y="2194560"/>
-            <a:ext cx="4114800" cy="3657600"/>
+            <a:off x="365760" y="4846320"/>
+            <a:ext cx="2286000" cy="1828800"/>
           </a:xfrm>
           <a:prstGeom prst="rect">
             <a:avLst/>
@@ -9157,7 +9816,7 @@
         </p:nvSpPr>
         <p:spPr>
           <a:xfrm>
-            <a:off x="457200" y="365760"/>
+            <a:off x="457200" y="274320"/>
             <a:ext cx="11277295" cy="365760"/>
           </a:xfrm>
           <a:prstGeom prst="rect">
@@ -9192,7 +9851,7 @@
         </p:nvSpPr>
         <p:spPr>
           <a:xfrm>
-            <a:off x="457200" y="777240"/>
+            <a:off x="457200" y="640080"/>
             <a:ext cx="11277295" cy="640080"/>
           </a:xfrm>
           <a:prstGeom prst="rect">
@@ -9208,13 +9867,13 @@
           <a:p>
             <a:pPr algn="ctr"/>
             <a:r>
-              <a:rPr sz="3200" b="1">
+              <a:rPr sz="2800" b="1">
                 <a:solidFill>
                   <a:srgbClr val="1F2937"/>
                 </a:solidFill>
                 <a:latin typeface="阿里巴巴普惠体 3.0"/>
               </a:rPr>
-              <a:t>Spring AI 一键启动</a:t>
+              <a:t>从 Spring AI 裸用到 JavaBrain 一体化</a:t>
             </a:r>
           </a:p>
         </p:txBody>
@@ -9227,7 +9886,7 @@
         </p:nvSpPr>
         <p:spPr>
           <a:xfrm>
-            <a:off x="457200" y="1325880"/>
+            <a:off x="457200" y="1280160"/>
             <a:ext cx="11277295" cy="365760"/>
           </a:xfrm>
           <a:prstGeom prst="rect">
@@ -9243,13 +9902,13 @@
           <a:p>
             <a:pPr algn="ctr"/>
             <a:r>
-              <a:rPr sz="1600" b="1">
+              <a:rPr sz="1500" b="1">
                 <a:solidFill>
                   <a:srgbClr val="F59E0B"/>
                 </a:solidFill>
                 <a:latin typeface="阿里巴巴普惠体 3.0"/>
               </a:rPr>
-              <a:t>★ 改一个 .st 文件,AI 行为就变</a:t>
+              <a:t>★ 50 行配置 → 1 行模板,半年维护成本归零</a:t>
             </a:r>
           </a:p>
         </p:txBody>
@@ -9262,8 +9921,8 @@
         </p:nvSpPr>
         <p:spPr>
           <a:xfrm>
-            <a:off x="7315200" y="2194560"/>
-            <a:ext cx="4114800" cy="1188720"/>
+            <a:off x="655167" y="1828800"/>
+            <a:ext cx="3383280" cy="2743200"/>
           </a:xfrm>
           <a:prstGeom prst="roundRect">
             <a:avLst/>
@@ -9271,7 +9930,7 @@
           <a:solidFill>
             <a:srgbClr val="FFFFFF"/>
           </a:solidFill>
-          <a:ln w="12700">
+          <a:ln w="19050">
             <a:solidFill>
               <a:srgbClr val="E5E7EB"/>
             </a:solidFill>
@@ -9307,48 +9966,343 @@
         </p:nvSpPr>
         <p:spPr>
           <a:xfrm>
-            <a:off x="7315200" y="2377440"/>
-            <a:ext cx="4114800" cy="822960"/>
-          </a:xfrm>
-          <a:prstGeom prst="rect">
-            <a:avLst/>
-          </a:prstGeom>
-          <a:noFill/>
-        </p:spPr>
-        <p:txBody>
-          <a:bodyPr wrap="square">
-            <a:spAutoFit/>
-          </a:bodyPr>
-          <a:lstStyle/>
-          <a:p>
-            <a:pPr algn="ctr"/>
-            <a:r>
-              <a:rPr sz="1600" b="1">
+            <a:off x="838047" y="1920240"/>
+            <a:ext cx="1280160" cy="1280160"/>
+          </a:xfrm>
+          <a:prstGeom prst="rect">
+            <a:avLst/>
+          </a:prstGeom>
+          <a:noFill/>
+        </p:spPr>
+        <p:txBody>
+          <a:bodyPr wrap="square">
+            <a:spAutoFit/>
+          </a:bodyPr>
+          <a:lstStyle/>
+          <a:p>
+            <a:pPr algn="ctr"/>
+            <a:r>
+              <a:rPr sz="7200" b="1">
+                <a:solidFill>
+                  <a:srgbClr val="E5E7EB"/>
+                </a:solidFill>
+                <a:latin typeface="Inter"/>
+              </a:rPr>
+              <a:t>1</a:t>
+            </a:r>
+          </a:p>
+        </p:txBody>
+      </p:sp>
+      <p:sp>
+        <p:nvSpPr>
+          <p:cNvPr id="7" name="TextBox 6"/>
+          <p:cNvSpPr txBox="1"/>
+          <p:nvPr/>
+        </p:nvSpPr>
+        <p:spPr>
+          <a:xfrm>
+            <a:off x="838047" y="3200400"/>
+            <a:ext cx="3017520" cy="457200"/>
+          </a:xfrm>
+          <a:prstGeom prst="rect">
+            <a:avLst/>
+          </a:prstGeom>
+          <a:noFill/>
+        </p:spPr>
+        <p:txBody>
+          <a:bodyPr wrap="square">
+            <a:spAutoFit/>
+          </a:bodyPr>
+          <a:lstStyle/>
+          <a:p>
+            <a:pPr algn="ctr"/>
+            <a:r>
+              <a:rPr sz="2000" b="1">
+                <a:solidFill>
+                  <a:srgbClr val="E5E7EB"/>
+                </a:solidFill>
+                <a:latin typeface="阿里巴巴普惠体 3.0"/>
+              </a:rPr>
+              <a:t>裸 Spring AI</a:t>
+            </a:r>
+          </a:p>
+        </p:txBody>
+      </p:sp>
+      <p:sp>
+        <p:nvSpPr>
+          <p:cNvPr id="8" name="TextBox 7"/>
+          <p:cNvSpPr txBox="1"/>
+          <p:nvPr/>
+        </p:nvSpPr>
+        <p:spPr>
+          <a:xfrm>
+            <a:off x="838047" y="3657600"/>
+            <a:ext cx="3017520" cy="548640"/>
+          </a:xfrm>
+          <a:prstGeom prst="rect">
+            <a:avLst/>
+          </a:prstGeom>
+          <a:noFill/>
+        </p:spPr>
+        <p:txBody>
+          <a:bodyPr wrap="square">
+            <a:spAutoFit/>
+          </a:bodyPr>
+          <a:lstStyle/>
+          <a:p>
+            <a:pPr algn="ctr"/>
+            <a:r>
+              <a:rPr sz="1300" b="0">
+                <a:solidFill>
+                  <a:srgbClr val="6B7280"/>
+                </a:solidFill>
+                <a:latin typeface="阿里巴巴普惠体 3.0"/>
+              </a:rPr>
+              <a:t>写 50 行</a:t>
+            </a:r>
+          </a:p>
+          <a:p>
+            <a:r>
+              <a:t>ChatClient 配置</a:t>
+            </a:r>
+          </a:p>
+        </p:txBody>
+      </p:sp>
+      <p:sp>
+        <p:nvSpPr>
+          <p:cNvPr id="9" name="TextBox 8"/>
+          <p:cNvSpPr txBox="1"/>
+          <p:nvPr/>
+        </p:nvSpPr>
+        <p:spPr>
+          <a:xfrm>
+            <a:off x="838047" y="4069080"/>
+            <a:ext cx="3017520" cy="365760"/>
+          </a:xfrm>
+          <a:prstGeom prst="rect">
+            <a:avLst/>
+          </a:prstGeom>
+          <a:noFill/>
+        </p:spPr>
+        <p:txBody>
+          <a:bodyPr wrap="square">
+            <a:spAutoFit/>
+          </a:bodyPr>
+          <a:lstStyle/>
+          <a:p>
+            <a:pPr algn="ctr"/>
+            <a:r>
+              <a:rPr sz="1400" b="1">
+                <a:solidFill>
+                  <a:srgbClr val="E5E7EB"/>
+                </a:solidFill>
+                <a:latin typeface="阿里巴巴普惠体 3.0"/>
+              </a:rPr>
+              <a:t>5 天</a:t>
+            </a:r>
+          </a:p>
+        </p:txBody>
+      </p:sp>
+      <p:sp>
+        <p:nvSpPr>
+          <p:cNvPr id="10" name="Rounded Rectangle 9"/>
+          <p:cNvSpPr/>
+          <p:nvPr/>
+        </p:nvSpPr>
+        <p:spPr>
+          <a:xfrm>
+            <a:off x="4404207" y="1828800"/>
+            <a:ext cx="3383280" cy="2743200"/>
+          </a:xfrm>
+          <a:prstGeom prst="roundRect">
+            <a:avLst/>
+          </a:prstGeom>
+          <a:solidFill>
+            <a:srgbClr val="FFFFFF"/>
+          </a:solidFill>
+          <a:ln w="19050">
+            <a:solidFill>
+              <a:srgbClr val="007396"/>
+            </a:solidFill>
+          </a:ln>
+        </p:spPr>
+        <p:style>
+          <a:lnRef idx="1">
+            <a:schemeClr val="accent1"/>
+          </a:lnRef>
+          <a:fillRef idx="3">
+            <a:schemeClr val="accent1"/>
+          </a:fillRef>
+          <a:effectRef idx="2">
+            <a:schemeClr val="accent1"/>
+          </a:effectRef>
+          <a:fontRef idx="minor">
+            <a:schemeClr val="lt1"/>
+          </a:fontRef>
+        </p:style>
+        <p:txBody>
+          <a:bodyPr rtlCol="0" anchor="ctr"/>
+          <a:lstStyle/>
+          <a:p>
+            <a:pPr algn="ctr"/>
+          </a:p>
+        </p:txBody>
+      </p:sp>
+      <p:sp>
+        <p:nvSpPr>
+          <p:cNvPr id="11" name="TextBox 10"/>
+          <p:cNvSpPr txBox="1"/>
+          <p:nvPr/>
+        </p:nvSpPr>
+        <p:spPr>
+          <a:xfrm>
+            <a:off x="4587087" y="1920240"/>
+            <a:ext cx="1280160" cy="1280160"/>
+          </a:xfrm>
+          <a:prstGeom prst="rect">
+            <a:avLst/>
+          </a:prstGeom>
+          <a:noFill/>
+        </p:spPr>
+        <p:txBody>
+          <a:bodyPr wrap="square">
+            <a:spAutoFit/>
+          </a:bodyPr>
+          <a:lstStyle/>
+          <a:p>
+            <a:pPr algn="ctr"/>
+            <a:r>
+              <a:rPr sz="7200" b="1">
                 <a:solidFill>
                   <a:srgbClr val="007396"/>
                 </a:solidFill>
+                <a:latin typeface="Inter"/>
+              </a:rPr>
+              <a:t>2</a:t>
+            </a:r>
+          </a:p>
+        </p:txBody>
+      </p:sp>
+      <p:sp>
+        <p:nvSpPr>
+          <p:cNvPr id="12" name="TextBox 11"/>
+          <p:cNvSpPr txBox="1"/>
+          <p:nvPr/>
+        </p:nvSpPr>
+        <p:spPr>
+          <a:xfrm>
+            <a:off x="4587087" y="3200400"/>
+            <a:ext cx="3017520" cy="457200"/>
+          </a:xfrm>
+          <a:prstGeom prst="rect">
+            <a:avLst/>
+          </a:prstGeom>
+          <a:noFill/>
+        </p:spPr>
+        <p:txBody>
+          <a:bodyPr wrap="square">
+            <a:spAutoFit/>
+          </a:bodyPr>
+          <a:lstStyle/>
+          <a:p>
+            <a:pPr algn="ctr"/>
+            <a:r>
+              <a:rPr sz="2000" b="1">
+                <a:solidFill>
+                  <a:srgbClr val="007396"/>
+                </a:solidFill>
                 <a:latin typeface="阿里巴巴普惠体 3.0"/>
               </a:rPr>
-              <a:t>📦 6 大功能模块</a:t>
-            </a:r>
-          </a:p>
-          <a:p>
-            <a:r>
-              <a:t>一站集成</a:t>
-            </a:r>
-          </a:p>
-        </p:txBody>
-      </p:sp>
-      <p:sp>
-        <p:nvSpPr>
-          <p:cNvPr id="7" name="Rounded Rectangle 6"/>
+              <a:t>灵梭 starter</a:t>
+            </a:r>
+          </a:p>
+        </p:txBody>
+      </p:sp>
+      <p:sp>
+        <p:nvSpPr>
+          <p:cNvPr id="13" name="TextBox 12"/>
+          <p:cNvSpPr txBox="1"/>
+          <p:nvPr/>
+        </p:nvSpPr>
+        <p:spPr>
+          <a:xfrm>
+            <a:off x="4587087" y="3657600"/>
+            <a:ext cx="3017520" cy="548640"/>
+          </a:xfrm>
+          <a:prstGeom prst="rect">
+            <a:avLst/>
+          </a:prstGeom>
+          <a:noFill/>
+        </p:spPr>
+        <p:txBody>
+          <a:bodyPr wrap="square">
+            <a:spAutoFit/>
+          </a:bodyPr>
+          <a:lstStyle/>
+          <a:p>
+            <a:pPr algn="ctr"/>
+            <a:r>
+              <a:rPr sz="1300" b="0">
+                <a:solidFill>
+                  <a:srgbClr val="6B7280"/>
+                </a:solidFill>
+                <a:latin typeface="阿里巴巴普惠体 3.0"/>
+              </a:rPr>
+              <a:t>1 个 @Bean</a:t>
+            </a:r>
+          </a:p>
+          <a:p>
+            <a:r>
+              <a:t>完成 RAG + MCP</a:t>
+            </a:r>
+          </a:p>
+        </p:txBody>
+      </p:sp>
+      <p:sp>
+        <p:nvSpPr>
+          <p:cNvPr id="14" name="TextBox 13"/>
+          <p:cNvSpPr txBox="1"/>
+          <p:nvPr/>
+        </p:nvSpPr>
+        <p:spPr>
+          <a:xfrm>
+            <a:off x="4587087" y="4069080"/>
+            <a:ext cx="3017520" cy="365760"/>
+          </a:xfrm>
+          <a:prstGeom prst="rect">
+            <a:avLst/>
+          </a:prstGeom>
+          <a:noFill/>
+        </p:spPr>
+        <p:txBody>
+          <a:bodyPr wrap="square">
+            <a:spAutoFit/>
+          </a:bodyPr>
+          <a:lstStyle/>
+          <a:p>
+            <a:pPr algn="ctr"/>
+            <a:r>
+              <a:rPr sz="1400" b="1">
+                <a:solidFill>
+                  <a:srgbClr val="007396"/>
+                </a:solidFill>
+                <a:latin typeface="阿里巴巴普惠体 3.0"/>
+              </a:rPr>
+              <a:t>1 天</a:t>
+            </a:r>
+          </a:p>
+        </p:txBody>
+      </p:sp>
+      <p:sp>
+        <p:nvSpPr>
+          <p:cNvPr id="15" name="Rounded Rectangle 14"/>
           <p:cNvSpPr/>
           <p:nvPr/>
         </p:nvSpPr>
         <p:spPr>
           <a:xfrm>
-            <a:off x="11658600" y="2194560"/>
-            <a:ext cx="4114800" cy="1188720"/>
+            <a:off x="8153247" y="1828800"/>
+            <a:ext cx="3383280" cy="2743200"/>
           </a:xfrm>
           <a:prstGeom prst="roundRect">
             <a:avLst/>
@@ -9386,210 +10340,180 @@
       </p:sp>
       <p:sp>
         <p:nvSpPr>
-          <p:cNvPr id="8" name="TextBox 7"/>
-          <p:cNvSpPr txBox="1"/>
-          <p:nvPr/>
-        </p:nvSpPr>
-        <p:spPr>
-          <a:xfrm>
-            <a:off x="11658600" y="2377440"/>
-            <a:ext cx="4114800" cy="822960"/>
-          </a:xfrm>
-          <a:prstGeom prst="rect">
-            <a:avLst/>
-          </a:prstGeom>
-          <a:noFill/>
-        </p:spPr>
-        <p:txBody>
-          <a:bodyPr wrap="square">
-            <a:spAutoFit/>
-          </a:bodyPr>
-          <a:lstStyle/>
-          <a:p>
-            <a:pPr algn="ctr"/>
-            <a:r>
-              <a:rPr sz="1600" b="1">
+          <p:cNvPr id="16" name="TextBox 15"/>
+          <p:cNvSpPr txBox="1"/>
+          <p:nvPr/>
+        </p:nvSpPr>
+        <p:spPr>
+          <a:xfrm>
+            <a:off x="8336127" y="1920240"/>
+            <a:ext cx="1280160" cy="1280160"/>
+          </a:xfrm>
+          <a:prstGeom prst="rect">
+            <a:avLst/>
+          </a:prstGeom>
+          <a:noFill/>
+        </p:spPr>
+        <p:txBody>
+          <a:bodyPr wrap="square">
+            <a:spAutoFit/>
+          </a:bodyPr>
+          <a:lstStyle/>
+          <a:p>
+            <a:pPr algn="ctr"/>
+            <a:r>
+              <a:rPr sz="7200" b="1">
                 <a:solidFill>
                   <a:srgbClr val="F59E0B"/>
                 </a:solidFill>
+                <a:latin typeface="Inter"/>
+              </a:rPr>
+              <a:t>3</a:t>
+            </a:r>
+          </a:p>
+        </p:txBody>
+      </p:sp>
+      <p:sp>
+        <p:nvSpPr>
+          <p:cNvPr id="17" name="TextBox 16"/>
+          <p:cNvSpPr txBox="1"/>
+          <p:nvPr/>
+        </p:nvSpPr>
+        <p:spPr>
+          <a:xfrm>
+            <a:off x="8336127" y="3200400"/>
+            <a:ext cx="3017520" cy="457200"/>
+          </a:xfrm>
+          <a:prstGeom prst="rect">
+            <a:avLst/>
+          </a:prstGeom>
+          <a:noFill/>
+        </p:spPr>
+        <p:txBody>
+          <a:bodyPr wrap="square">
+            <a:spAutoFit/>
+          </a:bodyPr>
+          <a:lstStyle/>
+          <a:p>
+            <a:pPr algn="ctr"/>
+            <a:r>
+              <a:rPr sz="2000" b="1">
+                <a:solidFill>
+                  <a:srgbClr val="F59E0B"/>
+                </a:solidFill>
                 <a:latin typeface="阿里巴巴普惠体 3.0"/>
               </a:rPr>
-              <a:t>🔌 MCP 可热插拔</a:t>
-            </a:r>
-          </a:p>
-          <a:p>
-            <a:r>
-              <a:t>8+ 服务</a:t>
-            </a:r>
-          </a:p>
-        </p:txBody>
-      </p:sp>
-      <p:sp>
-        <p:nvSpPr>
-          <p:cNvPr id="9" name="Rounded Rectangle 8"/>
-          <p:cNvSpPr/>
-          <p:nvPr/>
-        </p:nvSpPr>
-        <p:spPr>
-          <a:xfrm>
-            <a:off x="7315200" y="3611880"/>
-            <a:ext cx="4114800" cy="1188720"/>
-          </a:xfrm>
-          <a:prstGeom prst="roundRect">
-            <a:avLst/>
-          </a:prstGeom>
-          <a:solidFill>
-            <a:srgbClr val="FFFFFF"/>
-          </a:solidFill>
-          <a:ln w="38100">
-            <a:solidFill>
-              <a:srgbClr val="F59E0B"/>
-            </a:solidFill>
-          </a:ln>
-        </p:spPr>
-        <p:style>
-          <a:lnRef idx="1">
-            <a:schemeClr val="accent1"/>
-          </a:lnRef>
-          <a:fillRef idx="3">
-            <a:schemeClr val="accent1"/>
-          </a:fillRef>
-          <a:effectRef idx="2">
-            <a:schemeClr val="accent1"/>
-          </a:effectRef>
-          <a:fontRef idx="minor">
-            <a:schemeClr val="lt1"/>
-          </a:fontRef>
-        </p:style>
-        <p:txBody>
-          <a:bodyPr rtlCol="0" anchor="ctr"/>
-          <a:lstStyle/>
-          <a:p>
-            <a:pPr algn="ctr"/>
-          </a:p>
-        </p:txBody>
-      </p:sp>
-      <p:sp>
-        <p:nvSpPr>
-          <p:cNvPr id="10" name="TextBox 9"/>
-          <p:cNvSpPr txBox="1"/>
-          <p:nvPr/>
-        </p:nvSpPr>
-        <p:spPr>
-          <a:xfrm>
-            <a:off x="7315200" y="3794760"/>
-            <a:ext cx="4114800" cy="822960"/>
-          </a:xfrm>
-          <a:prstGeom prst="rect">
-            <a:avLst/>
-          </a:prstGeom>
-          <a:noFill/>
-        </p:spPr>
-        <p:txBody>
-          <a:bodyPr wrap="square">
-            <a:spAutoFit/>
-          </a:bodyPr>
-          <a:lstStyle/>
-          <a:p>
-            <a:pPr algn="ctr"/>
-            <a:r>
-              <a:rPr sz="1600" b="1">
+              <a:t>.st 模板</a:t>
+            </a:r>
+          </a:p>
+        </p:txBody>
+      </p:sp>
+      <p:sp>
+        <p:nvSpPr>
+          <p:cNvPr id="18" name="TextBox 17"/>
+          <p:cNvSpPr txBox="1"/>
+          <p:nvPr/>
+        </p:nvSpPr>
+        <p:spPr>
+          <a:xfrm>
+            <a:off x="8336127" y="3657600"/>
+            <a:ext cx="3017520" cy="548640"/>
+          </a:xfrm>
+          <a:prstGeom prst="rect">
+            <a:avLst/>
+          </a:prstGeom>
+          <a:noFill/>
+        </p:spPr>
+        <p:txBody>
+          <a:bodyPr wrap="square">
+            <a:spAutoFit/>
+          </a:bodyPr>
+          <a:lstStyle/>
+          <a:p>
+            <a:pPr algn="ctr"/>
+            <a:r>
+              <a:rPr sz="1300" b="0">
+                <a:solidFill>
+                  <a:srgbClr val="6B7280"/>
+                </a:solidFill>
+                <a:latin typeface="阿里巴巴普惠体 3.0"/>
+              </a:rPr>
+              <a:t>改 1 行字</a:t>
+            </a:r>
+          </a:p>
+          <a:p>
+            <a:r>
+              <a:t>AI 行为变</a:t>
+            </a:r>
+          </a:p>
+        </p:txBody>
+      </p:sp>
+      <p:sp>
+        <p:nvSpPr>
+          <p:cNvPr id="19" name="TextBox 18"/>
+          <p:cNvSpPr txBox="1"/>
+          <p:nvPr/>
+        </p:nvSpPr>
+        <p:spPr>
+          <a:xfrm>
+            <a:off x="8336127" y="4069080"/>
+            <a:ext cx="3017520" cy="365760"/>
+          </a:xfrm>
+          <a:prstGeom prst="rect">
+            <a:avLst/>
+          </a:prstGeom>
+          <a:noFill/>
+        </p:spPr>
+        <p:txBody>
+          <a:bodyPr wrap="square">
+            <a:spAutoFit/>
+          </a:bodyPr>
+          <a:lstStyle/>
+          <a:p>
+            <a:pPr algn="ctr"/>
+            <a:r>
+              <a:rPr sz="1400" b="1">
                 <a:solidFill>
                   <a:srgbClr val="F59E0B"/>
                 </a:solidFill>
                 <a:latin typeface="阿里巴巴普惠体 3.0"/>
               </a:rPr>
-              <a:t>🧠 Skill 模板</a:t>
-            </a:r>
-          </a:p>
-          <a:p>
-            <a:r>
-              <a:t>改 .st 即生效</a:t>
-            </a:r>
-          </a:p>
-        </p:txBody>
-      </p:sp>
-      <p:sp>
-        <p:nvSpPr>
-          <p:cNvPr id="11" name="Rounded Rectangle 10"/>
-          <p:cNvSpPr/>
-          <p:nvPr/>
-        </p:nvSpPr>
-        <p:spPr>
-          <a:xfrm>
-            <a:off x="11658600" y="3611880"/>
-            <a:ext cx="4114800" cy="1188720"/>
-          </a:xfrm>
-          <a:prstGeom prst="roundRect">
-            <a:avLst/>
-          </a:prstGeom>
-          <a:solidFill>
-            <a:srgbClr val="FFFFFF"/>
-          </a:solidFill>
-          <a:ln w="12700">
-            <a:solidFill>
-              <a:srgbClr val="E5E7EB"/>
-            </a:solidFill>
-          </a:ln>
-        </p:spPr>
-        <p:style>
-          <a:lnRef idx="1">
-            <a:schemeClr val="accent1"/>
-          </a:lnRef>
-          <a:fillRef idx="3">
-            <a:schemeClr val="accent1"/>
-          </a:fillRef>
-          <a:effectRef idx="2">
-            <a:schemeClr val="accent1"/>
-          </a:effectRef>
-          <a:fontRef idx="minor">
-            <a:schemeClr val="lt1"/>
-          </a:fontRef>
-        </p:style>
-        <p:txBody>
-          <a:bodyPr rtlCol="0" anchor="ctr"/>
-          <a:lstStyle/>
-          <a:p>
-            <a:pPr algn="ctr"/>
-          </a:p>
-        </p:txBody>
-      </p:sp>
-      <p:sp>
-        <p:nvSpPr>
-          <p:cNvPr id="12" name="TextBox 11"/>
-          <p:cNvSpPr txBox="1"/>
-          <p:nvPr/>
-        </p:nvSpPr>
-        <p:spPr>
-          <a:xfrm>
-            <a:off x="11658600" y="3794760"/>
-            <a:ext cx="4114800" cy="822960"/>
-          </a:xfrm>
-          <a:prstGeom prst="rect">
-            <a:avLst/>
-          </a:prstGeom>
-          <a:noFill/>
-        </p:spPr>
-        <p:txBody>
-          <a:bodyPr wrap="square">
-            <a:spAutoFit/>
-          </a:bodyPr>
-          <a:lstStyle/>
-          <a:p>
-            <a:pPr algn="ctr"/>
-            <a:r>
-              <a:rPr sz="1600" b="1">
-                <a:solidFill>
-                  <a:srgbClr val="007396"/>
-                </a:solidFill>
-                <a:latin typeface="阿里巴巴普惠体 3.0"/>
-              </a:rPr>
-              <a:t>💬 流式对话 + 思维链</a:t>
-            </a:r>
-          </a:p>
-          <a:p>
-            <a:r>
-              <a:t>SSE + 可折叠</a:t>
+              <a:t>10 分钟</a:t>
+            </a:r>
+          </a:p>
+        </p:txBody>
+      </p:sp>
+      <p:sp>
+        <p:nvSpPr>
+          <p:cNvPr id="21" name="TextBox 20"/>
+          <p:cNvSpPr txBox="1"/>
+          <p:nvPr/>
+        </p:nvSpPr>
+        <p:spPr>
+          <a:xfrm>
+            <a:off x="10607040" y="6446520"/>
+            <a:ext cx="1280160" cy="274320"/>
+          </a:xfrm>
+          <a:prstGeom prst="rect">
+            <a:avLst/>
+          </a:prstGeom>
+          <a:noFill/>
+        </p:spPr>
+        <p:txBody>
+          <a:bodyPr wrap="square">
+            <a:spAutoFit/>
+          </a:bodyPr>
+          <a:lstStyle/>
+          <a:p>
+            <a:pPr algn="ctr"/>
+            <a:r>
+              <a:rPr sz="1000" b="0">
+                <a:solidFill>
+                  <a:srgbClr val="6B7280"/>
+                </a:solidFill>
+                <a:latin typeface="Inter"/>
+              </a:rPr>
+              <a:t>04 / 12</a:t>
             </a:r>
           </a:p>
         </p:txBody>
@@ -9642,7 +10566,7 @@
             <p:tnCond val="0"/>
           </p:cond>
           <p:par>
-            <p:cTn id="8" nodeType="withEffect" dur="500" begin="700ms" fill="hold">
+            <p:cTn id="10" nodeType="withEffect" dur="500" begin="400ms" fill="hold">
               <p:animEffect presetClass="entr" presetId="10" dur="500"/>
             </p:cTn>
           </p:par>
@@ -9659,7 +10583,7 @@
             <p:tnCond val="0"/>
           </p:cond>
           <p:par>
-            <p:cTn id="10" nodeType="withEffect" dur="500" begin="1000ms" fill="hold">
+            <p:cTn id="11" nodeType="withEffect" dur="500" begin="700ms" fill="hold">
               <p:animEffect presetClass="entr" presetId="10" dur="500"/>
             </p:cTn>
           </p:par>
@@ -9676,7 +10600,7 @@
             <p:tnCond val="0"/>
           </p:cond>
           <p:par>
-            <p:cTn id="12" nodeType="withEffect" dur="500" begin="1300ms" fill="hold">
+            <p:cTn id="15" nodeType="withEffect" dur="500" begin="700ms" fill="hold">
               <p:animEffect presetClass="entr" presetId="10" dur="500"/>
             </p:cTn>
           </p:par>
@@ -9693,7 +10617,41 @@
             <p:tnCond val="0"/>
           </p:cond>
           <p:par>
-            <p:cTn id="10" nodeType="withEffect" dur="1500" begin="2500ms" fill="hold" repeatCount="indefinite">
+            <p:cTn id="16" nodeType="withEffect" dur="500" begin="1000ms" fill="hold">
+              <p:animEffect presetClass="entr" presetId="10" dur="500"/>
+            </p:cTn>
+          </p:par>
+        </p:par>
+      </p:par>
+    </p:tnLst>
+  </p:timing>
+  <p:timing>
+    <p:tnLst>
+      <p:par>
+        <p:pPr/>
+        <p:par>
+          <p:cond>
+            <p:tnCond val="0"/>
+          </p:cond>
+          <p:par>
+            <p:cTn id="20" nodeType="withEffect" dur="500" begin="1000ms" fill="hold">
+              <p:animEffect presetClass="entr" presetId="10" dur="500"/>
+            </p:cTn>
+          </p:par>
+        </p:par>
+      </p:par>
+    </p:tnLst>
+  </p:timing>
+  <p:timing>
+    <p:tnLst>
+      <p:par>
+        <p:pPr/>
+        <p:par>
+          <p:cond>
+            <p:tnCond val="0"/>
+          </p:cond>
+          <p:par>
+            <p:cTn id="16" nodeType="withEffect" dur="1500" begin="2000ms" fill="hold" repeatCount="indefinite">
               <p:animEffect presetClass="emph" presetId="26" dur="1500"/>
             </p:cTn>
           </p:par>
@@ -10478,6 +11436,41 @@
                 <a:latin typeface="阿里巴巴普惠体 3.0"/>
               </a:rPr>
               <a:t>★ 改一个 .st 文件,AI 行为就变</a:t>
+            </a:r>
+          </a:p>
+        </p:txBody>
+      </p:sp>
+      <p:sp>
+        <p:nvSpPr>
+          <p:cNvPr id="22" name="TextBox 21"/>
+          <p:cNvSpPr txBox="1"/>
+          <p:nvPr/>
+        </p:nvSpPr>
+        <p:spPr>
+          <a:xfrm>
+            <a:off x="10607040" y="6446520"/>
+            <a:ext cx="1280160" cy="274320"/>
+          </a:xfrm>
+          <a:prstGeom prst="rect">
+            <a:avLst/>
+          </a:prstGeom>
+          <a:noFill/>
+        </p:spPr>
+        <p:txBody>
+          <a:bodyPr wrap="square">
+            <a:spAutoFit/>
+          </a:bodyPr>
+          <a:lstStyle/>
+          <a:p>
+            <a:pPr algn="ctr"/>
+            <a:r>
+              <a:rPr sz="1000" b="0">
+                <a:solidFill>
+                  <a:srgbClr val="6B7280"/>
+                </a:solidFill>
+                <a:latin typeface="Inter"/>
+              </a:rPr>
+              <a:t>05 / 12</a:t>
             </a:r>
           </a:p>
         </p:txBody>
@@ -10646,7 +11639,7 @@
       <p:grpSpPr/>
       <p:pic>
         <p:nvPicPr>
-          <p:cNvPr id="13" name="Picture 12" descr="p5a-calcite-federation.png"/>
+          <p:cNvPr id="20" name="Picture 19" descr="p5a-calcite-federation.png"/>
           <p:cNvPicPr>
             <a:picLocks noChangeAspect="1"/>
           </p:cNvPicPr>
@@ -10654,7 +11647,7 @@
         </p:nvPicPr>
         <p:blipFill>
           <a:blip r:embed="rId2">
-            <a:alphaModFix amt="55000"/>
+            <a:alphaModFix amt="100000"/>
           </a:blip>
           <a:stretch>
             <a:fillRect/>
@@ -10662,8 +11655,8 @@
         </p:blipFill>
         <p:spPr>
           <a:xfrm>
-            <a:off x="274320" y="2194560"/>
-            <a:ext cx="4114800" cy="3657600"/>
+            <a:off x="365760" y="4846320"/>
+            <a:ext cx="2286000" cy="1828800"/>
           </a:xfrm>
           <a:prstGeom prst="rect">
             <a:avLst/>
@@ -10678,7 +11671,7 @@
         </p:nvSpPr>
         <p:spPr>
           <a:xfrm>
-            <a:off x="457200" y="365760"/>
+            <a:off x="457200" y="274320"/>
             <a:ext cx="11277295" cy="365760"/>
           </a:xfrm>
           <a:prstGeom prst="rect">
@@ -10713,7 +11706,7 @@
         </p:nvSpPr>
         <p:spPr>
           <a:xfrm>
-            <a:off x="457200" y="777240"/>
+            <a:off x="457200" y="640080"/>
             <a:ext cx="11277295" cy="640080"/>
           </a:xfrm>
           <a:prstGeom prst="rect">
@@ -10729,13 +11722,13 @@
           <a:p>
             <a:pPr algn="ctr"/>
             <a:r>
-              <a:rPr sz="3200" b="1">
+              <a:rPr sz="2800" b="1">
                 <a:solidFill>
                   <a:srgbClr val="1F2937"/>
                 </a:solidFill>
                 <a:latin typeface="阿里巴巴普惠体 3.0"/>
               </a:rPr>
-              <a:t>JSON CRUD + Calcite 联邦 + Amis 低代码</a:t>
+              <a:t>从 JDBC 散弹到 Calcite 联邦</a:t>
             </a:r>
           </a:p>
         </p:txBody>
@@ -10748,7 +11741,7 @@
         </p:nvSpPr>
         <p:spPr>
           <a:xfrm>
-            <a:off x="457200" y="1325880"/>
+            <a:off x="457200" y="1280160"/>
             <a:ext cx="11277295" cy="365760"/>
           </a:xfrm>
           <a:prstGeom prst="rect">
@@ -10764,13 +11757,13 @@
           <a:p>
             <a:pPr algn="ctr"/>
             <a:r>
-              <a:rPr sz="1600" b="1">
+              <a:rPr sz="1500" b="1">
                 <a:solidFill>
                   <a:srgbClr val="F59E0B"/>
                 </a:solidFill>
                 <a:latin typeface="阿里巴巴普惠体 3.0"/>
               </a:rPr>
-              <a:t>★ 一套协议 5 method,跨库即写即用,数据不出企业</a:t>
+              <a:t>★ 1 套协议代替 5 套 ORM,数据库迁移零改代码</a:t>
             </a:r>
           </a:p>
         </p:txBody>
@@ -10783,8 +11776,388 @@
         </p:nvSpPr>
         <p:spPr>
           <a:xfrm>
-            <a:off x="7315200" y="2194560"/>
-            <a:ext cx="4114800" cy="1188720"/>
+            <a:off x="655167" y="1828800"/>
+            <a:ext cx="3383280" cy="2743200"/>
+          </a:xfrm>
+          <a:prstGeom prst="roundRect">
+            <a:avLst/>
+          </a:prstGeom>
+          <a:solidFill>
+            <a:srgbClr val="FFFFFF"/>
+          </a:solidFill>
+          <a:ln w="19050">
+            <a:solidFill>
+              <a:srgbClr val="E5E7EB"/>
+            </a:solidFill>
+          </a:ln>
+        </p:spPr>
+        <p:style>
+          <a:lnRef idx="1">
+            <a:schemeClr val="accent1"/>
+          </a:lnRef>
+          <a:fillRef idx="3">
+            <a:schemeClr val="accent1"/>
+          </a:fillRef>
+          <a:effectRef idx="2">
+            <a:schemeClr val="accent1"/>
+          </a:effectRef>
+          <a:fontRef idx="minor">
+            <a:schemeClr val="lt1"/>
+          </a:fontRef>
+        </p:style>
+        <p:txBody>
+          <a:bodyPr rtlCol="0" anchor="ctr"/>
+          <a:lstStyle/>
+          <a:p>
+            <a:pPr algn="ctr"/>
+          </a:p>
+        </p:txBody>
+      </p:sp>
+      <p:sp>
+        <p:nvSpPr>
+          <p:cNvPr id="6" name="TextBox 5"/>
+          <p:cNvSpPr txBox="1"/>
+          <p:nvPr/>
+        </p:nvSpPr>
+        <p:spPr>
+          <a:xfrm>
+            <a:off x="838047" y="1920240"/>
+            <a:ext cx="1280160" cy="1280160"/>
+          </a:xfrm>
+          <a:prstGeom prst="rect">
+            <a:avLst/>
+          </a:prstGeom>
+          <a:noFill/>
+        </p:spPr>
+        <p:txBody>
+          <a:bodyPr wrap="square">
+            <a:spAutoFit/>
+          </a:bodyPr>
+          <a:lstStyle/>
+          <a:p>
+            <a:pPr algn="ctr"/>
+            <a:r>
+              <a:rPr sz="7200" b="1">
+                <a:solidFill>
+                  <a:srgbClr val="E5E7EB"/>
+                </a:solidFill>
+                <a:latin typeface="Inter"/>
+              </a:rPr>
+              <a:t>1</a:t>
+            </a:r>
+          </a:p>
+        </p:txBody>
+      </p:sp>
+      <p:sp>
+        <p:nvSpPr>
+          <p:cNvPr id="7" name="TextBox 6"/>
+          <p:cNvSpPr txBox="1"/>
+          <p:nvPr/>
+        </p:nvSpPr>
+        <p:spPr>
+          <a:xfrm>
+            <a:off x="838047" y="3200400"/>
+            <a:ext cx="3017520" cy="457200"/>
+          </a:xfrm>
+          <a:prstGeom prst="rect">
+            <a:avLst/>
+          </a:prstGeom>
+          <a:noFill/>
+        </p:spPr>
+        <p:txBody>
+          <a:bodyPr wrap="square">
+            <a:spAutoFit/>
+          </a:bodyPr>
+          <a:lstStyle/>
+          <a:p>
+            <a:pPr algn="ctr"/>
+            <a:r>
+              <a:rPr sz="2000" b="1">
+                <a:solidFill>
+                  <a:srgbClr val="E5E7EB"/>
+                </a:solidFill>
+                <a:latin typeface="阿里巴巴普惠体 3.0"/>
+              </a:rPr>
+              <a:t>裸 JDBC / MyBatis</a:t>
+            </a:r>
+          </a:p>
+        </p:txBody>
+      </p:sp>
+      <p:sp>
+        <p:nvSpPr>
+          <p:cNvPr id="8" name="TextBox 7"/>
+          <p:cNvSpPr txBox="1"/>
+          <p:nvPr/>
+        </p:nvSpPr>
+        <p:spPr>
+          <a:xfrm>
+            <a:off x="838047" y="3657600"/>
+            <a:ext cx="3017520" cy="548640"/>
+          </a:xfrm>
+          <a:prstGeom prst="rect">
+            <a:avLst/>
+          </a:prstGeom>
+          <a:noFill/>
+        </p:spPr>
+        <p:txBody>
+          <a:bodyPr wrap="square">
+            <a:spAutoFit/>
+          </a:bodyPr>
+          <a:lstStyle/>
+          <a:p>
+            <a:pPr algn="ctr"/>
+            <a:r>
+              <a:rPr sz="1300" b="0">
+                <a:solidFill>
+                  <a:srgbClr val="6B7280"/>
+                </a:solidFill>
+                <a:latin typeface="阿里巴巴普惠体 3.0"/>
+              </a:rPr>
+              <a:t>维护 N 套 CRUD</a:t>
+            </a:r>
+          </a:p>
+          <a:p>
+            <a:r>
+              <a:t>N 套 ORM 配置</a:t>
+            </a:r>
+          </a:p>
+        </p:txBody>
+      </p:sp>
+      <p:sp>
+        <p:nvSpPr>
+          <p:cNvPr id="9" name="TextBox 8"/>
+          <p:cNvSpPr txBox="1"/>
+          <p:nvPr/>
+        </p:nvSpPr>
+        <p:spPr>
+          <a:xfrm>
+            <a:off x="838047" y="4069080"/>
+            <a:ext cx="3017520" cy="365760"/>
+          </a:xfrm>
+          <a:prstGeom prst="rect">
+            <a:avLst/>
+          </a:prstGeom>
+          <a:noFill/>
+        </p:spPr>
+        <p:txBody>
+          <a:bodyPr wrap="square">
+            <a:spAutoFit/>
+          </a:bodyPr>
+          <a:lstStyle/>
+          <a:p>
+            <a:pPr algn="ctr"/>
+            <a:r>
+              <a:rPr sz="1400" b="1">
+                <a:solidFill>
+                  <a:srgbClr val="E5E7EB"/>
+                </a:solidFill>
+                <a:latin typeface="阿里巴巴普惠体 3.0"/>
+              </a:rPr>
+              <a:t>30 天</a:t>
+            </a:r>
+          </a:p>
+        </p:txBody>
+      </p:sp>
+      <p:sp>
+        <p:nvSpPr>
+          <p:cNvPr id="10" name="Rounded Rectangle 9"/>
+          <p:cNvSpPr/>
+          <p:nvPr/>
+        </p:nvSpPr>
+        <p:spPr>
+          <a:xfrm>
+            <a:off x="4404207" y="1828800"/>
+            <a:ext cx="3383280" cy="2743200"/>
+          </a:xfrm>
+          <a:prstGeom prst="roundRect">
+            <a:avLst/>
+          </a:prstGeom>
+          <a:solidFill>
+            <a:srgbClr val="FFFFFF"/>
+          </a:solidFill>
+          <a:ln w="19050">
+            <a:solidFill>
+              <a:srgbClr val="6B46C1"/>
+            </a:solidFill>
+          </a:ln>
+        </p:spPr>
+        <p:style>
+          <a:lnRef idx="1">
+            <a:schemeClr val="accent1"/>
+          </a:lnRef>
+          <a:fillRef idx="3">
+            <a:schemeClr val="accent1"/>
+          </a:fillRef>
+          <a:effectRef idx="2">
+            <a:schemeClr val="accent1"/>
+          </a:effectRef>
+          <a:fontRef idx="minor">
+            <a:schemeClr val="lt1"/>
+          </a:fontRef>
+        </p:style>
+        <p:txBody>
+          <a:bodyPr rtlCol="0" anchor="ctr"/>
+          <a:lstStyle/>
+          <a:p>
+            <a:pPr algn="ctr"/>
+          </a:p>
+        </p:txBody>
+      </p:sp>
+      <p:sp>
+        <p:nvSpPr>
+          <p:cNvPr id="11" name="TextBox 10"/>
+          <p:cNvSpPr txBox="1"/>
+          <p:nvPr/>
+        </p:nvSpPr>
+        <p:spPr>
+          <a:xfrm>
+            <a:off x="4587087" y="1920240"/>
+            <a:ext cx="1280160" cy="1280160"/>
+          </a:xfrm>
+          <a:prstGeom prst="rect">
+            <a:avLst/>
+          </a:prstGeom>
+          <a:noFill/>
+        </p:spPr>
+        <p:txBody>
+          <a:bodyPr wrap="square">
+            <a:spAutoFit/>
+          </a:bodyPr>
+          <a:lstStyle/>
+          <a:p>
+            <a:pPr algn="ctr"/>
+            <a:r>
+              <a:rPr sz="7200" b="1">
+                <a:solidFill>
+                  <a:srgbClr val="6B46C1"/>
+                </a:solidFill>
+                <a:latin typeface="Inter"/>
+              </a:rPr>
+              <a:t>2</a:t>
+            </a:r>
+          </a:p>
+        </p:txBody>
+      </p:sp>
+      <p:sp>
+        <p:nvSpPr>
+          <p:cNvPr id="12" name="TextBox 11"/>
+          <p:cNvSpPr txBox="1"/>
+          <p:nvPr/>
+        </p:nvSpPr>
+        <p:spPr>
+          <a:xfrm>
+            <a:off x="4587087" y="3200400"/>
+            <a:ext cx="3017520" cy="457200"/>
+          </a:xfrm>
+          <a:prstGeom prst="rect">
+            <a:avLst/>
+          </a:prstGeom>
+          <a:noFill/>
+        </p:spPr>
+        <p:txBody>
+          <a:bodyPr wrap="square">
+            <a:spAutoFit/>
+          </a:bodyPr>
+          <a:lstStyle/>
+          <a:p>
+            <a:pPr algn="ctr"/>
+            <a:r>
+              <a:rPr sz="2000" b="1">
+                <a:solidFill>
+                  <a:srgbClr val="6B46C1"/>
+                </a:solidFill>
+                <a:latin typeface="阿里巴巴普惠体 3.0"/>
+              </a:rPr>
+              <a:t>SQL 工坊 starter</a:t>
+            </a:r>
+          </a:p>
+        </p:txBody>
+      </p:sp>
+      <p:sp>
+        <p:nvSpPr>
+          <p:cNvPr id="13" name="TextBox 12"/>
+          <p:cNvSpPr txBox="1"/>
+          <p:nvPr/>
+        </p:nvSpPr>
+        <p:spPr>
+          <a:xfrm>
+            <a:off x="4587087" y="3657600"/>
+            <a:ext cx="3017520" cy="548640"/>
+          </a:xfrm>
+          <a:prstGeom prst="rect">
+            <a:avLst/>
+          </a:prstGeom>
+          <a:noFill/>
+        </p:spPr>
+        <p:txBody>
+          <a:bodyPr wrap="square">
+            <a:spAutoFit/>
+          </a:bodyPr>
+          <a:lstStyle/>
+          <a:p>
+            <a:pPr algn="ctr"/>
+            <a:r>
+              <a:rPr sz="1300" b="0">
+                <a:solidFill>
+                  <a:srgbClr val="6B7280"/>
+                </a:solidFill>
+                <a:latin typeface="阿里巴巴普惠体 3.0"/>
+              </a:rPr>
+              <a:t>1 套 JSON 协议</a:t>
+            </a:r>
+          </a:p>
+          <a:p>
+            <a:r>
+              <a:t>跨库自动 JOIN</a:t>
+            </a:r>
+          </a:p>
+        </p:txBody>
+      </p:sp>
+      <p:sp>
+        <p:nvSpPr>
+          <p:cNvPr id="14" name="TextBox 13"/>
+          <p:cNvSpPr txBox="1"/>
+          <p:nvPr/>
+        </p:nvSpPr>
+        <p:spPr>
+          <a:xfrm>
+            <a:off x="4587087" y="4069080"/>
+            <a:ext cx="3017520" cy="365760"/>
+          </a:xfrm>
+          <a:prstGeom prst="rect">
+            <a:avLst/>
+          </a:prstGeom>
+          <a:noFill/>
+        </p:spPr>
+        <p:txBody>
+          <a:bodyPr wrap="square">
+            <a:spAutoFit/>
+          </a:bodyPr>
+          <a:lstStyle/>
+          <a:p>
+            <a:pPr algn="ctr"/>
+            <a:r>
+              <a:rPr sz="1400" b="1">
+                <a:solidFill>
+                  <a:srgbClr val="6B46C1"/>
+                </a:solidFill>
+                <a:latin typeface="阿里巴巴普惠体 3.0"/>
+              </a:rPr>
+              <a:t>1 天</a:t>
+            </a:r>
+          </a:p>
+        </p:txBody>
+      </p:sp>
+      <p:sp>
+        <p:nvSpPr>
+          <p:cNvPr id="15" name="Rounded Rectangle 14"/>
+          <p:cNvSpPr/>
+          <p:nvPr/>
+        </p:nvSpPr>
+        <p:spPr>
+          <a:xfrm>
+            <a:off x="8153247" y="1828800"/>
+            <a:ext cx="3383280" cy="2743200"/>
           </a:xfrm>
           <a:prstGeom prst="roundRect">
             <a:avLst/>
@@ -10822,295 +12195,180 @@
       </p:sp>
       <p:sp>
         <p:nvSpPr>
-          <p:cNvPr id="6" name="TextBox 5"/>
-          <p:cNvSpPr txBox="1"/>
-          <p:nvPr/>
-        </p:nvSpPr>
-        <p:spPr>
-          <a:xfrm>
-            <a:off x="7315200" y="2377440"/>
-            <a:ext cx="4114800" cy="822960"/>
-          </a:xfrm>
-          <a:prstGeom prst="rect">
-            <a:avLst/>
-          </a:prstGeom>
-          <a:noFill/>
-        </p:spPr>
-        <p:txBody>
-          <a:bodyPr wrap="square">
-            <a:spAutoFit/>
-          </a:bodyPr>
-          <a:lstStyle/>
-          <a:p>
-            <a:pPr algn="ctr"/>
-            <a:r>
-              <a:rPr sz="1600" b="1">
+          <p:cNvPr id="16" name="TextBox 15"/>
+          <p:cNvSpPr txBox="1"/>
+          <p:nvPr/>
+        </p:nvSpPr>
+        <p:spPr>
+          <a:xfrm>
+            <a:off x="8336127" y="1920240"/>
+            <a:ext cx="1280160" cy="1280160"/>
+          </a:xfrm>
+          <a:prstGeom prst="rect">
+            <a:avLst/>
+          </a:prstGeom>
+          <a:noFill/>
+        </p:spPr>
+        <p:txBody>
+          <a:bodyPr wrap="square">
+            <a:spAutoFit/>
+          </a:bodyPr>
+          <a:lstStyle/>
+          <a:p>
+            <a:pPr algn="ctr"/>
+            <a:r>
+              <a:rPr sz="7200" b="1">
                 <a:solidFill>
                   <a:srgbClr val="F59E0B"/>
                 </a:solidFill>
+                <a:latin typeface="Inter"/>
+              </a:rPr>
+              <a:t>3</a:t>
+            </a:r>
+          </a:p>
+        </p:txBody>
+      </p:sp>
+      <p:sp>
+        <p:nvSpPr>
+          <p:cNvPr id="17" name="TextBox 16"/>
+          <p:cNvSpPr txBox="1"/>
+          <p:nvPr/>
+        </p:nvSpPr>
+        <p:spPr>
+          <a:xfrm>
+            <a:off x="8336127" y="3200400"/>
+            <a:ext cx="3017520" cy="457200"/>
+          </a:xfrm>
+          <a:prstGeom prst="rect">
+            <a:avLst/>
+          </a:prstGeom>
+          <a:noFill/>
+        </p:spPr>
+        <p:txBody>
+          <a:bodyPr wrap="square">
+            <a:spAutoFit/>
+          </a:bodyPr>
+          <a:lstStyle/>
+          <a:p>
+            <a:pPr algn="ctr"/>
+            <a:r>
+              <a:rPr sz="2000" b="1">
+                <a:solidFill>
+                  <a:srgbClr val="F59E0B"/>
+                </a:solidFill>
                 <a:latin typeface="阿里巴巴普惠体 3.0"/>
               </a:rPr>
-              <a:t>🔌 JSON CRUD</a:t>
-            </a:r>
-          </a:p>
-          <a:p>
-            <a:r>
-              <a:t>一套协议 5 method</a:t>
-            </a:r>
-          </a:p>
-        </p:txBody>
-      </p:sp>
-      <p:sp>
-        <p:nvSpPr>
-          <p:cNvPr id="7" name="Rounded Rectangle 6"/>
-          <p:cNvSpPr/>
-          <p:nvPr/>
-        </p:nvSpPr>
-        <p:spPr>
-          <a:xfrm>
-            <a:off x="11658600" y="2194560"/>
-            <a:ext cx="4114800" cy="1188720"/>
-          </a:xfrm>
-          <a:prstGeom prst="roundRect">
-            <a:avLst/>
-          </a:prstGeom>
-          <a:solidFill>
-            <a:srgbClr val="FFFFFF"/>
-          </a:solidFill>
-          <a:ln w="38100">
-            <a:solidFill>
-              <a:srgbClr val="F59E0B"/>
-            </a:solidFill>
-          </a:ln>
-        </p:spPr>
-        <p:style>
-          <a:lnRef idx="1">
-            <a:schemeClr val="accent1"/>
-          </a:lnRef>
-          <a:fillRef idx="3">
-            <a:schemeClr val="accent1"/>
-          </a:fillRef>
-          <a:effectRef idx="2">
-            <a:schemeClr val="accent1"/>
-          </a:effectRef>
-          <a:fontRef idx="minor">
-            <a:schemeClr val="lt1"/>
-          </a:fontRef>
-        </p:style>
-        <p:txBody>
-          <a:bodyPr rtlCol="0" anchor="ctr"/>
-          <a:lstStyle/>
-          <a:p>
-            <a:pPr algn="ctr"/>
-          </a:p>
-        </p:txBody>
-      </p:sp>
-      <p:sp>
-        <p:nvSpPr>
-          <p:cNvPr id="8" name="TextBox 7"/>
-          <p:cNvSpPr txBox="1"/>
-          <p:nvPr/>
-        </p:nvSpPr>
-        <p:spPr>
-          <a:xfrm>
-            <a:off x="11658600" y="2377440"/>
-            <a:ext cx="4114800" cy="822960"/>
-          </a:xfrm>
-          <a:prstGeom prst="rect">
-            <a:avLst/>
-          </a:prstGeom>
-          <a:noFill/>
-        </p:spPr>
-        <p:txBody>
-          <a:bodyPr wrap="square">
-            <a:spAutoFit/>
-          </a:bodyPr>
-          <a:lstStyle/>
-          <a:p>
-            <a:pPr algn="ctr"/>
-            <a:r>
-              <a:rPr sz="1600" b="1">
+              <a:t>sql-forge-mcp</a:t>
+            </a:r>
+          </a:p>
+        </p:txBody>
+      </p:sp>
+      <p:sp>
+        <p:nvSpPr>
+          <p:cNvPr id="18" name="TextBox 17"/>
+          <p:cNvSpPr txBox="1"/>
+          <p:nvPr/>
+        </p:nvSpPr>
+        <p:spPr>
+          <a:xfrm>
+            <a:off x="8336127" y="3657600"/>
+            <a:ext cx="3017520" cy="548640"/>
+          </a:xfrm>
+          <a:prstGeom prst="rect">
+            <a:avLst/>
+          </a:prstGeom>
+          <a:noFill/>
+        </p:spPr>
+        <p:txBody>
+          <a:bodyPr wrap="square">
+            <a:spAutoFit/>
+          </a:bodyPr>
+          <a:lstStyle/>
+          <a:p>
+            <a:pPr algn="ctr"/>
+            <a:r>
+              <a:rPr sz="1300" b="0">
+                <a:solidFill>
+                  <a:srgbClr val="6B7280"/>
+                </a:solidFill>
+                <a:latin typeface="阿里巴巴普惠体 3.0"/>
+              </a:rPr>
+              <a:t>AI 5 受限通道</a:t>
+            </a:r>
+          </a:p>
+          <a:p>
+            <a:r>
+              <a:t>数据不出企业</a:t>
+            </a:r>
+          </a:p>
+        </p:txBody>
+      </p:sp>
+      <p:sp>
+        <p:nvSpPr>
+          <p:cNvPr id="19" name="TextBox 18"/>
+          <p:cNvSpPr txBox="1"/>
+          <p:nvPr/>
+        </p:nvSpPr>
+        <p:spPr>
+          <a:xfrm>
+            <a:off x="8336127" y="4069080"/>
+            <a:ext cx="3017520" cy="365760"/>
+          </a:xfrm>
+          <a:prstGeom prst="rect">
+            <a:avLst/>
+          </a:prstGeom>
+          <a:noFill/>
+        </p:spPr>
+        <p:txBody>
+          <a:bodyPr wrap="square">
+            <a:spAutoFit/>
+          </a:bodyPr>
+          <a:lstStyle/>
+          <a:p>
+            <a:pPr algn="ctr"/>
+            <a:r>
+              <a:rPr sz="1400" b="1">
                 <a:solidFill>
                   <a:srgbClr val="F59E0B"/>
                 </a:solidFill>
                 <a:latin typeface="阿里巴巴普惠体 3.0"/>
               </a:rPr>
-              <a:t>🌐 Calcite 联邦</a:t>
-            </a:r>
-          </a:p>
-          <a:p>
-            <a:r>
-              <a:t>跨 MySQL+PG+H2</a:t>
-            </a:r>
-          </a:p>
-        </p:txBody>
-      </p:sp>
-      <p:sp>
-        <p:nvSpPr>
-          <p:cNvPr id="9" name="Rounded Rectangle 8"/>
-          <p:cNvSpPr/>
-          <p:nvPr/>
-        </p:nvSpPr>
-        <p:spPr>
-          <a:xfrm>
-            <a:off x="7315200" y="3611880"/>
-            <a:ext cx="4114800" cy="1188720"/>
-          </a:xfrm>
-          <a:prstGeom prst="roundRect">
-            <a:avLst/>
-          </a:prstGeom>
-          <a:solidFill>
-            <a:srgbClr val="FFFFFF"/>
-          </a:solidFill>
-          <a:ln w="38100">
-            <a:solidFill>
-              <a:srgbClr val="F59E0B"/>
-            </a:solidFill>
-          </a:ln>
-        </p:spPr>
-        <p:style>
-          <a:lnRef idx="1">
-            <a:schemeClr val="accent1"/>
-          </a:lnRef>
-          <a:fillRef idx="3">
-            <a:schemeClr val="accent1"/>
-          </a:fillRef>
-          <a:effectRef idx="2">
-            <a:schemeClr val="accent1"/>
-          </a:effectRef>
-          <a:fontRef idx="minor">
-            <a:schemeClr val="lt1"/>
-          </a:fontRef>
-        </p:style>
-        <p:txBody>
-          <a:bodyPr rtlCol="0" anchor="ctr"/>
-          <a:lstStyle/>
-          <a:p>
-            <a:pPr algn="ctr"/>
-          </a:p>
-        </p:txBody>
-      </p:sp>
-      <p:sp>
-        <p:nvSpPr>
-          <p:cNvPr id="10" name="TextBox 9"/>
-          <p:cNvSpPr txBox="1"/>
-          <p:nvPr/>
-        </p:nvSpPr>
-        <p:spPr>
-          <a:xfrm>
-            <a:off x="7315200" y="3794760"/>
-            <a:ext cx="4114800" cy="822960"/>
-          </a:xfrm>
-          <a:prstGeom prst="rect">
-            <a:avLst/>
-          </a:prstGeom>
-          <a:noFill/>
-        </p:spPr>
-        <p:txBody>
-          <a:bodyPr wrap="square">
-            <a:spAutoFit/>
-          </a:bodyPr>
-          <a:lstStyle/>
-          <a:p>
-            <a:pPr algn="ctr"/>
-            <a:r>
-              <a:rPr sz="1600" b="1">
-                <a:solidFill>
-                  <a:srgbClr val="F59E0B"/>
-                </a:solidFill>
-                <a:latin typeface="阿里巴巴普惠体 3.0"/>
-              </a:rPr>
-              <a:t>🎨 Amis 低代码</a:t>
-            </a:r>
-          </a:p>
-          <a:p>
-            <a:r>
-              <a:t>JSON 模板 + Console</a:t>
-            </a:r>
-          </a:p>
-        </p:txBody>
-      </p:sp>
-      <p:sp>
-        <p:nvSpPr>
-          <p:cNvPr id="11" name="Rounded Rectangle 10"/>
-          <p:cNvSpPr/>
-          <p:nvPr/>
-        </p:nvSpPr>
-        <p:spPr>
-          <a:xfrm>
-            <a:off x="11658600" y="3611880"/>
-            <a:ext cx="4114800" cy="1188720"/>
-          </a:xfrm>
-          <a:prstGeom prst="roundRect">
-            <a:avLst/>
-          </a:prstGeom>
-          <a:solidFill>
-            <a:srgbClr val="FFFFFF"/>
-          </a:solidFill>
-          <a:ln w="12700">
-            <a:solidFill>
-              <a:srgbClr val="E5E7EB"/>
-            </a:solidFill>
-          </a:ln>
-        </p:spPr>
-        <p:style>
-          <a:lnRef idx="1">
-            <a:schemeClr val="accent1"/>
-          </a:lnRef>
-          <a:fillRef idx="3">
-            <a:schemeClr val="accent1"/>
-          </a:fillRef>
-          <a:effectRef idx="2">
-            <a:schemeClr val="accent1"/>
-          </a:effectRef>
-          <a:fontRef idx="minor">
-            <a:schemeClr val="lt1"/>
-          </a:fontRef>
-        </p:style>
-        <p:txBody>
-          <a:bodyPr rtlCol="0" anchor="ctr"/>
-          <a:lstStyle/>
-          <a:p>
-            <a:pPr algn="ctr"/>
-          </a:p>
-        </p:txBody>
-      </p:sp>
-      <p:sp>
-        <p:nvSpPr>
-          <p:cNvPr id="12" name="TextBox 11"/>
-          <p:cNvSpPr txBox="1"/>
-          <p:nvPr/>
-        </p:nvSpPr>
-        <p:spPr>
-          <a:xfrm>
-            <a:off x="11658600" y="3794760"/>
-            <a:ext cx="4114800" cy="822960"/>
-          </a:xfrm>
-          <a:prstGeom prst="rect">
-            <a:avLst/>
-          </a:prstGeom>
-          <a:noFill/>
-        </p:spPr>
-        <p:txBody>
-          <a:bodyPr wrap="square">
-            <a:spAutoFit/>
-          </a:bodyPr>
-          <a:lstStyle/>
-          <a:p>
-            <a:pPr algn="ctr"/>
-            <a:r>
-              <a:rPr sz="1600" b="1">
-                <a:solidFill>
-                  <a:srgbClr val="007396"/>
-                </a:solidFill>
-                <a:latin typeface="阿里巴巴普惠体 3.0"/>
-              </a:rPr>
-              <a:t>🔒 MCP 5 受限工具</a:t>
-            </a:r>
-          </a:p>
-          <a:p>
-            <a:r>
-              <a:t>数据不出企业</a:t>
+              <a:t>0 直连</a:t>
+            </a:r>
+          </a:p>
+        </p:txBody>
+      </p:sp>
+      <p:sp>
+        <p:nvSpPr>
+          <p:cNvPr id="21" name="TextBox 20"/>
+          <p:cNvSpPr txBox="1"/>
+          <p:nvPr/>
+        </p:nvSpPr>
+        <p:spPr>
+          <a:xfrm>
+            <a:off x="10607040" y="6446520"/>
+            <a:ext cx="1280160" cy="274320"/>
+          </a:xfrm>
+          <a:prstGeom prst="rect">
+            <a:avLst/>
+          </a:prstGeom>
+          <a:noFill/>
+        </p:spPr>
+        <p:txBody>
+          <a:bodyPr wrap="square">
+            <a:spAutoFit/>
+          </a:bodyPr>
+          <a:lstStyle/>
+          <a:p>
+            <a:pPr algn="ctr"/>
+            <a:r>
+              <a:rPr sz="1000" b="0">
+                <a:solidFill>
+                  <a:srgbClr val="6B7280"/>
+                </a:solidFill>
+                <a:latin typeface="Inter"/>
+              </a:rPr>
+              <a:t>06 / 12</a:t>
             </a:r>
           </a:p>
         </p:txBody>
@@ -11163,7 +12421,7 @@
             <p:tnCond val="0"/>
           </p:cond>
           <p:par>
-            <p:cTn id="8" nodeType="withEffect" dur="500" begin="700ms" fill="hold">
+            <p:cTn id="10" nodeType="withEffect" dur="500" begin="400ms" fill="hold">
               <p:animEffect presetClass="entr" presetId="10" dur="500"/>
             </p:cTn>
           </p:par>
@@ -11180,7 +12438,7 @@
             <p:tnCond val="0"/>
           </p:cond>
           <p:par>
-            <p:cTn id="10" nodeType="withEffect" dur="500" begin="1000ms" fill="hold">
+            <p:cTn id="11" nodeType="withEffect" dur="500" begin="700ms" fill="hold">
               <p:animEffect presetClass="entr" presetId="10" dur="500"/>
             </p:cTn>
           </p:par>
@@ -11197,7 +12455,7 @@
             <p:tnCond val="0"/>
           </p:cond>
           <p:par>
-            <p:cTn id="12" nodeType="withEffect" dur="500" begin="1300ms" fill="hold">
+            <p:cTn id="15" nodeType="withEffect" dur="500" begin="700ms" fill="hold">
               <p:animEffect presetClass="entr" presetId="10" dur="500"/>
             </p:cTn>
           </p:par>
@@ -11214,7 +12472,41 @@
             <p:tnCond val="0"/>
           </p:cond>
           <p:par>
-            <p:cTn id="12" nodeType="withEffect" dur="1500" begin="2500ms" fill="hold" repeatCount="indefinite">
+            <p:cTn id="16" nodeType="withEffect" dur="500" begin="1000ms" fill="hold">
+              <p:animEffect presetClass="entr" presetId="10" dur="500"/>
+            </p:cTn>
+          </p:par>
+        </p:par>
+      </p:par>
+    </p:tnLst>
+  </p:timing>
+  <p:timing>
+    <p:tnLst>
+      <p:par>
+        <p:pPr/>
+        <p:par>
+          <p:cond>
+            <p:tnCond val="0"/>
+          </p:cond>
+          <p:par>
+            <p:cTn id="20" nodeType="withEffect" dur="500" begin="1000ms" fill="hold">
+              <p:animEffect presetClass="entr" presetId="10" dur="500"/>
+            </p:cTn>
+          </p:par>
+        </p:par>
+      </p:par>
+    </p:tnLst>
+  </p:timing>
+  <p:timing>
+    <p:tnLst>
+      <p:par>
+        <p:pPr/>
+        <p:par>
+          <p:cond>
+            <p:tnCond val="0"/>
+          </p:cond>
+          <p:par>
+            <p:cTn id="16" nodeType="withEffect" dur="1500" begin="2000ms" fill="hold" repeatCount="indefinite">
               <p:animEffect presetClass="emph" presetId="26" dur="1500"/>
             </p:cTn>
           </p:par>
@@ -12101,6 +13393,41 @@
                 <a:latin typeface="阿里巴巴普惠体 3.0"/>
               </a:rPr>
               <a:t>★ AI 通过 5 个受限通道安全对话业务库,数据不出企业</a:t>
+            </a:r>
+          </a:p>
+        </p:txBody>
+      </p:sp>
+      <p:sp>
+        <p:nvSpPr>
+          <p:cNvPr id="24" name="TextBox 23"/>
+          <p:cNvSpPr txBox="1"/>
+          <p:nvPr/>
+        </p:nvSpPr>
+        <p:spPr>
+          <a:xfrm>
+            <a:off x="10607040" y="6446520"/>
+            <a:ext cx="1280160" cy="274320"/>
+          </a:xfrm>
+          <a:prstGeom prst="rect">
+            <a:avLst/>
+          </a:prstGeom>
+          <a:noFill/>
+        </p:spPr>
+        <p:txBody>
+          <a:bodyPr wrap="square">
+            <a:spAutoFit/>
+          </a:bodyPr>
+          <a:lstStyle/>
+          <a:p>
+            <a:pPr algn="ctr"/>
+            <a:r>
+              <a:rPr sz="1000" b="0">
+                <a:solidFill>
+                  <a:srgbClr val="6B7280"/>
+                </a:solidFill>
+                <a:latin typeface="Inter"/>
+              </a:rPr>
+              <a:t>07 / 12</a:t>
             </a:r>
           </a:p>
         </p:txBody>
@@ -13172,6 +14499,41 @@
           </a:p>
         </p:txBody>
       </p:sp>
+      <p:sp>
+        <p:nvSpPr>
+          <p:cNvPr id="24" name="TextBox 23"/>
+          <p:cNvSpPr txBox="1"/>
+          <p:nvPr/>
+        </p:nvSpPr>
+        <p:spPr>
+          <a:xfrm>
+            <a:off x="10607040" y="6446520"/>
+            <a:ext cx="1280160" cy="274320"/>
+          </a:xfrm>
+          <a:prstGeom prst="rect">
+            <a:avLst/>
+          </a:prstGeom>
+          <a:noFill/>
+        </p:spPr>
+        <p:txBody>
+          <a:bodyPr wrap="square">
+            <a:spAutoFit/>
+          </a:bodyPr>
+          <a:lstStyle/>
+          <a:p>
+            <a:pPr algn="ctr"/>
+            <a:r>
+              <a:rPr sz="1000" b="0">
+                <a:solidFill>
+                  <a:srgbClr val="6B7280"/>
+                </a:solidFill>
+                <a:latin typeface="Inter"/>
+              </a:rPr>
+              <a:t>08 / 12</a:t>
+            </a:r>
+          </a:p>
+        </p:txBody>
+      </p:sp>
     </p:spTree>
   </p:cSld>
   <p:clrMapOvr>
@@ -14116,6 +15478,41 @@
                 <a:latin typeface="阿里巴巴普惠体 3.0"/>
               </a:rPr>
               <a:t>▼ 接下来看 40 秒真实录屏</a:t>
+            </a:r>
+          </a:p>
+        </p:txBody>
+      </p:sp>
+      <p:sp>
+        <p:nvSpPr>
+          <p:cNvPr id="24" name="TextBox 23"/>
+          <p:cNvSpPr txBox="1"/>
+          <p:nvPr/>
+        </p:nvSpPr>
+        <p:spPr>
+          <a:xfrm>
+            <a:off x="10607040" y="6446520"/>
+            <a:ext cx="1280160" cy="274320"/>
+          </a:xfrm>
+          <a:prstGeom prst="rect">
+            <a:avLst/>
+          </a:prstGeom>
+          <a:noFill/>
+        </p:spPr>
+        <p:txBody>
+          <a:bodyPr wrap="square">
+            <a:spAutoFit/>
+          </a:bodyPr>
+          <a:lstStyle/>
+          <a:p>
+            <a:pPr algn="ctr"/>
+            <a:r>
+              <a:rPr sz="1000" b="0">
+                <a:solidFill>
+                  <a:srgbClr val="6B7280"/>
+                </a:solidFill>
+                <a:latin typeface="Inter"/>
+              </a:rPr>
+              <a:t>09 / 12</a:t>
             </a:r>
           </a:p>
         </p:txBody>

</xml_diff>

<commit_message>
feat(ppt): 14 项 P0+P1+P2 优化全部完成
P0(5 项 · 必做):
- P3 4 行 ✓ 改为杀手锏金句(灵梭/SQL工坊/SQL工坊 MCP/全部杀手锏)
- P4-b 模块顺序重排:Row1 杀手锏(RAG★/MCP★/Skill★)+ Row2 基础(对话/文件/工具)
- P9 加 PIL 双轨时间线背景图(灵梭 7.6" + SQL工坊 5.0")
- P9 列宽 60/40 视觉对比(灵梭主线 / SQL工坊辅线)
- P6/P7 流程动画改为 400ms 间隔强调过程感

P1(5 项 · 应做):
- P10 真实信息(github.com/wb04307201 + LoomAgentApplication 25.394s)
- P3 加 PIL 依赖关系图(3 核心 + 6 周边 + 连线)
- P4-a/P5-a 配图放大 2.5x2.0 → 3.3x2.4
- P1 大脑 zoom_in 0.9→1.0 缩放入场
- P2 图标重画为 2.5D 几何(沙漏/分叉/缠结/闪电/秒表/拼图)

P2(4 项 · 锦上添花):
- P5-b 底部 3 func 改 TEXT_SECONDARY 视觉区分杀手锏金边
- P10 logo 8s 慢转(loop)+ 金句持续脉冲
- P1 金钩 zoom_in 0.5x→1.0x 弹跳模拟打字机
- P8 动画精简为 3.5s 分组滑入(4 tech 225ms + 3 bar 200ms + 5 biz 200ms)

累计动画:87 → 100(15 pulse_loop,5 chase)
验证:T1/T3/T5/T6/T7 全部通过(T2/T4 历史遗留与本次无关)

🤖 Generated with [Claude Code](https://claude.com/claude-code)

Co-Authored-By: Claude Fable 5 <noreply@anthropic.com>
</commit_message>
<xml_diff>
--- a/docs/ppt/javabrain.pptx
+++ b/docs/ppt/javabrain.pptx
@@ -3564,7 +3564,24 @@
             <p:tnCond val="0"/>
           </p:cond>
           <p:par>
-            <p:cTn id="4" nodeType="withEffect" dur="500" begin="0ms" fill="hold">
+            <p:cTn id="3" nodeType="withEffect" dur="800" begin="0ms" fill="hold">
+              <p:animEffect presetClass="entr" presetId="23" dur="800"/>
+            </p:cTn>
+          </p:par>
+        </p:par>
+      </p:par>
+    </p:tnLst>
+  </p:timing>
+  <p:timing>
+    <p:tnLst>
+      <p:par>
+        <p:pPr/>
+        <p:par>
+          <p:cond>
+            <p:tnCond val="0"/>
+          </p:cond>
+          <p:par>
+            <p:cTn id="4" nodeType="withEffect" dur="500" begin="600ms" fill="hold">
               <p:animEffect presetClass="entr" presetId="10" dur="500"/>
             </p:cTn>
           </p:par>
@@ -3581,7 +3598,7 @@
             <p:tnCond val="0"/>
           </p:cond>
           <p:par>
-            <p:cTn id="5" nodeType="withEffect" dur="500" begin="400ms" fill="hold">
+            <p:cTn id="5" nodeType="withEffect" dur="500" begin="1000ms" fill="hold">
               <p:animEffect presetClass="entr" presetId="10" dur="500"/>
             </p:cTn>
           </p:par>
@@ -3598,7 +3615,7 @@
             <p:tnCond val="0"/>
           </p:cond>
           <p:par>
-            <p:cTn id="6" nodeType="withEffect" dur="500" begin="800ms" fill="hold">
+            <p:cTn id="6" nodeType="withEffect" dur="500" begin="1400ms" fill="hold">
               <p:animEffect presetClass="entr" presetId="10" dur="500"/>
             </p:cTn>
           </p:par>
@@ -3615,7 +3632,7 @@
             <p:tnCond val="0"/>
           </p:cond>
           <p:par>
-            <p:cTn id="9" nodeType="withEffect" dur="500" begin="1000ms" fill="hold">
+            <p:cTn id="9" nodeType="withEffect" dur="500" begin="1600ms" fill="hold">
               <p:animEffect presetClass="entr" presetId="10" dur="500"/>
             </p:cTn>
           </p:par>
@@ -3632,8 +3649,8 @@
             <p:tnCond val="0"/>
           </p:cond>
           <p:par>
-            <p:cTn id="12" nodeType="withEffect" dur="500" begin="1400ms" fill="hold">
-              <p:animEffect presetClass="entr" presetId="10" dur="500"/>
+            <p:cTn id="12" nodeType="withEffect" dur="600" begin="2000ms" fill="hold">
+              <p:animEffect presetClass="entr" presetId="23" dur="600"/>
             </p:cTn>
           </p:par>
         </p:par>
@@ -4934,8 +4951,8 @@
             <p:tnCond val="0"/>
           </p:cond>
           <p:par>
-            <p:cTn id="5" nodeType="withEffect" dur="500" begin="0ms" fill="hold">
-              <p:animEffect presetClass="entr" presetId="10" dur="500"/>
+            <p:cTn id="5" nodeType="withEffect" dur="400" begin="0ms" fill="hold">
+              <p:animEffect presetClass="entr" presetId="10" dur="400"/>
             </p:cTn>
           </p:par>
         </p:par>
@@ -4951,8 +4968,8 @@
             <p:tnCond val="0"/>
           </p:cond>
           <p:par>
-            <p:cTn id="6" nodeType="withEffect" dur="500" begin="400ms" fill="hold">
-              <p:animEffect presetClass="entr" presetId="10" dur="500"/>
+            <p:cTn id="6" nodeType="withEffect" dur="400" begin="225ms" fill="hold">
+              <p:animEffect presetClass="entr" presetId="10" dur="400"/>
             </p:cTn>
           </p:par>
         </p:par>
@@ -4968,8 +4985,8 @@
             <p:tnCond val="0"/>
           </p:cond>
           <p:par>
-            <p:cTn id="7" nodeType="withEffect" dur="500" begin="800ms" fill="hold">
-              <p:animEffect presetClass="entr" presetId="10" dur="500"/>
+            <p:cTn id="7" nodeType="withEffect" dur="400" begin="450ms" fill="hold">
+              <p:animEffect presetClass="entr" presetId="10" dur="400"/>
             </p:cTn>
           </p:par>
         </p:par>
@@ -4985,8 +5002,8 @@
             <p:tnCond val="0"/>
           </p:cond>
           <p:par>
-            <p:cTn id="8" nodeType="withEffect" dur="500" begin="1200ms" fill="hold">
-              <p:animEffect presetClass="entr" presetId="10" dur="500"/>
+            <p:cTn id="8" nodeType="withEffect" dur="400" begin="675ms" fill="hold">
+              <p:animEffect presetClass="entr" presetId="10" dur="400"/>
             </p:cTn>
           </p:par>
         </p:par>
@@ -5002,8 +5019,8 @@
             <p:tnCond val="0"/>
           </p:cond>
           <p:par>
-            <p:cTn id="10" nodeType="withEffect" dur="500" begin="1800ms" fill="hold">
-              <p:animEffect presetClass="entr" presetId="10" dur="500"/>
+            <p:cTn id="10" nodeType="withEffect" dur="400" begin="1200ms" fill="hold">
+              <p:animEffect presetClass="entr" presetId="10" dur="400"/>
             </p:cTn>
           </p:par>
         </p:par>
@@ -5019,8 +5036,8 @@
             <p:tnCond val="0"/>
           </p:cond>
           <p:par>
-            <p:cTn id="13" nodeType="withEffect" dur="500" begin="2050ms" fill="hold">
-              <p:animEffect presetClass="entr" presetId="10" dur="500"/>
+            <p:cTn id="13" nodeType="withEffect" dur="400" begin="1400ms" fill="hold">
+              <p:animEffect presetClass="entr" presetId="10" dur="400"/>
             </p:cTn>
           </p:par>
         </p:par>
@@ -5036,8 +5053,8 @@
             <p:tnCond val="0"/>
           </p:cond>
           <p:par>
-            <p:cTn id="16" nodeType="withEffect" dur="500" begin="2300ms" fill="hold">
-              <p:animEffect presetClass="entr" presetId="10" dur="500"/>
+            <p:cTn id="16" nodeType="withEffect" dur="400" begin="1600ms" fill="hold">
+              <p:animEffect presetClass="entr" presetId="10" dur="400"/>
             </p:cTn>
           </p:par>
         </p:par>
@@ -5053,8 +5070,8 @@
             <p:tnCond val="0"/>
           </p:cond>
           <p:par>
-            <p:cTn id="21" nodeType="withEffect" dur="500" begin="3000ms" fill="hold">
-              <p:animEffect presetClass="entr" presetId="10" dur="500"/>
+            <p:cTn id="21" nodeType="withEffect" dur="400" begin="2100ms" fill="hold">
+              <p:animEffect presetClass="entr" presetId="10" dur="400"/>
             </p:cTn>
           </p:par>
         </p:par>
@@ -5070,8 +5087,8 @@
             <p:tnCond val="0"/>
           </p:cond>
           <p:par>
-            <p:cTn id="24" nodeType="withEffect" dur="500" begin="3500ms" fill="hold">
-              <p:animEffect presetClass="entr" presetId="10" dur="500"/>
+            <p:cTn id="24" nodeType="withEffect" dur="400" begin="2300ms" fill="hold">
+              <p:animEffect presetClass="entr" presetId="10" dur="400"/>
             </p:cTn>
           </p:par>
         </p:par>
@@ -5087,8 +5104,8 @@
             <p:tnCond val="0"/>
           </p:cond>
           <p:par>
-            <p:cTn id="27" nodeType="withEffect" dur="500" begin="4000ms" fill="hold">
-              <p:animEffect presetClass="entr" presetId="10" dur="500"/>
+            <p:cTn id="27" nodeType="withEffect" dur="400" begin="2500ms" fill="hold">
+              <p:animEffect presetClass="entr" presetId="10" dur="400"/>
             </p:cTn>
           </p:par>
         </p:par>
@@ -5104,8 +5121,8 @@
             <p:tnCond val="0"/>
           </p:cond>
           <p:par>
-            <p:cTn id="30" nodeType="withEffect" dur="500" begin="4500ms" fill="hold">
-              <p:animEffect presetClass="entr" presetId="10" dur="500"/>
+            <p:cTn id="30" nodeType="withEffect" dur="400" begin="2700ms" fill="hold">
+              <p:animEffect presetClass="entr" presetId="10" dur="400"/>
             </p:cTn>
           </p:par>
         </p:par>
@@ -5121,8 +5138,8 @@
             <p:tnCond val="0"/>
           </p:cond>
           <p:par>
-            <p:cTn id="33" nodeType="withEffect" dur="500" begin="5000ms" fill="hold">
-              <p:animEffect presetClass="entr" presetId="10" dur="500"/>
+            <p:cTn id="33" nodeType="withEffect" dur="400" begin="2900ms" fill="hold">
+              <p:animEffect presetClass="entr" presetId="10" dur="400"/>
             </p:cTn>
           </p:par>
         </p:par>
@@ -5169,7 +5186,7 @@
       <p:grpSpPr/>
       <p:pic>
         <p:nvPicPr>
-          <p:cNvPr id="2" name="Picture 1" descr="p9-bg-timeline.png"/>
+          <p:cNvPr id="3" name="Picture 2" descr="p9_dual_timeline.png"/>
           <p:cNvPicPr>
             <a:picLocks noChangeAspect="1"/>
           </p:cNvPicPr>
@@ -5185,8 +5202,8 @@
         </p:blipFill>
         <p:spPr>
           <a:xfrm>
-            <a:off x="8686800" y="228600"/>
-            <a:ext cx="3200400" cy="594360"/>
+            <a:off x="457200" y="868680"/>
+            <a:ext cx="11277295" cy="1097280"/>
           </a:xfrm>
           <a:prstGeom prst="rect">
             <a:avLst/>
@@ -5195,7 +5212,7 @@
       </p:pic>
       <p:sp>
         <p:nvSpPr>
-          <p:cNvPr id="3" name="TextBox 2"/>
+          <p:cNvPr id="2" name="TextBox 1"/>
           <p:cNvSpPr txBox="1"/>
           <p:nvPr/>
         </p:nvSpPr>
@@ -5236,8 +5253,8 @@
         </p:nvSpPr>
         <p:spPr>
           <a:xfrm>
-            <a:off x="274320" y="960120"/>
-            <a:ext cx="5669280" cy="365760"/>
+            <a:off x="274320" y="2194560"/>
+            <a:ext cx="6949440" cy="365760"/>
           </a:xfrm>
           <a:prstGeom prst="rect">
             <a:avLst/>
@@ -5258,7 +5275,7 @@
                 </a:solidFill>
                 <a:latin typeface="阿里巴巴普惠体 3.0"/>
               </a:rPr>
-              <a:t>灵梭 · AI 赋能中心</a:t>
+              <a:t>灵梭 · AI 赋能中心 (主线 60%)</a:t>
             </a:r>
           </a:p>
         </p:txBody>
@@ -5271,8 +5288,8 @@
         </p:nvSpPr>
         <p:spPr>
           <a:xfrm>
-            <a:off x="274320" y="1463040"/>
-            <a:ext cx="5669280" cy="731520"/>
+            <a:off x="274320" y="2697480"/>
+            <a:ext cx="6949440" cy="457200"/>
           </a:xfrm>
           <a:prstGeom prst="roundRect">
             <a:avLst/>
@@ -5316,23 +5333,23 @@
         </p:nvSpPr>
         <p:spPr>
           <a:xfrm>
-            <a:off x="457200" y="1508760"/>
-            <a:ext cx="5486400" cy="320040"/>
-          </a:xfrm>
-          <a:prstGeom prst="rect">
-            <a:avLst/>
-          </a:prstGeom>
-          <a:noFill/>
-        </p:spPr>
-        <p:txBody>
-          <a:bodyPr wrap="square">
-            <a:spAutoFit/>
-          </a:bodyPr>
-          <a:lstStyle/>
-          <a:p>
-            <a:pPr algn="ctr"/>
-            <a:r>
-              <a:rPr sz="1500" b="1">
+            <a:off x="457200" y="2734056"/>
+            <a:ext cx="6766560" cy="228600"/>
+          </a:xfrm>
+          <a:prstGeom prst="rect">
+            <a:avLst/>
+          </a:prstGeom>
+          <a:noFill/>
+        </p:spPr>
+        <p:txBody>
+          <a:bodyPr wrap="square">
+            <a:spAutoFit/>
+          </a:bodyPr>
+          <a:lstStyle/>
+          <a:p>
+            <a:pPr algn="ctr"/>
+            <a:r>
+              <a:rPr sz="1300" b="1">
                 <a:solidFill>
                   <a:srgbClr val="007396"/>
                 </a:solidFill>
@@ -5351,23 +5368,23 @@
         </p:nvSpPr>
         <p:spPr>
           <a:xfrm>
-            <a:off x="457200" y="1847088"/>
-            <a:ext cx="5486400" cy="320040"/>
-          </a:xfrm>
-          <a:prstGeom prst="rect">
-            <a:avLst/>
-          </a:prstGeom>
-          <a:noFill/>
-        </p:spPr>
-        <p:txBody>
-          <a:bodyPr wrap="square">
-            <a:spAutoFit/>
-          </a:bodyPr>
-          <a:lstStyle/>
-          <a:p>
-            <a:pPr algn="ctr"/>
-            <a:r>
-              <a:rPr sz="1300" b="0">
+            <a:off x="457200" y="2953512"/>
+            <a:ext cx="6766560" cy="201168"/>
+          </a:xfrm>
+          <a:prstGeom prst="rect">
+            <a:avLst/>
+          </a:prstGeom>
+          <a:noFill/>
+        </p:spPr>
+        <p:txBody>
+          <a:bodyPr wrap="square">
+            <a:spAutoFit/>
+          </a:bodyPr>
+          <a:lstStyle/>
+          <a:p>
+            <a:pPr algn="ctr"/>
+            <a:r>
+              <a:rPr sz="1100" b="0">
                 <a:solidFill>
                   <a:srgbClr val="6B7280"/>
                 </a:solidFill>
@@ -5386,8 +5403,8 @@
         </p:nvSpPr>
         <p:spPr>
           <a:xfrm>
-            <a:off x="274320" y="2331720"/>
-            <a:ext cx="5669280" cy="731520"/>
+            <a:off x="274320" y="3246120"/>
+            <a:ext cx="6949440" cy="457200"/>
           </a:xfrm>
           <a:prstGeom prst="roundRect">
             <a:avLst/>
@@ -5431,23 +5448,23 @@
         </p:nvSpPr>
         <p:spPr>
           <a:xfrm>
-            <a:off x="457200" y="2377439"/>
-            <a:ext cx="5486400" cy="320040"/>
-          </a:xfrm>
-          <a:prstGeom prst="rect">
-            <a:avLst/>
-          </a:prstGeom>
-          <a:noFill/>
-        </p:spPr>
-        <p:txBody>
-          <a:bodyPr wrap="square">
-            <a:spAutoFit/>
-          </a:bodyPr>
-          <a:lstStyle/>
-          <a:p>
-            <a:pPr algn="ctr"/>
-            <a:r>
-              <a:rPr sz="1500" b="1">
+            <a:off x="457200" y="3282696"/>
+            <a:ext cx="6766560" cy="228600"/>
+          </a:xfrm>
+          <a:prstGeom prst="rect">
+            <a:avLst/>
+          </a:prstGeom>
+          <a:noFill/>
+        </p:spPr>
+        <p:txBody>
+          <a:bodyPr wrap="square">
+            <a:spAutoFit/>
+          </a:bodyPr>
+          <a:lstStyle/>
+          <a:p>
+            <a:pPr algn="ctr"/>
+            <a:r>
+              <a:rPr sz="1300" b="1">
                 <a:solidFill>
                   <a:srgbClr val="007396"/>
                 </a:solidFill>
@@ -5466,23 +5483,23 @@
         </p:nvSpPr>
         <p:spPr>
           <a:xfrm>
-            <a:off x="457200" y="2715768"/>
-            <a:ext cx="5486400" cy="320040"/>
-          </a:xfrm>
-          <a:prstGeom prst="rect">
-            <a:avLst/>
-          </a:prstGeom>
-          <a:noFill/>
-        </p:spPr>
-        <p:txBody>
-          <a:bodyPr wrap="square">
-            <a:spAutoFit/>
-          </a:bodyPr>
-          <a:lstStyle/>
-          <a:p>
-            <a:pPr algn="ctr"/>
-            <a:r>
-              <a:rPr sz="1300" b="0">
+            <a:off x="457200" y="3502152"/>
+            <a:ext cx="6766560" cy="201168"/>
+          </a:xfrm>
+          <a:prstGeom prst="rect">
+            <a:avLst/>
+          </a:prstGeom>
+          <a:noFill/>
+        </p:spPr>
+        <p:txBody>
+          <a:bodyPr wrap="square">
+            <a:spAutoFit/>
+          </a:bodyPr>
+          <a:lstStyle/>
+          <a:p>
+            <a:pPr algn="ctr"/>
+            <a:r>
+              <a:rPr sz="1100" b="0">
                 <a:solidFill>
                   <a:srgbClr val="6B7280"/>
                 </a:solidFill>
@@ -5501,8 +5518,8 @@
         </p:nvSpPr>
         <p:spPr>
           <a:xfrm>
-            <a:off x="274320" y="3200400"/>
-            <a:ext cx="5669280" cy="731520"/>
+            <a:off x="274320" y="3794760"/>
+            <a:ext cx="6949440" cy="457200"/>
           </a:xfrm>
           <a:prstGeom prst="roundRect">
             <a:avLst/>
@@ -5546,23 +5563,23 @@
         </p:nvSpPr>
         <p:spPr>
           <a:xfrm>
-            <a:off x="457200" y="3246120"/>
-            <a:ext cx="5486400" cy="320040"/>
-          </a:xfrm>
-          <a:prstGeom prst="rect">
-            <a:avLst/>
-          </a:prstGeom>
-          <a:noFill/>
-        </p:spPr>
-        <p:txBody>
-          <a:bodyPr wrap="square">
-            <a:spAutoFit/>
-          </a:bodyPr>
-          <a:lstStyle/>
-          <a:p>
-            <a:pPr algn="ctr"/>
-            <a:r>
-              <a:rPr sz="1500" b="1">
+            <a:off x="457200" y="3831336"/>
+            <a:ext cx="6766560" cy="228600"/>
+          </a:xfrm>
+          <a:prstGeom prst="rect">
+            <a:avLst/>
+          </a:prstGeom>
+          <a:noFill/>
+        </p:spPr>
+        <p:txBody>
+          <a:bodyPr wrap="square">
+            <a:spAutoFit/>
+          </a:bodyPr>
+          <a:lstStyle/>
+          <a:p>
+            <a:pPr algn="ctr"/>
+            <a:r>
+              <a:rPr sz="1300" b="1">
                 <a:solidFill>
                   <a:srgbClr val="007396"/>
                 </a:solidFill>
@@ -5581,23 +5598,23 @@
         </p:nvSpPr>
         <p:spPr>
           <a:xfrm>
-            <a:off x="457200" y="3584448"/>
-            <a:ext cx="5486400" cy="320040"/>
-          </a:xfrm>
-          <a:prstGeom prst="rect">
-            <a:avLst/>
-          </a:prstGeom>
-          <a:noFill/>
-        </p:spPr>
-        <p:txBody>
-          <a:bodyPr wrap="square">
-            <a:spAutoFit/>
-          </a:bodyPr>
-          <a:lstStyle/>
-          <a:p>
-            <a:pPr algn="ctr"/>
-            <a:r>
-              <a:rPr sz="1300" b="0">
+            <a:off x="457200" y="4050792"/>
+            <a:ext cx="6766560" cy="201168"/>
+          </a:xfrm>
+          <a:prstGeom prst="rect">
+            <a:avLst/>
+          </a:prstGeom>
+          <a:noFill/>
+        </p:spPr>
+        <p:txBody>
+          <a:bodyPr wrap="square">
+            <a:spAutoFit/>
+          </a:bodyPr>
+          <a:lstStyle/>
+          <a:p>
+            <a:pPr algn="ctr"/>
+            <a:r>
+              <a:rPr sz="1100" b="0">
                 <a:solidFill>
                   <a:srgbClr val="6B7280"/>
                 </a:solidFill>
@@ -5616,8 +5633,8 @@
         </p:nvSpPr>
         <p:spPr>
           <a:xfrm>
-            <a:off x="274320" y="4069079"/>
-            <a:ext cx="5669280" cy="731520"/>
+            <a:off x="274320" y="4343400"/>
+            <a:ext cx="6949440" cy="457200"/>
           </a:xfrm>
           <a:prstGeom prst="roundRect">
             <a:avLst/>
@@ -5661,23 +5678,23 @@
         </p:nvSpPr>
         <p:spPr>
           <a:xfrm>
-            <a:off x="457200" y="4114799"/>
-            <a:ext cx="5486400" cy="320040"/>
-          </a:xfrm>
-          <a:prstGeom prst="rect">
-            <a:avLst/>
-          </a:prstGeom>
-          <a:noFill/>
-        </p:spPr>
-        <p:txBody>
-          <a:bodyPr wrap="square">
-            <a:spAutoFit/>
-          </a:bodyPr>
-          <a:lstStyle/>
-          <a:p>
-            <a:pPr algn="ctr"/>
-            <a:r>
-              <a:rPr sz="1500" b="1">
+            <a:off x="457200" y="4379976"/>
+            <a:ext cx="6766560" cy="228600"/>
+          </a:xfrm>
+          <a:prstGeom prst="rect">
+            <a:avLst/>
+          </a:prstGeom>
+          <a:noFill/>
+        </p:spPr>
+        <p:txBody>
+          <a:bodyPr wrap="square">
+            <a:spAutoFit/>
+          </a:bodyPr>
+          <a:lstStyle/>
+          <a:p>
+            <a:pPr algn="ctr"/>
+            <a:r>
+              <a:rPr sz="1300" b="1">
                 <a:solidFill>
                   <a:srgbClr val="007396"/>
                 </a:solidFill>
@@ -5696,23 +5713,23 @@
         </p:nvSpPr>
         <p:spPr>
           <a:xfrm>
-            <a:off x="457200" y="4453127"/>
-            <a:ext cx="5486400" cy="320040"/>
-          </a:xfrm>
-          <a:prstGeom prst="rect">
-            <a:avLst/>
-          </a:prstGeom>
-          <a:noFill/>
-        </p:spPr>
-        <p:txBody>
-          <a:bodyPr wrap="square">
-            <a:spAutoFit/>
-          </a:bodyPr>
-          <a:lstStyle/>
-          <a:p>
-            <a:pPr algn="ctr"/>
-            <a:r>
-              <a:rPr sz="1300" b="0">
+            <a:off x="457200" y="4599432"/>
+            <a:ext cx="6766560" cy="201168"/>
+          </a:xfrm>
+          <a:prstGeom prst="rect">
+            <a:avLst/>
+          </a:prstGeom>
+          <a:noFill/>
+        </p:spPr>
+        <p:txBody>
+          <a:bodyPr wrap="square">
+            <a:spAutoFit/>
+          </a:bodyPr>
+          <a:lstStyle/>
+          <a:p>
+            <a:pPr algn="ctr"/>
+            <a:r>
+              <a:rPr sz="1100" b="0">
                 <a:solidFill>
                   <a:srgbClr val="6B7280"/>
                 </a:solidFill>
@@ -5731,29 +5748,29 @@
         </p:nvSpPr>
         <p:spPr>
           <a:xfrm>
-            <a:off x="6248095" y="960120"/>
-            <a:ext cx="5669280" cy="365760"/>
-          </a:xfrm>
-          <a:prstGeom prst="rect">
-            <a:avLst/>
-          </a:prstGeom>
-          <a:noFill/>
-        </p:spPr>
-        <p:txBody>
-          <a:bodyPr wrap="square">
-            <a:spAutoFit/>
-          </a:bodyPr>
-          <a:lstStyle/>
-          <a:p>
-            <a:pPr algn="ctr"/>
-            <a:r>
-              <a:rPr sz="1800" b="1">
+            <a:off x="7406640" y="2194560"/>
+            <a:ext cx="4572000" cy="365760"/>
+          </a:xfrm>
+          <a:prstGeom prst="rect">
+            <a:avLst/>
+          </a:prstGeom>
+          <a:noFill/>
+        </p:spPr>
+        <p:txBody>
+          <a:bodyPr wrap="square">
+            <a:spAutoFit/>
+          </a:bodyPr>
+          <a:lstStyle/>
+          <a:p>
+            <a:pPr algn="ctr"/>
+            <a:r>
+              <a:rPr sz="1600" b="1">
                 <a:solidFill>
                   <a:srgbClr val="6B46C1"/>
                 </a:solidFill>
                 <a:latin typeface="阿里巴巴普惠体 3.0"/>
               </a:rPr>
-              <a:t>SQL工坊 · 数据管理引擎</a:t>
+              <a:t>SQL工坊 · 数据引擎</a:t>
             </a:r>
           </a:p>
         </p:txBody>
@@ -5766,8 +5783,8 @@
         </p:nvSpPr>
         <p:spPr>
           <a:xfrm>
-            <a:off x="6248095" y="1463040"/>
-            <a:ext cx="5669280" cy="731520"/>
+            <a:off x="7406640" y="2697480"/>
+            <a:ext cx="4572000" cy="457200"/>
           </a:xfrm>
           <a:prstGeom prst="roundRect">
             <a:avLst/>
@@ -5811,23 +5828,23 @@
         </p:nvSpPr>
         <p:spPr>
           <a:xfrm>
-            <a:off x="6430975" y="1508760"/>
-            <a:ext cx="5486400" cy="320040"/>
-          </a:xfrm>
-          <a:prstGeom prst="rect">
-            <a:avLst/>
-          </a:prstGeom>
-          <a:noFill/>
-        </p:spPr>
-        <p:txBody>
-          <a:bodyPr wrap="square">
-            <a:spAutoFit/>
-          </a:bodyPr>
-          <a:lstStyle/>
-          <a:p>
-            <a:pPr algn="ctr"/>
-            <a:r>
-              <a:rPr sz="1500" b="1">
+            <a:off x="7589520" y="2734056"/>
+            <a:ext cx="4389120" cy="228600"/>
+          </a:xfrm>
+          <a:prstGeom prst="rect">
+            <a:avLst/>
+          </a:prstGeom>
+          <a:noFill/>
+        </p:spPr>
+        <p:txBody>
+          <a:bodyPr wrap="square">
+            <a:spAutoFit/>
+          </a:bodyPr>
+          <a:lstStyle/>
+          <a:p>
+            <a:pPr algn="ctr"/>
+            <a:r>
+              <a:rPr sz="1200" b="1">
                 <a:solidFill>
                   <a:srgbClr val="6B46C1"/>
                 </a:solidFill>
@@ -5846,29 +5863,29 @@
         </p:nvSpPr>
         <p:spPr>
           <a:xfrm>
-            <a:off x="6430975" y="1847088"/>
-            <a:ext cx="5486400" cy="320040"/>
-          </a:xfrm>
-          <a:prstGeom prst="rect">
-            <a:avLst/>
-          </a:prstGeom>
-          <a:noFill/>
-        </p:spPr>
-        <p:txBody>
-          <a:bodyPr wrap="square">
-            <a:spAutoFit/>
-          </a:bodyPr>
-          <a:lstStyle/>
-          <a:p>
-            <a:pPr algn="ctr"/>
-            <a:r>
-              <a:rPr sz="1300" b="0">
+            <a:off x="7589520" y="2953512"/>
+            <a:ext cx="4389120" cy="201168"/>
+          </a:xfrm>
+          <a:prstGeom prst="rect">
+            <a:avLst/>
+          </a:prstGeom>
+          <a:noFill/>
+        </p:spPr>
+        <p:txBody>
+          <a:bodyPr wrap="square">
+            <a:spAutoFit/>
+          </a:bodyPr>
+          <a:lstStyle/>
+          <a:p>
+            <a:pPr algn="ctr"/>
+            <a:r>
+              <a:rPr sz="1000" b="0">
                 <a:solidFill>
                   <a:srgbClr val="6B7280"/>
                 </a:solidFill>
                 <a:latin typeface="阿里巴巴普惠体 3.0"/>
               </a:rPr>
-              <a:t>准确率 &gt;95% + 本地代码大模型 + Explain 优化</a:t>
+              <a:t>准确率 &gt;95% · 本地代码大模型</a:t>
             </a:r>
           </a:p>
         </p:txBody>
@@ -5881,8 +5898,8 @@
         </p:nvSpPr>
         <p:spPr>
           <a:xfrm>
-            <a:off x="6248095" y="2331720"/>
-            <a:ext cx="5669280" cy="731520"/>
+            <a:off x="7406640" y="3246120"/>
+            <a:ext cx="4572000" cy="457200"/>
           </a:xfrm>
           <a:prstGeom prst="roundRect">
             <a:avLst/>
@@ -5926,23 +5943,23 @@
         </p:nvSpPr>
         <p:spPr>
           <a:xfrm>
-            <a:off x="6430975" y="2377439"/>
-            <a:ext cx="5486400" cy="320040"/>
-          </a:xfrm>
-          <a:prstGeom prst="rect">
-            <a:avLst/>
-          </a:prstGeom>
-          <a:noFill/>
-        </p:spPr>
-        <p:txBody>
-          <a:bodyPr wrap="square">
-            <a:spAutoFit/>
-          </a:bodyPr>
-          <a:lstStyle/>
-          <a:p>
-            <a:pPr algn="ctr"/>
-            <a:r>
-              <a:rPr sz="1500" b="1">
+            <a:off x="7589520" y="3282696"/>
+            <a:ext cx="4389120" cy="228600"/>
+          </a:xfrm>
+          <a:prstGeom prst="rect">
+            <a:avLst/>
+          </a:prstGeom>
+          <a:noFill/>
+        </p:spPr>
+        <p:txBody>
+          <a:bodyPr wrap="square">
+            <a:spAutoFit/>
+          </a:bodyPr>
+          <a:lstStyle/>
+          <a:p>
+            <a:pPr algn="ctr"/>
+            <a:r>
+              <a:rPr sz="1200" b="1">
                 <a:solidFill>
                   <a:srgbClr val="6B46C1"/>
                 </a:solidFill>
@@ -5961,29 +5978,29 @@
         </p:nvSpPr>
         <p:spPr>
           <a:xfrm>
-            <a:off x="6430975" y="2715768"/>
-            <a:ext cx="5486400" cy="320040"/>
-          </a:xfrm>
-          <a:prstGeom prst="rect">
-            <a:avLst/>
-          </a:prstGeom>
-          <a:noFill/>
-        </p:spPr>
-        <p:txBody>
-          <a:bodyPr wrap="square">
-            <a:spAutoFit/>
-          </a:bodyPr>
-          <a:lstStyle/>
-          <a:p>
-            <a:pPr algn="ctr"/>
-            <a:r>
-              <a:rPr sz="1300" b="0">
+            <a:off x="7589520" y="3502152"/>
+            <a:ext cx="4389120" cy="201168"/>
+          </a:xfrm>
+          <a:prstGeom prst="rect">
+            <a:avLst/>
+          </a:prstGeom>
+          <a:noFill/>
+        </p:spPr>
+        <p:txBody>
+          <a:bodyPr wrap="square">
+            <a:spAutoFit/>
+          </a:bodyPr>
+          <a:lstStyle/>
+          <a:p>
+            <a:pPr algn="ctr"/>
+            <a:r>
+              <a:rPr sz="1000" b="0">
                 <a:solidFill>
                   <a:srgbClr val="6B7280"/>
                 </a:solidFill>
                 <a:latin typeface="阿里巴巴普惠体 3.0"/>
               </a:rPr>
-              <a:t>Flink 实时流 + Iceberg / Hudi 湖仓格式</a:t>
+              <a:t>Flink + Iceberg/Hudi</a:t>
             </a:r>
           </a:p>
         </p:txBody>
@@ -5996,8 +6013,8 @@
         </p:nvSpPr>
         <p:spPr>
           <a:xfrm>
-            <a:off x="6248095" y="3200400"/>
-            <a:ext cx="5669280" cy="731520"/>
+            <a:off x="7406640" y="3794760"/>
+            <a:ext cx="4572000" cy="457200"/>
           </a:xfrm>
           <a:prstGeom prst="roundRect">
             <a:avLst/>
@@ -6041,23 +6058,23 @@
         </p:nvSpPr>
         <p:spPr>
           <a:xfrm>
-            <a:off x="6430975" y="3246120"/>
-            <a:ext cx="5486400" cy="320040"/>
-          </a:xfrm>
-          <a:prstGeom prst="rect">
-            <a:avLst/>
-          </a:prstGeom>
-          <a:noFill/>
-        </p:spPr>
-        <p:txBody>
-          <a:bodyPr wrap="square">
-            <a:spAutoFit/>
-          </a:bodyPr>
-          <a:lstStyle/>
-          <a:p>
-            <a:pPr algn="ctr"/>
-            <a:r>
-              <a:rPr sz="1500" b="1">
+            <a:off x="7589520" y="3831336"/>
+            <a:ext cx="4389120" cy="228600"/>
+          </a:xfrm>
+          <a:prstGeom prst="rect">
+            <a:avLst/>
+          </a:prstGeom>
+          <a:noFill/>
+        </p:spPr>
+        <p:txBody>
+          <a:bodyPr wrap="square">
+            <a:spAutoFit/>
+          </a:bodyPr>
+          <a:lstStyle/>
+          <a:p>
+            <a:pPr algn="ctr"/>
+            <a:r>
+              <a:rPr sz="1200" b="1">
                 <a:solidFill>
                   <a:srgbClr val="6B46C1"/>
                 </a:solidFill>
@@ -6076,29 +6093,29 @@
         </p:nvSpPr>
         <p:spPr>
           <a:xfrm>
-            <a:off x="6430975" y="3584448"/>
-            <a:ext cx="5486400" cy="320040"/>
-          </a:xfrm>
-          <a:prstGeom prst="rect">
-            <a:avLst/>
-          </a:prstGeom>
-          <a:noFill/>
-        </p:spPr>
-        <p:txBody>
-          <a:bodyPr wrap="square">
-            <a:spAutoFit/>
-          </a:bodyPr>
-          <a:lstStyle/>
-          <a:p>
-            <a:pPr algn="ctr"/>
-            <a:r>
-              <a:rPr sz="1300" b="0">
+            <a:off x="7589520" y="4050792"/>
+            <a:ext cx="4389120" cy="201168"/>
+          </a:xfrm>
+          <a:prstGeom prst="rect">
+            <a:avLst/>
+          </a:prstGeom>
+          <a:noFill/>
+        </p:spPr>
+        <p:txBody>
+          <a:bodyPr wrap="square">
+            <a:spAutoFit/>
+          </a:bodyPr>
+          <a:lstStyle/>
+          <a:p>
+            <a:pPr algn="ctr"/>
+            <a:r>
+              <a:rPr sz="1000" b="0">
                 <a:solidFill>
                   <a:srgbClr val="6B7280"/>
                 </a:solidFill>
                 <a:latin typeface="阿里巴巴普惠体 3.0"/>
               </a:rPr>
-              <a:t>血缘分析 + 动态脱敏 + 自动化审计</a:t>
+              <a:t>血缘 + 脱敏 + 审计</a:t>
             </a:r>
           </a:p>
         </p:txBody>
@@ -6111,8 +6128,8 @@
         </p:nvSpPr>
         <p:spPr>
           <a:xfrm>
-            <a:off x="6248095" y="4069079"/>
-            <a:ext cx="5669280" cy="731520"/>
+            <a:off x="7406640" y="4343400"/>
+            <a:ext cx="4572000" cy="457200"/>
           </a:xfrm>
           <a:prstGeom prst="roundRect">
             <a:avLst/>
@@ -6156,23 +6173,23 @@
         </p:nvSpPr>
         <p:spPr>
           <a:xfrm>
-            <a:off x="6430975" y="4114799"/>
-            <a:ext cx="5486400" cy="320040"/>
-          </a:xfrm>
-          <a:prstGeom prst="rect">
-            <a:avLst/>
-          </a:prstGeom>
-          <a:noFill/>
-        </p:spPr>
-        <p:txBody>
-          <a:bodyPr wrap="square">
-            <a:spAutoFit/>
-          </a:bodyPr>
-          <a:lstStyle/>
-          <a:p>
-            <a:pPr algn="ctr"/>
-            <a:r>
-              <a:rPr sz="1500" b="1">
+            <a:off x="7589520" y="4379976"/>
+            <a:ext cx="4389120" cy="228600"/>
+          </a:xfrm>
+          <a:prstGeom prst="rect">
+            <a:avLst/>
+          </a:prstGeom>
+          <a:noFill/>
+        </p:spPr>
+        <p:txBody>
+          <a:bodyPr wrap="square">
+            <a:spAutoFit/>
+          </a:bodyPr>
+          <a:lstStyle/>
+          <a:p>
+            <a:pPr algn="ctr"/>
+            <a:r>
+              <a:rPr sz="1200" b="1">
                 <a:solidFill>
                   <a:srgbClr val="6B46C1"/>
                 </a:solidFill>
@@ -6191,29 +6208,29 @@
         </p:nvSpPr>
         <p:spPr>
           <a:xfrm>
-            <a:off x="6430975" y="4453127"/>
-            <a:ext cx="5486400" cy="320040"/>
-          </a:xfrm>
-          <a:prstGeom prst="rect">
-            <a:avLst/>
-          </a:prstGeom>
-          <a:noFill/>
-        </p:spPr>
-        <p:txBody>
-          <a:bodyPr wrap="square">
-            <a:spAutoFit/>
-          </a:bodyPr>
-          <a:lstStyle/>
-          <a:p>
-            <a:pPr algn="ctr"/>
-            <a:r>
-              <a:rPr sz="1300" b="0">
+            <a:off x="7589520" y="4599432"/>
+            <a:ext cx="4389120" cy="201168"/>
+          </a:xfrm>
+          <a:prstGeom prst="rect">
+            <a:avLst/>
+          </a:prstGeom>
+          <a:noFill/>
+        </p:spPr>
+        <p:txBody>
+          <a:bodyPr wrap="square">
+            <a:spAutoFit/>
+          </a:bodyPr>
+          <a:lstStyle/>
+          <a:p>
+            <a:pPr algn="ctr"/>
+            <a:r>
+              <a:rPr sz="1000" b="0">
                 <a:solidFill>
                   <a:srgbClr val="6B7280"/>
                 </a:solidFill>
                 <a:latin typeface="阿里巴巴普惠体 3.0"/>
               </a:rPr>
-              <a:t>计算/存储分离 + 自动扩缩容</a:t>
+              <a:t>计算/存储分离</a:t>
             </a:r>
           </a:p>
         </p:txBody>
@@ -6507,7 +6524,7 @@
             <p:tnCond val="0"/>
           </p:cond>
           <p:par>
-            <p:cTn id="4" nodeType="withEffect" dur="500" begin="0ms" fill="hold">
+            <p:cTn id="3" nodeType="withEffect" dur="500" begin="0ms" fill="hold">
               <p:animEffect presetClass="entr" presetId="10" dur="500"/>
             </p:cTn>
           </p:par>
@@ -7127,7 +7144,7 @@
                 </a:solidFill>
                 <a:latin typeface="阿里巴巴普惠体 3.0"/>
               </a:rPr>
-              <a:t>感谢 [团队名] · 联系: [邮箱]</a:t>
+              <a:t>感谢聆听 · Star 支持: github.com/wb04307201/spring-ai-loom-agent</a:t>
             </a:r>
           </a:p>
         </p:txBody>
@@ -7172,6 +7189,23 @@
   <p:clrMapOvr>
     <a:masterClrMapping/>
   </p:clrMapOvr>
+  <p:timing>
+    <p:tnLst>
+      <p:par>
+        <p:pPr/>
+        <p:par>
+          <p:cond>
+            <p:tnCond val="0"/>
+          </p:cond>
+          <p:par>
+            <p:cTn id="3" nodeType="withEffect" dur="8000" begin="0ms" fill="hold" repeatCount="indefinite">
+              <p:animEffect presetClass="emph" presetId="8" dur="8000"/>
+            </p:cTn>
+          </p:par>
+        </p:par>
+      </p:par>
+    </p:tnLst>
+  </p:timing>
   <p:timing>
     <p:tnLst>
       <p:par>
@@ -7266,7 +7300,7 @@
             <p:tnCond val="0"/>
           </p:cond>
           <p:par>
-            <p:cTn id="10" nodeType="withEffect" dur="500" begin="10000ms" fill="hold">
+            <p:cTn id="10" nodeType="withEffect" dur="500" begin="4000ms" fill="hold">
               <p:animEffect presetClass="entr" presetId="10" dur="500"/>
             </p:cTn>
           </p:par>
@@ -7504,7 +7538,7 @@
       </p:sp>
       <p:pic>
         <p:nvPicPr>
-          <p:cNvPr id="7" name="Picture 6" descr="p2-red-1-overwork.png"/>
+          <p:cNvPr id="7" name="Picture 6" descr="p2-red-1-hourglass.png"/>
           <p:cNvPicPr>
             <a:picLocks noChangeAspect="1"/>
           </p:cNvPicPr>
@@ -7643,7 +7677,7 @@
       </p:sp>
       <p:pic>
         <p:nvPicPr>
-          <p:cNvPr id="11" name="Picture 10" descr="p2-red-2-bureaucracy.png"/>
+          <p:cNvPr id="11" name="Picture 10" descr="p2-red-2-bifurcation.png"/>
           <p:cNvPicPr>
             <a:picLocks noChangeAspect="1"/>
           </p:cNvPicPr>
@@ -7921,7 +7955,7 @@
       </p:sp>
       <p:pic>
         <p:nvPicPr>
-          <p:cNvPr id="19" name="Picture 18" descr="p2-green-3-dashboard.png"/>
+          <p:cNvPr id="19" name="Picture 18" descr="p2-green-1-lightning.png"/>
           <p:cNvPicPr>
             <a:picLocks noChangeAspect="1"/>
           </p:cNvPicPr>
@@ -8060,7 +8094,7 @@
       </p:sp>
       <p:pic>
         <p:nvPicPr>
-          <p:cNvPr id="23" name="Picture 22" descr="p2-green-2-rocket.png"/>
+          <p:cNvPr id="23" name="Picture 22" descr="p2-green-2-stopwatch.png"/>
           <p:cNvPicPr>
             <a:picLocks noChangeAspect="1"/>
           </p:cNvPicPr>
@@ -8199,7 +8233,7 @@
       </p:sp>
       <p:pic>
         <p:nvPicPr>
-          <p:cNvPr id="27" name="Picture 26" descr="p2-green-1-final.png"/>
+          <p:cNvPr id="27" name="Picture 26" descr="p2-green-3-puzzle.png"/>
           <p:cNvPicPr>
             <a:picLocks noChangeAspect="1"/>
           </p:cNvPicPr>
@@ -8728,6 +8762,32 @@
         <p:nvPr/>
       </p:nvGrpSpPr>
       <p:grpSpPr/>
+      <p:pic>
+        <p:nvPicPr>
+          <p:cNvPr id="3" name="Picture 2" descr="p3_dependency.png"/>
+          <p:cNvPicPr>
+            <a:picLocks noChangeAspect="1"/>
+          </p:cNvPicPr>
+          <p:nvPr/>
+        </p:nvPicPr>
+        <p:blipFill>
+          <a:blip r:embed="rId2">
+            <a:alphaModFix amt="100000"/>
+          </a:blip>
+          <a:stretch>
+            <a:fillRect/>
+          </a:stretch>
+        </p:blipFill>
+        <p:spPr>
+          <a:xfrm>
+            <a:off x="3200400" y="914400"/>
+            <a:ext cx="5790895" cy="2743200"/>
+          </a:xfrm>
+          <a:prstGeom prst="rect">
+            <a:avLst/>
+          </a:prstGeom>
+        </p:spPr>
+      </p:pic>
       <p:sp>
         <p:nvSpPr>
           <p:cNvPr id="2" name="TextBox 1"/>
@@ -8765,229 +8825,14 @@
       </p:sp>
       <p:sp>
         <p:nvSpPr>
-          <p:cNvPr id="3" name="Rounded Rectangle 2"/>
-          <p:cNvSpPr/>
-          <p:nvPr/>
-        </p:nvSpPr>
-        <p:spPr>
-          <a:xfrm>
-            <a:off x="4312767" y="1371600"/>
-            <a:ext cx="822960" cy="822960"/>
-          </a:xfrm>
-          <a:prstGeom prst="roundRect">
-            <a:avLst/>
-          </a:prstGeom>
-          <a:solidFill>
-            <a:srgbClr val="007396"/>
-          </a:solidFill>
-          <a:ln>
-            <a:noFill/>
-          </a:ln>
-        </p:spPr>
-        <p:style>
-          <a:lnRef idx="1">
-            <a:schemeClr val="accent1"/>
-          </a:lnRef>
-          <a:fillRef idx="3">
-            <a:schemeClr val="accent1"/>
-          </a:fillRef>
-          <a:effectRef idx="2">
-            <a:schemeClr val="accent1"/>
-          </a:effectRef>
-          <a:fontRef idx="minor">
-            <a:schemeClr val="lt1"/>
-          </a:fontRef>
-        </p:style>
-        <p:txBody>
-          <a:bodyPr rtlCol="0" anchor="ctr"/>
-          <a:lstStyle/>
-          <a:p>
-            <a:pPr algn="ctr"/>
-          </a:p>
-        </p:txBody>
-      </p:sp>
-      <p:sp>
-        <p:nvSpPr>
-          <p:cNvPr id="4" name="Oval 3"/>
-          <p:cNvSpPr/>
-          <p:nvPr/>
-        </p:nvSpPr>
-        <p:spPr>
-          <a:xfrm>
-            <a:off x="4395063" y="1305763"/>
-            <a:ext cx="131673" cy="131673"/>
-          </a:xfrm>
-          <a:prstGeom prst="ellipse">
-            <a:avLst/>
-          </a:prstGeom>
-          <a:solidFill>
-            <a:srgbClr val="007396"/>
-          </a:solidFill>
-          <a:ln>
-            <a:noFill/>
-          </a:ln>
-        </p:spPr>
-        <p:style>
-          <a:lnRef idx="1">
-            <a:schemeClr val="accent1"/>
-          </a:lnRef>
-          <a:fillRef idx="3">
-            <a:schemeClr val="accent1"/>
-          </a:fillRef>
-          <a:effectRef idx="2">
-            <a:schemeClr val="accent1"/>
-          </a:effectRef>
-          <a:fontRef idx="minor">
-            <a:schemeClr val="lt1"/>
-          </a:fontRef>
-        </p:style>
-        <p:txBody>
-          <a:bodyPr rtlCol="0" anchor="ctr"/>
-          <a:lstStyle/>
-          <a:p>
-            <a:pPr algn="ctr"/>
-          </a:p>
-        </p:txBody>
-      </p:sp>
-      <p:sp>
-        <p:nvSpPr>
-          <p:cNvPr id="5" name="Oval 4"/>
-          <p:cNvSpPr/>
-          <p:nvPr/>
-        </p:nvSpPr>
-        <p:spPr>
-          <a:xfrm>
-            <a:off x="4576114" y="1305763"/>
-            <a:ext cx="131673" cy="131673"/>
-          </a:xfrm>
-          <a:prstGeom prst="ellipse">
-            <a:avLst/>
-          </a:prstGeom>
-          <a:solidFill>
-            <a:srgbClr val="007396"/>
-          </a:solidFill>
-          <a:ln>
-            <a:noFill/>
-          </a:ln>
-        </p:spPr>
-        <p:style>
-          <a:lnRef idx="1">
-            <a:schemeClr val="accent1"/>
-          </a:lnRef>
-          <a:fillRef idx="3">
-            <a:schemeClr val="accent1"/>
-          </a:fillRef>
-          <a:effectRef idx="2">
-            <a:schemeClr val="accent1"/>
-          </a:effectRef>
-          <a:fontRef idx="minor">
-            <a:schemeClr val="lt1"/>
-          </a:fontRef>
-        </p:style>
-        <p:txBody>
-          <a:bodyPr rtlCol="0" anchor="ctr"/>
-          <a:lstStyle/>
-          <a:p>
-            <a:pPr algn="ctr"/>
-          </a:p>
-        </p:txBody>
-      </p:sp>
-      <p:sp>
-        <p:nvSpPr>
-          <p:cNvPr id="6" name="Oval 5"/>
-          <p:cNvSpPr/>
-          <p:nvPr/>
-        </p:nvSpPr>
-        <p:spPr>
-          <a:xfrm>
-            <a:off x="4740706" y="1305763"/>
-            <a:ext cx="131673" cy="131673"/>
-          </a:xfrm>
-          <a:prstGeom prst="ellipse">
-            <a:avLst/>
-          </a:prstGeom>
-          <a:solidFill>
-            <a:srgbClr val="007396"/>
-          </a:solidFill>
-          <a:ln>
-            <a:noFill/>
-          </a:ln>
-        </p:spPr>
-        <p:style>
-          <a:lnRef idx="1">
-            <a:schemeClr val="accent1"/>
-          </a:lnRef>
-          <a:fillRef idx="3">
-            <a:schemeClr val="accent1"/>
-          </a:fillRef>
-          <a:effectRef idx="2">
-            <a:schemeClr val="accent1"/>
-          </a:effectRef>
-          <a:fontRef idx="minor">
-            <a:schemeClr val="lt1"/>
-          </a:fontRef>
-        </p:style>
-        <p:txBody>
-          <a:bodyPr rtlCol="0" anchor="ctr"/>
-          <a:lstStyle/>
-          <a:p>
-            <a:pPr algn="ctr"/>
-          </a:p>
-        </p:txBody>
-      </p:sp>
-      <p:sp>
-        <p:nvSpPr>
-          <p:cNvPr id="7" name="Oval 6"/>
-          <p:cNvSpPr/>
-          <p:nvPr/>
-        </p:nvSpPr>
-        <p:spPr>
-          <a:xfrm>
-            <a:off x="4921757" y="1305763"/>
-            <a:ext cx="131673" cy="131673"/>
-          </a:xfrm>
-          <a:prstGeom prst="ellipse">
-            <a:avLst/>
-          </a:prstGeom>
-          <a:solidFill>
-            <a:srgbClr val="007396"/>
-          </a:solidFill>
-          <a:ln>
-            <a:noFill/>
-          </a:ln>
-        </p:spPr>
-        <p:style>
-          <a:lnRef idx="1">
-            <a:schemeClr val="accent1"/>
-          </a:lnRef>
-          <a:fillRef idx="3">
-            <a:schemeClr val="accent1"/>
-          </a:fillRef>
-          <a:effectRef idx="2">
-            <a:schemeClr val="accent1"/>
-          </a:effectRef>
-          <a:fontRef idx="minor">
-            <a:schemeClr val="lt1"/>
-          </a:fontRef>
-        </p:style>
-        <p:txBody>
-          <a:bodyPr rtlCol="0" anchor="ctr"/>
-          <a:lstStyle/>
-          <a:p>
-            <a:pPr algn="ctr"/>
-          </a:p>
-        </p:txBody>
-      </p:sp>
-      <p:sp>
-        <p:nvSpPr>
-          <p:cNvPr id="8" name="TextBox 7"/>
-          <p:cNvSpPr txBox="1"/>
-          <p:nvPr/>
-        </p:nvSpPr>
-        <p:spPr>
-          <a:xfrm>
-            <a:off x="4038447" y="2240279"/>
-            <a:ext cx="1371600" cy="274320"/>
+          <p:cNvPr id="4" name="TextBox 3"/>
+          <p:cNvSpPr txBox="1"/>
+          <p:nvPr/>
+        </p:nvSpPr>
+        <p:spPr>
+          <a:xfrm>
+            <a:off x="3200400" y="3657600"/>
+            <a:ext cx="1828800" cy="274320"/>
           </a:xfrm>
           <a:prstGeom prst="rect">
             <a:avLst/>
@@ -9008,236 +8853,21 @@
                 </a:solidFill>
                 <a:latin typeface="阿里巴巴普惠体 3.0"/>
               </a:rPr>
-              <a:t>灵梭</a:t>
-            </a:r>
-          </a:p>
-        </p:txBody>
-      </p:sp>
-      <p:sp>
-        <p:nvSpPr>
-          <p:cNvPr id="9" name="Rounded Rectangle 8"/>
-          <p:cNvSpPr/>
-          <p:nvPr/>
-        </p:nvSpPr>
-        <p:spPr>
-          <a:xfrm>
-            <a:off x="5684367" y="1371600"/>
-            <a:ext cx="822960" cy="822960"/>
-          </a:xfrm>
-          <a:prstGeom prst="roundRect">
-            <a:avLst/>
-          </a:prstGeom>
-          <a:solidFill>
-            <a:srgbClr val="6B46C1"/>
-          </a:solidFill>
-          <a:ln>
-            <a:noFill/>
-          </a:ln>
-        </p:spPr>
-        <p:style>
-          <a:lnRef idx="1">
-            <a:schemeClr val="accent1"/>
-          </a:lnRef>
-          <a:fillRef idx="3">
-            <a:schemeClr val="accent1"/>
-          </a:fillRef>
-          <a:effectRef idx="2">
-            <a:schemeClr val="accent1"/>
-          </a:effectRef>
-          <a:fontRef idx="minor">
-            <a:schemeClr val="lt1"/>
-          </a:fontRef>
-        </p:style>
-        <p:txBody>
-          <a:bodyPr rtlCol="0" anchor="ctr"/>
-          <a:lstStyle/>
-          <a:p>
-            <a:pPr algn="ctr"/>
-          </a:p>
-        </p:txBody>
-      </p:sp>
-      <p:sp>
-        <p:nvSpPr>
-          <p:cNvPr id="10" name="Oval 9"/>
-          <p:cNvSpPr/>
-          <p:nvPr/>
-        </p:nvSpPr>
-        <p:spPr>
-          <a:xfrm>
-            <a:off x="5766663" y="1305763"/>
-            <a:ext cx="131673" cy="131673"/>
-          </a:xfrm>
-          <a:prstGeom prst="ellipse">
-            <a:avLst/>
-          </a:prstGeom>
-          <a:solidFill>
-            <a:srgbClr val="6B46C1"/>
-          </a:solidFill>
-          <a:ln>
-            <a:noFill/>
-          </a:ln>
-        </p:spPr>
-        <p:style>
-          <a:lnRef idx="1">
-            <a:schemeClr val="accent1"/>
-          </a:lnRef>
-          <a:fillRef idx="3">
-            <a:schemeClr val="accent1"/>
-          </a:fillRef>
-          <a:effectRef idx="2">
-            <a:schemeClr val="accent1"/>
-          </a:effectRef>
-          <a:fontRef idx="minor">
-            <a:schemeClr val="lt1"/>
-          </a:fontRef>
-        </p:style>
-        <p:txBody>
-          <a:bodyPr rtlCol="0" anchor="ctr"/>
-          <a:lstStyle/>
-          <a:p>
-            <a:pPr algn="ctr"/>
-          </a:p>
-        </p:txBody>
-      </p:sp>
-      <p:sp>
-        <p:nvSpPr>
-          <p:cNvPr id="11" name="Oval 10"/>
-          <p:cNvSpPr/>
-          <p:nvPr/>
-        </p:nvSpPr>
-        <p:spPr>
-          <a:xfrm>
-            <a:off x="5947714" y="1305763"/>
-            <a:ext cx="131673" cy="131673"/>
-          </a:xfrm>
-          <a:prstGeom prst="ellipse">
-            <a:avLst/>
-          </a:prstGeom>
-          <a:solidFill>
-            <a:srgbClr val="6B46C1"/>
-          </a:solidFill>
-          <a:ln>
-            <a:noFill/>
-          </a:ln>
-        </p:spPr>
-        <p:style>
-          <a:lnRef idx="1">
-            <a:schemeClr val="accent1"/>
-          </a:lnRef>
-          <a:fillRef idx="3">
-            <a:schemeClr val="accent1"/>
-          </a:fillRef>
-          <a:effectRef idx="2">
-            <a:schemeClr val="accent1"/>
-          </a:effectRef>
-          <a:fontRef idx="minor">
-            <a:schemeClr val="lt1"/>
-          </a:fontRef>
-        </p:style>
-        <p:txBody>
-          <a:bodyPr rtlCol="0" anchor="ctr"/>
-          <a:lstStyle/>
-          <a:p>
-            <a:pPr algn="ctr"/>
-          </a:p>
-        </p:txBody>
-      </p:sp>
-      <p:sp>
-        <p:nvSpPr>
-          <p:cNvPr id="12" name="Oval 11"/>
-          <p:cNvSpPr/>
-          <p:nvPr/>
-        </p:nvSpPr>
-        <p:spPr>
-          <a:xfrm>
-            <a:off x="6112306" y="1305763"/>
-            <a:ext cx="131673" cy="131673"/>
-          </a:xfrm>
-          <a:prstGeom prst="ellipse">
-            <a:avLst/>
-          </a:prstGeom>
-          <a:solidFill>
-            <a:srgbClr val="6B46C1"/>
-          </a:solidFill>
-          <a:ln>
-            <a:noFill/>
-          </a:ln>
-        </p:spPr>
-        <p:style>
-          <a:lnRef idx="1">
-            <a:schemeClr val="accent1"/>
-          </a:lnRef>
-          <a:fillRef idx="3">
-            <a:schemeClr val="accent1"/>
-          </a:fillRef>
-          <a:effectRef idx="2">
-            <a:schemeClr val="accent1"/>
-          </a:effectRef>
-          <a:fontRef idx="minor">
-            <a:schemeClr val="lt1"/>
-          </a:fontRef>
-        </p:style>
-        <p:txBody>
-          <a:bodyPr rtlCol="0" anchor="ctr"/>
-          <a:lstStyle/>
-          <a:p>
-            <a:pPr algn="ctr"/>
-          </a:p>
-        </p:txBody>
-      </p:sp>
-      <p:sp>
-        <p:nvSpPr>
-          <p:cNvPr id="13" name="Oval 12"/>
-          <p:cNvSpPr/>
-          <p:nvPr/>
-        </p:nvSpPr>
-        <p:spPr>
-          <a:xfrm>
-            <a:off x="6293357" y="1305763"/>
-            <a:ext cx="131673" cy="131673"/>
-          </a:xfrm>
-          <a:prstGeom prst="ellipse">
-            <a:avLst/>
-          </a:prstGeom>
-          <a:solidFill>
-            <a:srgbClr val="6B46C1"/>
-          </a:solidFill>
-          <a:ln>
-            <a:noFill/>
-          </a:ln>
-        </p:spPr>
-        <p:style>
-          <a:lnRef idx="1">
-            <a:schemeClr val="accent1"/>
-          </a:lnRef>
-          <a:fillRef idx="3">
-            <a:schemeClr val="accent1"/>
-          </a:fillRef>
-          <a:effectRef idx="2">
-            <a:schemeClr val="accent1"/>
-          </a:effectRef>
-          <a:fontRef idx="minor">
-            <a:schemeClr val="lt1"/>
-          </a:fontRef>
-        </p:style>
-        <p:txBody>
-          <a:bodyPr rtlCol="0" anchor="ctr"/>
-          <a:lstStyle/>
-          <a:p>
-            <a:pPr algn="ctr"/>
-          </a:p>
-        </p:txBody>
-      </p:sp>
-      <p:sp>
-        <p:nvSpPr>
-          <p:cNvPr id="14" name="TextBox 13"/>
-          <p:cNvSpPr txBox="1"/>
-          <p:nvPr/>
-        </p:nvSpPr>
-        <p:spPr>
-          <a:xfrm>
-            <a:off x="5410047" y="2240279"/>
-            <a:ext cx="1371600" cy="274320"/>
+              <a:t>灵梭 (AI 编排)</a:t>
+            </a:r>
+          </a:p>
+        </p:txBody>
+      </p:sp>
+      <p:sp>
+        <p:nvSpPr>
+          <p:cNvPr id="5" name="TextBox 4"/>
+          <p:cNvSpPr txBox="1"/>
+          <p:nvPr/>
+        </p:nvSpPr>
+        <p:spPr>
+          <a:xfrm>
+            <a:off x="5212080" y="3657600"/>
+            <a:ext cx="1828800" cy="274320"/>
           </a:xfrm>
           <a:prstGeom prst="rect">
             <a:avLst/>
@@ -9258,236 +8888,21 @@
                 </a:solidFill>
                 <a:latin typeface="阿里巴巴普惠体 3.0"/>
               </a:rPr>
-              <a:t>SQL工坊</a:t>
-            </a:r>
-          </a:p>
-        </p:txBody>
-      </p:sp>
-      <p:sp>
-        <p:nvSpPr>
-          <p:cNvPr id="15" name="Rounded Rectangle 14"/>
-          <p:cNvSpPr/>
-          <p:nvPr/>
-        </p:nvSpPr>
-        <p:spPr>
-          <a:xfrm>
-            <a:off x="7055967" y="1371600"/>
-            <a:ext cx="822960" cy="822960"/>
-          </a:xfrm>
-          <a:prstGeom prst="roundRect">
-            <a:avLst/>
-          </a:prstGeom>
-          <a:solidFill>
-            <a:srgbClr val="10B981"/>
-          </a:solidFill>
-          <a:ln>
-            <a:noFill/>
-          </a:ln>
-        </p:spPr>
-        <p:style>
-          <a:lnRef idx="1">
-            <a:schemeClr val="accent1"/>
-          </a:lnRef>
-          <a:fillRef idx="3">
-            <a:schemeClr val="accent1"/>
-          </a:fillRef>
-          <a:effectRef idx="2">
-            <a:schemeClr val="accent1"/>
-          </a:effectRef>
-          <a:fontRef idx="minor">
-            <a:schemeClr val="lt1"/>
-          </a:fontRef>
-        </p:style>
-        <p:txBody>
-          <a:bodyPr rtlCol="0" anchor="ctr"/>
-          <a:lstStyle/>
-          <a:p>
-            <a:pPr algn="ctr"/>
-          </a:p>
-        </p:txBody>
-      </p:sp>
-      <p:sp>
-        <p:nvSpPr>
-          <p:cNvPr id="16" name="Oval 15"/>
-          <p:cNvSpPr/>
-          <p:nvPr/>
-        </p:nvSpPr>
-        <p:spPr>
-          <a:xfrm>
-            <a:off x="7138263" y="1305763"/>
-            <a:ext cx="131673" cy="131673"/>
-          </a:xfrm>
-          <a:prstGeom prst="ellipse">
-            <a:avLst/>
-          </a:prstGeom>
-          <a:solidFill>
-            <a:srgbClr val="10B981"/>
-          </a:solidFill>
-          <a:ln>
-            <a:noFill/>
-          </a:ln>
-        </p:spPr>
-        <p:style>
-          <a:lnRef idx="1">
-            <a:schemeClr val="accent1"/>
-          </a:lnRef>
-          <a:fillRef idx="3">
-            <a:schemeClr val="accent1"/>
-          </a:fillRef>
-          <a:effectRef idx="2">
-            <a:schemeClr val="accent1"/>
-          </a:effectRef>
-          <a:fontRef idx="minor">
-            <a:schemeClr val="lt1"/>
-          </a:fontRef>
-        </p:style>
-        <p:txBody>
-          <a:bodyPr rtlCol="0" anchor="ctr"/>
-          <a:lstStyle/>
-          <a:p>
-            <a:pPr algn="ctr"/>
-          </a:p>
-        </p:txBody>
-      </p:sp>
-      <p:sp>
-        <p:nvSpPr>
-          <p:cNvPr id="17" name="Oval 16"/>
-          <p:cNvSpPr/>
-          <p:nvPr/>
-        </p:nvSpPr>
-        <p:spPr>
-          <a:xfrm>
-            <a:off x="7319314" y="1305763"/>
-            <a:ext cx="131673" cy="131673"/>
-          </a:xfrm>
-          <a:prstGeom prst="ellipse">
-            <a:avLst/>
-          </a:prstGeom>
-          <a:solidFill>
-            <a:srgbClr val="10B981"/>
-          </a:solidFill>
-          <a:ln>
-            <a:noFill/>
-          </a:ln>
-        </p:spPr>
-        <p:style>
-          <a:lnRef idx="1">
-            <a:schemeClr val="accent1"/>
-          </a:lnRef>
-          <a:fillRef idx="3">
-            <a:schemeClr val="accent1"/>
-          </a:fillRef>
-          <a:effectRef idx="2">
-            <a:schemeClr val="accent1"/>
-          </a:effectRef>
-          <a:fontRef idx="minor">
-            <a:schemeClr val="lt1"/>
-          </a:fontRef>
-        </p:style>
-        <p:txBody>
-          <a:bodyPr rtlCol="0" anchor="ctr"/>
-          <a:lstStyle/>
-          <a:p>
-            <a:pPr algn="ctr"/>
-          </a:p>
-        </p:txBody>
-      </p:sp>
-      <p:sp>
-        <p:nvSpPr>
-          <p:cNvPr id="18" name="Oval 17"/>
-          <p:cNvSpPr/>
-          <p:nvPr/>
-        </p:nvSpPr>
-        <p:spPr>
-          <a:xfrm>
-            <a:off x="7483906" y="1305763"/>
-            <a:ext cx="131673" cy="131673"/>
-          </a:xfrm>
-          <a:prstGeom prst="ellipse">
-            <a:avLst/>
-          </a:prstGeom>
-          <a:solidFill>
-            <a:srgbClr val="10B981"/>
-          </a:solidFill>
-          <a:ln>
-            <a:noFill/>
-          </a:ln>
-        </p:spPr>
-        <p:style>
-          <a:lnRef idx="1">
-            <a:schemeClr val="accent1"/>
-          </a:lnRef>
-          <a:fillRef idx="3">
-            <a:schemeClr val="accent1"/>
-          </a:fillRef>
-          <a:effectRef idx="2">
-            <a:schemeClr val="accent1"/>
-          </a:effectRef>
-          <a:fontRef idx="minor">
-            <a:schemeClr val="lt1"/>
-          </a:fontRef>
-        </p:style>
-        <p:txBody>
-          <a:bodyPr rtlCol="0" anchor="ctr"/>
-          <a:lstStyle/>
-          <a:p>
-            <a:pPr algn="ctr"/>
-          </a:p>
-        </p:txBody>
-      </p:sp>
-      <p:sp>
-        <p:nvSpPr>
-          <p:cNvPr id="19" name="Oval 18"/>
-          <p:cNvSpPr/>
-          <p:nvPr/>
-        </p:nvSpPr>
-        <p:spPr>
-          <a:xfrm>
-            <a:off x="7664958" y="1305763"/>
-            <a:ext cx="131673" cy="131673"/>
-          </a:xfrm>
-          <a:prstGeom prst="ellipse">
-            <a:avLst/>
-          </a:prstGeom>
-          <a:solidFill>
-            <a:srgbClr val="10B981"/>
-          </a:solidFill>
-          <a:ln>
-            <a:noFill/>
-          </a:ln>
-        </p:spPr>
-        <p:style>
-          <a:lnRef idx="1">
-            <a:schemeClr val="accent1"/>
-          </a:lnRef>
-          <a:fillRef idx="3">
-            <a:schemeClr val="accent1"/>
-          </a:fillRef>
-          <a:effectRef idx="2">
-            <a:schemeClr val="accent1"/>
-          </a:effectRef>
-          <a:fontRef idx="minor">
-            <a:schemeClr val="lt1"/>
-          </a:fontRef>
-        </p:style>
-        <p:txBody>
-          <a:bodyPr rtlCol="0" anchor="ctr"/>
-          <a:lstStyle/>
-          <a:p>
-            <a:pPr algn="ctr"/>
-          </a:p>
-        </p:txBody>
-      </p:sp>
-      <p:sp>
-        <p:nvSpPr>
-          <p:cNvPr id="20" name="TextBox 19"/>
-          <p:cNvSpPr txBox="1"/>
-          <p:nvPr/>
-        </p:nvSpPr>
-        <p:spPr>
-          <a:xfrm>
-            <a:off x="6781647" y="2240279"/>
-            <a:ext cx="1371600" cy="274320"/>
+              <a:t>SQL工坊 (数据底座)</a:t>
+            </a:r>
+          </a:p>
+        </p:txBody>
+      </p:sp>
+      <p:sp>
+        <p:nvSpPr>
+          <p:cNvPr id="6" name="TextBox 5"/>
+          <p:cNvSpPr txBox="1"/>
+          <p:nvPr/>
+        </p:nvSpPr>
+        <p:spPr>
+          <a:xfrm>
+            <a:off x="7132320" y="3657600"/>
+            <a:ext cx="1828800" cy="274320"/>
           </a:xfrm>
           <a:prstGeom prst="rect">
             <a:avLst/>
@@ -9508,14 +8923,14 @@
                 </a:solidFill>
                 <a:latin typeface="阿里巴巴普惠体 3.0"/>
               </a:rPr>
-              <a:t>SQL工坊 MCP</a:t>
-            </a:r>
-          </a:p>
-        </p:txBody>
-      </p:sp>
-      <p:sp>
-        <p:nvSpPr>
-          <p:cNvPr id="21" name="TextBox 20"/>
+              <a:t>SQL工坊 MCP (桥)</a:t>
+            </a:r>
+          </a:p>
+        </p:txBody>
+      </p:sp>
+      <p:sp>
+        <p:nvSpPr>
+          <p:cNvPr id="7" name="TextBox 6"/>
           <p:cNvSpPr txBox="1"/>
           <p:nvPr/>
         </p:nvSpPr>
@@ -9543,14 +8958,14 @@
                 </a:solidFill>
                 <a:latin typeface="阿里巴巴普惠体 3.0"/>
               </a:rPr>
-              <a:t>✓ 灵梭:Spring Boot AI 加速器,零配置接入 RAG / MCP / Skill</a:t>
-            </a:r>
-          </a:p>
-        </p:txBody>
-      </p:sp>
-      <p:sp>
-        <p:nvSpPr>
-          <p:cNvPr id="22" name="TextBox 21"/>
+              <a:t>★ 灵梭杀手锏:零配置接入 RAG / MCP / Skill · 50 行配置 → 1 行模板</a:t>
+            </a:r>
+          </a:p>
+        </p:txBody>
+      </p:sp>
+      <p:sp>
+        <p:nvSpPr>
+          <p:cNvPr id="8" name="TextBox 7"/>
           <p:cNvSpPr txBox="1"/>
           <p:nvPr/>
         </p:nvSpPr>
@@ -9578,14 +8993,14 @@
                 </a:solidFill>
                 <a:latin typeface="阿里巴巴普惠体 3.0"/>
               </a:rPr>
-              <a:t>✓ SQL工坊:JSON CRUD + Calcite 联邦 + Amis 低代码,数据开发效率 +300%</a:t>
-            </a:r>
-          </a:p>
-        </p:txBody>
-      </p:sp>
-      <p:sp>
-        <p:nvSpPr>
-          <p:cNvPr id="23" name="TextBox 22"/>
+              <a:t>★ SQL工坊杀手锏:JSON CRUD + Calcite 联邦 + Amis 低代码 · 开发效率 +300%</a:t>
+            </a:r>
+          </a:p>
+        </p:txBody>
+      </p:sp>
+      <p:sp>
+        <p:nvSpPr>
+          <p:cNvPr id="9" name="TextBox 8"/>
           <p:cNvSpPr txBox="1"/>
           <p:nvPr/>
         </p:nvSpPr>
@@ -9609,18 +9024,18 @@
             <a:r>
               <a:rPr sz="1600" b="0">
                 <a:solidFill>
-                  <a:srgbClr val="6B7280"/>
+                  <a:srgbClr val="6B46C1"/>
                 </a:solidFill>
                 <a:latin typeface="阿里巴巴普惠体 3.0"/>
               </a:rPr>
-              <a:t>✓ SQL工坊 MCP:打通 AI ↔ 业务数据库,数据不出企业</a:t>
-            </a:r>
-          </a:p>
-        </p:txBody>
-      </p:sp>
-      <p:sp>
-        <p:nvSpPr>
-          <p:cNvPr id="24" name="TextBox 23"/>
+              <a:t>★ SQL工坊 MCP 杀手锏:5 受限通道 · 数据不出企业 · 私有化部署</a:t>
+            </a:r>
+          </a:p>
+        </p:txBody>
+      </p:sp>
+      <p:sp>
+        <p:nvSpPr>
+          <p:cNvPr id="10" name="TextBox 9"/>
           <p:cNvSpPr txBox="1"/>
           <p:nvPr/>
         </p:nvSpPr>
@@ -9644,18 +9059,18 @@
             <a:r>
               <a:rPr sz="1600" b="0">
                 <a:solidFill>
-                  <a:srgbClr val="1F2937"/>
+                  <a:srgbClr val="10B981"/>
                 </a:solidFill>
                 <a:latin typeface="阿里巴巴普惠体 3.0"/>
               </a:rPr>
-              <a:t>✓ 3 个依赖库可单独引入;SQL工坊还可单独服务对接外部项目</a:t>
-            </a:r>
-          </a:p>
-        </p:txBody>
-      </p:sp>
-      <p:sp>
-        <p:nvSpPr>
-          <p:cNvPr id="25" name="TextBox 24"/>
+              <a:t>★ 全部杀手锏:3 个依赖库可独立按需引入 · 不绑死 Spring Boot 生态</a:t>
+            </a:r>
+          </a:p>
+        </p:txBody>
+      </p:sp>
+      <p:sp>
+        <p:nvSpPr>
+          <p:cNvPr id="11" name="TextBox 10"/>
           <p:cNvSpPr txBox="1"/>
           <p:nvPr/>
         </p:nvSpPr>
@@ -9736,7 +9151,7 @@
             <p:tnCond val="0"/>
           </p:cond>
           <p:par>
-            <p:cTn id="22" nodeType="withEffect" dur="500" begin="1200ms" fill="hold">
+            <p:cTn id="8" nodeType="withEffect" dur="500" begin="1200ms" fill="hold">
               <p:animEffect presetClass="entr" presetId="10" dur="500"/>
             </p:cTn>
           </p:par>
@@ -9753,7 +9168,7 @@
             <p:tnCond val="0"/>
           </p:cond>
           <p:par>
-            <p:cTn id="22" nodeType="withEffect" dur="1500" begin="2000ms" fill="hold" repeatCount="indefinite">
+            <p:cTn id="8" nodeType="withEffect" dur="1500" begin="2000ms" fill="hold" repeatCount="indefinite">
               <p:animEffect presetClass="emph" presetId="26" dur="1500"/>
             </p:cTn>
           </p:par>
@@ -9800,8 +9215,8 @@
         </p:blipFill>
         <p:spPr>
           <a:xfrm>
-            <a:off x="365760" y="4846320"/>
-            <a:ext cx="2286000" cy="1828800"/>
+            <a:off x="182880" y="4663440"/>
+            <a:ext cx="3017520" cy="2194560"/>
           </a:xfrm>
           <a:prstGeom prst="rect">
             <a:avLst/>
@@ -10732,9 +10147,9 @@
           <a:solidFill>
             <a:srgbClr val="FFFFFF"/>
           </a:solidFill>
-          <a:ln w="12700">
+          <a:ln w="38100">
             <a:solidFill>
-              <a:srgbClr val="E5E7EB"/>
+              <a:srgbClr val="F59E0B"/>
             </a:solidFill>
           </a:ln>
         </p:spPr>
@@ -10786,11 +10201,11 @@
             <a:r>
               <a:rPr sz="2000" b="1">
                 <a:solidFill>
-                  <a:srgbClr val="007396"/>
+                  <a:srgbClr val="F59E0B"/>
                 </a:solidFill>
                 <a:latin typeface="阿里巴巴普惠体 3.0"/>
               </a:rPr>
-              <a:t>📚 RAG 知识库</a:t>
+              <a:t>📚 RAG 知识库 ★</a:t>
             </a:r>
           </a:p>
         </p:txBody>
@@ -10826,6 +10241,11 @@
                 <a:latin typeface="阿里巴巴普惠体 3.0"/>
               </a:rPr>
               <a:t>Tika + JVector</a:t>
+            </a:r>
+          </a:p>
+          <a:p>
+            <a:r>
+              <a:t>文档向量化检索</a:t>
             </a:r>
           </a:p>
         </p:txBody>
@@ -10943,6 +10363,11 @@
               <a:t>8+ 服务可热插拔</a:t>
             </a:r>
           </a:p>
+          <a:p>
+            <a:r>
+              <a:t>工具热加载</a:t>
+            </a:r>
+          </a:p>
         </p:txBody>
       </p:sp>
       <p:sp>
@@ -11058,6 +10483,11 @@
               <a:t>.st 模板即提示词</a:t>
             </a:r>
           </a:p>
+          <a:p>
+            <a:r>
+              <a:t>改 1 行 AI 行为变</a:t>
+            </a:r>
+          </a:p>
         </p:txBody>
       </p:sp>
       <p:sp>
@@ -11135,7 +10565,7 @@
                 </a:solidFill>
                 <a:latin typeface="阿里巴巴普惠体 3.0"/>
               </a:rPr>
-              <a:t>📁 文件管理</a:t>
+              <a:t>💬 对话 UI</a:t>
             </a:r>
           </a:p>
         </p:txBody>
@@ -11170,7 +10600,12 @@
                 </a:solidFill>
                 <a:latin typeface="阿里巴巴普惠体 3.0"/>
               </a:rPr>
-              <a:t>磁盘 + H2 元数据</a:t>
+              <a:t>SSE + 思维链折叠</a:t>
+            </a:r>
+          </a:p>
+          <a:p>
+            <a:r>
+              <a:t>流式输出</a:t>
             </a:r>
           </a:p>
         </p:txBody>
@@ -11250,7 +10685,7 @@
                 </a:solidFill>
                 <a:latin typeface="阿里巴巴普惠体 3.0"/>
               </a:rPr>
-              <a:t>💬 对话 UI</a:t>
+              <a:t>📁 文件管理</a:t>
             </a:r>
           </a:p>
         </p:txBody>
@@ -11285,7 +10720,12 @@
                 </a:solidFill>
                 <a:latin typeface="阿里巴巴普惠体 3.0"/>
               </a:rPr>
-              <a:t>SSE + 思维链折叠</a:t>
+              <a:t>磁盘 + H2 元数据</a:t>
+            </a:r>
+          </a:p>
+          <a:p>
+            <a:r>
+              <a:t>会话持久化</a:t>
             </a:r>
           </a:p>
         </p:txBody>
@@ -11401,6 +10841,11 @@
                 <a:latin typeface="阿里巴巴普惠体 3.0"/>
               </a:rPr>
               <a:t>时间 / Git / Maven</a:t>
+            </a:r>
+          </a:p>
+          <a:p>
+            <a:r>
+              <a:t>沙箱执行</a:t>
             </a:r>
           </a:p>
         </p:txBody>
@@ -11655,8 +11100,8 @@
         </p:blipFill>
         <p:spPr>
           <a:xfrm>
-            <a:off x="365760" y="4846320"/>
-            <a:ext cx="2286000" cy="1828800"/>
+            <a:off x="182880" y="4663440"/>
+            <a:ext cx="3017520" cy="2194560"/>
           </a:xfrm>
           <a:prstGeom prst="rect">
             <a:avLst/>
@@ -13193,7 +12638,7 @@
             <a:r>
               <a:rPr sz="1800" b="1">
                 <a:solidFill>
-                  <a:srgbClr val="007396"/>
+                  <a:srgbClr val="6B7280"/>
                 </a:solidFill>
                 <a:latin typeface="阿里巴巴普惠体 3.0"/>
               </a:rPr>
@@ -13273,7 +12718,7 @@
             <a:r>
               <a:rPr sz="1800" b="1">
                 <a:solidFill>
-                  <a:srgbClr val="007396"/>
+                  <a:srgbClr val="6B7280"/>
                 </a:solidFill>
                 <a:latin typeface="阿里巴巴普惠体 3.0"/>
               </a:rPr>
@@ -13353,7 +12798,7 @@
             <a:r>
               <a:rPr sz="1800" b="1">
                 <a:solidFill>
-                  <a:srgbClr val="007396"/>
+                  <a:srgbClr val="6B7280"/>
                 </a:solidFill>
                 <a:latin typeface="阿里巴巴普惠体 3.0"/>
               </a:rPr>
@@ -14565,7 +14010,7 @@
             <p:tnCond val="0"/>
           </p:cond>
           <p:par>
-            <p:cTn id="8" nodeType="withEffect" dur="500" begin="1000ms" fill="hold">
+            <p:cTn id="8" nodeType="withEffect" dur="500" begin="400ms" fill="hold">
               <p:animEffect presetClass="entr" presetId="10" dur="500"/>
             </p:cTn>
           </p:par>
@@ -14582,7 +14027,7 @@
             <p:tnCond val="0"/>
           </p:cond>
           <p:par>
-            <p:cTn id="11" nodeType="withEffect" dur="500" begin="2000ms" fill="hold">
+            <p:cTn id="11" nodeType="withEffect" dur="500" begin="800ms" fill="hold">
               <p:animEffect presetClass="entr" presetId="10" dur="500"/>
             </p:cTn>
           </p:par>
@@ -14599,7 +14044,7 @@
             <p:tnCond val="0"/>
           </p:cond>
           <p:par>
-            <p:cTn id="14" nodeType="withEffect" dur="500" begin="3000ms" fill="hold">
+            <p:cTn id="14" nodeType="withEffect" dur="500" begin="1200ms" fill="hold">
               <p:animEffect presetClass="entr" presetId="10" dur="500"/>
             </p:cTn>
           </p:par>
@@ -14616,7 +14061,7 @@
             <p:tnCond val="0"/>
           </p:cond>
           <p:par>
-            <p:cTn id="17" nodeType="withEffect" dur="500" begin="4000ms" fill="hold">
+            <p:cTn id="17" nodeType="withEffect" dur="500" begin="1600ms" fill="hold">
               <p:animEffect presetClass="entr" presetId="10" dur="500"/>
             </p:cTn>
           </p:par>
@@ -14633,7 +14078,7 @@
             <p:tnCond val="0"/>
           </p:cond>
           <p:par>
-            <p:cTn id="17" nodeType="withEffect" dur="1500" begin="4500ms" fill="hold" repeatCount="indefinite">
+            <p:cTn id="17" nodeType="withEffect" dur="1500" begin="2500ms" fill="hold" repeatCount="indefinite">
               <p:animEffect presetClass="emph" presetId="26" dur="1500"/>
             </p:cTn>
           </p:par>
@@ -15548,7 +14993,7 @@
             <p:tnCond val="0"/>
           </p:cond>
           <p:par>
-            <p:cTn id="8" nodeType="withEffect" dur="500" begin="1000ms" fill="hold">
+            <p:cTn id="8" nodeType="withEffect" dur="500" begin="400ms" fill="hold">
               <p:animEffect presetClass="entr" presetId="10" dur="500"/>
             </p:cTn>
           </p:par>
@@ -15565,7 +15010,7 @@
             <p:tnCond val="0"/>
           </p:cond>
           <p:par>
-            <p:cTn id="11" nodeType="withEffect" dur="500" begin="2000ms" fill="hold">
+            <p:cTn id="11" nodeType="withEffect" dur="500" begin="800ms" fill="hold">
               <p:animEffect presetClass="entr" presetId="10" dur="500"/>
             </p:cTn>
           </p:par>
@@ -15582,7 +15027,7 @@
             <p:tnCond val="0"/>
           </p:cond>
           <p:par>
-            <p:cTn id="14" nodeType="withEffect" dur="500" begin="3000ms" fill="hold">
+            <p:cTn id="14" nodeType="withEffect" dur="500" begin="1200ms" fill="hold">
               <p:animEffect presetClass="entr" presetId="10" dur="500"/>
             </p:cTn>
           </p:par>
@@ -15599,7 +15044,7 @@
             <p:tnCond val="0"/>
           </p:cond>
           <p:par>
-            <p:cTn id="17" nodeType="withEffect" dur="500" begin="4000ms" fill="hold">
+            <p:cTn id="17" nodeType="withEffect" dur="500" begin="1600ms" fill="hold">
               <p:animEffect presetClass="entr" presetId="10" dur="500"/>
             </p:cTn>
           </p:par>
@@ -15616,7 +15061,7 @@
             <p:tnCond val="0"/>
           </p:cond>
           <p:par>
-            <p:cTn id="17" nodeType="withEffect" dur="1500" begin="4500ms" fill="hold" repeatCount="indefinite">
+            <p:cTn id="17" nodeType="withEffect" dur="1500" begin="2500ms" fill="hold" repeatCount="indefinite">
               <p:animEffect presetClass="emph" presetId="26" dur="1500"/>
             </p:cTn>
           </p:par>

</xml_diff>

<commit_message>
fix(ppt): 修复 add_anim 累积式 timing 注入,OnlyOffice 之前看不到任何动画
问题:原 add_anim 每次调用都 slide._element.append(新 <p:timing> 元素),
导致每页生成 6-13 个独立 timing。PowerPoint / OnlyOffice 规定每张 slide
只能有 1 个 <p:timing>,所有动画必须嵌套在同一 timing 的 tnLst 中,
遇到多 timing 时只识别第 1 个(或全部忽略)→ 看不到任何动画。

修复:改为累积式注入 — 找到/创建 slide 唯一的 <p:timing>,把新动画
作为并列 par 追加到顶层 par 下,共享同一 tnLst。

测试:断言从 xml.count("<p:timing") 改为 xml.count("<p:animEffect"),
T1 增加 timing=1 健全性检查。每页 1 timing + N animEffect,
12 页累计 100 animEffect + 15 pulse_loop。

🤖 Generated with [Claude Code](https://claude.com/claude-code)

Co-Authored-By: Claude Fable 5 <noreply@anthropic.com>
</commit_message>
<xml_diff>
--- a/docs/ppt/javabrain.pptx
+++ b/docs/ppt/javabrain.pptx
@@ -3569,13 +3569,6 @@
             </p:cTn>
           </p:par>
         </p:par>
-      </p:par>
-    </p:tnLst>
-  </p:timing>
-  <p:timing>
-    <p:tnLst>
-      <p:par>
-        <p:pPr/>
         <p:par>
           <p:cond>
             <p:tnCond val="0"/>
@@ -3586,13 +3579,6 @@
             </p:cTn>
           </p:par>
         </p:par>
-      </p:par>
-    </p:tnLst>
-  </p:timing>
-  <p:timing>
-    <p:tnLst>
-      <p:par>
-        <p:pPr/>
         <p:par>
           <p:cond>
             <p:tnCond val="0"/>
@@ -3603,13 +3589,6 @@
             </p:cTn>
           </p:par>
         </p:par>
-      </p:par>
-    </p:tnLst>
-  </p:timing>
-  <p:timing>
-    <p:tnLst>
-      <p:par>
-        <p:pPr/>
         <p:par>
           <p:cond>
             <p:tnCond val="0"/>
@@ -3620,13 +3599,6 @@
             </p:cTn>
           </p:par>
         </p:par>
-      </p:par>
-    </p:tnLst>
-  </p:timing>
-  <p:timing>
-    <p:tnLst>
-      <p:par>
-        <p:pPr/>
         <p:par>
           <p:cond>
             <p:tnCond val="0"/>
@@ -3637,13 +3609,6 @@
             </p:cTn>
           </p:par>
         </p:par>
-      </p:par>
-    </p:tnLst>
-  </p:timing>
-  <p:timing>
-    <p:tnLst>
-      <p:par>
-        <p:pPr/>
         <p:par>
           <p:cond>
             <p:tnCond val="0"/>
@@ -4956,13 +4921,6 @@
             </p:cTn>
           </p:par>
         </p:par>
-      </p:par>
-    </p:tnLst>
-  </p:timing>
-  <p:timing>
-    <p:tnLst>
-      <p:par>
-        <p:pPr/>
         <p:par>
           <p:cond>
             <p:tnCond val="0"/>
@@ -4973,13 +4931,6 @@
             </p:cTn>
           </p:par>
         </p:par>
-      </p:par>
-    </p:tnLst>
-  </p:timing>
-  <p:timing>
-    <p:tnLst>
-      <p:par>
-        <p:pPr/>
         <p:par>
           <p:cond>
             <p:tnCond val="0"/>
@@ -4990,13 +4941,6 @@
             </p:cTn>
           </p:par>
         </p:par>
-      </p:par>
-    </p:tnLst>
-  </p:timing>
-  <p:timing>
-    <p:tnLst>
-      <p:par>
-        <p:pPr/>
         <p:par>
           <p:cond>
             <p:tnCond val="0"/>
@@ -5007,13 +4951,6 @@
             </p:cTn>
           </p:par>
         </p:par>
-      </p:par>
-    </p:tnLst>
-  </p:timing>
-  <p:timing>
-    <p:tnLst>
-      <p:par>
-        <p:pPr/>
         <p:par>
           <p:cond>
             <p:tnCond val="0"/>
@@ -5024,13 +4961,6 @@
             </p:cTn>
           </p:par>
         </p:par>
-      </p:par>
-    </p:tnLst>
-  </p:timing>
-  <p:timing>
-    <p:tnLst>
-      <p:par>
-        <p:pPr/>
         <p:par>
           <p:cond>
             <p:tnCond val="0"/>
@@ -5041,13 +4971,6 @@
             </p:cTn>
           </p:par>
         </p:par>
-      </p:par>
-    </p:tnLst>
-  </p:timing>
-  <p:timing>
-    <p:tnLst>
-      <p:par>
-        <p:pPr/>
         <p:par>
           <p:cond>
             <p:tnCond val="0"/>
@@ -5058,13 +4981,6 @@
             </p:cTn>
           </p:par>
         </p:par>
-      </p:par>
-    </p:tnLst>
-  </p:timing>
-  <p:timing>
-    <p:tnLst>
-      <p:par>
-        <p:pPr/>
         <p:par>
           <p:cond>
             <p:tnCond val="0"/>
@@ -5075,13 +4991,6 @@
             </p:cTn>
           </p:par>
         </p:par>
-      </p:par>
-    </p:tnLst>
-  </p:timing>
-  <p:timing>
-    <p:tnLst>
-      <p:par>
-        <p:pPr/>
         <p:par>
           <p:cond>
             <p:tnCond val="0"/>
@@ -5092,13 +5001,6 @@
             </p:cTn>
           </p:par>
         </p:par>
-      </p:par>
-    </p:tnLst>
-  </p:timing>
-  <p:timing>
-    <p:tnLst>
-      <p:par>
-        <p:pPr/>
         <p:par>
           <p:cond>
             <p:tnCond val="0"/>
@@ -5109,13 +5011,6 @@
             </p:cTn>
           </p:par>
         </p:par>
-      </p:par>
-    </p:tnLst>
-  </p:timing>
-  <p:timing>
-    <p:tnLst>
-      <p:par>
-        <p:pPr/>
         <p:par>
           <p:cond>
             <p:tnCond val="0"/>
@@ -5126,13 +5021,6 @@
             </p:cTn>
           </p:par>
         </p:par>
-      </p:par>
-    </p:tnLst>
-  </p:timing>
-  <p:timing>
-    <p:tnLst>
-      <p:par>
-        <p:pPr/>
         <p:par>
           <p:cond>
             <p:tnCond val="0"/>
@@ -5143,13 +5031,6 @@
             </p:cTn>
           </p:par>
         </p:par>
-      </p:par>
-    </p:tnLst>
-  </p:timing>
-  <p:timing>
-    <p:tnLst>
-      <p:par>
-        <p:pPr/>
         <p:par>
           <p:cond>
             <p:tnCond val="0"/>
@@ -6529,13 +6410,6 @@
             </p:cTn>
           </p:par>
         </p:par>
-      </p:par>
-    </p:tnLst>
-  </p:timing>
-  <p:timing>
-    <p:tnLst>
-      <p:par>
-        <p:pPr/>
         <p:par>
           <p:cond>
             <p:tnCond val="0"/>
@@ -6546,13 +6420,6 @@
             </p:cTn>
           </p:par>
         </p:par>
-      </p:par>
-    </p:tnLst>
-  </p:timing>
-  <p:timing>
-    <p:tnLst>
-      <p:par>
-        <p:pPr/>
         <p:par>
           <p:cond>
             <p:tnCond val="0"/>
@@ -6563,13 +6430,6 @@
             </p:cTn>
           </p:par>
         </p:par>
-      </p:par>
-    </p:tnLst>
-  </p:timing>
-  <p:timing>
-    <p:tnLst>
-      <p:par>
-        <p:pPr/>
         <p:par>
           <p:cond>
             <p:tnCond val="0"/>
@@ -6580,13 +6440,6 @@
             </p:cTn>
           </p:par>
         </p:par>
-      </p:par>
-    </p:tnLst>
-  </p:timing>
-  <p:timing>
-    <p:tnLst>
-      <p:par>
-        <p:pPr/>
         <p:par>
           <p:cond>
             <p:tnCond val="0"/>
@@ -6597,13 +6450,6 @@
             </p:cTn>
           </p:par>
         </p:par>
-      </p:par>
-    </p:tnLst>
-  </p:timing>
-  <p:timing>
-    <p:tnLst>
-      <p:par>
-        <p:pPr/>
         <p:par>
           <p:cond>
             <p:tnCond val="0"/>
@@ -6614,13 +6460,6 @@
             </p:cTn>
           </p:par>
         </p:par>
-      </p:par>
-    </p:tnLst>
-  </p:timing>
-  <p:timing>
-    <p:tnLst>
-      <p:par>
-        <p:pPr/>
         <p:par>
           <p:cond>
             <p:tnCond val="0"/>
@@ -6631,13 +6470,6 @@
             </p:cTn>
           </p:par>
         </p:par>
-      </p:par>
-    </p:tnLst>
-  </p:timing>
-  <p:timing>
-    <p:tnLst>
-      <p:par>
-        <p:pPr/>
         <p:par>
           <p:cond>
             <p:tnCond val="0"/>
@@ -6648,13 +6480,6 @@
             </p:cTn>
           </p:par>
         </p:par>
-      </p:par>
-    </p:tnLst>
-  </p:timing>
-  <p:timing>
-    <p:tnLst>
-      <p:par>
-        <p:pPr/>
         <p:par>
           <p:cond>
             <p:tnCond val="0"/>
@@ -6665,13 +6490,6 @@
             </p:cTn>
           </p:par>
         </p:par>
-      </p:par>
-    </p:tnLst>
-  </p:timing>
-  <p:timing>
-    <p:tnLst>
-      <p:par>
-        <p:pPr/>
         <p:par>
           <p:cond>
             <p:tnCond val="0"/>
@@ -6682,13 +6500,6 @@
             </p:cTn>
           </p:par>
         </p:par>
-      </p:par>
-    </p:tnLst>
-  </p:timing>
-  <p:timing>
-    <p:tnLst>
-      <p:par>
-        <p:pPr/>
         <p:par>
           <p:cond>
             <p:tnCond val="0"/>
@@ -6699,13 +6510,6 @@
             </p:cTn>
           </p:par>
         </p:par>
-      </p:par>
-    </p:tnLst>
-  </p:timing>
-  <p:timing>
-    <p:tnLst>
-      <p:par>
-        <p:pPr/>
         <p:par>
           <p:cond>
             <p:tnCond val="0"/>
@@ -6716,13 +6520,6 @@
             </p:cTn>
           </p:par>
         </p:par>
-      </p:par>
-    </p:tnLst>
-  </p:timing>
-  <p:timing>
-    <p:tnLst>
-      <p:par>
-        <p:pPr/>
         <p:par>
           <p:cond>
             <p:tnCond val="0"/>
@@ -7203,13 +7000,6 @@
             </p:cTn>
           </p:par>
         </p:par>
-      </p:par>
-    </p:tnLst>
-  </p:timing>
-  <p:timing>
-    <p:tnLst>
-      <p:par>
-        <p:pPr/>
         <p:par>
           <p:cond>
             <p:tnCond val="0"/>
@@ -7220,13 +7010,6 @@
             </p:cTn>
           </p:par>
         </p:par>
-      </p:par>
-    </p:tnLst>
-  </p:timing>
-  <p:timing>
-    <p:tnLst>
-      <p:par>
-        <p:pPr/>
         <p:par>
           <p:cond>
             <p:tnCond val="0"/>
@@ -7237,13 +7020,6 @@
             </p:cTn>
           </p:par>
         </p:par>
-      </p:par>
-    </p:tnLst>
-  </p:timing>
-  <p:timing>
-    <p:tnLst>
-      <p:par>
-        <p:pPr/>
         <p:par>
           <p:cond>
             <p:tnCond val="0"/>
@@ -7254,13 +7030,6 @@
             </p:cTn>
           </p:par>
         </p:par>
-      </p:par>
-    </p:tnLst>
-  </p:timing>
-  <p:timing>
-    <p:tnLst>
-      <p:par>
-        <p:pPr/>
         <p:par>
           <p:cond>
             <p:tnCond val="0"/>
@@ -7271,13 +7040,6 @@
             </p:cTn>
           </p:par>
         </p:par>
-      </p:par>
-    </p:tnLst>
-  </p:timing>
-  <p:timing>
-    <p:tnLst>
-      <p:par>
-        <p:pPr/>
         <p:par>
           <p:cond>
             <p:tnCond val="0"/>
@@ -7288,13 +7050,6 @@
             </p:cTn>
           </p:par>
         </p:par>
-      </p:par>
-    </p:tnLst>
-  </p:timing>
-  <p:timing>
-    <p:tnLst>
-      <p:par>
-        <p:pPr/>
         <p:par>
           <p:cond>
             <p:tnCond val="0"/>
@@ -8619,13 +8374,6 @@
             </p:cTn>
           </p:par>
         </p:par>
-      </p:par>
-    </p:tnLst>
-  </p:timing>
-  <p:timing>
-    <p:tnLst>
-      <p:par>
-        <p:pPr/>
         <p:par>
           <p:cond>
             <p:tnCond val="0"/>
@@ -8636,13 +8384,6 @@
             </p:cTn>
           </p:par>
         </p:par>
-      </p:par>
-    </p:tnLst>
-  </p:timing>
-  <p:timing>
-    <p:tnLst>
-      <p:par>
-        <p:pPr/>
         <p:par>
           <p:cond>
             <p:tnCond val="0"/>
@@ -8653,13 +8394,6 @@
             </p:cTn>
           </p:par>
         </p:par>
-      </p:par>
-    </p:tnLst>
-  </p:timing>
-  <p:timing>
-    <p:tnLst>
-      <p:par>
-        <p:pPr/>
         <p:par>
           <p:cond>
             <p:tnCond val="0"/>
@@ -8670,13 +8404,6 @@
             </p:cTn>
           </p:par>
         </p:par>
-      </p:par>
-    </p:tnLst>
-  </p:timing>
-  <p:timing>
-    <p:tnLst>
-      <p:par>
-        <p:pPr/>
         <p:par>
           <p:cond>
             <p:tnCond val="0"/>
@@ -8687,13 +8414,6 @@
             </p:cTn>
           </p:par>
         </p:par>
-      </p:par>
-    </p:tnLst>
-  </p:timing>
-  <p:timing>
-    <p:tnLst>
-      <p:par>
-        <p:pPr/>
         <p:par>
           <p:cond>
             <p:tnCond val="0"/>
@@ -8704,13 +8424,6 @@
             </p:cTn>
           </p:par>
         </p:par>
-      </p:par>
-    </p:tnLst>
-  </p:timing>
-  <p:timing>
-    <p:tnLst>
-      <p:par>
-        <p:pPr/>
         <p:par>
           <p:cond>
             <p:tnCond val="0"/>
@@ -8721,13 +8434,6 @@
             </p:cTn>
           </p:par>
         </p:par>
-      </p:par>
-    </p:tnLst>
-  </p:timing>
-  <p:timing>
-    <p:tnLst>
-      <p:par>
-        <p:pPr/>
         <p:par>
           <p:cond>
             <p:tnCond val="0"/>
@@ -9122,13 +8828,6 @@
             </p:cTn>
           </p:par>
         </p:par>
-      </p:par>
-    </p:tnLst>
-  </p:timing>
-  <p:timing>
-    <p:tnLst>
-      <p:par>
-        <p:pPr/>
         <p:par>
           <p:cond>
             <p:tnCond val="0"/>
@@ -9139,13 +8838,6 @@
             </p:cTn>
           </p:par>
         </p:par>
-      </p:par>
-    </p:tnLst>
-  </p:timing>
-  <p:timing>
-    <p:tnLst>
-      <p:par>
-        <p:pPr/>
         <p:par>
           <p:cond>
             <p:tnCond val="0"/>
@@ -9156,13 +8848,6 @@
             </p:cTn>
           </p:par>
         </p:par>
-      </p:par>
-    </p:tnLst>
-  </p:timing>
-  <p:timing>
-    <p:tnLst>
-      <p:par>
-        <p:pPr/>
         <p:par>
           <p:cond>
             <p:tnCond val="0"/>
@@ -9952,13 +9637,6 @@
             </p:cTn>
           </p:par>
         </p:par>
-      </p:par>
-    </p:tnLst>
-  </p:timing>
-  <p:timing>
-    <p:tnLst>
-      <p:par>
-        <p:pPr/>
         <p:par>
           <p:cond>
             <p:tnCond val="0"/>
@@ -9969,13 +9647,6 @@
             </p:cTn>
           </p:par>
         </p:par>
-      </p:par>
-    </p:tnLst>
-  </p:timing>
-  <p:timing>
-    <p:tnLst>
-      <p:par>
-        <p:pPr/>
         <p:par>
           <p:cond>
             <p:tnCond val="0"/>
@@ -9986,13 +9657,6 @@
             </p:cTn>
           </p:par>
         </p:par>
-      </p:par>
-    </p:tnLst>
-  </p:timing>
-  <p:timing>
-    <p:tnLst>
-      <p:par>
-        <p:pPr/>
         <p:par>
           <p:cond>
             <p:tnCond val="0"/>
@@ -10003,13 +9667,6 @@
             </p:cTn>
           </p:par>
         </p:par>
-      </p:par>
-    </p:tnLst>
-  </p:timing>
-  <p:timing>
-    <p:tnLst>
-      <p:par>
-        <p:pPr/>
         <p:par>
           <p:cond>
             <p:tnCond val="0"/>
@@ -10020,13 +9677,6 @@
             </p:cTn>
           </p:par>
         </p:par>
-      </p:par>
-    </p:tnLst>
-  </p:timing>
-  <p:timing>
-    <p:tnLst>
-      <p:par>
-        <p:pPr/>
         <p:par>
           <p:cond>
             <p:tnCond val="0"/>
@@ -10037,13 +9687,6 @@
             </p:cTn>
           </p:par>
         </p:par>
-      </p:par>
-    </p:tnLst>
-  </p:timing>
-  <p:timing>
-    <p:tnLst>
-      <p:par>
-        <p:pPr/>
         <p:par>
           <p:cond>
             <p:tnCond val="0"/>
@@ -10054,13 +9697,6 @@
             </p:cTn>
           </p:par>
         </p:par>
-      </p:par>
-    </p:tnLst>
-  </p:timing>
-  <p:timing>
-    <p:tnLst>
-      <p:par>
-        <p:pPr/>
         <p:par>
           <p:cond>
             <p:tnCond val="0"/>
@@ -10939,13 +10575,6 @@
             </p:cTn>
           </p:par>
         </p:par>
-      </p:par>
-    </p:tnLst>
-  </p:timing>
-  <p:timing>
-    <p:tnLst>
-      <p:par>
-        <p:pPr/>
         <p:par>
           <p:cond>
             <p:tnCond val="0"/>
@@ -10956,13 +10585,6 @@
             </p:cTn>
           </p:par>
         </p:par>
-      </p:par>
-    </p:tnLst>
-  </p:timing>
-  <p:timing>
-    <p:tnLst>
-      <p:par>
-        <p:pPr/>
         <p:par>
           <p:cond>
             <p:tnCond val="0"/>
@@ -10973,13 +10595,6 @@
             </p:cTn>
           </p:par>
         </p:par>
-      </p:par>
-    </p:tnLst>
-  </p:timing>
-  <p:timing>
-    <p:tnLst>
-      <p:par>
-        <p:pPr/>
         <p:par>
           <p:cond>
             <p:tnCond val="0"/>
@@ -10990,13 +10605,6 @@
             </p:cTn>
           </p:par>
         </p:par>
-      </p:par>
-    </p:tnLst>
-  </p:timing>
-  <p:timing>
-    <p:tnLst>
-      <p:par>
-        <p:pPr/>
         <p:par>
           <p:cond>
             <p:tnCond val="0"/>
@@ -11007,13 +10615,6 @@
             </p:cTn>
           </p:par>
         </p:par>
-      </p:par>
-    </p:tnLst>
-  </p:timing>
-  <p:timing>
-    <p:tnLst>
-      <p:par>
-        <p:pPr/>
         <p:par>
           <p:cond>
             <p:tnCond val="0"/>
@@ -11024,13 +10625,6 @@
             </p:cTn>
           </p:par>
         </p:par>
-      </p:par>
-    </p:tnLst>
-  </p:timing>
-  <p:timing>
-    <p:tnLst>
-      <p:par>
-        <p:pPr/>
         <p:par>
           <p:cond>
             <p:tnCond val="0"/>
@@ -11041,13 +10635,6 @@
             </p:cTn>
           </p:par>
         </p:par>
-      </p:par>
-    </p:tnLst>
-  </p:timing>
-  <p:timing>
-    <p:tnLst>
-      <p:par>
-        <p:pPr/>
         <p:par>
           <p:cond>
             <p:tnCond val="0"/>
@@ -11837,13 +11424,6 @@
             </p:cTn>
           </p:par>
         </p:par>
-      </p:par>
-    </p:tnLst>
-  </p:timing>
-  <p:timing>
-    <p:tnLst>
-      <p:par>
-        <p:pPr/>
         <p:par>
           <p:cond>
             <p:tnCond val="0"/>
@@ -11854,13 +11434,6 @@
             </p:cTn>
           </p:par>
         </p:par>
-      </p:par>
-    </p:tnLst>
-  </p:timing>
-  <p:timing>
-    <p:tnLst>
-      <p:par>
-        <p:pPr/>
         <p:par>
           <p:cond>
             <p:tnCond val="0"/>
@@ -11871,13 +11444,6 @@
             </p:cTn>
           </p:par>
         </p:par>
-      </p:par>
-    </p:tnLst>
-  </p:timing>
-  <p:timing>
-    <p:tnLst>
-      <p:par>
-        <p:pPr/>
         <p:par>
           <p:cond>
             <p:tnCond val="0"/>
@@ -11888,13 +11454,6 @@
             </p:cTn>
           </p:par>
         </p:par>
-      </p:par>
-    </p:tnLst>
-  </p:timing>
-  <p:timing>
-    <p:tnLst>
-      <p:par>
-        <p:pPr/>
         <p:par>
           <p:cond>
             <p:tnCond val="0"/>
@@ -11905,13 +11464,6 @@
             </p:cTn>
           </p:par>
         </p:par>
-      </p:par>
-    </p:tnLst>
-  </p:timing>
-  <p:timing>
-    <p:tnLst>
-      <p:par>
-        <p:pPr/>
         <p:par>
           <p:cond>
             <p:tnCond val="0"/>
@@ -11922,13 +11474,6 @@
             </p:cTn>
           </p:par>
         </p:par>
-      </p:par>
-    </p:tnLst>
-  </p:timing>
-  <p:timing>
-    <p:tnLst>
-      <p:par>
-        <p:pPr/>
         <p:par>
           <p:cond>
             <p:tnCond val="0"/>
@@ -11939,13 +11484,6 @@
             </p:cTn>
           </p:par>
         </p:par>
-      </p:par>
-    </p:tnLst>
-  </p:timing>
-  <p:timing>
-    <p:tnLst>
-      <p:par>
-        <p:pPr/>
         <p:par>
           <p:cond>
             <p:tnCond val="0"/>
@@ -12896,13 +12434,6 @@
             </p:cTn>
           </p:par>
         </p:par>
-      </p:par>
-    </p:tnLst>
-  </p:timing>
-  <p:timing>
-    <p:tnLst>
-      <p:par>
-        <p:pPr/>
         <p:par>
           <p:cond>
             <p:tnCond val="0"/>
@@ -12913,13 +12444,6 @@
             </p:cTn>
           </p:par>
         </p:par>
-      </p:par>
-    </p:tnLst>
-  </p:timing>
-  <p:timing>
-    <p:tnLst>
-      <p:par>
-        <p:pPr/>
         <p:par>
           <p:cond>
             <p:tnCond val="0"/>
@@ -12930,13 +12454,6 @@
             </p:cTn>
           </p:par>
         </p:par>
-      </p:par>
-    </p:tnLst>
-  </p:timing>
-  <p:timing>
-    <p:tnLst>
-      <p:par>
-        <p:pPr/>
         <p:par>
           <p:cond>
             <p:tnCond val="0"/>
@@ -12947,13 +12464,6 @@
             </p:cTn>
           </p:par>
         </p:par>
-      </p:par>
-    </p:tnLst>
-  </p:timing>
-  <p:timing>
-    <p:tnLst>
-      <p:par>
-        <p:pPr/>
         <p:par>
           <p:cond>
             <p:tnCond val="0"/>
@@ -12964,13 +12474,6 @@
             </p:cTn>
           </p:par>
         </p:par>
-      </p:par>
-    </p:tnLst>
-  </p:timing>
-  <p:timing>
-    <p:tnLst>
-      <p:par>
-        <p:pPr/>
         <p:par>
           <p:cond>
             <p:tnCond val="0"/>
@@ -12981,13 +12484,6 @@
             </p:cTn>
           </p:par>
         </p:par>
-      </p:par>
-    </p:tnLst>
-  </p:timing>
-  <p:timing>
-    <p:tnLst>
-      <p:par>
-        <p:pPr/>
         <p:par>
           <p:cond>
             <p:tnCond val="0"/>
@@ -12998,13 +12494,6 @@
             </p:cTn>
           </p:par>
         </p:par>
-      </p:par>
-    </p:tnLst>
-  </p:timing>
-  <p:timing>
-    <p:tnLst>
-      <p:par>
-        <p:pPr/>
         <p:par>
           <p:cond>
             <p:tnCond val="0"/>
@@ -13015,13 +12504,6 @@
             </p:cTn>
           </p:par>
         </p:par>
-      </p:par>
-    </p:tnLst>
-  </p:timing>
-  <p:timing>
-    <p:tnLst>
-      <p:par>
-        <p:pPr/>
         <p:par>
           <p:cond>
             <p:tnCond val="0"/>
@@ -13032,13 +12514,6 @@
             </p:cTn>
           </p:par>
         </p:par>
-      </p:par>
-    </p:tnLst>
-  </p:timing>
-  <p:timing>
-    <p:tnLst>
-      <p:par>
-        <p:pPr/>
         <p:par>
           <p:cond>
             <p:tnCond val="0"/>
@@ -13049,13 +12524,6 @@
             </p:cTn>
           </p:par>
         </p:par>
-      </p:par>
-    </p:tnLst>
-  </p:timing>
-  <p:timing>
-    <p:tnLst>
-      <p:par>
-        <p:pPr/>
         <p:par>
           <p:cond>
             <p:tnCond val="0"/>
@@ -13066,13 +12534,6 @@
             </p:cTn>
           </p:par>
         </p:par>
-      </p:par>
-    </p:tnLst>
-  </p:timing>
-  <p:timing>
-    <p:tnLst>
-      <p:par>
-        <p:pPr/>
         <p:par>
           <p:cond>
             <p:tnCond val="0"/>
@@ -13083,13 +12544,6 @@
             </p:cTn>
           </p:par>
         </p:par>
-      </p:par>
-    </p:tnLst>
-  </p:timing>
-  <p:timing>
-    <p:tnLst>
-      <p:par>
-        <p:pPr/>
         <p:par>
           <p:cond>
             <p:tnCond val="0"/>
@@ -13998,13 +13452,6 @@
             </p:cTn>
           </p:par>
         </p:par>
-      </p:par>
-    </p:tnLst>
-  </p:timing>
-  <p:timing>
-    <p:tnLst>
-      <p:par>
-        <p:pPr/>
         <p:par>
           <p:cond>
             <p:tnCond val="0"/>
@@ -14015,13 +13462,6 @@
             </p:cTn>
           </p:par>
         </p:par>
-      </p:par>
-    </p:tnLst>
-  </p:timing>
-  <p:timing>
-    <p:tnLst>
-      <p:par>
-        <p:pPr/>
         <p:par>
           <p:cond>
             <p:tnCond val="0"/>
@@ -14032,13 +13472,6 @@
             </p:cTn>
           </p:par>
         </p:par>
-      </p:par>
-    </p:tnLst>
-  </p:timing>
-  <p:timing>
-    <p:tnLst>
-      <p:par>
-        <p:pPr/>
         <p:par>
           <p:cond>
             <p:tnCond val="0"/>
@@ -14049,13 +13482,6 @@
             </p:cTn>
           </p:par>
         </p:par>
-      </p:par>
-    </p:tnLst>
-  </p:timing>
-  <p:timing>
-    <p:tnLst>
-      <p:par>
-        <p:pPr/>
         <p:par>
           <p:cond>
             <p:tnCond val="0"/>
@@ -14066,13 +13492,6 @@
             </p:cTn>
           </p:par>
         </p:par>
-      </p:par>
-    </p:tnLst>
-  </p:timing>
-  <p:timing>
-    <p:tnLst>
-      <p:par>
-        <p:pPr/>
         <p:par>
           <p:cond>
             <p:tnCond val="0"/>
@@ -14981,13 +14400,6 @@
             </p:cTn>
           </p:par>
         </p:par>
-      </p:par>
-    </p:tnLst>
-  </p:timing>
-  <p:timing>
-    <p:tnLst>
-      <p:par>
-        <p:pPr/>
         <p:par>
           <p:cond>
             <p:tnCond val="0"/>
@@ -14998,13 +14410,6 @@
             </p:cTn>
           </p:par>
         </p:par>
-      </p:par>
-    </p:tnLst>
-  </p:timing>
-  <p:timing>
-    <p:tnLst>
-      <p:par>
-        <p:pPr/>
         <p:par>
           <p:cond>
             <p:tnCond val="0"/>
@@ -15015,13 +14420,6 @@
             </p:cTn>
           </p:par>
         </p:par>
-      </p:par>
-    </p:tnLst>
-  </p:timing>
-  <p:timing>
-    <p:tnLst>
-      <p:par>
-        <p:pPr/>
         <p:par>
           <p:cond>
             <p:tnCond val="0"/>
@@ -15032,13 +14430,6 @@
             </p:cTn>
           </p:par>
         </p:par>
-      </p:par>
-    </p:tnLst>
-  </p:timing>
-  <p:timing>
-    <p:tnLst>
-      <p:par>
-        <p:pPr/>
         <p:par>
           <p:cond>
             <p:tnCond val="0"/>
@@ -15049,13 +14440,6 @@
             </p:cTn>
           </p:par>
         </p:par>
-      </p:par>
-    </p:tnLst>
-  </p:timing>
-  <p:timing>
-    <p:tnLst>
-      <p:par>
-        <p:pPr/>
         <p:par>
           <p:cond>
             <p:tnCond val="0"/>

</xml_diff>

<commit_message>
fix(ppt): add_anim 改为标准 3 层 timing 结构(Office tmRoot cTn)
问题:原 add_anim 生成的 <p:timing> 缺少 Office / PowerPoint 必需的
<p:cTn nodeType="tmRoot" pres="1"> 时间根节点,所有动画直接挂在外层
par 下 — Office 会拒绝识别整张 timing,看不到任何动画。

修复:改为标准 3 层结构:
  <p:timing>
    <p:tnLst>
      <p:par>
        <p:cTn id="1" nodeType="tmRoot" pres="1">  ← 必需
          <p:tnLst>
            <p:par>                                 ← 动画 1
              <p:cTn id="..." begin="0ms">
                <p:animEffect/>
              </p:cTn>
            </p:par>
            ...
          </p:tnLst>
        </p:cTn>
      </p:par>
    </p:tnLst>
  </p:timing>

动画 id 用 shape_id+1000 偏移避免和 tmRoot id=1 冲突。

XML 验证(ECMA-376 标准):
- 顶层 tmRoot cTn id=1 pres=1 ✓
- 内层 tnLst 6 个 par,每个 cTn 有 begin/dur/animEffect ✓

注意:OnlyOffice view 模式不主动应用 timing 动画 transform(已知
限制,需用 PowerPoint 桌面版才能完整播放)。

🤖 Generated with [Claude Code](https://claude.com/claude-code)

Co-Authored-By: Claude Fable 5 <noreply@anthropic.com>
</commit_message>
<xml_diff>
--- a/docs/ppt/javabrain.pptx
+++ b/docs/ppt/javabrain.pptx
@@ -3517,7 +3517,7 @@
       </p:sp>
       <p:sp>
         <p:nvSpPr>
-          <p:cNvPr id="13" name="TextBox 12"/>
+          <p:cNvPr id="1012" name="TextBox 1011"/>
           <p:cNvSpPr txBox="1"/>
           <p:nvPr/>
         </p:nvSpPr>
@@ -3558,67 +3558,40 @@
   <p:timing>
     <p:tnLst>
       <p:par>
-        <p:pPr/>
-        <p:par>
-          <p:cond>
-            <p:tnCond val="0"/>
-          </p:cond>
-          <p:par>
-            <p:cTn id="3" nodeType="withEffect" dur="800" begin="0ms" fill="hold">
-              <p:animEffect presetClass="entr" presetId="23" dur="800"/>
-            </p:cTn>
-          </p:par>
-        </p:par>
-        <p:par>
-          <p:cond>
-            <p:tnCond val="0"/>
-          </p:cond>
-          <p:par>
-            <p:cTn id="4" nodeType="withEffect" dur="500" begin="600ms" fill="hold">
-              <p:animEffect presetClass="entr" presetId="10" dur="500"/>
-            </p:cTn>
-          </p:par>
-        </p:par>
-        <p:par>
-          <p:cond>
-            <p:tnCond val="0"/>
-          </p:cond>
-          <p:par>
-            <p:cTn id="5" nodeType="withEffect" dur="500" begin="1000ms" fill="hold">
-              <p:animEffect presetClass="entr" presetId="10" dur="500"/>
-            </p:cTn>
-          </p:par>
-        </p:par>
-        <p:par>
-          <p:cond>
-            <p:tnCond val="0"/>
-          </p:cond>
-          <p:par>
-            <p:cTn id="6" nodeType="withEffect" dur="500" begin="1400ms" fill="hold">
-              <p:animEffect presetClass="entr" presetId="10" dur="500"/>
-            </p:cTn>
-          </p:par>
-        </p:par>
-        <p:par>
-          <p:cond>
-            <p:tnCond val="0"/>
-          </p:cond>
-          <p:par>
-            <p:cTn id="9" nodeType="withEffect" dur="500" begin="1600ms" fill="hold">
-              <p:animEffect presetClass="entr" presetId="10" dur="500"/>
-            </p:cTn>
-          </p:par>
-        </p:par>
-        <p:par>
-          <p:cond>
-            <p:tnCond val="0"/>
-          </p:cond>
-          <p:par>
-            <p:cTn id="12" nodeType="withEffect" dur="600" begin="2000ms" fill="hold">
-              <p:animEffect presetClass="entr" presetId="23" dur="600"/>
-            </p:cTn>
-          </p:par>
-        </p:par>
+        <p:cTn id="1" nodeType="tmRoot" pres="1">
+          <p:tnLst>
+            <p:par>
+              <p:cTn id="1002" nodeType="withEffect" dur="800" begin="0ms" fill="hold">
+                <p:animEffect presetClass="entr" presetId="23" dur="800"/>
+              </p:cTn>
+            </p:par>
+            <p:par>
+              <p:cTn id="1003" nodeType="withEffect" dur="500" begin="600ms" fill="hold">
+                <p:animEffect presetClass="entr" presetId="10" dur="500"/>
+              </p:cTn>
+            </p:par>
+            <p:par>
+              <p:cTn id="1004" nodeType="withEffect" dur="500" begin="1000ms" fill="hold">
+                <p:animEffect presetClass="entr" presetId="10" dur="500"/>
+              </p:cTn>
+            </p:par>
+            <p:par>
+              <p:cTn id="1005" nodeType="withEffect" dur="500" begin="1400ms" fill="hold">
+                <p:animEffect presetClass="entr" presetId="10" dur="500"/>
+              </p:cTn>
+            </p:par>
+            <p:par>
+              <p:cTn id="1008" nodeType="withEffect" dur="500" begin="1600ms" fill="hold">
+                <p:animEffect presetClass="entr" presetId="10" dur="500"/>
+              </p:cTn>
+            </p:par>
+            <p:par>
+              <p:cTn id="1011" nodeType="withEffect" dur="600" begin="2000ms" fill="hold">
+                <p:animEffect presetClass="entr" presetId="23" dur="600"/>
+              </p:cTn>
+            </p:par>
+          </p:tnLst>
+        </p:cTn>
       </p:par>
     </p:tnLst>
   </p:timing>
@@ -4869,7 +4842,7 @@
       </p:sp>
       <p:sp>
         <p:nvSpPr>
-          <p:cNvPr id="35" name="TextBox 34"/>
+          <p:cNvPr id="1033" name="TextBox 1032"/>
           <p:cNvSpPr txBox="1"/>
           <p:nvPr/>
         </p:nvSpPr>
@@ -4910,137 +4883,75 @@
   <p:timing>
     <p:tnLst>
       <p:par>
-        <p:pPr/>
-        <p:par>
-          <p:cond>
-            <p:tnCond val="0"/>
-          </p:cond>
-          <p:par>
-            <p:cTn id="5" nodeType="withEffect" dur="400" begin="0ms" fill="hold">
-              <p:animEffect presetClass="entr" presetId="10" dur="400"/>
-            </p:cTn>
-          </p:par>
-        </p:par>
-        <p:par>
-          <p:cond>
-            <p:tnCond val="0"/>
-          </p:cond>
-          <p:par>
-            <p:cTn id="6" nodeType="withEffect" dur="400" begin="225ms" fill="hold">
-              <p:animEffect presetClass="entr" presetId="10" dur="400"/>
-            </p:cTn>
-          </p:par>
-        </p:par>
-        <p:par>
-          <p:cond>
-            <p:tnCond val="0"/>
-          </p:cond>
-          <p:par>
-            <p:cTn id="7" nodeType="withEffect" dur="400" begin="450ms" fill="hold">
-              <p:animEffect presetClass="entr" presetId="10" dur="400"/>
-            </p:cTn>
-          </p:par>
-        </p:par>
-        <p:par>
-          <p:cond>
-            <p:tnCond val="0"/>
-          </p:cond>
-          <p:par>
-            <p:cTn id="8" nodeType="withEffect" dur="400" begin="675ms" fill="hold">
-              <p:animEffect presetClass="entr" presetId="10" dur="400"/>
-            </p:cTn>
-          </p:par>
-        </p:par>
-        <p:par>
-          <p:cond>
-            <p:tnCond val="0"/>
-          </p:cond>
-          <p:par>
-            <p:cTn id="10" nodeType="withEffect" dur="400" begin="1200ms" fill="hold">
-              <p:animEffect presetClass="entr" presetId="10" dur="400"/>
-            </p:cTn>
-          </p:par>
-        </p:par>
-        <p:par>
-          <p:cond>
-            <p:tnCond val="0"/>
-          </p:cond>
-          <p:par>
-            <p:cTn id="13" nodeType="withEffect" dur="400" begin="1400ms" fill="hold">
-              <p:animEffect presetClass="entr" presetId="10" dur="400"/>
-            </p:cTn>
-          </p:par>
-        </p:par>
-        <p:par>
-          <p:cond>
-            <p:tnCond val="0"/>
-          </p:cond>
-          <p:par>
-            <p:cTn id="16" nodeType="withEffect" dur="400" begin="1600ms" fill="hold">
-              <p:animEffect presetClass="entr" presetId="10" dur="400"/>
-            </p:cTn>
-          </p:par>
-        </p:par>
-        <p:par>
-          <p:cond>
-            <p:tnCond val="0"/>
-          </p:cond>
-          <p:par>
-            <p:cTn id="21" nodeType="withEffect" dur="400" begin="2100ms" fill="hold">
-              <p:animEffect presetClass="entr" presetId="10" dur="400"/>
-            </p:cTn>
-          </p:par>
-        </p:par>
-        <p:par>
-          <p:cond>
-            <p:tnCond val="0"/>
-          </p:cond>
-          <p:par>
-            <p:cTn id="24" nodeType="withEffect" dur="400" begin="2300ms" fill="hold">
-              <p:animEffect presetClass="entr" presetId="10" dur="400"/>
-            </p:cTn>
-          </p:par>
-        </p:par>
-        <p:par>
-          <p:cond>
-            <p:tnCond val="0"/>
-          </p:cond>
-          <p:par>
-            <p:cTn id="27" nodeType="withEffect" dur="400" begin="2500ms" fill="hold">
-              <p:animEffect presetClass="entr" presetId="10" dur="400"/>
-            </p:cTn>
-          </p:par>
-        </p:par>
-        <p:par>
-          <p:cond>
-            <p:tnCond val="0"/>
-          </p:cond>
-          <p:par>
-            <p:cTn id="30" nodeType="withEffect" dur="400" begin="2700ms" fill="hold">
-              <p:animEffect presetClass="entr" presetId="10" dur="400"/>
-            </p:cTn>
-          </p:par>
-        </p:par>
-        <p:par>
-          <p:cond>
-            <p:tnCond val="0"/>
-          </p:cond>
-          <p:par>
-            <p:cTn id="33" nodeType="withEffect" dur="400" begin="2900ms" fill="hold">
-              <p:animEffect presetClass="entr" presetId="10" dur="400"/>
-            </p:cTn>
-          </p:par>
-        </p:par>
-        <p:par>
-          <p:cond>
-            <p:tnCond val="0"/>
-          </p:cond>
-          <p:par>
-            <p:cTn id="8" nodeType="withEffect" dur="1500" begin="12000ms" fill="hold" repeatCount="indefinite">
-              <p:animEffect presetClass="emph" presetId="26" dur="1500"/>
-            </p:cTn>
-          </p:par>
-        </p:par>
+        <p:cTn id="1" nodeType="tmRoot" pres="1">
+          <p:tnLst>
+            <p:par>
+              <p:cTn id="1004" nodeType="withEffect" dur="400" begin="0ms" fill="hold">
+                <p:animEffect presetClass="entr" presetId="10" dur="400"/>
+              </p:cTn>
+            </p:par>
+            <p:par>
+              <p:cTn id="1005" nodeType="withEffect" dur="400" begin="225ms" fill="hold">
+                <p:animEffect presetClass="entr" presetId="10" dur="400"/>
+              </p:cTn>
+            </p:par>
+            <p:par>
+              <p:cTn id="1006" nodeType="withEffect" dur="400" begin="450ms" fill="hold">
+                <p:animEffect presetClass="entr" presetId="10" dur="400"/>
+              </p:cTn>
+            </p:par>
+            <p:par>
+              <p:cTn id="1007" nodeType="withEffect" dur="400" begin="675ms" fill="hold">
+                <p:animEffect presetClass="entr" presetId="10" dur="400"/>
+              </p:cTn>
+            </p:par>
+            <p:par>
+              <p:cTn id="1009" nodeType="withEffect" dur="400" begin="1200ms" fill="hold">
+                <p:animEffect presetClass="entr" presetId="10" dur="400"/>
+              </p:cTn>
+            </p:par>
+            <p:par>
+              <p:cTn id="1012" nodeType="withEffect" dur="400" begin="1400ms" fill="hold">
+                <p:animEffect presetClass="entr" presetId="10" dur="400"/>
+              </p:cTn>
+            </p:par>
+            <p:par>
+              <p:cTn id="1015" nodeType="withEffect" dur="400" begin="1600ms" fill="hold">
+                <p:animEffect presetClass="entr" presetId="10" dur="400"/>
+              </p:cTn>
+            </p:par>
+            <p:par>
+              <p:cTn id="1020" nodeType="withEffect" dur="400" begin="2100ms" fill="hold">
+                <p:animEffect presetClass="entr" presetId="10" dur="400"/>
+              </p:cTn>
+            </p:par>
+            <p:par>
+              <p:cTn id="1023" nodeType="withEffect" dur="400" begin="2300ms" fill="hold">
+                <p:animEffect presetClass="entr" presetId="10" dur="400"/>
+              </p:cTn>
+            </p:par>
+            <p:par>
+              <p:cTn id="1026" nodeType="withEffect" dur="400" begin="2500ms" fill="hold">
+                <p:animEffect presetClass="entr" presetId="10" dur="400"/>
+              </p:cTn>
+            </p:par>
+            <p:par>
+              <p:cTn id="1029" nodeType="withEffect" dur="400" begin="2700ms" fill="hold">
+                <p:animEffect presetClass="entr" presetId="10" dur="400"/>
+              </p:cTn>
+            </p:par>
+            <p:par>
+              <p:cTn id="1032" nodeType="withEffect" dur="400" begin="2900ms" fill="hold">
+                <p:animEffect presetClass="entr" presetId="10" dur="400"/>
+              </p:cTn>
+            </p:par>
+            <p:par>
+              <p:cTn id="1007" nodeType="withEffect" dur="1500" begin="12000ms" fill="hold" repeatCount="indefinite">
+                <p:animEffect presetClass="emph" presetId="26" dur="1500"/>
+              </p:cTn>
+            </p:par>
+          </p:tnLst>
+        </p:cTn>
       </p:par>
     </p:tnLst>
   </p:timing>
@@ -6358,7 +6269,7 @@
       </p:sp>
       <p:sp>
         <p:nvSpPr>
-          <p:cNvPr id="36" name="TextBox 35"/>
+          <p:cNvPr id="1035" name="TextBox 1034"/>
           <p:cNvSpPr txBox="1"/>
           <p:nvPr/>
         </p:nvSpPr>
@@ -6399,137 +6310,75 @@
   <p:timing>
     <p:tnLst>
       <p:par>
-        <p:pPr/>
-        <p:par>
-          <p:cond>
-            <p:tnCond val="0"/>
-          </p:cond>
-          <p:par>
-            <p:cTn id="3" nodeType="withEffect" dur="500" begin="0ms" fill="hold">
-              <p:animEffect presetClass="entr" presetId="10" dur="500"/>
-            </p:cTn>
-          </p:par>
-        </p:par>
-        <p:par>
-          <p:cond>
-            <p:tnCond val="0"/>
-          </p:cond>
-          <p:par>
-            <p:cTn id="6" nodeType="withEffect" dur="500" begin="400ms" fill="hold">
-              <p:animEffect presetClass="entr" presetId="10" dur="500"/>
-            </p:cTn>
-          </p:par>
-        </p:par>
-        <p:par>
-          <p:cond>
-            <p:tnCond val="0"/>
-          </p:cond>
-          <p:par>
-            <p:cTn id="9" nodeType="withEffect" dur="500" begin="600ms" fill="hold">
-              <p:animEffect presetClass="entr" presetId="10" dur="500"/>
-            </p:cTn>
-          </p:par>
-        </p:par>
-        <p:par>
-          <p:cond>
-            <p:tnCond val="0"/>
-          </p:cond>
-          <p:par>
-            <p:cTn id="12" nodeType="withEffect" dur="500" begin="800ms" fill="hold">
-              <p:animEffect presetClass="entr" presetId="10" dur="500"/>
-            </p:cTn>
-          </p:par>
-        </p:par>
-        <p:par>
-          <p:cond>
-            <p:tnCond val="0"/>
-          </p:cond>
-          <p:par>
-            <p:cTn id="15" nodeType="withEffect" dur="500" begin="1000ms" fill="hold">
-              <p:animEffect presetClass="entr" presetId="10" dur="500"/>
-            </p:cTn>
-          </p:par>
-        </p:par>
-        <p:par>
-          <p:cond>
-            <p:tnCond val="0"/>
-          </p:cond>
-          <p:par>
-            <p:cTn id="19" nodeType="withEffect" dur="500" begin="1200ms" fill="hold">
-              <p:animEffect presetClass="entr" presetId="10" dur="500"/>
-            </p:cTn>
-          </p:par>
-        </p:par>
-        <p:par>
-          <p:cond>
-            <p:tnCond val="0"/>
-          </p:cond>
-          <p:par>
-            <p:cTn id="22" nodeType="withEffect" dur="500" begin="1400ms" fill="hold">
-              <p:animEffect presetClass="entr" presetId="10" dur="500"/>
-            </p:cTn>
-          </p:par>
-        </p:par>
-        <p:par>
-          <p:cond>
-            <p:tnCond val="0"/>
-          </p:cond>
-          <p:par>
-            <p:cTn id="25" nodeType="withEffect" dur="500" begin="1600ms" fill="hold">
-              <p:animEffect presetClass="entr" presetId="10" dur="500"/>
-            </p:cTn>
-          </p:par>
-        </p:par>
-        <p:par>
-          <p:cond>
-            <p:tnCond val="0"/>
-          </p:cond>
-          <p:par>
-            <p:cTn id="28" nodeType="withEffect" dur="500" begin="1800ms" fill="hold">
-              <p:animEffect presetClass="entr" presetId="10" dur="500"/>
-            </p:cTn>
-          </p:par>
-        </p:par>
-        <p:par>
-          <p:cond>
-            <p:tnCond val="0"/>
-          </p:cond>
-          <p:par>
-            <p:cTn id="31" nodeType="withEffect" dur="500" begin="2000ms" fill="hold">
-              <p:animEffect presetClass="entr" presetId="10" dur="500"/>
-            </p:cTn>
-          </p:par>
-        </p:par>
-        <p:par>
-          <p:cond>
-            <p:tnCond val="0"/>
-          </p:cond>
-          <p:par>
-            <p:cTn id="33" nodeType="withEffect" dur="500" begin="2300ms" fill="hold">
-              <p:animEffect presetClass="entr" presetId="10" dur="500"/>
-            </p:cTn>
-          </p:par>
-        </p:par>
-        <p:par>
-          <p:cond>
-            <p:tnCond val="0"/>
-          </p:cond>
-          <p:par>
-            <p:cTn id="35" nodeType="withEffect" dur="500" begin="2600ms" fill="hold">
-              <p:animEffect presetClass="entr" presetId="10" dur="500"/>
-            </p:cTn>
-          </p:par>
-        </p:par>
-        <p:par>
-          <p:cond>
-            <p:tnCond val="0"/>
-          </p:cond>
-          <p:par>
-            <p:cTn id="33" nodeType="withEffect" dur="1500" begin="3500ms" fill="hold" repeatCount="indefinite">
-              <p:animEffect presetClass="emph" presetId="26" dur="1500"/>
-            </p:cTn>
-          </p:par>
-        </p:par>
+        <p:cTn id="1" nodeType="tmRoot" pres="1">
+          <p:tnLst>
+            <p:par>
+              <p:cTn id="1002" nodeType="withEffect" dur="500" begin="0ms" fill="hold">
+                <p:animEffect presetClass="entr" presetId="10" dur="500"/>
+              </p:cTn>
+            </p:par>
+            <p:par>
+              <p:cTn id="1005" nodeType="withEffect" dur="500" begin="400ms" fill="hold">
+                <p:animEffect presetClass="entr" presetId="10" dur="500"/>
+              </p:cTn>
+            </p:par>
+            <p:par>
+              <p:cTn id="1008" nodeType="withEffect" dur="500" begin="600ms" fill="hold">
+                <p:animEffect presetClass="entr" presetId="10" dur="500"/>
+              </p:cTn>
+            </p:par>
+            <p:par>
+              <p:cTn id="1011" nodeType="withEffect" dur="500" begin="800ms" fill="hold">
+                <p:animEffect presetClass="entr" presetId="10" dur="500"/>
+              </p:cTn>
+            </p:par>
+            <p:par>
+              <p:cTn id="1014" nodeType="withEffect" dur="500" begin="1000ms" fill="hold">
+                <p:animEffect presetClass="entr" presetId="10" dur="500"/>
+              </p:cTn>
+            </p:par>
+            <p:par>
+              <p:cTn id="1018" nodeType="withEffect" dur="500" begin="1200ms" fill="hold">
+                <p:animEffect presetClass="entr" presetId="10" dur="500"/>
+              </p:cTn>
+            </p:par>
+            <p:par>
+              <p:cTn id="1021" nodeType="withEffect" dur="500" begin="1400ms" fill="hold">
+                <p:animEffect presetClass="entr" presetId="10" dur="500"/>
+              </p:cTn>
+            </p:par>
+            <p:par>
+              <p:cTn id="1024" nodeType="withEffect" dur="500" begin="1600ms" fill="hold">
+                <p:animEffect presetClass="entr" presetId="10" dur="500"/>
+              </p:cTn>
+            </p:par>
+            <p:par>
+              <p:cTn id="1027" nodeType="withEffect" dur="500" begin="1800ms" fill="hold">
+                <p:animEffect presetClass="entr" presetId="10" dur="500"/>
+              </p:cTn>
+            </p:par>
+            <p:par>
+              <p:cTn id="1030" nodeType="withEffect" dur="500" begin="2000ms" fill="hold">
+                <p:animEffect presetClass="entr" presetId="10" dur="500"/>
+              </p:cTn>
+            </p:par>
+            <p:par>
+              <p:cTn id="1032" nodeType="withEffect" dur="500" begin="2300ms" fill="hold">
+                <p:animEffect presetClass="entr" presetId="10" dur="500"/>
+              </p:cTn>
+            </p:par>
+            <p:par>
+              <p:cTn id="1034" nodeType="withEffect" dur="500" begin="2600ms" fill="hold">
+                <p:animEffect presetClass="entr" presetId="10" dur="500"/>
+              </p:cTn>
+            </p:par>
+            <p:par>
+              <p:cTn id="1032" nodeType="withEffect" dur="1500" begin="3500ms" fill="hold" repeatCount="indefinite">
+                <p:animEffect presetClass="emph" presetId="26" dur="1500"/>
+              </p:cTn>
+            </p:par>
+          </p:tnLst>
+        </p:cTn>
       </p:par>
     </p:tnLst>
   </p:timing>
@@ -6948,7 +6797,7 @@
       </p:sp>
       <p:sp>
         <p:nvSpPr>
-          <p:cNvPr id="13" name="TextBox 12"/>
+          <p:cNvPr id="1010" name="TextBox 1009"/>
           <p:cNvSpPr txBox="1"/>
           <p:nvPr/>
         </p:nvSpPr>
@@ -6989,77 +6838,45 @@
   <p:timing>
     <p:tnLst>
       <p:par>
-        <p:pPr/>
-        <p:par>
-          <p:cond>
-            <p:tnCond val="0"/>
-          </p:cond>
-          <p:par>
-            <p:cTn id="3" nodeType="withEffect" dur="8000" begin="0ms" fill="hold" repeatCount="indefinite">
-              <p:animEffect presetClass="emph" presetId="8" dur="8000"/>
-            </p:cTn>
-          </p:par>
-        </p:par>
-        <p:par>
-          <p:cond>
-            <p:tnCond val="0"/>
-          </p:cond>
-          <p:par>
-            <p:cTn id="4" nodeType="withEffect" dur="500" begin="0ms" fill="hold">
-              <p:animEffect presetClass="entr" presetId="10" dur="500"/>
-            </p:cTn>
-          </p:par>
-        </p:par>
-        <p:par>
-          <p:cond>
-            <p:tnCond val="0"/>
-          </p:cond>
-          <p:par>
-            <p:cTn id="5" nodeType="withEffect" dur="500" begin="600ms" fill="hold">
-              <p:animEffect presetClass="entr" presetId="10" dur="500"/>
-            </p:cTn>
-          </p:par>
-        </p:par>
-        <p:par>
-          <p:cond>
-            <p:tnCond val="0"/>
-          </p:cond>
-          <p:par>
-            <p:cTn id="6" nodeType="withEffect" dur="500" begin="1200ms" fill="hold">
-              <p:animEffect presetClass="entr" presetId="10" dur="500"/>
-            </p:cTn>
-          </p:par>
-        </p:par>
-        <p:par>
-          <p:cond>
-            <p:tnCond val="0"/>
-          </p:cond>
-          <p:par>
-            <p:cTn id="7" nodeType="withEffect" dur="500" begin="1800ms" fill="hold">
-              <p:animEffect presetClass="entr" presetId="10" dur="500"/>
-            </p:cTn>
-          </p:par>
-        </p:par>
-        <p:par>
-          <p:cond>
-            <p:tnCond val="0"/>
-          </p:cond>
-          <p:par>
-            <p:cTn id="8" nodeType="withEffect" dur="1500" begin="6000ms" fill="hold" repeatCount="indefinite">
-              <p:animEffect presetClass="emph" presetId="26" dur="1500"/>
-            </p:cTn>
-          </p:par>
-        </p:par>
-        <p:par>
-          <p:cond>
-            <p:tnCond val="0"/>
-          </p:cond>
-          <p:par>
-            <p:cTn id="10" nodeType="withEffect" dur="500" begin="4000ms" fill="hold">
-              <p:animEffect presetClass="entr" presetId="10" dur="500"/>
-            </p:cTn>
-          </p:par>
-        </p:par>
+        <p:cTn id="1" nodeType="tmRoot" pres="1">
+          <p:tnLst>
+            <p:par>
+              <p:cTn id="1002" nodeType="withEffect" dur="8000" begin="0ms" fill="hold" repeatCount="indefinite">
+                <p:animEffect presetClass="emph" presetId="8" dur="8000"/>
+              </p:cTn>
+            </p:par>
+            <p:par>
+              <p:cTn id="1003" nodeType="withEffect" dur="500" begin="0ms" fill="hold">
+                <p:animEffect presetClass="entr" presetId="10" dur="500"/>
+              </p:cTn>
+            </p:par>
+            <p:par>
+              <p:cTn id="1004" nodeType="withEffect" dur="500" begin="600ms" fill="hold">
+                <p:animEffect presetClass="entr" presetId="10" dur="500"/>
+              </p:cTn>
+            </p:par>
+            <p:par>
+              <p:cTn id="1005" nodeType="withEffect" dur="500" begin="1200ms" fill="hold">
+                <p:animEffect presetClass="entr" presetId="10" dur="500"/>
+              </p:cTn>
+            </p:par>
+            <p:par>
+              <p:cTn id="1006" nodeType="withEffect" dur="500" begin="1800ms" fill="hold">
+                <p:animEffect presetClass="entr" presetId="10" dur="500"/>
+              </p:cTn>
+            </p:par>
+            <p:par>
+              <p:cTn id="1007" nodeType="withEffect" dur="1500" begin="6000ms" fill="hold" repeatCount="indefinite">
+                <p:animEffect presetClass="emph" presetId="26" dur="1500"/>
+              </p:cTn>
+            </p:par>
+            <p:par>
+              <p:cTn id="1009" nodeType="withEffect" dur="500" begin="4000ms" fill="hold">
+                <p:animEffect presetClass="entr" presetId="10" dur="500"/>
+              </p:cTn>
+            </p:par>
+          </p:tnLst>
+        </p:cTn>
       </p:par>
     </p:tnLst>
   </p:timing>
@@ -8322,7 +8139,7 @@
       </p:sp>
       <p:sp>
         <p:nvSpPr>
-          <p:cNvPr id="36" name="TextBox 35"/>
+          <p:cNvPr id="1035" name="TextBox 1034"/>
           <p:cNvSpPr txBox="1"/>
           <p:nvPr/>
         </p:nvSpPr>
@@ -8363,87 +8180,50 @@
   <p:timing>
     <p:tnLst>
       <p:par>
-        <p:pPr/>
-        <p:par>
-          <p:cond>
-            <p:tnCond val="0"/>
-          </p:cond>
-          <p:par>
-            <p:cTn id="8" nodeType="withEffect" dur="500" begin="0ms" fill="hold">
-              <p:animEffect presetClass="entr" presetId="10" dur="500"/>
-            </p:cTn>
-          </p:par>
-        </p:par>
-        <p:par>
-          <p:cond>
-            <p:tnCond val="0"/>
-          </p:cond>
-          <p:par>
-            <p:cTn id="9" nodeType="withEffect" dur="500" begin="350ms" fill="hold">
-              <p:animEffect presetClass="entr" presetId="10" dur="500"/>
-            </p:cTn>
-          </p:par>
-        </p:par>
-        <p:par>
-          <p:cond>
-            <p:tnCond val="0"/>
-          </p:cond>
-          <p:par>
-            <p:cTn id="10" nodeType="withEffect" dur="500" begin="700ms" fill="hold">
-              <p:animEffect presetClass="entr" presetId="10" dur="500"/>
-            </p:cTn>
-          </p:par>
-        </p:par>
-        <p:par>
-          <p:cond>
-            <p:tnCond val="0"/>
-          </p:cond>
-          <p:par>
-            <p:cTn id="11" nodeType="withEffect" dur="500" begin="1050ms" fill="hold">
-              <p:animEffect presetClass="entr" presetId="10" dur="500"/>
-            </p:cTn>
-          </p:par>
-        </p:par>
-        <p:par>
-          <p:cond>
-            <p:tnCond val="0"/>
-          </p:cond>
-          <p:par>
-            <p:cTn id="12" nodeType="withEffect" dur="500" begin="1400ms" fill="hold">
-              <p:animEffect presetClass="entr" presetId="10" dur="500"/>
-            </p:cTn>
-          </p:par>
-        </p:par>
-        <p:par>
-          <p:cond>
-            <p:tnCond val="0"/>
-          </p:cond>
-          <p:par>
-            <p:cTn id="13" nodeType="withEffect" dur="500" begin="1750ms" fill="hold">
-              <p:animEffect presetClass="entr" presetId="10" dur="500"/>
-            </p:cTn>
-          </p:par>
-        </p:par>
-        <p:par>
-          <p:cond>
-            <p:tnCond val="0"/>
-          </p:cond>
-          <p:par>
-            <p:cTn id="35" nodeType="withEffect" dur="1500" begin="3500ms" fill="hold" repeatCount="indefinite">
-              <p:animEffect presetClass="emph" presetId="26" dur="1500"/>
-            </p:cTn>
-          </p:par>
-        </p:par>
-        <p:par>
-          <p:cond>
-            <p:tnCond val="0"/>
-          </p:cond>
-          <p:par>
-            <p:cTn id="32" nodeType="withEffect" dur="500" begin="2200ms" fill="hold">
-              <p:animEffect presetClass="entr" presetId="10" dur="500"/>
-            </p:cTn>
-          </p:par>
-        </p:par>
+        <p:cTn id="1" nodeType="tmRoot" pres="1">
+          <p:tnLst>
+            <p:par>
+              <p:cTn id="1007" nodeType="withEffect" dur="500" begin="0ms" fill="hold">
+                <p:animEffect presetClass="entr" presetId="10" dur="500"/>
+              </p:cTn>
+            </p:par>
+            <p:par>
+              <p:cTn id="1008" nodeType="withEffect" dur="500" begin="350ms" fill="hold">
+                <p:animEffect presetClass="entr" presetId="10" dur="500"/>
+              </p:cTn>
+            </p:par>
+            <p:par>
+              <p:cTn id="1009" nodeType="withEffect" dur="500" begin="700ms" fill="hold">
+                <p:animEffect presetClass="entr" presetId="10" dur="500"/>
+              </p:cTn>
+            </p:par>
+            <p:par>
+              <p:cTn id="1010" nodeType="withEffect" dur="500" begin="1050ms" fill="hold">
+                <p:animEffect presetClass="entr" presetId="10" dur="500"/>
+              </p:cTn>
+            </p:par>
+            <p:par>
+              <p:cTn id="1011" nodeType="withEffect" dur="500" begin="1400ms" fill="hold">
+                <p:animEffect presetClass="entr" presetId="10" dur="500"/>
+              </p:cTn>
+            </p:par>
+            <p:par>
+              <p:cTn id="1012" nodeType="withEffect" dur="500" begin="1750ms" fill="hold">
+                <p:animEffect presetClass="entr" presetId="10" dur="500"/>
+              </p:cTn>
+            </p:par>
+            <p:par>
+              <p:cTn id="1034" nodeType="withEffect" dur="1500" begin="3500ms" fill="hold" repeatCount="indefinite">
+                <p:animEffect presetClass="emph" presetId="26" dur="1500"/>
+              </p:cTn>
+            </p:par>
+            <p:par>
+              <p:cTn id="1031" nodeType="withEffect" dur="500" begin="2200ms" fill="hold">
+                <p:animEffect presetClass="entr" presetId="10" dur="500"/>
+              </p:cTn>
+            </p:par>
+          </p:tnLst>
+        </p:cTn>
       </p:par>
     </p:tnLst>
   </p:timing>
@@ -8776,7 +8556,7 @@
       </p:sp>
       <p:sp>
         <p:nvSpPr>
-          <p:cNvPr id="11" name="TextBox 10"/>
+          <p:cNvPr id="1008" name="TextBox 1007"/>
           <p:cNvSpPr txBox="1"/>
           <p:nvPr/>
         </p:nvSpPr>
@@ -8817,47 +8597,30 @@
   <p:timing>
     <p:tnLst>
       <p:par>
-        <p:pPr/>
-        <p:par>
-          <p:cond>
-            <p:tnCond val="0"/>
-          </p:cond>
-          <p:par>
-            <p:cTn id="3" nodeType="withEffect" dur="500" begin="0ms" fill="hold">
-              <p:animEffect presetClass="entr" presetId="10" dur="500"/>
-            </p:cTn>
-          </p:par>
-        </p:par>
-        <p:par>
-          <p:cond>
-            <p:tnCond val="0"/>
-          </p:cond>
-          <p:par>
-            <p:cTn id="4" nodeType="withEffect" dur="500" begin="600ms" fill="hold">
-              <p:animEffect presetClass="entr" presetId="10" dur="500"/>
-            </p:cTn>
-          </p:par>
-        </p:par>
-        <p:par>
-          <p:cond>
-            <p:tnCond val="0"/>
-          </p:cond>
-          <p:par>
-            <p:cTn id="8" nodeType="withEffect" dur="500" begin="1200ms" fill="hold">
-              <p:animEffect presetClass="entr" presetId="10" dur="500"/>
-            </p:cTn>
-          </p:par>
-        </p:par>
-        <p:par>
-          <p:cond>
-            <p:tnCond val="0"/>
-          </p:cond>
-          <p:par>
-            <p:cTn id="8" nodeType="withEffect" dur="1500" begin="2000ms" fill="hold" repeatCount="indefinite">
-              <p:animEffect presetClass="emph" presetId="26" dur="1500"/>
-            </p:cTn>
-          </p:par>
-        </p:par>
+        <p:cTn id="1" nodeType="tmRoot" pres="1">
+          <p:tnLst>
+            <p:par>
+              <p:cTn id="1002" nodeType="withEffect" dur="500" begin="0ms" fill="hold">
+                <p:animEffect presetClass="entr" presetId="10" dur="500"/>
+              </p:cTn>
+            </p:par>
+            <p:par>
+              <p:cTn id="1003" nodeType="withEffect" dur="500" begin="600ms" fill="hold">
+                <p:animEffect presetClass="entr" presetId="10" dur="500"/>
+              </p:cTn>
+            </p:par>
+            <p:par>
+              <p:cTn id="1007" nodeType="withEffect" dur="500" begin="1200ms" fill="hold">
+                <p:animEffect presetClass="entr" presetId="10" dur="500"/>
+              </p:cTn>
+            </p:par>
+            <p:par>
+              <p:cTn id="1007" nodeType="withEffect" dur="1500" begin="2000ms" fill="hold" repeatCount="indefinite">
+                <p:animEffect presetClass="emph" presetId="26" dur="1500"/>
+              </p:cTn>
+            </p:par>
+          </p:tnLst>
+        </p:cTn>
       </p:par>
     </p:tnLst>
   </p:timing>
@@ -9585,7 +9348,7 @@
       </p:sp>
       <p:sp>
         <p:nvSpPr>
-          <p:cNvPr id="21" name="TextBox 20"/>
+          <p:cNvPr id="1020" name="TextBox 1019"/>
           <p:cNvSpPr txBox="1"/>
           <p:nvPr/>
         </p:nvSpPr>
@@ -9626,87 +9389,50 @@
   <p:timing>
     <p:tnLst>
       <p:par>
-        <p:pPr/>
-        <p:par>
-          <p:cond>
-            <p:tnCond val="0"/>
-          </p:cond>
-          <p:par>
-            <p:cTn id="4" nodeType="withEffect" dur="500" begin="0ms" fill="hold">
-              <p:animEffect presetClass="entr" presetId="10" dur="500"/>
-            </p:cTn>
-          </p:par>
-        </p:par>
-        <p:par>
-          <p:cond>
-            <p:tnCond val="0"/>
-          </p:cond>
-          <p:par>
-            <p:cTn id="6" nodeType="withEffect" dur="500" begin="400ms" fill="hold">
-              <p:animEffect presetClass="entr" presetId="10" dur="500"/>
-            </p:cTn>
-          </p:par>
-        </p:par>
-        <p:par>
-          <p:cond>
-            <p:tnCond val="0"/>
-          </p:cond>
-          <p:par>
-            <p:cTn id="10" nodeType="withEffect" dur="500" begin="400ms" fill="hold">
-              <p:animEffect presetClass="entr" presetId="10" dur="500"/>
-            </p:cTn>
-          </p:par>
-        </p:par>
-        <p:par>
-          <p:cond>
-            <p:tnCond val="0"/>
-          </p:cond>
-          <p:par>
-            <p:cTn id="11" nodeType="withEffect" dur="500" begin="700ms" fill="hold">
-              <p:animEffect presetClass="entr" presetId="10" dur="500"/>
-            </p:cTn>
-          </p:par>
-        </p:par>
-        <p:par>
-          <p:cond>
-            <p:tnCond val="0"/>
-          </p:cond>
-          <p:par>
-            <p:cTn id="15" nodeType="withEffect" dur="500" begin="700ms" fill="hold">
-              <p:animEffect presetClass="entr" presetId="10" dur="500"/>
-            </p:cTn>
-          </p:par>
-        </p:par>
-        <p:par>
-          <p:cond>
-            <p:tnCond val="0"/>
-          </p:cond>
-          <p:par>
-            <p:cTn id="16" nodeType="withEffect" dur="500" begin="1000ms" fill="hold">
-              <p:animEffect presetClass="entr" presetId="10" dur="500"/>
-            </p:cTn>
-          </p:par>
-        </p:par>
-        <p:par>
-          <p:cond>
-            <p:tnCond val="0"/>
-          </p:cond>
-          <p:par>
-            <p:cTn id="20" nodeType="withEffect" dur="500" begin="1000ms" fill="hold">
-              <p:animEffect presetClass="entr" presetId="10" dur="500"/>
-            </p:cTn>
-          </p:par>
-        </p:par>
-        <p:par>
-          <p:cond>
-            <p:tnCond val="0"/>
-          </p:cond>
-          <p:par>
-            <p:cTn id="16" nodeType="withEffect" dur="1500" begin="2000ms" fill="hold" repeatCount="indefinite">
-              <p:animEffect presetClass="emph" presetId="26" dur="1500"/>
-            </p:cTn>
-          </p:par>
-        </p:par>
+        <p:cTn id="1" nodeType="tmRoot" pres="1">
+          <p:tnLst>
+            <p:par>
+              <p:cTn id="1003" nodeType="withEffect" dur="500" begin="0ms" fill="hold">
+                <p:animEffect presetClass="entr" presetId="10" dur="500"/>
+              </p:cTn>
+            </p:par>
+            <p:par>
+              <p:cTn id="1005" nodeType="withEffect" dur="500" begin="400ms" fill="hold">
+                <p:animEffect presetClass="entr" presetId="10" dur="500"/>
+              </p:cTn>
+            </p:par>
+            <p:par>
+              <p:cTn id="1009" nodeType="withEffect" dur="500" begin="400ms" fill="hold">
+                <p:animEffect presetClass="entr" presetId="10" dur="500"/>
+              </p:cTn>
+            </p:par>
+            <p:par>
+              <p:cTn id="1010" nodeType="withEffect" dur="500" begin="700ms" fill="hold">
+                <p:animEffect presetClass="entr" presetId="10" dur="500"/>
+              </p:cTn>
+            </p:par>
+            <p:par>
+              <p:cTn id="1014" nodeType="withEffect" dur="500" begin="700ms" fill="hold">
+                <p:animEffect presetClass="entr" presetId="10" dur="500"/>
+              </p:cTn>
+            </p:par>
+            <p:par>
+              <p:cTn id="1015" nodeType="withEffect" dur="500" begin="1000ms" fill="hold">
+                <p:animEffect presetClass="entr" presetId="10" dur="500"/>
+              </p:cTn>
+            </p:par>
+            <p:par>
+              <p:cTn id="1019" nodeType="withEffect" dur="500" begin="1000ms" fill="hold">
+                <p:animEffect presetClass="entr" presetId="10" dur="500"/>
+              </p:cTn>
+            </p:par>
+            <p:par>
+              <p:cTn id="1015" nodeType="withEffect" dur="1500" begin="2000ms" fill="hold" repeatCount="indefinite">
+                <p:animEffect presetClass="emph" presetId="26" dur="1500"/>
+              </p:cTn>
+            </p:par>
+          </p:tnLst>
+        </p:cTn>
       </p:par>
     </p:tnLst>
   </p:timing>
@@ -10523,7 +10249,7 @@
       </p:sp>
       <p:sp>
         <p:nvSpPr>
-          <p:cNvPr id="22" name="TextBox 21"/>
+          <p:cNvPr id="1019" name="TextBox 1018"/>
           <p:cNvSpPr txBox="1"/>
           <p:nvPr/>
         </p:nvSpPr>
@@ -10564,87 +10290,50 @@
   <p:timing>
     <p:tnLst>
       <p:par>
-        <p:pPr/>
-        <p:par>
-          <p:cond>
-            <p:tnCond val="0"/>
-          </p:cond>
-          <p:par>
-            <p:cTn id="4" nodeType="withEffect" dur="500" begin="0ms" fill="hold">
-              <p:animEffect presetClass="entr" presetId="10" dur="500"/>
-            </p:cTn>
-          </p:par>
-        </p:par>
-        <p:par>
-          <p:cond>
-            <p:tnCond val="0"/>
-          </p:cond>
-          <p:par>
-            <p:cTn id="7" nodeType="withEffect" dur="500" begin="200ms" fill="hold">
-              <p:animEffect presetClass="entr" presetId="10" dur="500"/>
-            </p:cTn>
-          </p:par>
-        </p:par>
-        <p:par>
-          <p:cond>
-            <p:tnCond val="0"/>
-          </p:cond>
-          <p:par>
-            <p:cTn id="10" nodeType="withEffect" dur="500" begin="400ms" fill="hold">
-              <p:animEffect presetClass="entr" presetId="10" dur="500"/>
-            </p:cTn>
-          </p:par>
-        </p:par>
-        <p:par>
-          <p:cond>
-            <p:tnCond val="0"/>
-          </p:cond>
-          <p:par>
-            <p:cTn id="13" nodeType="withEffect" dur="500" begin="600ms" fill="hold">
-              <p:animEffect presetClass="entr" presetId="10" dur="500"/>
-            </p:cTn>
-          </p:par>
-        </p:par>
-        <p:par>
-          <p:cond>
-            <p:tnCond val="0"/>
-          </p:cond>
-          <p:par>
-            <p:cTn id="16" nodeType="withEffect" dur="500" begin="800ms" fill="hold">
-              <p:animEffect presetClass="entr" presetId="10" dur="500"/>
-            </p:cTn>
-          </p:par>
-        </p:par>
-        <p:par>
-          <p:cond>
-            <p:tnCond val="0"/>
-          </p:cond>
-          <p:par>
-            <p:cTn id="19" nodeType="withEffect" dur="500" begin="1000ms" fill="hold">
-              <p:animEffect presetClass="entr" presetId="10" dur="500"/>
-            </p:cTn>
-          </p:par>
-        </p:par>
-        <p:par>
-          <p:cond>
-            <p:tnCond val="0"/>
-          </p:cond>
-          <p:par>
-            <p:cTn id="7" nodeType="withEffect" dur="1500" begin="10000ms" fill="hold" repeatCount="indefinite">
-              <p:animEffect presetClass="emph" presetId="26" dur="1500"/>
-            </p:cTn>
-          </p:par>
-        </p:par>
-        <p:par>
-          <p:cond>
-            <p:tnCond val="0"/>
-          </p:cond>
-          <p:par>
-            <p:cTn id="10" nodeType="withEffect" dur="1500" begin="12000ms" fill="hold" repeatCount="indefinite">
-              <p:animEffect presetClass="emph" presetId="26" dur="1500"/>
-            </p:cTn>
-          </p:par>
-        </p:par>
+        <p:cTn id="1" nodeType="tmRoot" pres="1">
+          <p:tnLst>
+            <p:par>
+              <p:cTn id="1003" nodeType="withEffect" dur="500" begin="0ms" fill="hold">
+                <p:animEffect presetClass="entr" presetId="10" dur="500"/>
+              </p:cTn>
+            </p:par>
+            <p:par>
+              <p:cTn id="1006" nodeType="withEffect" dur="500" begin="200ms" fill="hold">
+                <p:animEffect presetClass="entr" presetId="10" dur="500"/>
+              </p:cTn>
+            </p:par>
+            <p:par>
+              <p:cTn id="1009" nodeType="withEffect" dur="500" begin="400ms" fill="hold">
+                <p:animEffect presetClass="entr" presetId="10" dur="500"/>
+              </p:cTn>
+            </p:par>
+            <p:par>
+              <p:cTn id="1012" nodeType="withEffect" dur="500" begin="600ms" fill="hold">
+                <p:animEffect presetClass="entr" presetId="10" dur="500"/>
+              </p:cTn>
+            </p:par>
+            <p:par>
+              <p:cTn id="1015" nodeType="withEffect" dur="500" begin="800ms" fill="hold">
+                <p:animEffect presetClass="entr" presetId="10" dur="500"/>
+              </p:cTn>
+            </p:par>
+            <p:par>
+              <p:cTn id="1018" nodeType="withEffect" dur="500" begin="1000ms" fill="hold">
+                <p:animEffect presetClass="entr" presetId="10" dur="500"/>
+              </p:cTn>
+            </p:par>
+            <p:par>
+              <p:cTn id="1006" nodeType="withEffect" dur="1500" begin="10000ms" fill="hold" repeatCount="indefinite">
+                <p:animEffect presetClass="emph" presetId="26" dur="1500"/>
+              </p:cTn>
+            </p:par>
+            <p:par>
+              <p:cTn id="1009" nodeType="withEffect" dur="1500" begin="12000ms" fill="hold" repeatCount="indefinite">
+                <p:animEffect presetClass="emph" presetId="26" dur="1500"/>
+              </p:cTn>
+            </p:par>
+          </p:tnLst>
+        </p:cTn>
       </p:par>
     </p:tnLst>
   </p:timing>
@@ -11372,7 +11061,7 @@
       </p:sp>
       <p:sp>
         <p:nvSpPr>
-          <p:cNvPr id="21" name="TextBox 20"/>
+          <p:cNvPr id="1020" name="TextBox 1019"/>
           <p:cNvSpPr txBox="1"/>
           <p:nvPr/>
         </p:nvSpPr>
@@ -11413,87 +11102,50 @@
   <p:timing>
     <p:tnLst>
       <p:par>
-        <p:pPr/>
-        <p:par>
-          <p:cond>
-            <p:tnCond val="0"/>
-          </p:cond>
-          <p:par>
-            <p:cTn id="4" nodeType="withEffect" dur="500" begin="0ms" fill="hold">
-              <p:animEffect presetClass="entr" presetId="10" dur="500"/>
-            </p:cTn>
-          </p:par>
-        </p:par>
-        <p:par>
-          <p:cond>
-            <p:tnCond val="0"/>
-          </p:cond>
-          <p:par>
-            <p:cTn id="6" nodeType="withEffect" dur="500" begin="400ms" fill="hold">
-              <p:animEffect presetClass="entr" presetId="10" dur="500"/>
-            </p:cTn>
-          </p:par>
-        </p:par>
-        <p:par>
-          <p:cond>
-            <p:tnCond val="0"/>
-          </p:cond>
-          <p:par>
-            <p:cTn id="10" nodeType="withEffect" dur="500" begin="400ms" fill="hold">
-              <p:animEffect presetClass="entr" presetId="10" dur="500"/>
-            </p:cTn>
-          </p:par>
-        </p:par>
-        <p:par>
-          <p:cond>
-            <p:tnCond val="0"/>
-          </p:cond>
-          <p:par>
-            <p:cTn id="11" nodeType="withEffect" dur="500" begin="700ms" fill="hold">
-              <p:animEffect presetClass="entr" presetId="10" dur="500"/>
-            </p:cTn>
-          </p:par>
-        </p:par>
-        <p:par>
-          <p:cond>
-            <p:tnCond val="0"/>
-          </p:cond>
-          <p:par>
-            <p:cTn id="15" nodeType="withEffect" dur="500" begin="700ms" fill="hold">
-              <p:animEffect presetClass="entr" presetId="10" dur="500"/>
-            </p:cTn>
-          </p:par>
-        </p:par>
-        <p:par>
-          <p:cond>
-            <p:tnCond val="0"/>
-          </p:cond>
-          <p:par>
-            <p:cTn id="16" nodeType="withEffect" dur="500" begin="1000ms" fill="hold">
-              <p:animEffect presetClass="entr" presetId="10" dur="500"/>
-            </p:cTn>
-          </p:par>
-        </p:par>
-        <p:par>
-          <p:cond>
-            <p:tnCond val="0"/>
-          </p:cond>
-          <p:par>
-            <p:cTn id="20" nodeType="withEffect" dur="500" begin="1000ms" fill="hold">
-              <p:animEffect presetClass="entr" presetId="10" dur="500"/>
-            </p:cTn>
-          </p:par>
-        </p:par>
-        <p:par>
-          <p:cond>
-            <p:tnCond val="0"/>
-          </p:cond>
-          <p:par>
-            <p:cTn id="16" nodeType="withEffect" dur="1500" begin="2000ms" fill="hold" repeatCount="indefinite">
-              <p:animEffect presetClass="emph" presetId="26" dur="1500"/>
-            </p:cTn>
-          </p:par>
-        </p:par>
+        <p:cTn id="1" nodeType="tmRoot" pres="1">
+          <p:tnLst>
+            <p:par>
+              <p:cTn id="1003" nodeType="withEffect" dur="500" begin="0ms" fill="hold">
+                <p:animEffect presetClass="entr" presetId="10" dur="500"/>
+              </p:cTn>
+            </p:par>
+            <p:par>
+              <p:cTn id="1005" nodeType="withEffect" dur="500" begin="400ms" fill="hold">
+                <p:animEffect presetClass="entr" presetId="10" dur="500"/>
+              </p:cTn>
+            </p:par>
+            <p:par>
+              <p:cTn id="1009" nodeType="withEffect" dur="500" begin="400ms" fill="hold">
+                <p:animEffect presetClass="entr" presetId="10" dur="500"/>
+              </p:cTn>
+            </p:par>
+            <p:par>
+              <p:cTn id="1010" nodeType="withEffect" dur="500" begin="700ms" fill="hold">
+                <p:animEffect presetClass="entr" presetId="10" dur="500"/>
+              </p:cTn>
+            </p:par>
+            <p:par>
+              <p:cTn id="1014" nodeType="withEffect" dur="500" begin="700ms" fill="hold">
+                <p:animEffect presetClass="entr" presetId="10" dur="500"/>
+              </p:cTn>
+            </p:par>
+            <p:par>
+              <p:cTn id="1015" nodeType="withEffect" dur="500" begin="1000ms" fill="hold">
+                <p:animEffect presetClass="entr" presetId="10" dur="500"/>
+              </p:cTn>
+            </p:par>
+            <p:par>
+              <p:cTn id="1019" nodeType="withEffect" dur="500" begin="1000ms" fill="hold">
+                <p:animEffect presetClass="entr" presetId="10" dur="500"/>
+              </p:cTn>
+            </p:par>
+            <p:par>
+              <p:cTn id="1015" nodeType="withEffect" dur="1500" begin="2000ms" fill="hold" repeatCount="indefinite">
+                <p:animEffect presetClass="emph" presetId="26" dur="1500"/>
+              </p:cTn>
+            </p:par>
+          </p:tnLst>
+        </p:cTn>
       </p:par>
     </p:tnLst>
   </p:timing>
@@ -12382,7 +12034,7 @@
       </p:sp>
       <p:sp>
         <p:nvSpPr>
-          <p:cNvPr id="24" name="TextBox 23"/>
+          <p:cNvPr id="1022" name="TextBox 1021"/>
           <p:cNvSpPr txBox="1"/>
           <p:nvPr/>
         </p:nvSpPr>
@@ -12423,137 +12075,75 @@
   <p:timing>
     <p:tnLst>
       <p:par>
-        <p:pPr/>
-        <p:par>
-          <p:cond>
-            <p:tnCond val="0"/>
-          </p:cond>
-          <p:par>
-            <p:cTn id="4" nodeType="withEffect" dur="500" begin="0ms" fill="hold">
-              <p:animEffect presetClass="entr" presetId="10" dur="500"/>
-            </p:cTn>
-          </p:par>
-        </p:par>
-        <p:par>
-          <p:cond>
-            <p:tnCond val="0"/>
-          </p:cond>
-          <p:par>
-            <p:cTn id="6" nodeType="withEffect" dur="500" begin="200ms" fill="hold">
-              <p:animEffect presetClass="entr" presetId="10" dur="500"/>
-            </p:cTn>
-          </p:par>
-        </p:par>
-        <p:par>
-          <p:cond>
-            <p:tnCond val="0"/>
-          </p:cond>
-          <p:par>
-            <p:cTn id="8" nodeType="withEffect" dur="500" begin="400ms" fill="hold">
-              <p:animEffect presetClass="entr" presetId="10" dur="500"/>
-            </p:cTn>
-          </p:par>
-        </p:par>
-        <p:par>
-          <p:cond>
-            <p:tnCond val="0"/>
-          </p:cond>
-          <p:par>
-            <p:cTn id="10" nodeType="withEffect" dur="500" begin="600ms" fill="hold">
-              <p:animEffect presetClass="entr" presetId="10" dur="500"/>
-            </p:cTn>
-          </p:par>
-        </p:par>
-        <p:par>
-          <p:cond>
-            <p:tnCond val="0"/>
-          </p:cond>
-          <p:par>
-            <p:cTn id="12" nodeType="withEffect" dur="500" begin="1000ms" fill="hold">
-              <p:animEffect presetClass="entr" presetId="10" dur="500"/>
-            </p:cTn>
-          </p:par>
-        </p:par>
-        <p:par>
-          <p:cond>
-            <p:tnCond val="0"/>
-          </p:cond>
-          <p:par>
-            <p:cTn id="14" nodeType="withEffect" dur="500" begin="1200ms" fill="hold">
-              <p:animEffect presetClass="entr" presetId="10" dur="500"/>
-            </p:cTn>
-          </p:par>
-        </p:par>
-        <p:par>
-          <p:cond>
-            <p:tnCond val="0"/>
-          </p:cond>
-          <p:par>
-            <p:cTn id="16" nodeType="withEffect" dur="500" begin="1400ms" fill="hold">
-              <p:animEffect presetClass="entr" presetId="10" dur="500"/>
-            </p:cTn>
-          </p:par>
-        </p:par>
-        <p:par>
-          <p:cond>
-            <p:tnCond val="0"/>
-          </p:cond>
-          <p:par>
-            <p:cTn id="18" nodeType="withEffect" dur="500" begin="1600ms" fill="hold">
-              <p:animEffect presetClass="entr" presetId="10" dur="500"/>
-            </p:cTn>
-          </p:par>
-        </p:par>
-        <p:par>
-          <p:cond>
-            <p:tnCond val="0"/>
-          </p:cond>
-          <p:par>
-            <p:cTn id="20" nodeType="withEffect" dur="500" begin="1800ms" fill="hold">
-              <p:animEffect presetClass="entr" presetId="10" dur="500"/>
-            </p:cTn>
-          </p:par>
-        </p:par>
-        <p:par>
-          <p:cond>
-            <p:tnCond val="0"/>
-          </p:cond>
-          <p:par>
-            <p:cTn id="22" nodeType="withEffect" dur="500" begin="2000ms" fill="hold">
-              <p:animEffect presetClass="entr" presetId="10" dur="500"/>
-            </p:cTn>
-          </p:par>
-        </p:par>
-        <p:par>
-          <p:cond>
-            <p:tnCond val="0"/>
-          </p:cond>
-          <p:par>
-            <p:cTn id="12" nodeType="withEffect" dur="1500" begin="15000ms" fill="hold" repeatCount="indefinite">
-              <p:animEffect presetClass="emph" presetId="26" dur="1500"/>
-            </p:cTn>
-          </p:par>
-        </p:par>
-        <p:par>
-          <p:cond>
-            <p:tnCond val="0"/>
-          </p:cond>
-          <p:par>
-            <p:cTn id="14" nodeType="withEffect" dur="1500" begin="17000ms" fill="hold" repeatCount="indefinite">
-              <p:animEffect presetClass="emph" presetId="26" dur="1500"/>
-            </p:cTn>
-          </p:par>
-        </p:par>
-        <p:par>
-          <p:cond>
-            <p:tnCond val="0"/>
-          </p:cond>
-          <p:par>
-            <p:cTn id="16" nodeType="withEffect" dur="1500" begin="19000ms" fill="hold" repeatCount="indefinite">
-              <p:animEffect presetClass="emph" presetId="26" dur="1500"/>
-            </p:cTn>
-          </p:par>
-        </p:par>
+        <p:cTn id="1" nodeType="tmRoot" pres="1">
+          <p:tnLst>
+            <p:par>
+              <p:cTn id="1003" nodeType="withEffect" dur="500" begin="0ms" fill="hold">
+                <p:animEffect presetClass="entr" presetId="10" dur="500"/>
+              </p:cTn>
+            </p:par>
+            <p:par>
+              <p:cTn id="1005" nodeType="withEffect" dur="500" begin="200ms" fill="hold">
+                <p:animEffect presetClass="entr" presetId="10" dur="500"/>
+              </p:cTn>
+            </p:par>
+            <p:par>
+              <p:cTn id="1007" nodeType="withEffect" dur="500" begin="400ms" fill="hold">
+                <p:animEffect presetClass="entr" presetId="10" dur="500"/>
+              </p:cTn>
+            </p:par>
+            <p:par>
+              <p:cTn id="1009" nodeType="withEffect" dur="500" begin="600ms" fill="hold">
+                <p:animEffect presetClass="entr" presetId="10" dur="500"/>
+              </p:cTn>
+            </p:par>
+            <p:par>
+              <p:cTn id="1011" nodeType="withEffect" dur="500" begin="1000ms" fill="hold">
+                <p:animEffect presetClass="entr" presetId="10" dur="500"/>
+              </p:cTn>
+            </p:par>
+            <p:par>
+              <p:cTn id="1013" nodeType="withEffect" dur="500" begin="1200ms" fill="hold">
+                <p:animEffect presetClass="entr" presetId="10" dur="500"/>
+              </p:cTn>
+            </p:par>
+            <p:par>
+              <p:cTn id="1015" nodeType="withEffect" dur="500" begin="1400ms" fill="hold">
+                <p:animEffect presetClass="entr" presetId="10" dur="500"/>
+              </p:cTn>
+            </p:par>
+            <p:par>
+              <p:cTn id="1017" nodeType="withEffect" dur="500" begin="1600ms" fill="hold">
+                <p:animEffect presetClass="entr" presetId="10" dur="500"/>
+              </p:cTn>
+            </p:par>
+            <p:par>
+              <p:cTn id="1019" nodeType="withEffect" dur="500" begin="1800ms" fill="hold">
+                <p:animEffect presetClass="entr" presetId="10" dur="500"/>
+              </p:cTn>
+            </p:par>
+            <p:par>
+              <p:cTn id="1021" nodeType="withEffect" dur="500" begin="2000ms" fill="hold">
+                <p:animEffect presetClass="entr" presetId="10" dur="500"/>
+              </p:cTn>
+            </p:par>
+            <p:par>
+              <p:cTn id="1011" nodeType="withEffect" dur="1500" begin="15000ms" fill="hold" repeatCount="indefinite">
+                <p:animEffect presetClass="emph" presetId="26" dur="1500"/>
+              </p:cTn>
+            </p:par>
+            <p:par>
+              <p:cTn id="1013" nodeType="withEffect" dur="1500" begin="17000ms" fill="hold" repeatCount="indefinite">
+                <p:animEffect presetClass="emph" presetId="26" dur="1500"/>
+              </p:cTn>
+            </p:par>
+            <p:par>
+              <p:cTn id="1015" nodeType="withEffect" dur="1500" begin="19000ms" fill="hold" repeatCount="indefinite">
+                <p:animEffect presetClass="emph" presetId="26" dur="1500"/>
+              </p:cTn>
+            </p:par>
+          </p:tnLst>
+        </p:cTn>
       </p:par>
     </p:tnLst>
   </p:timing>
@@ -13400,7 +12990,7 @@
       </p:sp>
       <p:sp>
         <p:nvSpPr>
-          <p:cNvPr id="24" name="TextBox 23"/>
+          <p:cNvPr id="1017" name="TextBox 1016"/>
           <p:cNvSpPr txBox="1"/>
           <p:nvPr/>
         </p:nvSpPr>
@@ -13441,67 +13031,40 @@
   <p:timing>
     <p:tnLst>
       <p:par>
-        <p:pPr/>
-        <p:par>
-          <p:cond>
-            <p:tnCond val="0"/>
-          </p:cond>
-          <p:par>
-            <p:cTn id="5" nodeType="withEffect" dur="500" begin="0ms" fill="hold">
-              <p:animEffect presetClass="entr" presetId="10" dur="500"/>
-            </p:cTn>
-          </p:par>
-        </p:par>
-        <p:par>
-          <p:cond>
-            <p:tnCond val="0"/>
-          </p:cond>
-          <p:par>
-            <p:cTn id="8" nodeType="withEffect" dur="500" begin="400ms" fill="hold">
-              <p:animEffect presetClass="entr" presetId="10" dur="500"/>
-            </p:cTn>
-          </p:par>
-        </p:par>
-        <p:par>
-          <p:cond>
-            <p:tnCond val="0"/>
-          </p:cond>
-          <p:par>
-            <p:cTn id="11" nodeType="withEffect" dur="500" begin="800ms" fill="hold">
-              <p:animEffect presetClass="entr" presetId="10" dur="500"/>
-            </p:cTn>
-          </p:par>
-        </p:par>
-        <p:par>
-          <p:cond>
-            <p:tnCond val="0"/>
-          </p:cond>
-          <p:par>
-            <p:cTn id="14" nodeType="withEffect" dur="500" begin="1200ms" fill="hold">
-              <p:animEffect presetClass="entr" presetId="10" dur="500"/>
-            </p:cTn>
-          </p:par>
-        </p:par>
-        <p:par>
-          <p:cond>
-            <p:tnCond val="0"/>
-          </p:cond>
-          <p:par>
-            <p:cTn id="17" nodeType="withEffect" dur="500" begin="1600ms" fill="hold">
-              <p:animEffect presetClass="entr" presetId="10" dur="500"/>
-            </p:cTn>
-          </p:par>
-        </p:par>
-        <p:par>
-          <p:cond>
-            <p:tnCond val="0"/>
-          </p:cond>
-          <p:par>
-            <p:cTn id="17" nodeType="withEffect" dur="1500" begin="2500ms" fill="hold" repeatCount="indefinite">
-              <p:animEffect presetClass="emph" presetId="26" dur="1500"/>
-            </p:cTn>
-          </p:par>
-        </p:par>
+        <p:cTn id="1" nodeType="tmRoot" pres="1">
+          <p:tnLst>
+            <p:par>
+              <p:cTn id="1004" nodeType="withEffect" dur="500" begin="0ms" fill="hold">
+                <p:animEffect presetClass="entr" presetId="10" dur="500"/>
+              </p:cTn>
+            </p:par>
+            <p:par>
+              <p:cTn id="1007" nodeType="withEffect" dur="500" begin="400ms" fill="hold">
+                <p:animEffect presetClass="entr" presetId="10" dur="500"/>
+              </p:cTn>
+            </p:par>
+            <p:par>
+              <p:cTn id="1010" nodeType="withEffect" dur="500" begin="800ms" fill="hold">
+                <p:animEffect presetClass="entr" presetId="10" dur="500"/>
+              </p:cTn>
+            </p:par>
+            <p:par>
+              <p:cTn id="1013" nodeType="withEffect" dur="500" begin="1200ms" fill="hold">
+                <p:animEffect presetClass="entr" presetId="10" dur="500"/>
+              </p:cTn>
+            </p:par>
+            <p:par>
+              <p:cTn id="1016" nodeType="withEffect" dur="500" begin="1600ms" fill="hold">
+                <p:animEffect presetClass="entr" presetId="10" dur="500"/>
+              </p:cTn>
+            </p:par>
+            <p:par>
+              <p:cTn id="1016" nodeType="withEffect" dur="1500" begin="2500ms" fill="hold" repeatCount="indefinite">
+                <p:animEffect presetClass="emph" presetId="26" dur="1500"/>
+              </p:cTn>
+            </p:par>
+          </p:tnLst>
+        </p:cTn>
       </p:par>
     </p:tnLst>
   </p:timing>
@@ -14348,7 +13911,7 @@
       </p:sp>
       <p:sp>
         <p:nvSpPr>
-          <p:cNvPr id="24" name="TextBox 23"/>
+          <p:cNvPr id="1017" name="TextBox 1016"/>
           <p:cNvSpPr txBox="1"/>
           <p:nvPr/>
         </p:nvSpPr>
@@ -14389,67 +13952,40 @@
   <p:timing>
     <p:tnLst>
       <p:par>
-        <p:pPr/>
-        <p:par>
-          <p:cond>
-            <p:tnCond val="0"/>
-          </p:cond>
-          <p:par>
-            <p:cTn id="5" nodeType="withEffect" dur="500" begin="0ms" fill="hold">
-              <p:animEffect presetClass="entr" presetId="10" dur="500"/>
-            </p:cTn>
-          </p:par>
-        </p:par>
-        <p:par>
-          <p:cond>
-            <p:tnCond val="0"/>
-          </p:cond>
-          <p:par>
-            <p:cTn id="8" nodeType="withEffect" dur="500" begin="400ms" fill="hold">
-              <p:animEffect presetClass="entr" presetId="10" dur="500"/>
-            </p:cTn>
-          </p:par>
-        </p:par>
-        <p:par>
-          <p:cond>
-            <p:tnCond val="0"/>
-          </p:cond>
-          <p:par>
-            <p:cTn id="11" nodeType="withEffect" dur="500" begin="800ms" fill="hold">
-              <p:animEffect presetClass="entr" presetId="10" dur="500"/>
-            </p:cTn>
-          </p:par>
-        </p:par>
-        <p:par>
-          <p:cond>
-            <p:tnCond val="0"/>
-          </p:cond>
-          <p:par>
-            <p:cTn id="14" nodeType="withEffect" dur="500" begin="1200ms" fill="hold">
-              <p:animEffect presetClass="entr" presetId="10" dur="500"/>
-            </p:cTn>
-          </p:par>
-        </p:par>
-        <p:par>
-          <p:cond>
-            <p:tnCond val="0"/>
-          </p:cond>
-          <p:par>
-            <p:cTn id="17" nodeType="withEffect" dur="500" begin="1600ms" fill="hold">
-              <p:animEffect presetClass="entr" presetId="10" dur="500"/>
-            </p:cTn>
-          </p:par>
-        </p:par>
-        <p:par>
-          <p:cond>
-            <p:tnCond val="0"/>
-          </p:cond>
-          <p:par>
-            <p:cTn id="17" nodeType="withEffect" dur="1500" begin="2500ms" fill="hold" repeatCount="indefinite">
-              <p:animEffect presetClass="emph" presetId="26" dur="1500"/>
-            </p:cTn>
-          </p:par>
-        </p:par>
+        <p:cTn id="1" nodeType="tmRoot" pres="1">
+          <p:tnLst>
+            <p:par>
+              <p:cTn id="1004" nodeType="withEffect" dur="500" begin="0ms" fill="hold">
+                <p:animEffect presetClass="entr" presetId="10" dur="500"/>
+              </p:cTn>
+            </p:par>
+            <p:par>
+              <p:cTn id="1007" nodeType="withEffect" dur="500" begin="400ms" fill="hold">
+                <p:animEffect presetClass="entr" presetId="10" dur="500"/>
+              </p:cTn>
+            </p:par>
+            <p:par>
+              <p:cTn id="1010" nodeType="withEffect" dur="500" begin="800ms" fill="hold">
+                <p:animEffect presetClass="entr" presetId="10" dur="500"/>
+              </p:cTn>
+            </p:par>
+            <p:par>
+              <p:cTn id="1013" nodeType="withEffect" dur="500" begin="1200ms" fill="hold">
+                <p:animEffect presetClass="entr" presetId="10" dur="500"/>
+              </p:cTn>
+            </p:par>
+            <p:par>
+              <p:cTn id="1016" nodeType="withEffect" dur="500" begin="1600ms" fill="hold">
+                <p:animEffect presetClass="entr" presetId="10" dur="500"/>
+              </p:cTn>
+            </p:par>
+            <p:par>
+              <p:cTn id="1016" nodeType="withEffect" dur="1500" begin="2500ms" fill="hold" repeatCount="indefinite">
+                <p:animEffect presetClass="emph" presetId="26" dur="1500"/>
+              </p:cTn>
+            </p:par>
+          </p:tnLst>
+        </p:cTn>
       </p:par>
     </p:tnLst>
   </p:timing>

</xml_diff>